<commit_message>
docs(pitch): scale slide as three arithmetic chains so each number follows from the last
</commit_message>
<xml_diff>
--- a/pitch/CareCircle-pitch.pptx
+++ b/pitch/CareCircle-pitch.pptx
@@ -4769,7 +4769,7 @@
                 </a:solidFill>
                 <a:latin typeface="Instrument Sans"/>
               </a:rPr>
-              <a:t>THE SCALE</a:t>
+              <a:t>THE SCALE · FOLLOW THE ARITHMETIC</a:t>
             </a:r>
           </a:p>
         </p:txBody>
@@ -4782,8 +4782,8 @@
         </p:nvSpPr>
         <p:spPr>
           <a:xfrm>
-            <a:off x="731520" y="868680"/>
-            <a:ext cx="9144000" cy="731520"/>
+            <a:off x="731520" y="777240"/>
+            <a:ext cx="9144000" cy="640080"/>
           </a:xfrm>
           <a:prstGeom prst="rect">
             <a:avLst/>
@@ -4805,32 +4805,74 @@
               </a:spcAft>
             </a:pPr>
             <a:r>
-              <a:rPr sz="3600" b="1">
+              <a:rPr sz="3400" b="1">
                 <a:solidFill>
                   <a:srgbClr val="14261F"/>
                 </a:solidFill>
                 <a:latin typeface="Bricolage Grotesque"/>
               </a:rPr>
               <a:t>This is not one patient.</a:t>
+            </a:r>
+          </a:p>
+        </p:txBody>
+      </p:sp>
+      <p:sp>
+        <p:nvSpPr>
+          <p:cNvPr id="4" name="TextBox 3"/>
+          <p:cNvSpPr txBox="1"/>
+          <p:nvPr/>
+        </p:nvSpPr>
+        <p:spPr>
+          <a:xfrm>
+            <a:off x="731520" y="1463040"/>
+            <a:ext cx="7315200" cy="256032"/>
+          </a:xfrm>
+          <a:prstGeom prst="rect">
+            <a:avLst/>
+          </a:prstGeom>
+          <a:noFill/>
+        </p:spPr>
+        <p:txBody>
+          <a:bodyPr wrap="square" anchor="t" lIns="0" rIns="0" tIns="0" bIns="0">
+            <a:spAutoFit/>
+          </a:bodyPr>
+          <a:lstStyle/>
+          <a:p>
+            <a:pPr algn="l">
+              <a:lnSpc>
+                <a:spcPct val="115000"/>
+              </a:lnSpc>
+              <a:spcAft>
+                <a:spcPts val="0"/>
+              </a:spcAft>
+            </a:pPr>
+            <a:r>
+              <a:rPr sz="800" b="1">
+                <a:solidFill>
+                  <a:srgbClr val="6D2E5B"/>
+                </a:solidFill>
+                <a:latin typeface="Instrument Sans"/>
+              </a:rPr>
+              <a:t>SEEN, BUT NOT TOLD</a:t>
             </a:r>
           </a:p>
         </p:txBody>
       </p:sp>
       <p:cxnSp>
         <p:nvCxnSpPr>
-          <p:cNvPr id="4" name="Connector 3"/>
+          <p:cNvPr id="5" name="Connector 4"/>
           <p:cNvCxnSpPr/>
           <p:nvPr/>
         </p:nvCxnSpPr>
         <p:spPr>
           <a:xfrm>
-            <a:off x="731520" y="1783080"/>
-            <a:ext cx="10728655" cy="0"/>
+            <a:off x="731520" y="1737360"/>
+            <a:ext cx="2167813" cy="0"/>
           </a:xfrm>
           <a:prstGeom prst="line">
             <a:avLst/>
           </a:prstGeom>
-          <a:ln w="9525">
+          <a:ln w="28575">
             <a:solidFill>
               <a:srgbClr val="D8DED9"/>
             </a:solidFill>
@@ -4853,14 +4895,14 @@
       </p:cxnSp>
       <p:sp>
         <p:nvSpPr>
-          <p:cNvPr id="5" name="TextBox 4"/>
-          <p:cNvSpPr txBox="1"/>
-          <p:nvPr/>
-        </p:nvSpPr>
-        <p:spPr>
-          <a:xfrm>
-            <a:off x="731520" y="1892808"/>
-            <a:ext cx="2926080" cy="822960"/>
+          <p:cNvPr id="6" name="TextBox 5"/>
+          <p:cNvSpPr txBox="1"/>
+          <p:nvPr/>
+        </p:nvSpPr>
+        <p:spPr>
+          <a:xfrm>
+            <a:off x="731520" y="1810512"/>
+            <a:ext cx="2167813" cy="502920"/>
           </a:xfrm>
           <a:prstGeom prst="rect">
             <a:avLst/>
@@ -4882,36 +4924,36 @@
               </a:spcAft>
             </a:pPr>
             <a:r>
-              <a:rPr sz="4400" b="1">
+              <a:rPr sz="2600" b="1">
                 <a:solidFill>
                   <a:srgbClr val="14261F"/>
                 </a:solidFill>
                 <a:latin typeface="Bricolage Grotesque"/>
               </a:rPr>
-              <a:t>47</a:t>
-            </a:r>
-            <a:r>
-              <a:rPr sz="1800" b="1">
+              <a:t>12</a:t>
+            </a:r>
+            <a:r>
+              <a:rPr sz="1100" b="1">
                 <a:solidFill>
                   <a:srgbClr val="5F6D66"/>
                 </a:solidFill>
                 <a:latin typeface="Bricolage Grotesque"/>
               </a:rPr>
-              <a:t> %</a:t>
-            </a:r>
-          </a:p>
-        </p:txBody>
-      </p:sp>
-      <p:sp>
-        <p:nvSpPr>
-          <p:cNvPr id="6" name="TextBox 5"/>
-          <p:cNvSpPr txBox="1"/>
-          <p:nvPr/>
-        </p:nvSpPr>
-        <p:spPr>
-          <a:xfrm>
-            <a:off x="3840480" y="1947672"/>
-            <a:ext cx="7589520" cy="548640"/>
+              <a:t> m</a:t>
+            </a:r>
+          </a:p>
+        </p:txBody>
+      </p:sp>
+      <p:sp>
+        <p:nvSpPr>
+          <p:cNvPr id="7" name="TextBox 6"/>
+          <p:cNvSpPr txBox="1"/>
+          <p:nvPr/>
+        </p:nvSpPr>
+        <p:spPr>
+          <a:xfrm>
+            <a:off x="731520" y="2304288"/>
+            <a:ext cx="2167813" cy="502920"/>
           </a:xfrm>
           <a:prstGeom prst="rect">
             <a:avLst/>
@@ -4926,52 +4968,85 @@
           <a:p>
             <a:pPr algn="l">
               <a:lnSpc>
-                <a:spcPct val="120000"/>
-              </a:lnSpc>
-              <a:spcAft>
-                <a:spcPts val="0"/>
-              </a:spcAft>
-            </a:pPr>
-            <a:r>
-              <a:rPr sz="1450" b="0">
+                <a:spcPct val="115000"/>
+              </a:lnSpc>
+              <a:spcAft>
+                <a:spcPts val="0"/>
+              </a:spcAft>
+            </a:pPr>
+            <a:r>
+              <a:rPr sz="950" b="0">
                 <a:solidFill>
                   <a:srgbClr val="5F6D66"/>
                 </a:solidFill>
                 <a:latin typeface="Instrument Sans"/>
               </a:rPr>
-              <a:t>of blood results have </a:t>
-            </a:r>
-            <a:r>
-              <a:rPr sz="1450" b="1">
+              <a:t>test results viewed in the NHS App </a:t>
+            </a:r>
+            <a:r>
+              <a:rPr sz="950" b="1">
                 <a:solidFill>
                   <a:srgbClr val="14261F"/>
                 </a:solidFill>
                 <a:latin typeface="Instrument Sans"/>
               </a:rPr>
-              <a:t>no record of being communicated</a:t>
-            </a:r>
-            <a:r>
-              <a:rPr sz="1450" b="0">
+              <a:t>every month</a:t>
+            </a:r>
+          </a:p>
+        </p:txBody>
+      </p:sp>
+      <p:sp>
+        <p:nvSpPr>
+          <p:cNvPr id="8" name="TextBox 7"/>
+          <p:cNvSpPr txBox="1"/>
+          <p:nvPr/>
+        </p:nvSpPr>
+        <p:spPr>
+          <a:xfrm>
+            <a:off x="731520" y="2788920"/>
+            <a:ext cx="2167813" cy="274320"/>
+          </a:xfrm>
+          <a:prstGeom prst="rect">
+            <a:avLst/>
+          </a:prstGeom>
+          <a:noFill/>
+        </p:spPr>
+        <p:txBody>
+          <a:bodyPr wrap="square" anchor="t" lIns="0" rIns="0" tIns="0" bIns="0">
+            <a:spAutoFit/>
+          </a:bodyPr>
+          <a:lstStyle/>
+          <a:p>
+            <a:pPr algn="l">
+              <a:lnSpc>
+                <a:spcPct val="115000"/>
+              </a:lnSpc>
+              <a:spcAft>
+                <a:spcPts val="0"/>
+              </a:spcAft>
+            </a:pPr>
+            <a:r>
+              <a:rPr sz="750" b="0">
                 <a:solidFill>
                   <a:srgbClr val="5F6D66"/>
                 </a:solidFill>
                 <a:latin typeface="Instrument Sans"/>
               </a:rPr>
-              <a:t> to the patient. 31% for abnormal results.</a:t>
-            </a:r>
-          </a:p>
-        </p:txBody>
-      </p:sp>
-      <p:sp>
-        <p:nvSpPr>
-          <p:cNvPr id="7" name="TextBox 6"/>
-          <p:cNvSpPr txBox="1"/>
-          <p:nvPr/>
-        </p:nvSpPr>
-        <p:spPr>
-          <a:xfrm>
-            <a:off x="3840480" y="2551176"/>
-            <a:ext cx="7589520" cy="320040"/>
+              <a:t>NHS App roadmap, July 2026</a:t>
+            </a:r>
+          </a:p>
+        </p:txBody>
+      </p:sp>
+      <p:sp>
+        <p:nvSpPr>
+          <p:cNvPr id="9" name="TextBox 8"/>
+          <p:cNvSpPr txBox="1"/>
+          <p:nvPr/>
+        </p:nvSpPr>
+        <p:spPr>
+          <a:xfrm>
+            <a:off x="2899333" y="1901952"/>
+            <a:ext cx="640080" cy="457200"/>
           </a:xfrm>
           <a:prstGeom prst="rect">
             <a:avLst/>
@@ -4984,7 +5059,7 @@
           </a:bodyPr>
           <a:lstStyle/>
           <a:p>
-            <a:pPr algn="l">
+            <a:pPr algn="ctr">
               <a:lnSpc>
                 <a:spcPct val="115000"/>
               </a:lnSpc>
@@ -4993,32 +5068,32 @@
               </a:spcAft>
             </a:pPr>
             <a:r>
-              <a:rPr sz="950" b="0">
-                <a:solidFill>
-                  <a:srgbClr val="5F6D66"/>
-                </a:solidFill>
-                <a:latin typeface="Instrument Sans"/>
-              </a:rPr>
-              <a:t>PACT audit, 2,572 patients, 57 practices</a:t>
+              <a:rPr sz="1600" b="1">
+                <a:solidFill>
+                  <a:srgbClr val="6D2E5B"/>
+                </a:solidFill>
+                <a:latin typeface="Bricolage Grotesque"/>
+              </a:rPr>
+              <a:t>×</a:t>
             </a:r>
           </a:p>
         </p:txBody>
       </p:sp>
       <p:cxnSp>
         <p:nvCxnSpPr>
-          <p:cNvPr id="8" name="Connector 7"/>
+          <p:cNvPr id="10" name="Connector 9"/>
           <p:cNvCxnSpPr/>
           <p:nvPr/>
         </p:nvCxnSpPr>
         <p:spPr>
           <a:xfrm>
-            <a:off x="731520" y="2880360"/>
-            <a:ext cx="10728655" cy="0"/>
+            <a:off x="3539413" y="1737360"/>
+            <a:ext cx="2167813" cy="0"/>
           </a:xfrm>
           <a:prstGeom prst="line">
             <a:avLst/>
           </a:prstGeom>
-          <a:ln w="9525">
+          <a:ln w="28575">
             <a:solidFill>
               <a:srgbClr val="D8DED9"/>
             </a:solidFill>
@@ -5041,14 +5116,14 @@
       </p:cxnSp>
       <p:sp>
         <p:nvSpPr>
-          <p:cNvPr id="9" name="TextBox 8"/>
-          <p:cNvSpPr txBox="1"/>
-          <p:nvPr/>
-        </p:nvSpPr>
-        <p:spPr>
-          <a:xfrm>
-            <a:off x="731520" y="2990088"/>
-            <a:ext cx="2926080" cy="822960"/>
+          <p:cNvPr id="11" name="TextBox 10"/>
+          <p:cNvSpPr txBox="1"/>
+          <p:nvPr/>
+        </p:nvSpPr>
+        <p:spPr>
+          <a:xfrm>
+            <a:off x="3539413" y="1810512"/>
+            <a:ext cx="2167813" cy="502920"/>
           </a:xfrm>
           <a:prstGeom prst="rect">
             <a:avLst/>
@@ -5070,36 +5145,36 @@
               </a:spcAft>
             </a:pPr>
             <a:r>
-              <a:rPr sz="4400" b="1">
+              <a:rPr sz="2600" b="1">
                 <a:solidFill>
                   <a:srgbClr val="14261F"/>
                 </a:solidFill>
                 <a:latin typeface="Bricolage Grotesque"/>
               </a:rPr>
-              <a:t>5.6</a:t>
-            </a:r>
-            <a:r>
-              <a:rPr sz="1800" b="1">
+              <a:t>47</a:t>
+            </a:r>
+            <a:r>
+              <a:rPr sz="1100" b="1">
                 <a:solidFill>
                   <a:srgbClr val="5F6D66"/>
                 </a:solidFill>
                 <a:latin typeface="Bricolage Grotesque"/>
               </a:rPr>
-              <a:t> m</a:t>
-            </a:r>
-          </a:p>
-        </p:txBody>
-      </p:sp>
-      <p:sp>
-        <p:nvSpPr>
-          <p:cNvPr id="10" name="TextBox 9"/>
-          <p:cNvSpPr txBox="1"/>
-          <p:nvPr/>
-        </p:nvSpPr>
-        <p:spPr>
-          <a:xfrm>
-            <a:off x="3840480" y="3044952"/>
-            <a:ext cx="7589520" cy="548640"/>
+              <a:t> %</a:t>
+            </a:r>
+          </a:p>
+        </p:txBody>
+      </p:sp>
+      <p:sp>
+        <p:nvSpPr>
+          <p:cNvPr id="12" name="TextBox 11"/>
+          <p:cNvSpPr txBox="1"/>
+          <p:nvPr/>
+        </p:nvSpPr>
+        <p:spPr>
+          <a:xfrm>
+            <a:off x="3539413" y="2304288"/>
+            <a:ext cx="2167813" cy="502920"/>
           </a:xfrm>
           <a:prstGeom prst="rect">
             <a:avLst/>
@@ -5114,52 +5189,52 @@
           <a:p>
             <a:pPr algn="l">
               <a:lnSpc>
-                <a:spcPct val="120000"/>
-              </a:lnSpc>
-              <a:spcAft>
-                <a:spcPts val="0"/>
-              </a:spcAft>
-            </a:pPr>
-            <a:r>
-              <a:rPr sz="1450" b="0">
+                <a:spcPct val="115000"/>
+              </a:lnSpc>
+              <a:spcAft>
+                <a:spcPts val="0"/>
+              </a:spcAft>
+            </a:pPr>
+            <a:r>
+              <a:rPr sz="950" b="0">
                 <a:solidFill>
                   <a:srgbClr val="5F6D66"/>
                 </a:solidFill>
                 <a:latin typeface="Instrument Sans"/>
               </a:rPr>
-              <a:t>results a month, around </a:t>
-            </a:r>
-            <a:r>
-              <a:rPr sz="1450" b="1">
+              <a:t>have </a:t>
+            </a:r>
+            <a:r>
+              <a:rPr sz="950" b="1">
                 <a:solidFill>
                   <a:srgbClr val="14261F"/>
                 </a:solidFill>
                 <a:latin typeface="Instrument Sans"/>
               </a:rPr>
-              <a:t>68m a year</a:t>
-            </a:r>
-            <a:r>
-              <a:rPr sz="1450" b="0">
+              <a:t>no record of the patient being told</a:t>
+            </a:r>
+            <a:r>
+              <a:rPr sz="950" b="0">
                 <a:solidFill>
                   <a:srgbClr val="5F6D66"/>
                 </a:solidFill>
                 <a:latin typeface="Instrument Sans"/>
               </a:rPr>
-              <a:t>, with no evidence the patient was told.</a:t>
-            </a:r>
-          </a:p>
-        </p:txBody>
-      </p:sp>
-      <p:sp>
-        <p:nvSpPr>
-          <p:cNvPr id="11" name="TextBox 10"/>
-          <p:cNvSpPr txBox="1"/>
-          <p:nvPr/>
-        </p:nvSpPr>
-        <p:spPr>
-          <a:xfrm>
-            <a:off x="3840480" y="3648456"/>
-            <a:ext cx="7589520" cy="320040"/>
+              <a:t>. 31% even when abnormal.</a:t>
+            </a:r>
+          </a:p>
+        </p:txBody>
+      </p:sp>
+      <p:sp>
+        <p:nvSpPr>
+          <p:cNvPr id="13" name="TextBox 12"/>
+          <p:cNvSpPr txBox="1"/>
+          <p:nvPr/>
+        </p:nvSpPr>
+        <p:spPr>
+          <a:xfrm>
+            <a:off x="3539413" y="2788920"/>
+            <a:ext cx="2167813" cy="274320"/>
           </a:xfrm>
           <a:prstGeom prst="rect">
             <a:avLst/>
@@ -5181,41 +5256,74 @@
               </a:spcAft>
             </a:pPr>
             <a:r>
-              <a:rPr sz="800" b="1">
-                <a:solidFill>
-                  <a:srgbClr val="7A520C"/>
+              <a:rPr sz="750" b="0">
+                <a:solidFill>
+                  <a:srgbClr val="5F6D66"/>
                 </a:solidFill>
                 <a:latin typeface="Instrument Sans"/>
               </a:rPr>
-              <a:t>EXTRAPOLATED  </a:t>
-            </a:r>
-            <a:r>
-              <a:rPr sz="950" b="0">
-                <a:solidFill>
-                  <a:srgbClr val="5F6D66"/>
-                </a:solidFill>
-                <a:latin typeface="Instrument Sans"/>
-              </a:rPr>
-              <a:t>12m NHS App result views a month at 47%</a:t>
+              <a:t>PACT audit, 2,572 patients, 57 practices</a:t>
+            </a:r>
+          </a:p>
+        </p:txBody>
+      </p:sp>
+      <p:sp>
+        <p:nvSpPr>
+          <p:cNvPr id="14" name="TextBox 13"/>
+          <p:cNvSpPr txBox="1"/>
+          <p:nvPr/>
+        </p:nvSpPr>
+        <p:spPr>
+          <a:xfrm>
+            <a:off x="5707226" y="1901952"/>
+            <a:ext cx="640080" cy="457200"/>
+          </a:xfrm>
+          <a:prstGeom prst="rect">
+            <a:avLst/>
+          </a:prstGeom>
+          <a:noFill/>
+        </p:spPr>
+        <p:txBody>
+          <a:bodyPr wrap="square" anchor="t" lIns="0" rIns="0" tIns="0" bIns="0">
+            <a:spAutoFit/>
+          </a:bodyPr>
+          <a:lstStyle/>
+          <a:p>
+            <a:pPr algn="ctr">
+              <a:lnSpc>
+                <a:spcPct val="115000"/>
+              </a:lnSpc>
+              <a:spcAft>
+                <a:spcPts val="0"/>
+              </a:spcAft>
+            </a:pPr>
+            <a:r>
+              <a:rPr sz="1600" b="1">
+                <a:solidFill>
+                  <a:srgbClr val="6D2E5B"/>
+                </a:solidFill>
+                <a:latin typeface="Bricolage Grotesque"/>
+              </a:rPr>
+              <a:t>=</a:t>
             </a:r>
           </a:p>
         </p:txBody>
       </p:sp>
       <p:cxnSp>
         <p:nvCxnSpPr>
-          <p:cNvPr id="12" name="Connector 11"/>
+          <p:cNvPr id="15" name="Connector 14"/>
           <p:cNvCxnSpPr/>
           <p:nvPr/>
         </p:nvCxnSpPr>
         <p:spPr>
           <a:xfrm>
-            <a:off x="731520" y="3977640"/>
-            <a:ext cx="10728655" cy="0"/>
+            <a:off x="6347306" y="1737360"/>
+            <a:ext cx="2167813" cy="0"/>
           </a:xfrm>
           <a:prstGeom prst="line">
             <a:avLst/>
           </a:prstGeom>
-          <a:ln w="9525">
+          <a:ln w="28575">
             <a:solidFill>
               <a:srgbClr val="D8DED9"/>
             </a:solidFill>
@@ -5238,14 +5346,14 @@
       </p:cxnSp>
       <p:sp>
         <p:nvSpPr>
-          <p:cNvPr id="13" name="TextBox 12"/>
-          <p:cNvSpPr txBox="1"/>
-          <p:nvPr/>
-        </p:nvSpPr>
-        <p:spPr>
-          <a:xfrm>
-            <a:off x="731520" y="4087368"/>
-            <a:ext cx="2926080" cy="822960"/>
+          <p:cNvPr id="16" name="TextBox 15"/>
+          <p:cNvSpPr txBox="1"/>
+          <p:nvPr/>
+        </p:nvSpPr>
+        <p:spPr>
+          <a:xfrm>
+            <a:off x="6347306" y="1810512"/>
+            <a:ext cx="2167813" cy="502920"/>
           </a:xfrm>
           <a:prstGeom prst="rect">
             <a:avLst/>
@@ -5267,21 +5375,123 @@
               </a:spcAft>
             </a:pPr>
             <a:r>
-              <a:rPr sz="4400" b="1">
+              <a:rPr sz="2600" b="1">
                 <a:solidFill>
                   <a:srgbClr val="14261F"/>
                 </a:solidFill>
                 <a:latin typeface="Bricolage Grotesque"/>
               </a:rPr>
-              <a:t>35,000</a:t>
-            </a:r>
-            <a:r>
-              <a:rPr sz="1800" b="1">
+              <a:t>5.6</a:t>
+            </a:r>
+            <a:r>
+              <a:rPr sz="1100" b="1">
                 <a:solidFill>
                   <a:srgbClr val="5F6D66"/>
                 </a:solidFill>
                 <a:latin typeface="Bricolage Grotesque"/>
               </a:rPr>
+              <a:t> m</a:t>
+            </a:r>
+          </a:p>
+        </p:txBody>
+      </p:sp>
+      <p:sp>
+        <p:nvSpPr>
+          <p:cNvPr id="17" name="TextBox 16"/>
+          <p:cNvSpPr txBox="1"/>
+          <p:nvPr/>
+        </p:nvSpPr>
+        <p:spPr>
+          <a:xfrm>
+            <a:off x="6347306" y="2304288"/>
+            <a:ext cx="2167813" cy="502920"/>
+          </a:xfrm>
+          <a:prstGeom prst="rect">
+            <a:avLst/>
+          </a:prstGeom>
+          <a:noFill/>
+        </p:spPr>
+        <p:txBody>
+          <a:bodyPr wrap="square" anchor="t" lIns="0" rIns="0" tIns="0" bIns="0">
+            <a:spAutoFit/>
+          </a:bodyPr>
+          <a:lstStyle/>
+          <a:p>
+            <a:pPr algn="l">
+              <a:lnSpc>
+                <a:spcPct val="115000"/>
+              </a:lnSpc>
+              <a:spcAft>
+                <a:spcPts val="0"/>
+              </a:spcAft>
+            </a:pPr>
+            <a:r>
+              <a:rPr sz="950" b="0">
+                <a:solidFill>
+                  <a:srgbClr val="5F6D66"/>
+                </a:solidFill>
+                <a:latin typeface="Instrument Sans"/>
+              </a:rPr>
+              <a:t>results a month with </a:t>
+            </a:r>
+            <a:r>
+              <a:rPr sz="950" b="1">
+                <a:solidFill>
+                  <a:srgbClr val="14261F"/>
+                </a:solidFill>
+                <a:latin typeface="Instrument Sans"/>
+              </a:rPr>
+              <a:t>no evidence anyone told the patient</a:t>
+            </a:r>
+          </a:p>
+        </p:txBody>
+      </p:sp>
+      <p:sp>
+        <p:nvSpPr>
+          <p:cNvPr id="18" name="TextBox 17"/>
+          <p:cNvSpPr txBox="1"/>
+          <p:nvPr/>
+        </p:nvSpPr>
+        <p:spPr>
+          <a:xfrm>
+            <a:off x="6347306" y="2788920"/>
+            <a:ext cx="2167813" cy="274320"/>
+          </a:xfrm>
+          <a:prstGeom prst="rect">
+            <a:avLst/>
+          </a:prstGeom>
+          <a:noFill/>
+        </p:spPr>
+        <p:txBody>
+          <a:bodyPr wrap="square" anchor="t" lIns="0" rIns="0" tIns="0" bIns="0">
+            <a:spAutoFit/>
+          </a:bodyPr>
+          <a:lstStyle/>
+          <a:p>
+            <a:pPr algn="l">
+              <a:lnSpc>
+                <a:spcPct val="115000"/>
+              </a:lnSpc>
+              <a:spcAft>
+                <a:spcPts val="0"/>
+              </a:spcAft>
+            </a:pPr>
+            <a:r>
+              <a:rPr sz="700" b="1">
+                <a:solidFill>
+                  <a:srgbClr val="7A520C"/>
+                </a:solidFill>
+                <a:latin typeface="Instrument Sans"/>
+              </a:rPr>
+              <a:t>EXTRAPOLATED  </a:t>
+            </a:r>
+            <a:r>
+              <a:rPr sz="750" b="0">
+                <a:solidFill>
+                  <a:srgbClr val="5F6D66"/>
+                </a:solidFill>
+                <a:latin typeface="Instrument Sans"/>
+              </a:rPr>
               <a:t/>
             </a:r>
           </a:p>
@@ -5289,14 +5499,14 @@
       </p:sp>
       <p:sp>
         <p:nvSpPr>
-          <p:cNvPr id="14" name="TextBox 13"/>
-          <p:cNvSpPr txBox="1"/>
-          <p:nvPr/>
-        </p:nvSpPr>
-        <p:spPr>
-          <a:xfrm>
-            <a:off x="3840480" y="4142232"/>
-            <a:ext cx="7589520" cy="548640"/>
+          <p:cNvPr id="19" name="TextBox 18"/>
+          <p:cNvSpPr txBox="1"/>
+          <p:nvPr/>
+        </p:nvSpPr>
+        <p:spPr>
+          <a:xfrm>
+            <a:off x="8515119" y="1901952"/>
+            <a:ext cx="640080" cy="457200"/>
           </a:xfrm>
           <a:prstGeom prst="rect">
             <a:avLst/>
@@ -5309,58 +5519,7 @@
           </a:bodyPr>
           <a:lstStyle/>
           <a:p>
-            <a:pPr algn="l">
-              <a:lnSpc>
-                <a:spcPct val="120000"/>
-              </a:lnSpc>
-              <a:spcAft>
-                <a:spcPts val="0"/>
-              </a:spcAft>
-            </a:pPr>
-            <a:r>
-              <a:rPr sz="1450" b="1">
-                <a:solidFill>
-                  <a:srgbClr val="14261F"/>
-                </a:solidFill>
-                <a:latin typeface="Instrument Sans"/>
-              </a:rPr>
-              <a:t>GP-hours every working day</a:t>
-            </a:r>
-            <a:r>
-              <a:rPr sz="1450" b="0">
-                <a:solidFill>
-                  <a:srgbClr val="5F6D66"/>
-                </a:solidFill>
-                <a:latin typeface="Instrument Sans"/>
-              </a:rPr>
-              <a:t> spent managing results.</a:t>
-            </a:r>
-          </a:p>
-        </p:txBody>
-      </p:sp>
-      <p:sp>
-        <p:nvSpPr>
-          <p:cNvPr id="15" name="TextBox 14"/>
-          <p:cNvSpPr txBox="1"/>
-          <p:nvPr/>
-        </p:nvSpPr>
-        <p:spPr>
-          <a:xfrm>
-            <a:off x="3840480" y="4745736"/>
-            <a:ext cx="7589520" cy="320040"/>
-          </a:xfrm>
-          <a:prstGeom prst="rect">
-            <a:avLst/>
-          </a:prstGeom>
-          <a:noFill/>
-        </p:spPr>
-        <p:txBody>
-          <a:bodyPr wrap="square" anchor="t" lIns="0" rIns="0" tIns="0" bIns="0">
-            <a:spAutoFit/>
-          </a:bodyPr>
-          <a:lstStyle/>
-          <a:p>
-            <a:pPr algn="l">
+            <a:pPr algn="ctr">
               <a:lnSpc>
                 <a:spcPct val="115000"/>
               </a:lnSpc>
@@ -5369,43 +5528,34 @@
               </a:spcAft>
             </a:pPr>
             <a:r>
-              <a:rPr sz="800" b="1">
-                <a:solidFill>
-                  <a:srgbClr val="7A520C"/>
-                </a:solidFill>
-                <a:latin typeface="Instrument Sans"/>
-              </a:rPr>
-              <a:t>EXTRAPOLATED  </a:t>
-            </a:r>
-            <a:r>
-              <a:rPr sz="950" b="0">
-                <a:solidFill>
-                  <a:srgbClr val="5F6D66"/>
-                </a:solidFill>
-                <a:latin typeface="Instrument Sans"/>
-              </a:rPr>
-              <a:t>74 minutes a day per doctor across 28,426 FTE GPs in England</a:t>
+              <a:rPr sz="1600" b="1">
+                <a:solidFill>
+                  <a:srgbClr val="6D2E5B"/>
+                </a:solidFill>
+                <a:latin typeface="Bricolage Grotesque"/>
+              </a:rPr>
+              <a:t>× 12</a:t>
             </a:r>
           </a:p>
         </p:txBody>
       </p:sp>
       <p:cxnSp>
         <p:nvCxnSpPr>
-          <p:cNvPr id="16" name="Connector 15"/>
+          <p:cNvPr id="20" name="Connector 19"/>
           <p:cNvCxnSpPr/>
           <p:nvPr/>
         </p:nvCxnSpPr>
         <p:spPr>
           <a:xfrm>
-            <a:off x="731520" y="5074920"/>
-            <a:ext cx="10728655" cy="0"/>
+            <a:off x="9155199" y="1737360"/>
+            <a:ext cx="2167813" cy="0"/>
           </a:xfrm>
           <a:prstGeom prst="line">
             <a:avLst/>
           </a:prstGeom>
-          <a:ln w="9525">
+          <a:ln w="28575">
             <a:solidFill>
-              <a:srgbClr val="D8DED9"/>
+              <a:srgbClr val="6D2E5B"/>
             </a:solidFill>
           </a:ln>
         </p:spPr>
@@ -5426,14 +5576,14 @@
       </p:cxnSp>
       <p:sp>
         <p:nvSpPr>
-          <p:cNvPr id="17" name="TextBox 16"/>
-          <p:cNvSpPr txBox="1"/>
-          <p:nvPr/>
-        </p:nvSpPr>
-        <p:spPr>
-          <a:xfrm>
-            <a:off x="731520" y="5184648"/>
-            <a:ext cx="2926080" cy="822960"/>
+          <p:cNvPr id="21" name="TextBox 20"/>
+          <p:cNvSpPr txBox="1"/>
+          <p:nvPr/>
+        </p:nvSpPr>
+        <p:spPr>
+          <a:xfrm>
+            <a:off x="9155199" y="1810512"/>
+            <a:ext cx="2167813" cy="502920"/>
           </a:xfrm>
           <a:prstGeom prst="rect">
             <a:avLst/>
@@ -5455,16 +5605,1148 @@
               </a:spcAft>
             </a:pPr>
             <a:r>
-              <a:rPr sz="4400" b="1">
+              <a:rPr sz="2600" b="1">
+                <a:solidFill>
+                  <a:srgbClr val="6D2E5B"/>
+                </a:solidFill>
+                <a:latin typeface="Bricolage Grotesque"/>
+              </a:rPr>
+              <a:t>68</a:t>
+            </a:r>
+            <a:r>
+              <a:rPr sz="1100" b="1">
+                <a:solidFill>
+                  <a:srgbClr val="5F6D66"/>
+                </a:solidFill>
+                <a:latin typeface="Bricolage Grotesque"/>
+              </a:rPr>
+              <a:t> m</a:t>
+            </a:r>
+          </a:p>
+        </p:txBody>
+      </p:sp>
+      <p:sp>
+        <p:nvSpPr>
+          <p:cNvPr id="22" name="TextBox 21"/>
+          <p:cNvSpPr txBox="1"/>
+          <p:nvPr/>
+        </p:nvSpPr>
+        <p:spPr>
+          <a:xfrm>
+            <a:off x="9155199" y="2304288"/>
+            <a:ext cx="2167813" cy="502920"/>
+          </a:xfrm>
+          <a:prstGeom prst="rect">
+            <a:avLst/>
+          </a:prstGeom>
+          <a:noFill/>
+        </p:spPr>
+        <p:txBody>
+          <a:bodyPr wrap="square" anchor="t" lIns="0" rIns="0" tIns="0" bIns="0">
+            <a:spAutoFit/>
+          </a:bodyPr>
+          <a:lstStyle/>
+          <a:p>
+            <a:pPr algn="l">
+              <a:lnSpc>
+                <a:spcPct val="115000"/>
+              </a:lnSpc>
+              <a:spcAft>
+                <a:spcPts val="0"/>
+              </a:spcAft>
+            </a:pPr>
+            <a:r>
+              <a:rPr sz="950" b="0">
+                <a:solidFill>
+                  <a:srgbClr val="5F6D66"/>
+                </a:solidFill>
+                <a:latin typeface="Instrument Sans"/>
+              </a:rPr>
+              <a:t>a year. </a:t>
+            </a:r>
+            <a:r>
+              <a:rPr sz="950" b="1">
                 <a:solidFill>
                   <a:srgbClr val="14261F"/>
                 </a:solidFill>
+                <a:latin typeface="Instrument Sans"/>
+              </a:rPr>
+              <a:t>Every one of them is somebody's Eleanor.</a:t>
+            </a:r>
+          </a:p>
+        </p:txBody>
+      </p:sp>
+      <p:sp>
+        <p:nvSpPr>
+          <p:cNvPr id="23" name="TextBox 22"/>
+          <p:cNvSpPr txBox="1"/>
+          <p:nvPr/>
+        </p:nvSpPr>
+        <p:spPr>
+          <a:xfrm>
+            <a:off x="9155199" y="2788920"/>
+            <a:ext cx="2167813" cy="274320"/>
+          </a:xfrm>
+          <a:prstGeom prst="rect">
+            <a:avLst/>
+          </a:prstGeom>
+          <a:noFill/>
+        </p:spPr>
+        <p:txBody>
+          <a:bodyPr wrap="square" anchor="t" lIns="0" rIns="0" tIns="0" bIns="0">
+            <a:spAutoFit/>
+          </a:bodyPr>
+          <a:lstStyle/>
+          <a:p>
+            <a:pPr algn="l">
+              <a:lnSpc>
+                <a:spcPct val="115000"/>
+              </a:lnSpc>
+              <a:spcAft>
+                <a:spcPts val="0"/>
+              </a:spcAft>
+            </a:pPr>
+            <a:r>
+              <a:rPr sz="700" b="1">
+                <a:solidFill>
+                  <a:srgbClr val="7A520C"/>
+                </a:solidFill>
+                <a:latin typeface="Instrument Sans"/>
+              </a:rPr>
+              <a:t>EXTRAPOLATED  </a:t>
+            </a:r>
+            <a:r>
+              <a:rPr sz="750" b="0">
+                <a:solidFill>
+                  <a:srgbClr val="5F6D66"/>
+                </a:solidFill>
+                <a:latin typeface="Instrument Sans"/>
+              </a:rPr>
+              <a:t/>
+            </a:r>
+          </a:p>
+        </p:txBody>
+      </p:sp>
+      <p:sp>
+        <p:nvSpPr>
+          <p:cNvPr id="24" name="TextBox 23"/>
+          <p:cNvSpPr txBox="1"/>
+          <p:nvPr/>
+        </p:nvSpPr>
+        <p:spPr>
+          <a:xfrm>
+            <a:off x="731520" y="3154680"/>
+            <a:ext cx="7315200" cy="256032"/>
+          </a:xfrm>
+          <a:prstGeom prst="rect">
+            <a:avLst/>
+          </a:prstGeom>
+          <a:noFill/>
+        </p:spPr>
+        <p:txBody>
+          <a:bodyPr wrap="square" anchor="t" lIns="0" rIns="0" tIns="0" bIns="0">
+            <a:spAutoFit/>
+          </a:bodyPr>
+          <a:lstStyle/>
+          <a:p>
+            <a:pPr algn="l">
+              <a:lnSpc>
+                <a:spcPct val="115000"/>
+              </a:lnSpc>
+              <a:spcAft>
+                <a:spcPts val="0"/>
+              </a:spcAft>
+            </a:pPr>
+            <a:r>
+              <a:rPr sz="800" b="1">
+                <a:solidFill>
+                  <a:srgbClr val="6D2E5B"/>
+                </a:solidFill>
+                <a:latin typeface="Instrument Sans"/>
+              </a:rPr>
+              <a:t>WHAT IT COSTS THE PRACTICE</a:t>
+            </a:r>
+          </a:p>
+        </p:txBody>
+      </p:sp>
+      <p:cxnSp>
+        <p:nvCxnSpPr>
+          <p:cNvPr id="25" name="Connector 24"/>
+          <p:cNvCxnSpPr/>
+          <p:nvPr/>
+        </p:nvCxnSpPr>
+        <p:spPr>
+          <a:xfrm>
+            <a:off x="731520" y="3429000"/>
+            <a:ext cx="3103778" cy="0"/>
+          </a:xfrm>
+          <a:prstGeom prst="line">
+            <a:avLst/>
+          </a:prstGeom>
+          <a:ln w="28575">
+            <a:solidFill>
+              <a:srgbClr val="D8DED9"/>
+            </a:solidFill>
+          </a:ln>
+        </p:spPr>
+        <p:style>
+          <a:lnRef idx="2">
+            <a:schemeClr val="accent1"/>
+          </a:lnRef>
+          <a:fillRef idx="0">
+            <a:schemeClr val="accent1"/>
+          </a:fillRef>
+          <a:effectRef idx="1">
+            <a:schemeClr val="accent1"/>
+          </a:effectRef>
+          <a:fontRef idx="minor">
+            <a:schemeClr val="tx1"/>
+          </a:fontRef>
+        </p:style>
+      </p:cxnSp>
+      <p:sp>
+        <p:nvSpPr>
+          <p:cNvPr id="26" name="TextBox 25"/>
+          <p:cNvSpPr txBox="1"/>
+          <p:nvPr/>
+        </p:nvSpPr>
+        <p:spPr>
+          <a:xfrm>
+            <a:off x="731520" y="3502152"/>
+            <a:ext cx="3103778" cy="502920"/>
+          </a:xfrm>
+          <a:prstGeom prst="rect">
+            <a:avLst/>
+          </a:prstGeom>
+          <a:noFill/>
+        </p:spPr>
+        <p:txBody>
+          <a:bodyPr wrap="square" anchor="t" lIns="0" rIns="0" tIns="0" bIns="0">
+            <a:spAutoFit/>
+          </a:bodyPr>
+          <a:lstStyle/>
+          <a:p>
+            <a:pPr algn="l">
+              <a:lnSpc>
+                <a:spcPct val="115000"/>
+              </a:lnSpc>
+              <a:spcAft>
+                <a:spcPts val="0"/>
+              </a:spcAft>
+            </a:pPr>
+            <a:r>
+              <a:rPr sz="2600" b="1">
+                <a:solidFill>
+                  <a:srgbClr val="14261F"/>
+                </a:solidFill>
                 <a:latin typeface="Bricolage Grotesque"/>
               </a:rPr>
+              <a:t>74</a:t>
+            </a:r>
+            <a:r>
+              <a:rPr sz="1100" b="1">
+                <a:solidFill>
+                  <a:srgbClr val="5F6D66"/>
+                </a:solidFill>
+                <a:latin typeface="Bricolage Grotesque"/>
+              </a:rPr>
+              <a:t> min</a:t>
+            </a:r>
+          </a:p>
+        </p:txBody>
+      </p:sp>
+      <p:sp>
+        <p:nvSpPr>
+          <p:cNvPr id="27" name="TextBox 26"/>
+          <p:cNvSpPr txBox="1"/>
+          <p:nvPr/>
+        </p:nvSpPr>
+        <p:spPr>
+          <a:xfrm>
+            <a:off x="731520" y="3995928"/>
+            <a:ext cx="3103778" cy="502920"/>
+          </a:xfrm>
+          <a:prstGeom prst="rect">
+            <a:avLst/>
+          </a:prstGeom>
+          <a:noFill/>
+        </p:spPr>
+        <p:txBody>
+          <a:bodyPr wrap="square" anchor="t" lIns="0" rIns="0" tIns="0" bIns="0">
+            <a:spAutoFit/>
+          </a:bodyPr>
+          <a:lstStyle/>
+          <a:p>
+            <a:pPr algn="l">
+              <a:lnSpc>
+                <a:spcPct val="115000"/>
+              </a:lnSpc>
+              <a:spcAft>
+                <a:spcPts val="0"/>
+              </a:spcAft>
+            </a:pPr>
+            <a:r>
+              <a:rPr sz="950" b="0">
+                <a:solidFill>
+                  <a:srgbClr val="5F6D66"/>
+                </a:solidFill>
+                <a:latin typeface="Instrument Sans"/>
+              </a:rPr>
+              <a:t>a day </a:t>
+            </a:r>
+            <a:r>
+              <a:rPr sz="950" b="1">
+                <a:solidFill>
+                  <a:srgbClr val="14261F"/>
+                </a:solidFill>
+                <a:latin typeface="Instrument Sans"/>
+              </a:rPr>
+              <a:t>per GP</a:t>
+            </a:r>
+            <a:r>
+              <a:rPr sz="950" b="0">
+                <a:solidFill>
+                  <a:srgbClr val="5F6D66"/>
+                </a:solidFill>
+                <a:latin typeface="Instrument Sans"/>
+              </a:rPr>
+              <a:t> managing results</a:t>
+            </a:r>
+          </a:p>
+        </p:txBody>
+      </p:sp>
+      <p:sp>
+        <p:nvSpPr>
+          <p:cNvPr id="28" name="TextBox 27"/>
+          <p:cNvSpPr txBox="1"/>
+          <p:nvPr/>
+        </p:nvSpPr>
+        <p:spPr>
+          <a:xfrm>
+            <a:off x="731520" y="4480560"/>
+            <a:ext cx="3103778" cy="274320"/>
+          </a:xfrm>
+          <a:prstGeom prst="rect">
+            <a:avLst/>
+          </a:prstGeom>
+          <a:noFill/>
+        </p:spPr>
+        <p:txBody>
+          <a:bodyPr wrap="square" anchor="t" lIns="0" rIns="0" tIns="0" bIns="0">
+            <a:spAutoFit/>
+          </a:bodyPr>
+          <a:lstStyle/>
+          <a:p>
+            <a:pPr algn="l">
+              <a:lnSpc>
+                <a:spcPct val="115000"/>
+              </a:lnSpc>
+              <a:spcAft>
+                <a:spcPts val="0"/>
+              </a:spcAft>
+            </a:pPr>
+            <a:r>
+              <a:rPr sz="750" b="0">
+                <a:solidFill>
+                  <a:srgbClr val="5F6D66"/>
+                </a:solidFill>
+                <a:latin typeface="Instrument Sans"/>
+              </a:rPr>
+              <a:t>Poon et al. 2004, 262 physicians</a:t>
+            </a:r>
+          </a:p>
+        </p:txBody>
+      </p:sp>
+      <p:sp>
+        <p:nvSpPr>
+          <p:cNvPr id="29" name="TextBox 28"/>
+          <p:cNvSpPr txBox="1"/>
+          <p:nvPr/>
+        </p:nvSpPr>
+        <p:spPr>
+          <a:xfrm>
+            <a:off x="3835298" y="3593592"/>
+            <a:ext cx="640080" cy="457200"/>
+          </a:xfrm>
+          <a:prstGeom prst="rect">
+            <a:avLst/>
+          </a:prstGeom>
+          <a:noFill/>
+        </p:spPr>
+        <p:txBody>
+          <a:bodyPr wrap="square" anchor="t" lIns="0" rIns="0" tIns="0" bIns="0">
+            <a:spAutoFit/>
+          </a:bodyPr>
+          <a:lstStyle/>
+          <a:p>
+            <a:pPr algn="ctr">
+              <a:lnSpc>
+                <a:spcPct val="115000"/>
+              </a:lnSpc>
+              <a:spcAft>
+                <a:spcPts val="0"/>
+              </a:spcAft>
+            </a:pPr>
+            <a:r>
+              <a:rPr sz="1600" b="1">
+                <a:solidFill>
+                  <a:srgbClr val="6D2E5B"/>
+                </a:solidFill>
+                <a:latin typeface="Bricolage Grotesque"/>
+              </a:rPr>
+              <a:t>×</a:t>
+            </a:r>
+          </a:p>
+        </p:txBody>
+      </p:sp>
+      <p:cxnSp>
+        <p:nvCxnSpPr>
+          <p:cNvPr id="30" name="Connector 29"/>
+          <p:cNvCxnSpPr/>
+          <p:nvPr/>
+        </p:nvCxnSpPr>
+        <p:spPr>
+          <a:xfrm>
+            <a:off x="4475378" y="3429000"/>
+            <a:ext cx="3103778" cy="0"/>
+          </a:xfrm>
+          <a:prstGeom prst="line">
+            <a:avLst/>
+          </a:prstGeom>
+          <a:ln w="28575">
+            <a:solidFill>
+              <a:srgbClr val="D8DED9"/>
+            </a:solidFill>
+          </a:ln>
+        </p:spPr>
+        <p:style>
+          <a:lnRef idx="2">
+            <a:schemeClr val="accent1"/>
+          </a:lnRef>
+          <a:fillRef idx="0">
+            <a:schemeClr val="accent1"/>
+          </a:fillRef>
+          <a:effectRef idx="1">
+            <a:schemeClr val="accent1"/>
+          </a:effectRef>
+          <a:fontRef idx="minor">
+            <a:schemeClr val="tx1"/>
+          </a:fontRef>
+        </p:style>
+      </p:cxnSp>
+      <p:sp>
+        <p:nvSpPr>
+          <p:cNvPr id="31" name="TextBox 30"/>
+          <p:cNvSpPr txBox="1"/>
+          <p:nvPr/>
+        </p:nvSpPr>
+        <p:spPr>
+          <a:xfrm>
+            <a:off x="4475378" y="3502152"/>
+            <a:ext cx="3103778" cy="502920"/>
+          </a:xfrm>
+          <a:prstGeom prst="rect">
+            <a:avLst/>
+          </a:prstGeom>
+          <a:noFill/>
+        </p:spPr>
+        <p:txBody>
+          <a:bodyPr wrap="square" anchor="t" lIns="0" rIns="0" tIns="0" bIns="0">
+            <a:spAutoFit/>
+          </a:bodyPr>
+          <a:lstStyle/>
+          <a:p>
+            <a:pPr algn="l">
+              <a:lnSpc>
+                <a:spcPct val="115000"/>
+              </a:lnSpc>
+              <a:spcAft>
+                <a:spcPts val="0"/>
+              </a:spcAft>
+            </a:pPr>
+            <a:r>
+              <a:rPr sz="2600" b="1">
+                <a:solidFill>
+                  <a:srgbClr val="14261F"/>
+                </a:solidFill>
+                <a:latin typeface="Bricolage Grotesque"/>
+              </a:rPr>
+              <a:t>28,426</a:t>
+            </a:r>
+            <a:r>
+              <a:rPr sz="1100" b="1">
+                <a:solidFill>
+                  <a:srgbClr val="5F6D66"/>
+                </a:solidFill>
+                <a:latin typeface="Bricolage Grotesque"/>
+              </a:rPr>
+              <a:t/>
+            </a:r>
+          </a:p>
+        </p:txBody>
+      </p:sp>
+      <p:sp>
+        <p:nvSpPr>
+          <p:cNvPr id="32" name="TextBox 31"/>
+          <p:cNvSpPr txBox="1"/>
+          <p:nvPr/>
+        </p:nvSpPr>
+        <p:spPr>
+          <a:xfrm>
+            <a:off x="4475378" y="3995928"/>
+            <a:ext cx="3103778" cy="502920"/>
+          </a:xfrm>
+          <a:prstGeom prst="rect">
+            <a:avLst/>
+          </a:prstGeom>
+          <a:noFill/>
+        </p:spPr>
+        <p:txBody>
+          <a:bodyPr wrap="square" anchor="t" lIns="0" rIns="0" tIns="0" bIns="0">
+            <a:spAutoFit/>
+          </a:bodyPr>
+          <a:lstStyle/>
+          <a:p>
+            <a:pPr algn="l">
+              <a:lnSpc>
+                <a:spcPct val="115000"/>
+              </a:lnSpc>
+              <a:spcAft>
+                <a:spcPts val="0"/>
+              </a:spcAft>
+            </a:pPr>
+            <a:r>
+              <a:rPr sz="950" b="1">
+                <a:solidFill>
+                  <a:srgbClr val="14261F"/>
+                </a:solidFill>
+                <a:latin typeface="Instrument Sans"/>
+              </a:rPr>
+              <a:t>full-time GPs</a:t>
+            </a:r>
+            <a:r>
+              <a:rPr sz="950" b="0">
+                <a:solidFill>
+                  <a:srgbClr val="5F6D66"/>
+                </a:solidFill>
+                <a:latin typeface="Instrument Sans"/>
+              </a:rPr>
+              <a:t> in England</a:t>
+            </a:r>
+          </a:p>
+        </p:txBody>
+      </p:sp>
+      <p:sp>
+        <p:nvSpPr>
+          <p:cNvPr id="33" name="TextBox 32"/>
+          <p:cNvSpPr txBox="1"/>
+          <p:nvPr/>
+        </p:nvSpPr>
+        <p:spPr>
+          <a:xfrm>
+            <a:off x="4475378" y="4480560"/>
+            <a:ext cx="3103778" cy="274320"/>
+          </a:xfrm>
+          <a:prstGeom prst="rect">
+            <a:avLst/>
+          </a:prstGeom>
+          <a:noFill/>
+        </p:spPr>
+        <p:txBody>
+          <a:bodyPr wrap="square" anchor="t" lIns="0" rIns="0" tIns="0" bIns="0">
+            <a:spAutoFit/>
+          </a:bodyPr>
+          <a:lstStyle/>
+          <a:p>
+            <a:pPr algn="l">
+              <a:lnSpc>
+                <a:spcPct val="115000"/>
+              </a:lnSpc>
+              <a:spcAft>
+                <a:spcPts val="0"/>
+              </a:spcAft>
+            </a:pPr>
+            <a:r>
+              <a:rPr sz="750" b="0">
+                <a:solidFill>
+                  <a:srgbClr val="5F6D66"/>
+                </a:solidFill>
+                <a:latin typeface="Instrument Sans"/>
+              </a:rPr>
+              <a:t>NHS England GP Workforce, July 2026</a:t>
+            </a:r>
+          </a:p>
+        </p:txBody>
+      </p:sp>
+      <p:sp>
+        <p:nvSpPr>
+          <p:cNvPr id="34" name="TextBox 33"/>
+          <p:cNvSpPr txBox="1"/>
+          <p:nvPr/>
+        </p:nvSpPr>
+        <p:spPr>
+          <a:xfrm>
+            <a:off x="7579156" y="3593592"/>
+            <a:ext cx="640080" cy="457200"/>
+          </a:xfrm>
+          <a:prstGeom prst="rect">
+            <a:avLst/>
+          </a:prstGeom>
+          <a:noFill/>
+        </p:spPr>
+        <p:txBody>
+          <a:bodyPr wrap="square" anchor="t" lIns="0" rIns="0" tIns="0" bIns="0">
+            <a:spAutoFit/>
+          </a:bodyPr>
+          <a:lstStyle/>
+          <a:p>
+            <a:pPr algn="ctr">
+              <a:lnSpc>
+                <a:spcPct val="115000"/>
+              </a:lnSpc>
+              <a:spcAft>
+                <a:spcPts val="0"/>
+              </a:spcAft>
+            </a:pPr>
+            <a:r>
+              <a:rPr sz="1600" b="1">
+                <a:solidFill>
+                  <a:srgbClr val="6D2E5B"/>
+                </a:solidFill>
+                <a:latin typeface="Bricolage Grotesque"/>
+              </a:rPr>
+              <a:t>=</a:t>
+            </a:r>
+          </a:p>
+        </p:txBody>
+      </p:sp>
+      <p:cxnSp>
+        <p:nvCxnSpPr>
+          <p:cNvPr id="35" name="Connector 34"/>
+          <p:cNvCxnSpPr/>
+          <p:nvPr/>
+        </p:nvCxnSpPr>
+        <p:spPr>
+          <a:xfrm>
+            <a:off x="8219236" y="3429000"/>
+            <a:ext cx="3103778" cy="0"/>
+          </a:xfrm>
+          <a:prstGeom prst="line">
+            <a:avLst/>
+          </a:prstGeom>
+          <a:ln w="28575">
+            <a:solidFill>
+              <a:srgbClr val="6D2E5B"/>
+            </a:solidFill>
+          </a:ln>
+        </p:spPr>
+        <p:style>
+          <a:lnRef idx="2">
+            <a:schemeClr val="accent1"/>
+          </a:lnRef>
+          <a:fillRef idx="0">
+            <a:schemeClr val="accent1"/>
+          </a:fillRef>
+          <a:effectRef idx="1">
+            <a:schemeClr val="accent1"/>
+          </a:effectRef>
+          <a:fontRef idx="minor">
+            <a:schemeClr val="tx1"/>
+          </a:fontRef>
+        </p:style>
+      </p:cxnSp>
+      <p:sp>
+        <p:nvSpPr>
+          <p:cNvPr id="36" name="TextBox 35"/>
+          <p:cNvSpPr txBox="1"/>
+          <p:nvPr/>
+        </p:nvSpPr>
+        <p:spPr>
+          <a:xfrm>
+            <a:off x="8219236" y="3502152"/>
+            <a:ext cx="3103778" cy="502920"/>
+          </a:xfrm>
+          <a:prstGeom prst="rect">
+            <a:avLst/>
+          </a:prstGeom>
+          <a:noFill/>
+        </p:spPr>
+        <p:txBody>
+          <a:bodyPr wrap="square" anchor="t" lIns="0" rIns="0" tIns="0" bIns="0">
+            <a:spAutoFit/>
+          </a:bodyPr>
+          <a:lstStyle/>
+          <a:p>
+            <a:pPr algn="l">
+              <a:lnSpc>
+                <a:spcPct val="115000"/>
+              </a:lnSpc>
+              <a:spcAft>
+                <a:spcPts val="0"/>
+              </a:spcAft>
+            </a:pPr>
+            <a:r>
+              <a:rPr sz="2600" b="1">
+                <a:solidFill>
+                  <a:srgbClr val="6D2E5B"/>
+                </a:solidFill>
+                <a:latin typeface="Bricolage Grotesque"/>
+              </a:rPr>
+              <a:t>35,000</a:t>
+            </a:r>
+            <a:r>
+              <a:rPr sz="1100" b="1">
+                <a:solidFill>
+                  <a:srgbClr val="5F6D66"/>
+                </a:solidFill>
+                <a:latin typeface="Bricolage Grotesque"/>
+              </a:rPr>
+              <a:t/>
+            </a:r>
+          </a:p>
+        </p:txBody>
+      </p:sp>
+      <p:sp>
+        <p:nvSpPr>
+          <p:cNvPr id="37" name="TextBox 36"/>
+          <p:cNvSpPr txBox="1"/>
+          <p:nvPr/>
+        </p:nvSpPr>
+        <p:spPr>
+          <a:xfrm>
+            <a:off x="8219236" y="3995928"/>
+            <a:ext cx="3103778" cy="502920"/>
+          </a:xfrm>
+          <a:prstGeom prst="rect">
+            <a:avLst/>
+          </a:prstGeom>
+          <a:noFill/>
+        </p:spPr>
+        <p:txBody>
+          <a:bodyPr wrap="square" anchor="t" lIns="0" rIns="0" tIns="0" bIns="0">
+            <a:spAutoFit/>
+          </a:bodyPr>
+          <a:lstStyle/>
+          <a:p>
+            <a:pPr algn="l">
+              <a:lnSpc>
+                <a:spcPct val="115000"/>
+              </a:lnSpc>
+              <a:spcAft>
+                <a:spcPts val="0"/>
+              </a:spcAft>
+            </a:pPr>
+            <a:r>
+              <a:rPr sz="950" b="1">
+                <a:solidFill>
+                  <a:srgbClr val="14261F"/>
+                </a:solidFill>
+                <a:latin typeface="Instrument Sans"/>
+              </a:rPr>
+              <a:t>GP-hours every working day</a:t>
+            </a:r>
+            <a:r>
+              <a:rPr sz="950" b="0">
+                <a:solidFill>
+                  <a:srgbClr val="5F6D66"/>
+                </a:solidFill>
+                <a:latin typeface="Instrument Sans"/>
+              </a:rPr>
+              <a:t> on results alone</a:t>
+            </a:r>
+          </a:p>
+        </p:txBody>
+      </p:sp>
+      <p:sp>
+        <p:nvSpPr>
+          <p:cNvPr id="38" name="TextBox 37"/>
+          <p:cNvSpPr txBox="1"/>
+          <p:nvPr/>
+        </p:nvSpPr>
+        <p:spPr>
+          <a:xfrm>
+            <a:off x="8219236" y="4480560"/>
+            <a:ext cx="3103778" cy="274320"/>
+          </a:xfrm>
+          <a:prstGeom prst="rect">
+            <a:avLst/>
+          </a:prstGeom>
+          <a:noFill/>
+        </p:spPr>
+        <p:txBody>
+          <a:bodyPr wrap="square" anchor="t" lIns="0" rIns="0" tIns="0" bIns="0">
+            <a:spAutoFit/>
+          </a:bodyPr>
+          <a:lstStyle/>
+          <a:p>
+            <a:pPr algn="l">
+              <a:lnSpc>
+                <a:spcPct val="115000"/>
+              </a:lnSpc>
+              <a:spcAft>
+                <a:spcPts val="0"/>
+              </a:spcAft>
+            </a:pPr>
+            <a:r>
+              <a:rPr sz="700" b="1">
+                <a:solidFill>
+                  <a:srgbClr val="7A520C"/>
+                </a:solidFill>
+                <a:latin typeface="Instrument Sans"/>
+              </a:rPr>
+              <a:t>EXTRAPOLATED  </a:t>
+            </a:r>
+            <a:r>
+              <a:rPr sz="750" b="0">
+                <a:solidFill>
+                  <a:srgbClr val="5F6D66"/>
+                </a:solidFill>
+                <a:latin typeface="Instrument Sans"/>
+              </a:rPr>
+              <a:t/>
+            </a:r>
+          </a:p>
+        </p:txBody>
+      </p:sp>
+      <p:sp>
+        <p:nvSpPr>
+          <p:cNvPr id="39" name="TextBox 38"/>
+          <p:cNvSpPr txBox="1"/>
+          <p:nvPr/>
+        </p:nvSpPr>
+        <p:spPr>
+          <a:xfrm>
+            <a:off x="731520" y="4846320"/>
+            <a:ext cx="7315200" cy="256032"/>
+          </a:xfrm>
+          <a:prstGeom prst="rect">
+            <a:avLst/>
+          </a:prstGeom>
+          <a:noFill/>
+        </p:spPr>
+        <p:txBody>
+          <a:bodyPr wrap="square" anchor="t" lIns="0" rIns="0" tIns="0" bIns="0">
+            <a:spAutoFit/>
+          </a:bodyPr>
+          <a:lstStyle/>
+          <a:p>
+            <a:pPr algn="l">
+              <a:lnSpc>
+                <a:spcPct val="115000"/>
+              </a:lnSpc>
+              <a:spcAft>
+                <a:spcPts val="0"/>
+              </a:spcAft>
+            </a:pPr>
+            <a:r>
+              <a:rPr sz="800" b="1">
+                <a:solidFill>
+                  <a:srgbClr val="6D2E5B"/>
+                </a:solidFill>
+                <a:latin typeface="Instrument Sans"/>
+              </a:rPr>
+              <a:t>AND WHEN ONE SLIPS</a:t>
+            </a:r>
+          </a:p>
+        </p:txBody>
+      </p:sp>
+      <p:cxnSp>
+        <p:nvCxnSpPr>
+          <p:cNvPr id="40" name="Connector 39"/>
+          <p:cNvCxnSpPr/>
+          <p:nvPr/>
+        </p:nvCxnSpPr>
+        <p:spPr>
+          <a:xfrm>
+            <a:off x="731520" y="5120640"/>
+            <a:ext cx="3103778" cy="0"/>
+          </a:xfrm>
+          <a:prstGeom prst="line">
+            <a:avLst/>
+          </a:prstGeom>
+          <a:ln w="28575">
+            <a:solidFill>
+              <a:srgbClr val="D8DED9"/>
+            </a:solidFill>
+          </a:ln>
+        </p:spPr>
+        <p:style>
+          <a:lnRef idx="2">
+            <a:schemeClr val="accent1"/>
+          </a:lnRef>
+          <a:fillRef idx="0">
+            <a:schemeClr val="accent1"/>
+          </a:fillRef>
+          <a:effectRef idx="1">
+            <a:schemeClr val="accent1"/>
+          </a:effectRef>
+          <a:fontRef idx="minor">
+            <a:schemeClr val="tx1"/>
+          </a:fontRef>
+        </p:style>
+      </p:cxnSp>
+      <p:sp>
+        <p:nvSpPr>
+          <p:cNvPr id="41" name="TextBox 40"/>
+          <p:cNvSpPr txBox="1"/>
+          <p:nvPr/>
+        </p:nvSpPr>
+        <p:spPr>
+          <a:xfrm>
+            <a:off x="731520" y="5193792"/>
+            <a:ext cx="3103778" cy="502920"/>
+          </a:xfrm>
+          <a:prstGeom prst="rect">
+            <a:avLst/>
+          </a:prstGeom>
+          <a:noFill/>
+        </p:spPr>
+        <p:txBody>
+          <a:bodyPr wrap="square" anchor="t" lIns="0" rIns="0" tIns="0" bIns="0">
+            <a:spAutoFit/>
+          </a:bodyPr>
+          <a:lstStyle/>
+          <a:p>
+            <a:pPr algn="l">
+              <a:lnSpc>
+                <a:spcPct val="115000"/>
+              </a:lnSpc>
+              <a:spcAft>
+                <a:spcPts val="0"/>
+              </a:spcAft>
+            </a:pPr>
+            <a:r>
+              <a:rPr sz="2600" b="1">
+                <a:solidFill>
+                  <a:srgbClr val="14261F"/>
+                </a:solidFill>
+                <a:latin typeface="Bricolage Grotesque"/>
+              </a:rPr>
+              <a:t>41</a:t>
+            </a:r>
+            <a:r>
+              <a:rPr sz="1100" b="1">
+                <a:solidFill>
+                  <a:srgbClr val="5F6D66"/>
+                </a:solidFill>
+                <a:latin typeface="Bricolage Grotesque"/>
+              </a:rPr>
+              <a:t/>
+            </a:r>
+          </a:p>
+        </p:txBody>
+      </p:sp>
+      <p:sp>
+        <p:nvSpPr>
+          <p:cNvPr id="42" name="TextBox 41"/>
+          <p:cNvSpPr txBox="1"/>
+          <p:nvPr/>
+        </p:nvSpPr>
+        <p:spPr>
+          <a:xfrm>
+            <a:off x="731520" y="5687568"/>
+            <a:ext cx="3103778" cy="502920"/>
+          </a:xfrm>
+          <a:prstGeom prst="rect">
+            <a:avLst/>
+          </a:prstGeom>
+          <a:noFill/>
+        </p:spPr>
+        <p:txBody>
+          <a:bodyPr wrap="square" anchor="t" lIns="0" rIns="0" tIns="0" bIns="0">
+            <a:spAutoFit/>
+          </a:bodyPr>
+          <a:lstStyle/>
+          <a:p>
+            <a:pPr algn="l">
+              <a:lnSpc>
+                <a:spcPct val="115000"/>
+              </a:lnSpc>
+              <a:spcAft>
+                <a:spcPts val="0"/>
+              </a:spcAft>
+            </a:pPr>
+            <a:r>
+              <a:rPr sz="950" b="1">
+                <a:solidFill>
+                  <a:srgbClr val="14261F"/>
+                </a:solidFill>
+                <a:latin typeface="Instrument Sans"/>
+              </a:rPr>
+              <a:t>serious incidents in 13 months</a:t>
+            </a:r>
+            <a:r>
+              <a:rPr sz="950" b="0">
+                <a:solidFill>
+                  <a:srgbClr val="5F6D66"/>
+                </a:solidFill>
+                <a:latin typeface="Instrument Sans"/>
+              </a:rPr>
+              <a:t> from uncommunicated results, one a 45 mm lung mass</a:t>
+            </a:r>
+          </a:p>
+        </p:txBody>
+      </p:sp>
+      <p:sp>
+        <p:nvSpPr>
+          <p:cNvPr id="43" name="TextBox 42"/>
+          <p:cNvSpPr txBox="1"/>
+          <p:nvPr/>
+        </p:nvSpPr>
+        <p:spPr>
+          <a:xfrm>
+            <a:off x="731520" y="6172200"/>
+            <a:ext cx="3103778" cy="274320"/>
+          </a:xfrm>
+          <a:prstGeom prst="rect">
+            <a:avLst/>
+          </a:prstGeom>
+          <a:noFill/>
+        </p:spPr>
+        <p:txBody>
+          <a:bodyPr wrap="square" anchor="t" lIns="0" rIns="0" tIns="0" bIns="0">
+            <a:spAutoFit/>
+          </a:bodyPr>
+          <a:lstStyle/>
+          <a:p>
+            <a:pPr algn="l">
+              <a:lnSpc>
+                <a:spcPct val="115000"/>
+              </a:lnSpc>
+              <a:spcAft>
+                <a:spcPts val="0"/>
+              </a:spcAft>
+            </a:pPr>
+            <a:r>
+              <a:rPr sz="750" b="0">
+                <a:solidFill>
+                  <a:srgbClr val="5F6D66"/>
+                </a:solidFill>
+                <a:latin typeface="Instrument Sans"/>
+              </a:rPr>
+              <a:t>HSIB, 2019</a:t>
+            </a:r>
+          </a:p>
+        </p:txBody>
+      </p:sp>
+      <p:sp>
+        <p:nvSpPr>
+          <p:cNvPr id="44" name="TextBox 43"/>
+          <p:cNvSpPr txBox="1"/>
+          <p:nvPr/>
+        </p:nvSpPr>
+        <p:spPr>
+          <a:xfrm>
+            <a:off x="3835298" y="5285232"/>
+            <a:ext cx="640080" cy="457200"/>
+          </a:xfrm>
+          <a:prstGeom prst="rect">
+            <a:avLst/>
+          </a:prstGeom>
+          <a:noFill/>
+        </p:spPr>
+        <p:txBody>
+          <a:bodyPr wrap="square" anchor="t" lIns="0" rIns="0" tIns="0" bIns="0">
+            <a:spAutoFit/>
+          </a:bodyPr>
+          <a:lstStyle/>
+          <a:p>
+            <a:pPr algn="ctr">
+              <a:lnSpc>
+                <a:spcPct val="115000"/>
+              </a:lnSpc>
+              <a:spcAft>
+                <a:spcPts val="0"/>
+              </a:spcAft>
+            </a:pPr>
+            <a:r>
+              <a:rPr sz="1600" b="1">
+                <a:solidFill>
+                  <a:srgbClr val="6D2E5B"/>
+                </a:solidFill>
+                <a:latin typeface="Bricolage Grotesque"/>
+              </a:rPr>
+              <a:t/>
+            </a:r>
+          </a:p>
+        </p:txBody>
+      </p:sp>
+      <p:cxnSp>
+        <p:nvCxnSpPr>
+          <p:cNvPr id="45" name="Connector 44"/>
+          <p:cNvCxnSpPr/>
+          <p:nvPr/>
+        </p:nvCxnSpPr>
+        <p:spPr>
+          <a:xfrm>
+            <a:off x="4475378" y="5120640"/>
+            <a:ext cx="3103778" cy="0"/>
+          </a:xfrm>
+          <a:prstGeom prst="line">
+            <a:avLst/>
+          </a:prstGeom>
+          <a:ln w="28575">
+            <a:solidFill>
+              <a:srgbClr val="D8DED9"/>
+            </a:solidFill>
+          </a:ln>
+        </p:spPr>
+        <p:style>
+          <a:lnRef idx="2">
+            <a:schemeClr val="accent1"/>
+          </a:lnRef>
+          <a:fillRef idx="0">
+            <a:schemeClr val="accent1"/>
+          </a:fillRef>
+          <a:effectRef idx="1">
+            <a:schemeClr val="accent1"/>
+          </a:effectRef>
+          <a:fontRef idx="minor">
+            <a:schemeClr val="tx1"/>
+          </a:fontRef>
+        </p:style>
+      </p:cxnSp>
+      <p:sp>
+        <p:nvSpPr>
+          <p:cNvPr id="46" name="TextBox 45"/>
+          <p:cNvSpPr txBox="1"/>
+          <p:nvPr/>
+        </p:nvSpPr>
+        <p:spPr>
+          <a:xfrm>
+            <a:off x="4475378" y="5193792"/>
+            <a:ext cx="3103778" cy="502920"/>
+          </a:xfrm>
+          <a:prstGeom prst="rect">
+            <a:avLst/>
+          </a:prstGeom>
+          <a:noFill/>
+        </p:spPr>
+        <p:txBody>
+          <a:bodyPr wrap="square" anchor="t" lIns="0" rIns="0" tIns="0" bIns="0">
+            <a:spAutoFit/>
+          </a:bodyPr>
+          <a:lstStyle/>
+          <a:p>
+            <a:pPr algn="l">
+              <a:lnSpc>
+                <a:spcPct val="115000"/>
+              </a:lnSpc>
+              <a:spcAft>
+                <a:spcPts val="0"/>
+              </a:spcAft>
+            </a:pPr>
+            <a:r>
+              <a:rPr sz="2600" b="1">
+                <a:solidFill>
+                  <a:srgbClr val="14261F"/>
+                </a:solidFill>
+                <a:latin typeface="Bricolage Grotesque"/>
+              </a:rPr>
               <a:t>1</a:t>
             </a:r>
             <a:r>
-              <a:rPr sz="1800" b="1">
+              <a:rPr sz="1100" b="1">
                 <a:solidFill>
                   <a:srgbClr val="5F6D66"/>
                 </a:solidFill>
@@ -5477,14 +6759,14 @@
       </p:sp>
       <p:sp>
         <p:nvSpPr>
-          <p:cNvPr id="18" name="TextBox 17"/>
-          <p:cNvSpPr txBox="1"/>
-          <p:nvPr/>
-        </p:nvSpPr>
-        <p:spPr>
-          <a:xfrm>
-            <a:off x="3840480" y="5239512"/>
-            <a:ext cx="7589520" cy="548640"/>
+          <p:cNvPr id="47" name="TextBox 46"/>
+          <p:cNvSpPr txBox="1"/>
+          <p:nvPr/>
+        </p:nvSpPr>
+        <p:spPr>
+          <a:xfrm>
+            <a:off x="4475378" y="5687568"/>
+            <a:ext cx="3103778" cy="502920"/>
           </a:xfrm>
           <a:prstGeom prst="rect">
             <a:avLst/>
@@ -5499,52 +6781,52 @@
           <a:p>
             <a:pPr algn="l">
               <a:lnSpc>
-                <a:spcPct val="120000"/>
-              </a:lnSpc>
-              <a:spcAft>
-                <a:spcPts val="0"/>
-              </a:spcAft>
-            </a:pPr>
-            <a:r>
-              <a:rPr sz="1450" b="0">
+                <a:spcPct val="115000"/>
+              </a:lnSpc>
+              <a:spcAft>
+                <a:spcPts val="0"/>
+              </a:spcAft>
+            </a:pPr>
+            <a:r>
+              <a:rPr sz="950" b="0">
                 <a:solidFill>
                   <a:srgbClr val="5F6D66"/>
                 </a:solidFill>
                 <a:latin typeface="Instrument Sans"/>
               </a:rPr>
-              <a:t>is not effective at spotting decline. </a:t>
-            </a:r>
-            <a:r>
-              <a:rPr sz="1450" b="1">
+              <a:t>cannot show decline. </a:t>
+            </a:r>
+            <a:r>
+              <a:rPr sz="950" b="1">
                 <a:solidFill>
                   <a:srgbClr val="14261F"/>
                 </a:solidFill>
                 <a:latin typeface="Instrument Sans"/>
               </a:rPr>
-              <a:t>The trajectory is</a:t>
-            </a:r>
-            <a:r>
-              <a:rPr sz="1450" b="0">
+              <a:t>The trajectory can</a:t>
+            </a:r>
+            <a:r>
+              <a:rPr sz="950" b="0">
                 <a:solidFill>
                   <a:srgbClr val="5F6D66"/>
                 </a:solidFill>
                 <a:latin typeface="Instrument Sans"/>
               </a:rPr>
-              <a:t>, and every GP system already holds the data.</a:t>
-            </a:r>
-          </a:p>
-        </p:txBody>
-      </p:sp>
-      <p:sp>
-        <p:nvSpPr>
-          <p:cNvPr id="19" name="TextBox 18"/>
-          <p:cNvSpPr txBox="1"/>
-          <p:nvPr/>
-        </p:nvSpPr>
-        <p:spPr>
-          <a:xfrm>
-            <a:off x="3840480" y="5843016"/>
-            <a:ext cx="7589520" cy="320040"/>
+              <a:t>, and every GP system already holds it.</a:t>
+            </a:r>
+          </a:p>
+        </p:txBody>
+      </p:sp>
+      <p:sp>
+        <p:nvSpPr>
+          <p:cNvPr id="48" name="TextBox 47"/>
+          <p:cNvSpPr txBox="1"/>
+          <p:nvPr/>
+        </p:nvSpPr>
+        <p:spPr>
+          <a:xfrm>
+            <a:off x="4475378" y="6172200"/>
+            <a:ext cx="3103778" cy="274320"/>
           </a:xfrm>
           <a:prstGeom prst="rect">
             <a:avLst/>
@@ -5566,20 +6848,250 @@
               </a:spcAft>
             </a:pPr>
             <a:r>
+              <a:rPr sz="750" b="0">
+                <a:solidFill>
+                  <a:srgbClr val="5F6D66"/>
+                </a:solidFill>
+                <a:latin typeface="Instrument Sans"/>
+              </a:rPr>
+              <a:t>Stow et al., BMC Medicine 2018</a:t>
+            </a:r>
+          </a:p>
+        </p:txBody>
+      </p:sp>
+      <p:sp>
+        <p:nvSpPr>
+          <p:cNvPr id="49" name="TextBox 48"/>
+          <p:cNvSpPr txBox="1"/>
+          <p:nvPr/>
+        </p:nvSpPr>
+        <p:spPr>
+          <a:xfrm>
+            <a:off x="7579156" y="5285232"/>
+            <a:ext cx="640080" cy="457200"/>
+          </a:xfrm>
+          <a:prstGeom prst="rect">
+            <a:avLst/>
+          </a:prstGeom>
+          <a:noFill/>
+        </p:spPr>
+        <p:txBody>
+          <a:bodyPr wrap="square" anchor="t" lIns="0" rIns="0" tIns="0" bIns="0">
+            <a:spAutoFit/>
+          </a:bodyPr>
+          <a:lstStyle/>
+          <a:p>
+            <a:pPr algn="ctr">
+              <a:lnSpc>
+                <a:spcPct val="115000"/>
+              </a:lnSpc>
+              <a:spcAft>
+                <a:spcPts val="0"/>
+              </a:spcAft>
+            </a:pPr>
+            <a:r>
+              <a:rPr sz="1600" b="1">
+                <a:solidFill>
+                  <a:srgbClr val="6D2E5B"/>
+                </a:solidFill>
+                <a:latin typeface="Bricolage Grotesque"/>
+              </a:rPr>
+              <a:t/>
+            </a:r>
+          </a:p>
+        </p:txBody>
+      </p:sp>
+      <p:cxnSp>
+        <p:nvCxnSpPr>
+          <p:cNvPr id="50" name="Connector 49"/>
+          <p:cNvCxnSpPr/>
+          <p:nvPr/>
+        </p:nvCxnSpPr>
+        <p:spPr>
+          <a:xfrm>
+            <a:off x="8219236" y="5120640"/>
+            <a:ext cx="3103778" cy="0"/>
+          </a:xfrm>
+          <a:prstGeom prst="line">
+            <a:avLst/>
+          </a:prstGeom>
+          <a:ln w="28575">
+            <a:solidFill>
+              <a:srgbClr val="D8DED9"/>
+            </a:solidFill>
+          </a:ln>
+        </p:spPr>
+        <p:style>
+          <a:lnRef idx="2">
+            <a:schemeClr val="accent1"/>
+          </a:lnRef>
+          <a:fillRef idx="0">
+            <a:schemeClr val="accent1"/>
+          </a:fillRef>
+          <a:effectRef idx="1">
+            <a:schemeClr val="accent1"/>
+          </a:effectRef>
+          <a:fontRef idx="minor">
+            <a:schemeClr val="tx1"/>
+          </a:fontRef>
+        </p:style>
+      </p:cxnSp>
+      <p:sp>
+        <p:nvSpPr>
+          <p:cNvPr id="51" name="TextBox 50"/>
+          <p:cNvSpPr txBox="1"/>
+          <p:nvPr/>
+        </p:nvSpPr>
+        <p:spPr>
+          <a:xfrm>
+            <a:off x="8219236" y="5193792"/>
+            <a:ext cx="3103778" cy="502920"/>
+          </a:xfrm>
+          <a:prstGeom prst="rect">
+            <a:avLst/>
+          </a:prstGeom>
+          <a:noFill/>
+        </p:spPr>
+        <p:txBody>
+          <a:bodyPr wrap="square" anchor="t" lIns="0" rIns="0" tIns="0" bIns="0">
+            <a:spAutoFit/>
+          </a:bodyPr>
+          <a:lstStyle/>
+          <a:p>
+            <a:pPr algn="l">
+              <a:lnSpc>
+                <a:spcPct val="115000"/>
+              </a:lnSpc>
+              <a:spcAft>
+                <a:spcPts val="0"/>
+              </a:spcAft>
+            </a:pPr>
+            <a:r>
+              <a:rPr sz="2600" b="1">
+                <a:solidFill>
+                  <a:srgbClr val="14261F"/>
+                </a:solidFill>
+                <a:latin typeface="Bricolage Grotesque"/>
+              </a:rPr>
+              <a:t>0.4</a:t>
+            </a:r>
+            <a:r>
+              <a:rPr sz="1100" b="1">
+                <a:solidFill>
+                  <a:srgbClr val="5F6D66"/>
+                </a:solidFill>
+                <a:latin typeface="Bricolage Grotesque"/>
+              </a:rPr>
+              <a:t> %</a:t>
+            </a:r>
+          </a:p>
+        </p:txBody>
+      </p:sp>
+      <p:sp>
+        <p:nvSpPr>
+          <p:cNvPr id="52" name="TextBox 51"/>
+          <p:cNvSpPr txBox="1"/>
+          <p:nvPr/>
+        </p:nvSpPr>
+        <p:spPr>
+          <a:xfrm>
+            <a:off x="8219236" y="5687568"/>
+            <a:ext cx="3103778" cy="502920"/>
+          </a:xfrm>
+          <a:prstGeom prst="rect">
+            <a:avLst/>
+          </a:prstGeom>
+          <a:noFill/>
+        </p:spPr>
+        <p:txBody>
+          <a:bodyPr wrap="square" anchor="t" lIns="0" rIns="0" tIns="0" bIns="0">
+            <a:spAutoFit/>
+          </a:bodyPr>
+          <a:lstStyle/>
+          <a:p>
+            <a:pPr algn="l">
+              <a:lnSpc>
+                <a:spcPct val="115000"/>
+              </a:lnSpc>
+              <a:spcAft>
+                <a:spcPts val="0"/>
+              </a:spcAft>
+            </a:pPr>
+            <a:r>
               <a:rPr sz="950" b="0">
                 <a:solidFill>
                   <a:srgbClr val="5F6D66"/>
                 </a:solidFill>
                 <a:latin typeface="Instrument Sans"/>
               </a:rPr>
-              <a:t>41 serious incidents in 13 months from uncommunicated results, including a 45 mm lung mass (HSIB 2019). 5 million unpaid carers. 0.4% of portal users have shared access.</a:t>
-            </a:r>
-          </a:p>
-        </p:txBody>
-      </p:sp>
-      <p:sp>
-        <p:nvSpPr>
-          <p:cNvPr id="20" name="TextBox 19"/>
+              <a:t>of portal users have shared access for a carer. </a:t>
+            </a:r>
+            <a:r>
+              <a:rPr sz="950" b="1">
+                <a:solidFill>
+                  <a:srgbClr val="14261F"/>
+                </a:solidFill>
+                <a:latin typeface="Instrument Sans"/>
+              </a:rPr>
+              <a:t>5 million carers</a:t>
+            </a:r>
+            <a:r>
+              <a:rPr sz="950" b="0">
+                <a:solidFill>
+                  <a:srgbClr val="5F6D66"/>
+                </a:solidFill>
+                <a:latin typeface="Instrument Sans"/>
+              </a:rPr>
+              <a:t> in England and Wales.</a:t>
+            </a:r>
+          </a:p>
+        </p:txBody>
+      </p:sp>
+      <p:sp>
+        <p:nvSpPr>
+          <p:cNvPr id="53" name="TextBox 52"/>
+          <p:cNvSpPr txBox="1"/>
+          <p:nvPr/>
+        </p:nvSpPr>
+        <p:spPr>
+          <a:xfrm>
+            <a:off x="8219236" y="6172200"/>
+            <a:ext cx="3103778" cy="274320"/>
+          </a:xfrm>
+          <a:prstGeom prst="rect">
+            <a:avLst/>
+          </a:prstGeom>
+          <a:noFill/>
+        </p:spPr>
+        <p:txBody>
+          <a:bodyPr wrap="square" anchor="t" lIns="0" rIns="0" tIns="0" bIns="0">
+            <a:spAutoFit/>
+          </a:bodyPr>
+          <a:lstStyle/>
+          <a:p>
+            <a:pPr algn="l">
+              <a:lnSpc>
+                <a:spcPct val="115000"/>
+              </a:lnSpc>
+              <a:spcAft>
+                <a:spcPts val="0"/>
+              </a:spcAft>
+            </a:pPr>
+            <a:r>
+              <a:rPr sz="750" b="0">
+                <a:solidFill>
+                  <a:srgbClr val="5F6D66"/>
+                </a:solidFill>
+                <a:latin typeface="Instrument Sans"/>
+              </a:rPr>
+              <a:t>Wolff 2016 · Census 2021</a:t>
+            </a:r>
+          </a:p>
+        </p:txBody>
+      </p:sp>
+      <p:sp>
+        <p:nvSpPr>
+          <p:cNvPr id="54" name="TextBox 53"/>
           <p:cNvSpPr txBox="1"/>
           <p:nvPr/>
         </p:nvSpPr>
@@ -5614,14 +7126,14 @@
                 </a:solidFill>
                 <a:latin typeface="Instrument Sans"/>
               </a:rPr>
-              <a:t>Watson (PACT) 2024 · NHS App roadmap Jul 2026 · Poon 2004 · NHS England GP Workforce Jul 2026 · Stow 2018 · HSIB 2019 · Census 2021 · Wolff 2016. Working in the speaker notes.</a:t>
-            </a:r>
-          </a:p>
-        </p:txBody>
-      </p:sp>
-      <p:sp>
-        <p:nvSpPr>
-          <p:cNvPr id="21" name="TextBox 20"/>
+              <a:t>Working for every extrapolated figure is in the speaker notes. 12m × 47% = 5.6m; × 12 = 67.7m. 74 min × 28,426 ÷ 60 = 35,059 hours.</a:t>
+            </a:r>
+          </a:p>
+        </p:txBody>
+      </p:sp>
+      <p:sp>
+        <p:nvSpPr>
+          <p:cNvPr id="55" name="TextBox 54"/>
           <p:cNvSpPr txBox="1"/>
           <p:nvPr/>
         </p:nvSpPr>

</xml_diff>

<commit_message>
docs(pitch): scale slide reduced to one three-number chain
</commit_message>
<xml_diff>
--- a/pitch/CareCircle-pitch.pptx
+++ b/pitch/CareCircle-pitch.pptx
@@ -4769,7 +4769,7 @@
                 </a:solidFill>
                 <a:latin typeface="Instrument Sans"/>
               </a:rPr>
-              <a:t>THE SCALE · FOLLOW THE ARITHMETIC</a:t>
+              <a:t>THE SCALE</a:t>
             </a:r>
           </a:p>
         </p:txBody>
@@ -4816,63 +4816,21 @@
           </a:p>
         </p:txBody>
       </p:sp>
-      <p:sp>
-        <p:nvSpPr>
-          <p:cNvPr id="4" name="TextBox 3"/>
-          <p:cNvSpPr txBox="1"/>
-          <p:nvPr/>
-        </p:nvSpPr>
-        <p:spPr>
-          <a:xfrm>
-            <a:off x="731520" y="1463040"/>
-            <a:ext cx="7315200" cy="256032"/>
-          </a:xfrm>
-          <a:prstGeom prst="rect">
-            <a:avLst/>
-          </a:prstGeom>
-          <a:noFill/>
-        </p:spPr>
-        <p:txBody>
-          <a:bodyPr wrap="square" anchor="t" lIns="0" rIns="0" tIns="0" bIns="0">
-            <a:spAutoFit/>
-          </a:bodyPr>
-          <a:lstStyle/>
-          <a:p>
-            <a:pPr algn="l">
-              <a:lnSpc>
-                <a:spcPct val="115000"/>
-              </a:lnSpc>
-              <a:spcAft>
-                <a:spcPts val="0"/>
-              </a:spcAft>
-            </a:pPr>
-            <a:r>
-              <a:rPr sz="800" b="1">
-                <a:solidFill>
-                  <a:srgbClr val="6D2E5B"/>
-                </a:solidFill>
-                <a:latin typeface="Instrument Sans"/>
-              </a:rPr>
-              <a:t>SEEN, BUT NOT TOLD</a:t>
-            </a:r>
-          </a:p>
-        </p:txBody>
-      </p:sp>
       <p:cxnSp>
         <p:nvCxnSpPr>
-          <p:cNvPr id="5" name="Connector 4"/>
+          <p:cNvPr id="4" name="Connector 3"/>
           <p:cNvCxnSpPr/>
           <p:nvPr/>
         </p:nvCxnSpPr>
         <p:spPr>
           <a:xfrm>
-            <a:off x="731520" y="1737360"/>
-            <a:ext cx="2167813" cy="0"/>
+            <a:off x="731520" y="1828800"/>
+            <a:ext cx="2844698" cy="0"/>
           </a:xfrm>
           <a:prstGeom prst="line">
             <a:avLst/>
           </a:prstGeom>
-          <a:ln w="28575">
+          <a:ln w="38100">
             <a:solidFill>
               <a:srgbClr val="D8DED9"/>
             </a:solidFill>
@@ -4895,14 +4853,14 @@
       </p:cxnSp>
       <p:sp>
         <p:nvSpPr>
-          <p:cNvPr id="6" name="TextBox 5"/>
+          <p:cNvPr id="5" name="TextBox 4"/>
           <p:cNvSpPr txBox="1"/>
           <p:nvPr/>
         </p:nvSpPr>
         <p:spPr>
           <a:xfrm>
-            <a:off x="731520" y="1810512"/>
-            <a:ext cx="2167813" cy="502920"/>
+            <a:off x="731520" y="1965960"/>
+            <a:ext cx="2844698" cy="1005840"/>
           </a:xfrm>
           <a:prstGeom prst="rect">
             <a:avLst/>
@@ -4924,7 +4882,7 @@
               </a:spcAft>
             </a:pPr>
             <a:r>
-              <a:rPr sz="2600" b="1">
+              <a:rPr sz="6000" b="1">
                 <a:solidFill>
                   <a:srgbClr val="14261F"/>
                 </a:solidFill>
@@ -4933,13 +4891,64 @@
               <a:t>12</a:t>
             </a:r>
             <a:r>
-              <a:rPr sz="1100" b="1">
+              <a:rPr sz="2000" b="1">
                 <a:solidFill>
                   <a:srgbClr val="5F6D66"/>
                 </a:solidFill>
                 <a:latin typeface="Bricolage Grotesque"/>
               </a:rPr>
               <a:t> m</a:t>
+            </a:r>
+          </a:p>
+        </p:txBody>
+      </p:sp>
+      <p:sp>
+        <p:nvSpPr>
+          <p:cNvPr id="6" name="TextBox 5"/>
+          <p:cNvSpPr txBox="1"/>
+          <p:nvPr/>
+        </p:nvSpPr>
+        <p:spPr>
+          <a:xfrm>
+            <a:off x="731520" y="3063240"/>
+            <a:ext cx="2844698" cy="822960"/>
+          </a:xfrm>
+          <a:prstGeom prst="rect">
+            <a:avLst/>
+          </a:prstGeom>
+          <a:noFill/>
+        </p:spPr>
+        <p:txBody>
+          <a:bodyPr wrap="square" anchor="t" lIns="0" rIns="0" tIns="0" bIns="0">
+            <a:spAutoFit/>
+          </a:bodyPr>
+          <a:lstStyle/>
+          <a:p>
+            <a:pPr algn="l">
+              <a:lnSpc>
+                <a:spcPct val="120000"/>
+              </a:lnSpc>
+              <a:spcAft>
+                <a:spcPts val="0"/>
+              </a:spcAft>
+            </a:pPr>
+            <a:r>
+              <a:rPr sz="1500" b="0">
+                <a:solidFill>
+                  <a:srgbClr val="5F6D66"/>
+                </a:solidFill>
+                <a:latin typeface="Instrument Sans"/>
+              </a:rPr>
+              <a:t>results seen in the NHS App </a:t>
+            </a:r>
+            <a:r>
+              <a:rPr sz="1500" b="1">
+                <a:solidFill>
+                  <a:srgbClr val="14261F"/>
+                </a:solidFill>
+                <a:latin typeface="Instrument Sans"/>
+              </a:rPr>
+              <a:t>every month</a:t>
             </a:r>
           </a:p>
         </p:txBody>
@@ -4952,8 +4961,8 @@
         </p:nvSpPr>
         <p:spPr>
           <a:xfrm>
-            <a:off x="731520" y="2304288"/>
-            <a:ext cx="2167813" cy="502920"/>
+            <a:off x="731520" y="3840480"/>
+            <a:ext cx="2844698" cy="320040"/>
           </a:xfrm>
           <a:prstGeom prst="rect">
             <a:avLst/>
@@ -4975,22 +4984,13 @@
               </a:spcAft>
             </a:pPr>
             <a:r>
-              <a:rPr sz="950" b="0">
+              <a:rPr sz="900" b="0">
                 <a:solidFill>
                   <a:srgbClr val="5F6D66"/>
                 </a:solidFill>
                 <a:latin typeface="Instrument Sans"/>
               </a:rPr>
-              <a:t>test results viewed in the NHS App </a:t>
-            </a:r>
-            <a:r>
-              <a:rPr sz="950" b="1">
-                <a:solidFill>
-                  <a:srgbClr val="14261F"/>
-                </a:solidFill>
-                <a:latin typeface="Instrument Sans"/>
-              </a:rPr>
-              <a:t>every month</a:t>
+              <a:t>NHS App roadmap, July 2026</a:t>
             </a:r>
           </a:p>
         </p:txBody>
@@ -5003,50 +5003,8 @@
         </p:nvSpPr>
         <p:spPr>
           <a:xfrm>
-            <a:off x="731520" y="2788920"/>
-            <a:ext cx="2167813" cy="274320"/>
-          </a:xfrm>
-          <a:prstGeom prst="rect">
-            <a:avLst/>
-          </a:prstGeom>
-          <a:noFill/>
-        </p:spPr>
-        <p:txBody>
-          <a:bodyPr wrap="square" anchor="t" lIns="0" rIns="0" tIns="0" bIns="0">
-            <a:spAutoFit/>
-          </a:bodyPr>
-          <a:lstStyle/>
-          <a:p>
-            <a:pPr algn="l">
-              <a:lnSpc>
-                <a:spcPct val="115000"/>
-              </a:lnSpc>
-              <a:spcAft>
-                <a:spcPts val="0"/>
-              </a:spcAft>
-            </a:pPr>
-            <a:r>
-              <a:rPr sz="750" b="0">
-                <a:solidFill>
-                  <a:srgbClr val="5F6D66"/>
-                </a:solidFill>
-                <a:latin typeface="Instrument Sans"/>
-              </a:rPr>
-              <a:t>NHS App roadmap, July 2026</a:t>
-            </a:r>
-          </a:p>
-        </p:txBody>
-      </p:sp>
-      <p:sp>
-        <p:nvSpPr>
-          <p:cNvPr id="9" name="TextBox 8"/>
-          <p:cNvSpPr txBox="1"/>
-          <p:nvPr/>
-        </p:nvSpPr>
-        <p:spPr>
-          <a:xfrm>
-            <a:off x="2899333" y="1901952"/>
-            <a:ext cx="640080" cy="457200"/>
+            <a:off x="3576218" y="2148840"/>
+            <a:ext cx="1005840" cy="731520"/>
           </a:xfrm>
           <a:prstGeom prst="rect">
             <a:avLst/>
@@ -5068,7 +5026,7 @@
               </a:spcAft>
             </a:pPr>
             <a:r>
-              <a:rPr sz="1600" b="1">
+              <a:rPr sz="3600" b="1">
                 <a:solidFill>
                   <a:srgbClr val="6D2E5B"/>
                 </a:solidFill>
@@ -5081,19 +5039,19 @@
       </p:sp>
       <p:cxnSp>
         <p:nvCxnSpPr>
-          <p:cNvPr id="10" name="Connector 9"/>
+          <p:cNvPr id="9" name="Connector 8"/>
           <p:cNvCxnSpPr/>
           <p:nvPr/>
         </p:nvCxnSpPr>
         <p:spPr>
           <a:xfrm>
-            <a:off x="3539413" y="1737360"/>
-            <a:ext cx="2167813" cy="0"/>
+            <a:off x="4582058" y="1828800"/>
+            <a:ext cx="2844698" cy="0"/>
           </a:xfrm>
           <a:prstGeom prst="line">
             <a:avLst/>
           </a:prstGeom>
-          <a:ln w="28575">
+          <a:ln w="38100">
             <a:solidFill>
               <a:srgbClr val="D8DED9"/>
             </a:solidFill>
@@ -5116,14 +5074,14 @@
       </p:cxnSp>
       <p:sp>
         <p:nvSpPr>
-          <p:cNvPr id="11" name="TextBox 10"/>
+          <p:cNvPr id="10" name="TextBox 9"/>
           <p:cNvSpPr txBox="1"/>
           <p:nvPr/>
         </p:nvSpPr>
         <p:spPr>
           <a:xfrm>
-            <a:off x="3539413" y="1810512"/>
-            <a:ext cx="2167813" cy="502920"/>
+            <a:off x="4582058" y="1965960"/>
+            <a:ext cx="2844698" cy="1005840"/>
           </a:xfrm>
           <a:prstGeom prst="rect">
             <a:avLst/>
@@ -5145,7 +5103,7 @@
               </a:spcAft>
             </a:pPr>
             <a:r>
-              <a:rPr sz="2600" b="1">
+              <a:rPr sz="6000" b="1">
                 <a:solidFill>
                   <a:srgbClr val="14261F"/>
                 </a:solidFill>
@@ -5154,13 +5112,64 @@
               <a:t>47</a:t>
             </a:r>
             <a:r>
-              <a:rPr sz="1100" b="1">
+              <a:rPr sz="2000" b="1">
                 <a:solidFill>
                   <a:srgbClr val="5F6D66"/>
                 </a:solidFill>
                 <a:latin typeface="Bricolage Grotesque"/>
               </a:rPr>
               <a:t> %</a:t>
+            </a:r>
+          </a:p>
+        </p:txBody>
+      </p:sp>
+      <p:sp>
+        <p:nvSpPr>
+          <p:cNvPr id="11" name="TextBox 10"/>
+          <p:cNvSpPr txBox="1"/>
+          <p:nvPr/>
+        </p:nvSpPr>
+        <p:spPr>
+          <a:xfrm>
+            <a:off x="4582058" y="3063240"/>
+            <a:ext cx="2844698" cy="822960"/>
+          </a:xfrm>
+          <a:prstGeom prst="rect">
+            <a:avLst/>
+          </a:prstGeom>
+          <a:noFill/>
+        </p:spPr>
+        <p:txBody>
+          <a:bodyPr wrap="square" anchor="t" lIns="0" rIns="0" tIns="0" bIns="0">
+            <a:spAutoFit/>
+          </a:bodyPr>
+          <a:lstStyle/>
+          <a:p>
+            <a:pPr algn="l">
+              <a:lnSpc>
+                <a:spcPct val="120000"/>
+              </a:lnSpc>
+              <a:spcAft>
+                <a:spcPts val="0"/>
+              </a:spcAft>
+            </a:pPr>
+            <a:r>
+              <a:rPr sz="1500" b="1">
+                <a:solidFill>
+                  <a:srgbClr val="14261F"/>
+                </a:solidFill>
+                <a:latin typeface="Instrument Sans"/>
+              </a:rPr>
+              <a:t>never recorded as told</a:t>
+            </a:r>
+            <a:r>
+              <a:rPr sz="1500" b="0">
+                <a:solidFill>
+                  <a:srgbClr val="5F6D66"/>
+                </a:solidFill>
+                <a:latin typeface="Instrument Sans"/>
+              </a:rPr>
+              <a:t> to the patient</a:t>
             </a:r>
           </a:p>
         </p:txBody>
@@ -5173,8 +5182,8 @@
         </p:nvSpPr>
         <p:spPr>
           <a:xfrm>
-            <a:off x="3539413" y="2304288"/>
-            <a:ext cx="2167813" cy="502920"/>
+            <a:off x="4582058" y="3840480"/>
+            <a:ext cx="2844698" cy="320040"/>
           </a:xfrm>
           <a:prstGeom prst="rect">
             <a:avLst/>
@@ -5196,31 +5205,13 @@
               </a:spcAft>
             </a:pPr>
             <a:r>
-              <a:rPr sz="950" b="0">
+              <a:rPr sz="900" b="0">
                 <a:solidFill>
                   <a:srgbClr val="5F6D66"/>
                 </a:solidFill>
                 <a:latin typeface="Instrument Sans"/>
               </a:rPr>
-              <a:t>have </a:t>
-            </a:r>
-            <a:r>
-              <a:rPr sz="950" b="1">
-                <a:solidFill>
-                  <a:srgbClr val="14261F"/>
-                </a:solidFill>
-                <a:latin typeface="Instrument Sans"/>
-              </a:rPr>
-              <a:t>no record of the patient being told</a:t>
-            </a:r>
-            <a:r>
-              <a:rPr sz="950" b="0">
-                <a:solidFill>
-                  <a:srgbClr val="5F6D66"/>
-                </a:solidFill>
-                <a:latin typeface="Instrument Sans"/>
-              </a:rPr>
-              <a:t>. 31% even when abnormal.</a:t>
+              <a:t>UK audit, 2,572 patients, 57 practices</a:t>
             </a:r>
           </a:p>
         </p:txBody>
@@ -5233,50 +5224,8 @@
         </p:nvSpPr>
         <p:spPr>
           <a:xfrm>
-            <a:off x="3539413" y="2788920"/>
-            <a:ext cx="2167813" cy="274320"/>
-          </a:xfrm>
-          <a:prstGeom prst="rect">
-            <a:avLst/>
-          </a:prstGeom>
-          <a:noFill/>
-        </p:spPr>
-        <p:txBody>
-          <a:bodyPr wrap="square" anchor="t" lIns="0" rIns="0" tIns="0" bIns="0">
-            <a:spAutoFit/>
-          </a:bodyPr>
-          <a:lstStyle/>
-          <a:p>
-            <a:pPr algn="l">
-              <a:lnSpc>
-                <a:spcPct val="115000"/>
-              </a:lnSpc>
-              <a:spcAft>
-                <a:spcPts val="0"/>
-              </a:spcAft>
-            </a:pPr>
-            <a:r>
-              <a:rPr sz="750" b="0">
-                <a:solidFill>
-                  <a:srgbClr val="5F6D66"/>
-                </a:solidFill>
-                <a:latin typeface="Instrument Sans"/>
-              </a:rPr>
-              <a:t>PACT audit, 2,572 patients, 57 practices</a:t>
-            </a:r>
-          </a:p>
-        </p:txBody>
-      </p:sp>
-      <p:sp>
-        <p:nvSpPr>
-          <p:cNvPr id="14" name="TextBox 13"/>
-          <p:cNvSpPr txBox="1"/>
-          <p:nvPr/>
-        </p:nvSpPr>
-        <p:spPr>
-          <a:xfrm>
-            <a:off x="5707226" y="1901952"/>
-            <a:ext cx="640080" cy="457200"/>
+            <a:off x="7426756" y="2148840"/>
+            <a:ext cx="1005840" cy="731520"/>
           </a:xfrm>
           <a:prstGeom prst="rect">
             <a:avLst/>
@@ -5298,7 +5247,7 @@
               </a:spcAft>
             </a:pPr>
             <a:r>
-              <a:rPr sz="1600" b="1">
+              <a:rPr sz="3600" b="1">
                 <a:solidFill>
                   <a:srgbClr val="6D2E5B"/>
                 </a:solidFill>
@@ -5311,21 +5260,21 @@
       </p:sp>
       <p:cxnSp>
         <p:nvCxnSpPr>
-          <p:cNvPr id="15" name="Connector 14"/>
+          <p:cNvPr id="14" name="Connector 13"/>
           <p:cNvCxnSpPr/>
           <p:nvPr/>
         </p:nvCxnSpPr>
         <p:spPr>
           <a:xfrm>
-            <a:off x="6347306" y="1737360"/>
-            <a:ext cx="2167813" cy="0"/>
+            <a:off x="8432596" y="1828800"/>
+            <a:ext cx="2844698" cy="0"/>
           </a:xfrm>
           <a:prstGeom prst="line">
             <a:avLst/>
           </a:prstGeom>
-          <a:ln w="28575">
+          <a:ln w="38100">
             <a:solidFill>
-              <a:srgbClr val="D8DED9"/>
+              <a:srgbClr val="6D2E5B"/>
             </a:solidFill>
           </a:ln>
         </p:spPr>
@@ -5346,14 +5295,14 @@
       </p:cxnSp>
       <p:sp>
         <p:nvSpPr>
-          <p:cNvPr id="16" name="TextBox 15"/>
+          <p:cNvPr id="15" name="TextBox 14"/>
           <p:cNvSpPr txBox="1"/>
           <p:nvPr/>
         </p:nvSpPr>
         <p:spPr>
           <a:xfrm>
-            <a:off x="6347306" y="1810512"/>
-            <a:ext cx="2167813" cy="502920"/>
+            <a:off x="8432596" y="1965960"/>
+            <a:ext cx="2844698" cy="1005840"/>
           </a:xfrm>
           <a:prstGeom prst="rect">
             <a:avLst/>
@@ -5375,22 +5324,82 @@
               </a:spcAft>
             </a:pPr>
             <a:r>
-              <a:rPr sz="2600" b="1">
+              <a:rPr sz="6000" b="1">
+                <a:solidFill>
+                  <a:srgbClr val="6D2E5B"/>
+                </a:solidFill>
+                <a:latin typeface="Bricolage Grotesque"/>
+              </a:rPr>
+              <a:t>68</a:t>
+            </a:r>
+            <a:r>
+              <a:rPr sz="2000" b="1">
+                <a:solidFill>
+                  <a:srgbClr val="5F6D66"/>
+                </a:solidFill>
+                <a:latin typeface="Bricolage Grotesque"/>
+              </a:rPr>
+              <a:t> m</a:t>
+            </a:r>
+          </a:p>
+        </p:txBody>
+      </p:sp>
+      <p:sp>
+        <p:nvSpPr>
+          <p:cNvPr id="16" name="TextBox 15"/>
+          <p:cNvSpPr txBox="1"/>
+          <p:nvPr/>
+        </p:nvSpPr>
+        <p:spPr>
+          <a:xfrm>
+            <a:off x="8432596" y="3063240"/>
+            <a:ext cx="2844698" cy="822960"/>
+          </a:xfrm>
+          <a:prstGeom prst="rect">
+            <a:avLst/>
+          </a:prstGeom>
+          <a:noFill/>
+        </p:spPr>
+        <p:txBody>
+          <a:bodyPr wrap="square" anchor="t" lIns="0" rIns="0" tIns="0" bIns="0">
+            <a:spAutoFit/>
+          </a:bodyPr>
+          <a:lstStyle/>
+          <a:p>
+            <a:pPr algn="l">
+              <a:lnSpc>
+                <a:spcPct val="120000"/>
+              </a:lnSpc>
+              <a:spcAft>
+                <a:spcPts val="0"/>
+              </a:spcAft>
+            </a:pPr>
+            <a:r>
+              <a:rPr sz="1500" b="0">
+                <a:solidFill>
+                  <a:srgbClr val="5F6D66"/>
+                </a:solidFill>
+                <a:latin typeface="Instrument Sans"/>
+              </a:rPr>
+              <a:t>results </a:t>
+            </a:r>
+            <a:r>
+              <a:rPr sz="1500" b="1">
                 <a:solidFill>
                   <a:srgbClr val="14261F"/>
                 </a:solidFill>
-                <a:latin typeface="Bricolage Grotesque"/>
-              </a:rPr>
-              <a:t>5.6</a:t>
-            </a:r>
-            <a:r>
-              <a:rPr sz="1100" b="1">
+                <a:latin typeface="Instrument Sans"/>
+              </a:rPr>
+              <a:t>a year</a:t>
+            </a:r>
+            <a:r>
+              <a:rPr sz="1500" b="0">
                 <a:solidFill>
                   <a:srgbClr val="5F6D66"/>
                 </a:solidFill>
-                <a:latin typeface="Bricolage Grotesque"/>
-              </a:rPr>
-              <a:t> m</a:t>
+                <a:latin typeface="Instrument Sans"/>
+              </a:rPr>
+              <a:t> with no evidence the patient was told</a:t>
             </a:r>
           </a:p>
         </p:txBody>
@@ -5403,8 +5412,8 @@
         </p:nvSpPr>
         <p:spPr>
           <a:xfrm>
-            <a:off x="6347306" y="2304288"/>
-            <a:ext cx="2167813" cy="502920"/>
+            <a:off x="8432596" y="3840480"/>
+            <a:ext cx="2844698" cy="320040"/>
           </a:xfrm>
           <a:prstGeom prst="rect">
             <a:avLst/>
@@ -5426,22 +5435,22 @@
               </a:spcAft>
             </a:pPr>
             <a:r>
-              <a:rPr sz="950" b="0">
+              <a:rPr sz="800" b="1">
+                <a:solidFill>
+                  <a:srgbClr val="7A520C"/>
+                </a:solidFill>
+                <a:latin typeface="Instrument Sans"/>
+              </a:rPr>
+              <a:t>EXTRAPOLATED  </a:t>
+            </a:r>
+            <a:r>
+              <a:rPr sz="900" b="0">
                 <a:solidFill>
                   <a:srgbClr val="5F6D66"/>
                 </a:solidFill>
                 <a:latin typeface="Instrument Sans"/>
               </a:rPr>
-              <a:t>results a month with </a:t>
-            </a:r>
-            <a:r>
-              <a:rPr sz="950" b="1">
-                <a:solidFill>
-                  <a:srgbClr val="14261F"/>
-                </a:solidFill>
-                <a:latin typeface="Instrument Sans"/>
-              </a:rPr>
-              <a:t>no evidence anyone told the patient</a:t>
+              <a:t/>
             </a:r>
           </a:p>
         </p:txBody>
@@ -5454,8 +5463,8 @@
         </p:nvSpPr>
         <p:spPr>
           <a:xfrm>
-            <a:off x="6347306" y="2788920"/>
-            <a:ext cx="2167813" cy="274320"/>
+            <a:off x="731520" y="4754880"/>
+            <a:ext cx="10728655" cy="548640"/>
           </a:xfrm>
           <a:prstGeom prst="rect">
             <a:avLst/>
@@ -5477,22 +5486,40 @@
               </a:spcAft>
             </a:pPr>
             <a:r>
-              <a:rPr sz="700" b="1">
+              <a:rPr sz="1600" b="0">
+                <a:solidFill>
+                  <a:srgbClr val="5F6D66"/>
+                </a:solidFill>
+                <a:latin typeface="Instrument Sans"/>
+              </a:rPr>
+              <a:t>And GPs spend about </a:t>
+            </a:r>
+            <a:r>
+              <a:rPr sz="1600" b="1">
+                <a:solidFill>
+                  <a:srgbClr val="14261F"/>
+                </a:solidFill>
+                <a:latin typeface="Instrument Sans"/>
+              </a:rPr>
+              <a:t>35,000 hours every working day</a:t>
+            </a:r>
+            <a:r>
+              <a:rPr sz="1600" b="0">
+                <a:solidFill>
+                  <a:srgbClr val="5F6D66"/>
+                </a:solidFill>
+                <a:latin typeface="Instrument Sans"/>
+              </a:rPr>
+              <a:t> managing results.  </a:t>
+            </a:r>
+            <a:r>
+              <a:rPr sz="800" b="1">
                 <a:solidFill>
                   <a:srgbClr val="7A520C"/>
                 </a:solidFill>
                 <a:latin typeface="Instrument Sans"/>
               </a:rPr>
-              <a:t>EXTRAPOLATED  </a:t>
-            </a:r>
-            <a:r>
-              <a:rPr sz="750" b="0">
-                <a:solidFill>
-                  <a:srgbClr val="5F6D66"/>
-                </a:solidFill>
-                <a:latin typeface="Instrument Sans"/>
-              </a:rPr>
-              <a:t/>
+              <a:t>EXTRAPOLATED</a:t>
             </a:r>
           </a:p>
         </p:txBody>
@@ -5505,8 +5532,8 @@
         </p:nvSpPr>
         <p:spPr>
           <a:xfrm>
-            <a:off x="8515119" y="1901952"/>
-            <a:ext cx="640080" cy="457200"/>
+            <a:off x="731520" y="6309360"/>
+            <a:ext cx="7863840" cy="365760"/>
           </a:xfrm>
           <a:prstGeom prst="rect">
             <a:avLst/>
@@ -5514,84 +5541,7 @@
           <a:noFill/>
         </p:spPr>
         <p:txBody>
-          <a:bodyPr wrap="square" anchor="t" lIns="0" rIns="0" tIns="0" bIns="0">
-            <a:spAutoFit/>
-          </a:bodyPr>
-          <a:lstStyle/>
-          <a:p>
-            <a:pPr algn="ctr">
-              <a:lnSpc>
-                <a:spcPct val="115000"/>
-              </a:lnSpc>
-              <a:spcAft>
-                <a:spcPts val="0"/>
-              </a:spcAft>
-            </a:pPr>
-            <a:r>
-              <a:rPr sz="1600" b="1">
-                <a:solidFill>
-                  <a:srgbClr val="6D2E5B"/>
-                </a:solidFill>
-                <a:latin typeface="Bricolage Grotesque"/>
-              </a:rPr>
-              <a:t>× 12</a:t>
-            </a:r>
-          </a:p>
-        </p:txBody>
-      </p:sp>
-      <p:cxnSp>
-        <p:nvCxnSpPr>
-          <p:cNvPr id="20" name="Connector 19"/>
-          <p:cNvCxnSpPr/>
-          <p:nvPr/>
-        </p:nvCxnSpPr>
-        <p:spPr>
-          <a:xfrm>
-            <a:off x="9155199" y="1737360"/>
-            <a:ext cx="2167813" cy="0"/>
-          </a:xfrm>
-          <a:prstGeom prst="line">
-            <a:avLst/>
-          </a:prstGeom>
-          <a:ln w="28575">
-            <a:solidFill>
-              <a:srgbClr val="6D2E5B"/>
-            </a:solidFill>
-          </a:ln>
-        </p:spPr>
-        <p:style>
-          <a:lnRef idx="2">
-            <a:schemeClr val="accent1"/>
-          </a:lnRef>
-          <a:fillRef idx="0">
-            <a:schemeClr val="accent1"/>
-          </a:fillRef>
-          <a:effectRef idx="1">
-            <a:schemeClr val="accent1"/>
-          </a:effectRef>
-          <a:fontRef idx="minor">
-            <a:schemeClr val="tx1"/>
-          </a:fontRef>
-        </p:style>
-      </p:cxnSp>
-      <p:sp>
-        <p:nvSpPr>
-          <p:cNvPr id="21" name="TextBox 20"/>
-          <p:cNvSpPr txBox="1"/>
-          <p:nvPr/>
-        </p:nvSpPr>
-        <p:spPr>
-          <a:xfrm>
-            <a:off x="9155199" y="1810512"/>
-            <a:ext cx="2167813" cy="502920"/>
-          </a:xfrm>
-          <a:prstGeom prst="rect">
-            <a:avLst/>
-          </a:prstGeom>
-          <a:noFill/>
-        </p:spPr>
-        <p:txBody>
-          <a:bodyPr wrap="square" anchor="t" lIns="0" rIns="0" tIns="0" bIns="0">
+          <a:bodyPr wrap="square" anchor="b" lIns="0" rIns="0" tIns="0" bIns="0">
             <a:spAutoFit/>
           </a:bodyPr>
           <a:lstStyle/>
@@ -5605,1535 +5555,20 @@
               </a:spcAft>
             </a:pPr>
             <a:r>
-              <a:rPr sz="2600" b="1">
-                <a:solidFill>
-                  <a:srgbClr val="6D2E5B"/>
-                </a:solidFill>
-                <a:latin typeface="Bricolage Grotesque"/>
-              </a:rPr>
-              <a:t>68</a:t>
-            </a:r>
-            <a:r>
-              <a:rPr sz="1100" b="1">
+              <a:rPr sz="850" b="0">
                 <a:solidFill>
                   <a:srgbClr val="5F6D66"/>
                 </a:solidFill>
-                <a:latin typeface="Bricolage Grotesque"/>
-              </a:rPr>
-              <a:t> m</a:t>
-            </a:r>
-          </a:p>
-        </p:txBody>
-      </p:sp>
-      <p:sp>
-        <p:nvSpPr>
-          <p:cNvPr id="22" name="TextBox 21"/>
-          <p:cNvSpPr txBox="1"/>
-          <p:nvPr/>
-        </p:nvSpPr>
-        <p:spPr>
-          <a:xfrm>
-            <a:off x="9155199" y="2304288"/>
-            <a:ext cx="2167813" cy="502920"/>
-          </a:xfrm>
-          <a:prstGeom prst="rect">
-            <a:avLst/>
-          </a:prstGeom>
-          <a:noFill/>
-        </p:spPr>
-        <p:txBody>
-          <a:bodyPr wrap="square" anchor="t" lIns="0" rIns="0" tIns="0" bIns="0">
-            <a:spAutoFit/>
-          </a:bodyPr>
-          <a:lstStyle/>
-          <a:p>
-            <a:pPr algn="l">
-              <a:lnSpc>
-                <a:spcPct val="115000"/>
-              </a:lnSpc>
-              <a:spcAft>
-                <a:spcPts val="0"/>
-              </a:spcAft>
-            </a:pPr>
-            <a:r>
-              <a:rPr sz="950" b="0">
-                <a:solidFill>
-                  <a:srgbClr val="5F6D66"/>
-                </a:solidFill>
                 <a:latin typeface="Instrument Sans"/>
               </a:rPr>
-              <a:t>a year. </a:t>
-            </a:r>
-            <a:r>
-              <a:rPr sz="950" b="1">
-                <a:solidFill>
-                  <a:srgbClr val="14261F"/>
-                </a:solidFill>
-                <a:latin typeface="Instrument Sans"/>
-              </a:rPr>
-              <a:t>Every one of them is somebody's Eleanor.</a:t>
-            </a:r>
-          </a:p>
-        </p:txBody>
-      </p:sp>
-      <p:sp>
-        <p:nvSpPr>
-          <p:cNvPr id="23" name="TextBox 22"/>
-          <p:cNvSpPr txBox="1"/>
-          <p:nvPr/>
-        </p:nvSpPr>
-        <p:spPr>
-          <a:xfrm>
-            <a:off x="9155199" y="2788920"/>
-            <a:ext cx="2167813" cy="274320"/>
-          </a:xfrm>
-          <a:prstGeom prst="rect">
-            <a:avLst/>
-          </a:prstGeom>
-          <a:noFill/>
-        </p:spPr>
-        <p:txBody>
-          <a:bodyPr wrap="square" anchor="t" lIns="0" rIns="0" tIns="0" bIns="0">
-            <a:spAutoFit/>
-          </a:bodyPr>
-          <a:lstStyle/>
-          <a:p>
-            <a:pPr algn="l">
-              <a:lnSpc>
-                <a:spcPct val="115000"/>
-              </a:lnSpc>
-              <a:spcAft>
-                <a:spcPts val="0"/>
-              </a:spcAft>
-            </a:pPr>
-            <a:r>
-              <a:rPr sz="700" b="1">
-                <a:solidFill>
-                  <a:srgbClr val="7A520C"/>
-                </a:solidFill>
-                <a:latin typeface="Instrument Sans"/>
-              </a:rPr>
-              <a:t>EXTRAPOLATED  </a:t>
-            </a:r>
-            <a:r>
-              <a:rPr sz="750" b="0">
-                <a:solidFill>
-                  <a:srgbClr val="5F6D66"/>
-                </a:solidFill>
-                <a:latin typeface="Instrument Sans"/>
-              </a:rPr>
-              <a:t/>
-            </a:r>
-          </a:p>
-        </p:txBody>
-      </p:sp>
-      <p:sp>
-        <p:nvSpPr>
-          <p:cNvPr id="24" name="TextBox 23"/>
-          <p:cNvSpPr txBox="1"/>
-          <p:nvPr/>
-        </p:nvSpPr>
-        <p:spPr>
-          <a:xfrm>
-            <a:off x="731520" y="3154680"/>
-            <a:ext cx="7315200" cy="256032"/>
-          </a:xfrm>
-          <a:prstGeom prst="rect">
-            <a:avLst/>
-          </a:prstGeom>
-          <a:noFill/>
-        </p:spPr>
-        <p:txBody>
-          <a:bodyPr wrap="square" anchor="t" lIns="0" rIns="0" tIns="0" bIns="0">
-            <a:spAutoFit/>
-          </a:bodyPr>
-          <a:lstStyle/>
-          <a:p>
-            <a:pPr algn="l">
-              <a:lnSpc>
-                <a:spcPct val="115000"/>
-              </a:lnSpc>
-              <a:spcAft>
-                <a:spcPts val="0"/>
-              </a:spcAft>
-            </a:pPr>
-            <a:r>
-              <a:rPr sz="800" b="1">
-                <a:solidFill>
-                  <a:srgbClr val="6D2E5B"/>
-                </a:solidFill>
-                <a:latin typeface="Instrument Sans"/>
-              </a:rPr>
-              <a:t>WHAT IT COSTS THE PRACTICE</a:t>
-            </a:r>
-          </a:p>
-        </p:txBody>
-      </p:sp>
-      <p:cxnSp>
-        <p:nvCxnSpPr>
-          <p:cNvPr id="25" name="Connector 24"/>
-          <p:cNvCxnSpPr/>
-          <p:nvPr/>
-        </p:nvCxnSpPr>
-        <p:spPr>
-          <a:xfrm>
-            <a:off x="731520" y="3429000"/>
-            <a:ext cx="3103778" cy="0"/>
-          </a:xfrm>
-          <a:prstGeom prst="line">
-            <a:avLst/>
-          </a:prstGeom>
-          <a:ln w="28575">
-            <a:solidFill>
-              <a:srgbClr val="D8DED9"/>
-            </a:solidFill>
-          </a:ln>
-        </p:spPr>
-        <p:style>
-          <a:lnRef idx="2">
-            <a:schemeClr val="accent1"/>
-          </a:lnRef>
-          <a:fillRef idx="0">
-            <a:schemeClr val="accent1"/>
-          </a:fillRef>
-          <a:effectRef idx="1">
-            <a:schemeClr val="accent1"/>
-          </a:effectRef>
-          <a:fontRef idx="minor">
-            <a:schemeClr val="tx1"/>
-          </a:fontRef>
-        </p:style>
-      </p:cxnSp>
-      <p:sp>
-        <p:nvSpPr>
-          <p:cNvPr id="26" name="TextBox 25"/>
-          <p:cNvSpPr txBox="1"/>
-          <p:nvPr/>
-        </p:nvSpPr>
-        <p:spPr>
-          <a:xfrm>
-            <a:off x="731520" y="3502152"/>
-            <a:ext cx="3103778" cy="502920"/>
-          </a:xfrm>
-          <a:prstGeom prst="rect">
-            <a:avLst/>
-          </a:prstGeom>
-          <a:noFill/>
-        </p:spPr>
-        <p:txBody>
-          <a:bodyPr wrap="square" anchor="t" lIns="0" rIns="0" tIns="0" bIns="0">
-            <a:spAutoFit/>
-          </a:bodyPr>
-          <a:lstStyle/>
-          <a:p>
-            <a:pPr algn="l">
-              <a:lnSpc>
-                <a:spcPct val="115000"/>
-              </a:lnSpc>
-              <a:spcAft>
-                <a:spcPts val="0"/>
-              </a:spcAft>
-            </a:pPr>
-            <a:r>
-              <a:rPr sz="2600" b="1">
-                <a:solidFill>
-                  <a:srgbClr val="14261F"/>
-                </a:solidFill>
-                <a:latin typeface="Bricolage Grotesque"/>
-              </a:rPr>
-              <a:t>74</a:t>
-            </a:r>
-            <a:r>
-              <a:rPr sz="1100" b="1">
-                <a:solidFill>
-                  <a:srgbClr val="5F6D66"/>
-                </a:solidFill>
-                <a:latin typeface="Bricolage Grotesque"/>
-              </a:rPr>
-              <a:t> min</a:t>
-            </a:r>
-          </a:p>
-        </p:txBody>
-      </p:sp>
-      <p:sp>
-        <p:nvSpPr>
-          <p:cNvPr id="27" name="TextBox 26"/>
-          <p:cNvSpPr txBox="1"/>
-          <p:nvPr/>
-        </p:nvSpPr>
-        <p:spPr>
-          <a:xfrm>
-            <a:off x="731520" y="3995928"/>
-            <a:ext cx="3103778" cy="502920"/>
-          </a:xfrm>
-          <a:prstGeom prst="rect">
-            <a:avLst/>
-          </a:prstGeom>
-          <a:noFill/>
-        </p:spPr>
-        <p:txBody>
-          <a:bodyPr wrap="square" anchor="t" lIns="0" rIns="0" tIns="0" bIns="0">
-            <a:spAutoFit/>
-          </a:bodyPr>
-          <a:lstStyle/>
-          <a:p>
-            <a:pPr algn="l">
-              <a:lnSpc>
-                <a:spcPct val="115000"/>
-              </a:lnSpc>
-              <a:spcAft>
-                <a:spcPts val="0"/>
-              </a:spcAft>
-            </a:pPr>
-            <a:r>
-              <a:rPr sz="950" b="0">
-                <a:solidFill>
-                  <a:srgbClr val="5F6D66"/>
-                </a:solidFill>
-                <a:latin typeface="Instrument Sans"/>
-              </a:rPr>
-              <a:t>a day </a:t>
-            </a:r>
-            <a:r>
-              <a:rPr sz="950" b="1">
-                <a:solidFill>
-                  <a:srgbClr val="14261F"/>
-                </a:solidFill>
-                <a:latin typeface="Instrument Sans"/>
-              </a:rPr>
-              <a:t>per GP</a:t>
-            </a:r>
-            <a:r>
-              <a:rPr sz="950" b="0">
-                <a:solidFill>
-                  <a:srgbClr val="5F6D66"/>
-                </a:solidFill>
-                <a:latin typeface="Instrument Sans"/>
-              </a:rPr>
-              <a:t> managing results</a:t>
-            </a:r>
-          </a:p>
-        </p:txBody>
-      </p:sp>
-      <p:sp>
-        <p:nvSpPr>
-          <p:cNvPr id="28" name="TextBox 27"/>
-          <p:cNvSpPr txBox="1"/>
-          <p:nvPr/>
-        </p:nvSpPr>
-        <p:spPr>
-          <a:xfrm>
-            <a:off x="731520" y="4480560"/>
-            <a:ext cx="3103778" cy="274320"/>
-          </a:xfrm>
-          <a:prstGeom prst="rect">
-            <a:avLst/>
-          </a:prstGeom>
-          <a:noFill/>
-        </p:spPr>
-        <p:txBody>
-          <a:bodyPr wrap="square" anchor="t" lIns="0" rIns="0" tIns="0" bIns="0">
-            <a:spAutoFit/>
-          </a:bodyPr>
-          <a:lstStyle/>
-          <a:p>
-            <a:pPr algn="l">
-              <a:lnSpc>
-                <a:spcPct val="115000"/>
-              </a:lnSpc>
-              <a:spcAft>
-                <a:spcPts val="0"/>
-              </a:spcAft>
-            </a:pPr>
-            <a:r>
-              <a:rPr sz="750" b="0">
-                <a:solidFill>
-                  <a:srgbClr val="5F6D66"/>
-                </a:solidFill>
-                <a:latin typeface="Instrument Sans"/>
-              </a:rPr>
-              <a:t>Poon et al. 2004, 262 physicians</a:t>
-            </a:r>
-          </a:p>
-        </p:txBody>
-      </p:sp>
-      <p:sp>
-        <p:nvSpPr>
-          <p:cNvPr id="29" name="TextBox 28"/>
-          <p:cNvSpPr txBox="1"/>
-          <p:nvPr/>
-        </p:nvSpPr>
-        <p:spPr>
-          <a:xfrm>
-            <a:off x="3835298" y="3593592"/>
-            <a:ext cx="640080" cy="457200"/>
-          </a:xfrm>
-          <a:prstGeom prst="rect">
-            <a:avLst/>
-          </a:prstGeom>
-          <a:noFill/>
-        </p:spPr>
-        <p:txBody>
-          <a:bodyPr wrap="square" anchor="t" lIns="0" rIns="0" tIns="0" bIns="0">
-            <a:spAutoFit/>
-          </a:bodyPr>
-          <a:lstStyle/>
-          <a:p>
-            <a:pPr algn="ctr">
-              <a:lnSpc>
-                <a:spcPct val="115000"/>
-              </a:lnSpc>
-              <a:spcAft>
-                <a:spcPts val="0"/>
-              </a:spcAft>
-            </a:pPr>
-            <a:r>
-              <a:rPr sz="1600" b="1">
-                <a:solidFill>
-                  <a:srgbClr val="6D2E5B"/>
-                </a:solidFill>
-                <a:latin typeface="Bricolage Grotesque"/>
-              </a:rPr>
-              <a:t>×</a:t>
-            </a:r>
-          </a:p>
-        </p:txBody>
-      </p:sp>
-      <p:cxnSp>
-        <p:nvCxnSpPr>
-          <p:cNvPr id="30" name="Connector 29"/>
-          <p:cNvCxnSpPr/>
-          <p:nvPr/>
-        </p:nvCxnSpPr>
-        <p:spPr>
-          <a:xfrm>
-            <a:off x="4475378" y="3429000"/>
-            <a:ext cx="3103778" cy="0"/>
-          </a:xfrm>
-          <a:prstGeom prst="line">
-            <a:avLst/>
-          </a:prstGeom>
-          <a:ln w="28575">
-            <a:solidFill>
-              <a:srgbClr val="D8DED9"/>
-            </a:solidFill>
-          </a:ln>
-        </p:spPr>
-        <p:style>
-          <a:lnRef idx="2">
-            <a:schemeClr val="accent1"/>
-          </a:lnRef>
-          <a:fillRef idx="0">
-            <a:schemeClr val="accent1"/>
-          </a:fillRef>
-          <a:effectRef idx="1">
-            <a:schemeClr val="accent1"/>
-          </a:effectRef>
-          <a:fontRef idx="minor">
-            <a:schemeClr val="tx1"/>
-          </a:fontRef>
-        </p:style>
-      </p:cxnSp>
-      <p:sp>
-        <p:nvSpPr>
-          <p:cNvPr id="31" name="TextBox 30"/>
-          <p:cNvSpPr txBox="1"/>
-          <p:nvPr/>
-        </p:nvSpPr>
-        <p:spPr>
-          <a:xfrm>
-            <a:off x="4475378" y="3502152"/>
-            <a:ext cx="3103778" cy="502920"/>
-          </a:xfrm>
-          <a:prstGeom prst="rect">
-            <a:avLst/>
-          </a:prstGeom>
-          <a:noFill/>
-        </p:spPr>
-        <p:txBody>
-          <a:bodyPr wrap="square" anchor="t" lIns="0" rIns="0" tIns="0" bIns="0">
-            <a:spAutoFit/>
-          </a:bodyPr>
-          <a:lstStyle/>
-          <a:p>
-            <a:pPr algn="l">
-              <a:lnSpc>
-                <a:spcPct val="115000"/>
-              </a:lnSpc>
-              <a:spcAft>
-                <a:spcPts val="0"/>
-              </a:spcAft>
-            </a:pPr>
-            <a:r>
-              <a:rPr sz="2600" b="1">
-                <a:solidFill>
-                  <a:srgbClr val="14261F"/>
-                </a:solidFill>
-                <a:latin typeface="Bricolage Grotesque"/>
-              </a:rPr>
-              <a:t>28,426</a:t>
-            </a:r>
-            <a:r>
-              <a:rPr sz="1100" b="1">
-                <a:solidFill>
-                  <a:srgbClr val="5F6D66"/>
-                </a:solidFill>
-                <a:latin typeface="Bricolage Grotesque"/>
-              </a:rPr>
-              <a:t/>
-            </a:r>
-          </a:p>
-        </p:txBody>
-      </p:sp>
-      <p:sp>
-        <p:nvSpPr>
-          <p:cNvPr id="32" name="TextBox 31"/>
-          <p:cNvSpPr txBox="1"/>
-          <p:nvPr/>
-        </p:nvSpPr>
-        <p:spPr>
-          <a:xfrm>
-            <a:off x="4475378" y="3995928"/>
-            <a:ext cx="3103778" cy="502920"/>
-          </a:xfrm>
-          <a:prstGeom prst="rect">
-            <a:avLst/>
-          </a:prstGeom>
-          <a:noFill/>
-        </p:spPr>
-        <p:txBody>
-          <a:bodyPr wrap="square" anchor="t" lIns="0" rIns="0" tIns="0" bIns="0">
-            <a:spAutoFit/>
-          </a:bodyPr>
-          <a:lstStyle/>
-          <a:p>
-            <a:pPr algn="l">
-              <a:lnSpc>
-                <a:spcPct val="115000"/>
-              </a:lnSpc>
-              <a:spcAft>
-                <a:spcPts val="0"/>
-              </a:spcAft>
-            </a:pPr>
-            <a:r>
-              <a:rPr sz="950" b="1">
-                <a:solidFill>
-                  <a:srgbClr val="14261F"/>
-                </a:solidFill>
-                <a:latin typeface="Instrument Sans"/>
-              </a:rPr>
-              <a:t>full-time GPs</a:t>
-            </a:r>
-            <a:r>
-              <a:rPr sz="950" b="0">
-                <a:solidFill>
-                  <a:srgbClr val="5F6D66"/>
-                </a:solidFill>
-                <a:latin typeface="Instrument Sans"/>
-              </a:rPr>
-              <a:t> in England</a:t>
-            </a:r>
-          </a:p>
-        </p:txBody>
-      </p:sp>
-      <p:sp>
-        <p:nvSpPr>
-          <p:cNvPr id="33" name="TextBox 32"/>
-          <p:cNvSpPr txBox="1"/>
-          <p:nvPr/>
-        </p:nvSpPr>
-        <p:spPr>
-          <a:xfrm>
-            <a:off x="4475378" y="4480560"/>
-            <a:ext cx="3103778" cy="274320"/>
-          </a:xfrm>
-          <a:prstGeom prst="rect">
-            <a:avLst/>
-          </a:prstGeom>
-          <a:noFill/>
-        </p:spPr>
-        <p:txBody>
-          <a:bodyPr wrap="square" anchor="t" lIns="0" rIns="0" tIns="0" bIns="0">
-            <a:spAutoFit/>
-          </a:bodyPr>
-          <a:lstStyle/>
-          <a:p>
-            <a:pPr algn="l">
-              <a:lnSpc>
-                <a:spcPct val="115000"/>
-              </a:lnSpc>
-              <a:spcAft>
-                <a:spcPts val="0"/>
-              </a:spcAft>
-            </a:pPr>
-            <a:r>
-              <a:rPr sz="750" b="0">
-                <a:solidFill>
-                  <a:srgbClr val="5F6D66"/>
-                </a:solidFill>
-                <a:latin typeface="Instrument Sans"/>
-              </a:rPr>
-              <a:t>NHS England GP Workforce, July 2026</a:t>
-            </a:r>
-          </a:p>
-        </p:txBody>
-      </p:sp>
-      <p:sp>
-        <p:nvSpPr>
-          <p:cNvPr id="34" name="TextBox 33"/>
-          <p:cNvSpPr txBox="1"/>
-          <p:nvPr/>
-        </p:nvSpPr>
-        <p:spPr>
-          <a:xfrm>
-            <a:off x="7579156" y="3593592"/>
-            <a:ext cx="640080" cy="457200"/>
-          </a:xfrm>
-          <a:prstGeom prst="rect">
-            <a:avLst/>
-          </a:prstGeom>
-          <a:noFill/>
-        </p:spPr>
-        <p:txBody>
-          <a:bodyPr wrap="square" anchor="t" lIns="0" rIns="0" tIns="0" bIns="0">
-            <a:spAutoFit/>
-          </a:bodyPr>
-          <a:lstStyle/>
-          <a:p>
-            <a:pPr algn="ctr">
-              <a:lnSpc>
-                <a:spcPct val="115000"/>
-              </a:lnSpc>
-              <a:spcAft>
-                <a:spcPts val="0"/>
-              </a:spcAft>
-            </a:pPr>
-            <a:r>
-              <a:rPr sz="1600" b="1">
-                <a:solidFill>
-                  <a:srgbClr val="6D2E5B"/>
-                </a:solidFill>
-                <a:latin typeface="Bricolage Grotesque"/>
-              </a:rPr>
-              <a:t>=</a:t>
-            </a:r>
-          </a:p>
-        </p:txBody>
-      </p:sp>
-      <p:cxnSp>
-        <p:nvCxnSpPr>
-          <p:cNvPr id="35" name="Connector 34"/>
-          <p:cNvCxnSpPr/>
-          <p:nvPr/>
-        </p:nvCxnSpPr>
-        <p:spPr>
-          <a:xfrm>
-            <a:off x="8219236" y="3429000"/>
-            <a:ext cx="3103778" cy="0"/>
-          </a:xfrm>
-          <a:prstGeom prst="line">
-            <a:avLst/>
-          </a:prstGeom>
-          <a:ln w="28575">
-            <a:solidFill>
-              <a:srgbClr val="6D2E5B"/>
-            </a:solidFill>
-          </a:ln>
-        </p:spPr>
-        <p:style>
-          <a:lnRef idx="2">
-            <a:schemeClr val="accent1"/>
-          </a:lnRef>
-          <a:fillRef idx="0">
-            <a:schemeClr val="accent1"/>
-          </a:fillRef>
-          <a:effectRef idx="1">
-            <a:schemeClr val="accent1"/>
-          </a:effectRef>
-          <a:fontRef idx="minor">
-            <a:schemeClr val="tx1"/>
-          </a:fontRef>
-        </p:style>
-      </p:cxnSp>
-      <p:sp>
-        <p:nvSpPr>
-          <p:cNvPr id="36" name="TextBox 35"/>
-          <p:cNvSpPr txBox="1"/>
-          <p:nvPr/>
-        </p:nvSpPr>
-        <p:spPr>
-          <a:xfrm>
-            <a:off x="8219236" y="3502152"/>
-            <a:ext cx="3103778" cy="502920"/>
-          </a:xfrm>
-          <a:prstGeom prst="rect">
-            <a:avLst/>
-          </a:prstGeom>
-          <a:noFill/>
-        </p:spPr>
-        <p:txBody>
-          <a:bodyPr wrap="square" anchor="t" lIns="0" rIns="0" tIns="0" bIns="0">
-            <a:spAutoFit/>
-          </a:bodyPr>
-          <a:lstStyle/>
-          <a:p>
-            <a:pPr algn="l">
-              <a:lnSpc>
-                <a:spcPct val="115000"/>
-              </a:lnSpc>
-              <a:spcAft>
-                <a:spcPts val="0"/>
-              </a:spcAft>
-            </a:pPr>
-            <a:r>
-              <a:rPr sz="2600" b="1">
-                <a:solidFill>
-                  <a:srgbClr val="6D2E5B"/>
-                </a:solidFill>
-                <a:latin typeface="Bricolage Grotesque"/>
-              </a:rPr>
-              <a:t>35,000</a:t>
-            </a:r>
-            <a:r>
-              <a:rPr sz="1100" b="1">
-                <a:solidFill>
-                  <a:srgbClr val="5F6D66"/>
-                </a:solidFill>
-                <a:latin typeface="Bricolage Grotesque"/>
-              </a:rPr>
-              <a:t/>
-            </a:r>
-          </a:p>
-        </p:txBody>
-      </p:sp>
-      <p:sp>
-        <p:nvSpPr>
-          <p:cNvPr id="37" name="TextBox 36"/>
-          <p:cNvSpPr txBox="1"/>
-          <p:nvPr/>
-        </p:nvSpPr>
-        <p:spPr>
-          <a:xfrm>
-            <a:off x="8219236" y="3995928"/>
-            <a:ext cx="3103778" cy="502920"/>
-          </a:xfrm>
-          <a:prstGeom prst="rect">
-            <a:avLst/>
-          </a:prstGeom>
-          <a:noFill/>
-        </p:spPr>
-        <p:txBody>
-          <a:bodyPr wrap="square" anchor="t" lIns="0" rIns="0" tIns="0" bIns="0">
-            <a:spAutoFit/>
-          </a:bodyPr>
-          <a:lstStyle/>
-          <a:p>
-            <a:pPr algn="l">
-              <a:lnSpc>
-                <a:spcPct val="115000"/>
-              </a:lnSpc>
-              <a:spcAft>
-                <a:spcPts val="0"/>
-              </a:spcAft>
-            </a:pPr>
-            <a:r>
-              <a:rPr sz="950" b="1">
-                <a:solidFill>
-                  <a:srgbClr val="14261F"/>
-                </a:solidFill>
-                <a:latin typeface="Instrument Sans"/>
-              </a:rPr>
-              <a:t>GP-hours every working day</a:t>
-            </a:r>
-            <a:r>
-              <a:rPr sz="950" b="0">
-                <a:solidFill>
-                  <a:srgbClr val="5F6D66"/>
-                </a:solidFill>
-                <a:latin typeface="Instrument Sans"/>
-              </a:rPr>
-              <a:t> on results alone</a:t>
-            </a:r>
-          </a:p>
-        </p:txBody>
-      </p:sp>
-      <p:sp>
-        <p:nvSpPr>
-          <p:cNvPr id="38" name="TextBox 37"/>
-          <p:cNvSpPr txBox="1"/>
-          <p:nvPr/>
-        </p:nvSpPr>
-        <p:spPr>
-          <a:xfrm>
-            <a:off x="8219236" y="4480560"/>
-            <a:ext cx="3103778" cy="274320"/>
-          </a:xfrm>
-          <a:prstGeom prst="rect">
-            <a:avLst/>
-          </a:prstGeom>
-          <a:noFill/>
-        </p:spPr>
-        <p:txBody>
-          <a:bodyPr wrap="square" anchor="t" lIns="0" rIns="0" tIns="0" bIns="0">
-            <a:spAutoFit/>
-          </a:bodyPr>
-          <a:lstStyle/>
-          <a:p>
-            <a:pPr algn="l">
-              <a:lnSpc>
-                <a:spcPct val="115000"/>
-              </a:lnSpc>
-              <a:spcAft>
-                <a:spcPts val="0"/>
-              </a:spcAft>
-            </a:pPr>
-            <a:r>
-              <a:rPr sz="700" b="1">
-                <a:solidFill>
-                  <a:srgbClr val="7A520C"/>
-                </a:solidFill>
-                <a:latin typeface="Instrument Sans"/>
-              </a:rPr>
-              <a:t>EXTRAPOLATED  </a:t>
-            </a:r>
-            <a:r>
-              <a:rPr sz="750" b="0">
-                <a:solidFill>
-                  <a:srgbClr val="5F6D66"/>
-                </a:solidFill>
-                <a:latin typeface="Instrument Sans"/>
-              </a:rPr>
-              <a:t/>
-            </a:r>
-          </a:p>
-        </p:txBody>
-      </p:sp>
-      <p:sp>
-        <p:nvSpPr>
-          <p:cNvPr id="39" name="TextBox 38"/>
-          <p:cNvSpPr txBox="1"/>
-          <p:nvPr/>
-        </p:nvSpPr>
-        <p:spPr>
-          <a:xfrm>
-            <a:off x="731520" y="4846320"/>
-            <a:ext cx="7315200" cy="256032"/>
-          </a:xfrm>
-          <a:prstGeom prst="rect">
-            <a:avLst/>
-          </a:prstGeom>
-          <a:noFill/>
-        </p:spPr>
-        <p:txBody>
-          <a:bodyPr wrap="square" anchor="t" lIns="0" rIns="0" tIns="0" bIns="0">
-            <a:spAutoFit/>
-          </a:bodyPr>
-          <a:lstStyle/>
-          <a:p>
-            <a:pPr algn="l">
-              <a:lnSpc>
-                <a:spcPct val="115000"/>
-              </a:lnSpc>
-              <a:spcAft>
-                <a:spcPts val="0"/>
-              </a:spcAft>
-            </a:pPr>
-            <a:r>
-              <a:rPr sz="800" b="1">
-                <a:solidFill>
-                  <a:srgbClr val="6D2E5B"/>
-                </a:solidFill>
-                <a:latin typeface="Instrument Sans"/>
-              </a:rPr>
-              <a:t>AND WHEN ONE SLIPS</a:t>
-            </a:r>
-          </a:p>
-        </p:txBody>
-      </p:sp>
-      <p:cxnSp>
-        <p:nvCxnSpPr>
-          <p:cNvPr id="40" name="Connector 39"/>
-          <p:cNvCxnSpPr/>
-          <p:nvPr/>
-        </p:nvCxnSpPr>
-        <p:spPr>
-          <a:xfrm>
-            <a:off x="731520" y="5120640"/>
-            <a:ext cx="3103778" cy="0"/>
-          </a:xfrm>
-          <a:prstGeom prst="line">
-            <a:avLst/>
-          </a:prstGeom>
-          <a:ln w="28575">
-            <a:solidFill>
-              <a:srgbClr val="D8DED9"/>
-            </a:solidFill>
-          </a:ln>
-        </p:spPr>
-        <p:style>
-          <a:lnRef idx="2">
-            <a:schemeClr val="accent1"/>
-          </a:lnRef>
-          <a:fillRef idx="0">
-            <a:schemeClr val="accent1"/>
-          </a:fillRef>
-          <a:effectRef idx="1">
-            <a:schemeClr val="accent1"/>
-          </a:effectRef>
-          <a:fontRef idx="minor">
-            <a:schemeClr val="tx1"/>
-          </a:fontRef>
-        </p:style>
-      </p:cxnSp>
-      <p:sp>
-        <p:nvSpPr>
-          <p:cNvPr id="41" name="TextBox 40"/>
-          <p:cNvSpPr txBox="1"/>
-          <p:nvPr/>
-        </p:nvSpPr>
-        <p:spPr>
-          <a:xfrm>
-            <a:off x="731520" y="5193792"/>
-            <a:ext cx="3103778" cy="502920"/>
-          </a:xfrm>
-          <a:prstGeom prst="rect">
-            <a:avLst/>
-          </a:prstGeom>
-          <a:noFill/>
-        </p:spPr>
-        <p:txBody>
-          <a:bodyPr wrap="square" anchor="t" lIns="0" rIns="0" tIns="0" bIns="0">
-            <a:spAutoFit/>
-          </a:bodyPr>
-          <a:lstStyle/>
-          <a:p>
-            <a:pPr algn="l">
-              <a:lnSpc>
-                <a:spcPct val="115000"/>
-              </a:lnSpc>
-              <a:spcAft>
-                <a:spcPts val="0"/>
-              </a:spcAft>
-            </a:pPr>
-            <a:r>
-              <a:rPr sz="2600" b="1">
-                <a:solidFill>
-                  <a:srgbClr val="14261F"/>
-                </a:solidFill>
-                <a:latin typeface="Bricolage Grotesque"/>
-              </a:rPr>
-              <a:t>41</a:t>
-            </a:r>
-            <a:r>
-              <a:rPr sz="1100" b="1">
-                <a:solidFill>
-                  <a:srgbClr val="5F6D66"/>
-                </a:solidFill>
-                <a:latin typeface="Bricolage Grotesque"/>
-              </a:rPr>
-              <a:t/>
-            </a:r>
-          </a:p>
-        </p:txBody>
-      </p:sp>
-      <p:sp>
-        <p:nvSpPr>
-          <p:cNvPr id="42" name="TextBox 41"/>
-          <p:cNvSpPr txBox="1"/>
-          <p:nvPr/>
-        </p:nvSpPr>
-        <p:spPr>
-          <a:xfrm>
-            <a:off x="731520" y="5687568"/>
-            <a:ext cx="3103778" cy="502920"/>
-          </a:xfrm>
-          <a:prstGeom prst="rect">
-            <a:avLst/>
-          </a:prstGeom>
-          <a:noFill/>
-        </p:spPr>
-        <p:txBody>
-          <a:bodyPr wrap="square" anchor="t" lIns="0" rIns="0" tIns="0" bIns="0">
-            <a:spAutoFit/>
-          </a:bodyPr>
-          <a:lstStyle/>
-          <a:p>
-            <a:pPr algn="l">
-              <a:lnSpc>
-                <a:spcPct val="115000"/>
-              </a:lnSpc>
-              <a:spcAft>
-                <a:spcPts val="0"/>
-              </a:spcAft>
-            </a:pPr>
-            <a:r>
-              <a:rPr sz="950" b="1">
-                <a:solidFill>
-                  <a:srgbClr val="14261F"/>
-                </a:solidFill>
-                <a:latin typeface="Instrument Sans"/>
-              </a:rPr>
-              <a:t>serious incidents in 13 months</a:t>
-            </a:r>
-            <a:r>
-              <a:rPr sz="950" b="0">
-                <a:solidFill>
-                  <a:srgbClr val="5F6D66"/>
-                </a:solidFill>
-                <a:latin typeface="Instrument Sans"/>
-              </a:rPr>
-              <a:t> from uncommunicated results, one a 45 mm lung mass</a:t>
-            </a:r>
-          </a:p>
-        </p:txBody>
-      </p:sp>
-      <p:sp>
-        <p:nvSpPr>
-          <p:cNvPr id="43" name="TextBox 42"/>
-          <p:cNvSpPr txBox="1"/>
-          <p:nvPr/>
-        </p:nvSpPr>
-        <p:spPr>
-          <a:xfrm>
-            <a:off x="731520" y="6172200"/>
-            <a:ext cx="3103778" cy="274320"/>
-          </a:xfrm>
-          <a:prstGeom prst="rect">
-            <a:avLst/>
-          </a:prstGeom>
-          <a:noFill/>
-        </p:spPr>
-        <p:txBody>
-          <a:bodyPr wrap="square" anchor="t" lIns="0" rIns="0" tIns="0" bIns="0">
-            <a:spAutoFit/>
-          </a:bodyPr>
-          <a:lstStyle/>
-          <a:p>
-            <a:pPr algn="l">
-              <a:lnSpc>
-                <a:spcPct val="115000"/>
-              </a:lnSpc>
-              <a:spcAft>
-                <a:spcPts val="0"/>
-              </a:spcAft>
-            </a:pPr>
-            <a:r>
-              <a:rPr sz="750" b="0">
-                <a:solidFill>
-                  <a:srgbClr val="5F6D66"/>
-                </a:solidFill>
-                <a:latin typeface="Instrument Sans"/>
-              </a:rPr>
-              <a:t>HSIB, 2019</a:t>
-            </a:r>
-          </a:p>
-        </p:txBody>
-      </p:sp>
-      <p:sp>
-        <p:nvSpPr>
-          <p:cNvPr id="44" name="TextBox 43"/>
-          <p:cNvSpPr txBox="1"/>
-          <p:nvPr/>
-        </p:nvSpPr>
-        <p:spPr>
-          <a:xfrm>
-            <a:off x="3835298" y="5285232"/>
-            <a:ext cx="640080" cy="457200"/>
-          </a:xfrm>
-          <a:prstGeom prst="rect">
-            <a:avLst/>
-          </a:prstGeom>
-          <a:noFill/>
-        </p:spPr>
-        <p:txBody>
-          <a:bodyPr wrap="square" anchor="t" lIns="0" rIns="0" tIns="0" bIns="0">
-            <a:spAutoFit/>
-          </a:bodyPr>
-          <a:lstStyle/>
-          <a:p>
-            <a:pPr algn="ctr">
-              <a:lnSpc>
-                <a:spcPct val="115000"/>
-              </a:lnSpc>
-              <a:spcAft>
-                <a:spcPts val="0"/>
-              </a:spcAft>
-            </a:pPr>
-            <a:r>
-              <a:rPr sz="1600" b="1">
-                <a:solidFill>
-                  <a:srgbClr val="6D2E5B"/>
-                </a:solidFill>
-                <a:latin typeface="Bricolage Grotesque"/>
-              </a:rPr>
-              <a:t/>
-            </a:r>
-          </a:p>
-        </p:txBody>
-      </p:sp>
-      <p:cxnSp>
-        <p:nvCxnSpPr>
-          <p:cNvPr id="45" name="Connector 44"/>
-          <p:cNvCxnSpPr/>
-          <p:nvPr/>
-        </p:nvCxnSpPr>
-        <p:spPr>
-          <a:xfrm>
-            <a:off x="4475378" y="5120640"/>
-            <a:ext cx="3103778" cy="0"/>
-          </a:xfrm>
-          <a:prstGeom prst="line">
-            <a:avLst/>
-          </a:prstGeom>
-          <a:ln w="28575">
-            <a:solidFill>
-              <a:srgbClr val="D8DED9"/>
-            </a:solidFill>
-          </a:ln>
-        </p:spPr>
-        <p:style>
-          <a:lnRef idx="2">
-            <a:schemeClr val="accent1"/>
-          </a:lnRef>
-          <a:fillRef idx="0">
-            <a:schemeClr val="accent1"/>
-          </a:fillRef>
-          <a:effectRef idx="1">
-            <a:schemeClr val="accent1"/>
-          </a:effectRef>
-          <a:fontRef idx="minor">
-            <a:schemeClr val="tx1"/>
-          </a:fontRef>
-        </p:style>
-      </p:cxnSp>
-      <p:sp>
-        <p:nvSpPr>
-          <p:cNvPr id="46" name="TextBox 45"/>
-          <p:cNvSpPr txBox="1"/>
-          <p:nvPr/>
-        </p:nvSpPr>
-        <p:spPr>
-          <a:xfrm>
-            <a:off x="4475378" y="5193792"/>
-            <a:ext cx="3103778" cy="502920"/>
-          </a:xfrm>
-          <a:prstGeom prst="rect">
-            <a:avLst/>
-          </a:prstGeom>
-          <a:noFill/>
-        </p:spPr>
-        <p:txBody>
-          <a:bodyPr wrap="square" anchor="t" lIns="0" rIns="0" tIns="0" bIns="0">
-            <a:spAutoFit/>
-          </a:bodyPr>
-          <a:lstStyle/>
-          <a:p>
-            <a:pPr algn="l">
-              <a:lnSpc>
-                <a:spcPct val="115000"/>
-              </a:lnSpc>
-              <a:spcAft>
-                <a:spcPts val="0"/>
-              </a:spcAft>
-            </a:pPr>
-            <a:r>
-              <a:rPr sz="2600" b="1">
-                <a:solidFill>
-                  <a:srgbClr val="14261F"/>
-                </a:solidFill>
-                <a:latin typeface="Bricolage Grotesque"/>
-              </a:rPr>
-              <a:t>1</a:t>
-            </a:r>
-            <a:r>
-              <a:rPr sz="1100" b="1">
-                <a:solidFill>
-                  <a:srgbClr val="5F6D66"/>
-                </a:solidFill>
-                <a:latin typeface="Bricolage Grotesque"/>
-              </a:rPr>
-              <a:t> reading</a:t>
-            </a:r>
-          </a:p>
-        </p:txBody>
-      </p:sp>
-      <p:sp>
-        <p:nvSpPr>
-          <p:cNvPr id="47" name="TextBox 46"/>
-          <p:cNvSpPr txBox="1"/>
-          <p:nvPr/>
-        </p:nvSpPr>
-        <p:spPr>
-          <a:xfrm>
-            <a:off x="4475378" y="5687568"/>
-            <a:ext cx="3103778" cy="502920"/>
-          </a:xfrm>
-          <a:prstGeom prst="rect">
-            <a:avLst/>
-          </a:prstGeom>
-          <a:noFill/>
-        </p:spPr>
-        <p:txBody>
-          <a:bodyPr wrap="square" anchor="t" lIns="0" rIns="0" tIns="0" bIns="0">
-            <a:spAutoFit/>
-          </a:bodyPr>
-          <a:lstStyle/>
-          <a:p>
-            <a:pPr algn="l">
-              <a:lnSpc>
-                <a:spcPct val="115000"/>
-              </a:lnSpc>
-              <a:spcAft>
-                <a:spcPts val="0"/>
-              </a:spcAft>
-            </a:pPr>
-            <a:r>
-              <a:rPr sz="950" b="0">
-                <a:solidFill>
-                  <a:srgbClr val="5F6D66"/>
-                </a:solidFill>
-                <a:latin typeface="Instrument Sans"/>
-              </a:rPr>
-              <a:t>cannot show decline. </a:t>
-            </a:r>
-            <a:r>
-              <a:rPr sz="950" b="1">
-                <a:solidFill>
-                  <a:srgbClr val="14261F"/>
-                </a:solidFill>
-                <a:latin typeface="Instrument Sans"/>
-              </a:rPr>
-              <a:t>The trajectory can</a:t>
-            </a:r>
-            <a:r>
-              <a:rPr sz="950" b="0">
-                <a:solidFill>
-                  <a:srgbClr val="5F6D66"/>
-                </a:solidFill>
-                <a:latin typeface="Instrument Sans"/>
-              </a:rPr>
-              <a:t>, and every GP system already holds it.</a:t>
-            </a:r>
-          </a:p>
-        </p:txBody>
-      </p:sp>
-      <p:sp>
-        <p:nvSpPr>
-          <p:cNvPr id="48" name="TextBox 47"/>
-          <p:cNvSpPr txBox="1"/>
-          <p:nvPr/>
-        </p:nvSpPr>
-        <p:spPr>
-          <a:xfrm>
-            <a:off x="4475378" y="6172200"/>
-            <a:ext cx="3103778" cy="274320"/>
-          </a:xfrm>
-          <a:prstGeom prst="rect">
-            <a:avLst/>
-          </a:prstGeom>
-          <a:noFill/>
-        </p:spPr>
-        <p:txBody>
-          <a:bodyPr wrap="square" anchor="t" lIns="0" rIns="0" tIns="0" bIns="0">
-            <a:spAutoFit/>
-          </a:bodyPr>
-          <a:lstStyle/>
-          <a:p>
-            <a:pPr algn="l">
-              <a:lnSpc>
-                <a:spcPct val="115000"/>
-              </a:lnSpc>
-              <a:spcAft>
-                <a:spcPts val="0"/>
-              </a:spcAft>
-            </a:pPr>
-            <a:r>
-              <a:rPr sz="750" b="0">
-                <a:solidFill>
-                  <a:srgbClr val="5F6D66"/>
-                </a:solidFill>
-                <a:latin typeface="Instrument Sans"/>
-              </a:rPr>
-              <a:t>Stow et al., BMC Medicine 2018</a:t>
-            </a:r>
-          </a:p>
-        </p:txBody>
-      </p:sp>
-      <p:sp>
-        <p:nvSpPr>
-          <p:cNvPr id="49" name="TextBox 48"/>
-          <p:cNvSpPr txBox="1"/>
-          <p:nvPr/>
-        </p:nvSpPr>
-        <p:spPr>
-          <a:xfrm>
-            <a:off x="7579156" y="5285232"/>
-            <a:ext cx="640080" cy="457200"/>
-          </a:xfrm>
-          <a:prstGeom prst="rect">
-            <a:avLst/>
-          </a:prstGeom>
-          <a:noFill/>
-        </p:spPr>
-        <p:txBody>
-          <a:bodyPr wrap="square" anchor="t" lIns="0" rIns="0" tIns="0" bIns="0">
-            <a:spAutoFit/>
-          </a:bodyPr>
-          <a:lstStyle/>
-          <a:p>
-            <a:pPr algn="ctr">
-              <a:lnSpc>
-                <a:spcPct val="115000"/>
-              </a:lnSpc>
-              <a:spcAft>
-                <a:spcPts val="0"/>
-              </a:spcAft>
-            </a:pPr>
-            <a:r>
-              <a:rPr sz="1600" b="1">
-                <a:solidFill>
-                  <a:srgbClr val="6D2E5B"/>
-                </a:solidFill>
-                <a:latin typeface="Bricolage Grotesque"/>
-              </a:rPr>
-              <a:t/>
-            </a:r>
-          </a:p>
-        </p:txBody>
-      </p:sp>
-      <p:cxnSp>
-        <p:nvCxnSpPr>
-          <p:cNvPr id="50" name="Connector 49"/>
-          <p:cNvCxnSpPr/>
-          <p:nvPr/>
-        </p:nvCxnSpPr>
-        <p:spPr>
-          <a:xfrm>
-            <a:off x="8219236" y="5120640"/>
-            <a:ext cx="3103778" cy="0"/>
-          </a:xfrm>
-          <a:prstGeom prst="line">
-            <a:avLst/>
-          </a:prstGeom>
-          <a:ln w="28575">
-            <a:solidFill>
-              <a:srgbClr val="D8DED9"/>
-            </a:solidFill>
-          </a:ln>
-        </p:spPr>
-        <p:style>
-          <a:lnRef idx="2">
-            <a:schemeClr val="accent1"/>
-          </a:lnRef>
-          <a:fillRef idx="0">
-            <a:schemeClr val="accent1"/>
-          </a:fillRef>
-          <a:effectRef idx="1">
-            <a:schemeClr val="accent1"/>
-          </a:effectRef>
-          <a:fontRef idx="minor">
-            <a:schemeClr val="tx1"/>
-          </a:fontRef>
-        </p:style>
-      </p:cxnSp>
-      <p:sp>
-        <p:nvSpPr>
-          <p:cNvPr id="51" name="TextBox 50"/>
-          <p:cNvSpPr txBox="1"/>
-          <p:nvPr/>
-        </p:nvSpPr>
-        <p:spPr>
-          <a:xfrm>
-            <a:off x="8219236" y="5193792"/>
-            <a:ext cx="3103778" cy="502920"/>
-          </a:xfrm>
-          <a:prstGeom prst="rect">
-            <a:avLst/>
-          </a:prstGeom>
-          <a:noFill/>
-        </p:spPr>
-        <p:txBody>
-          <a:bodyPr wrap="square" anchor="t" lIns="0" rIns="0" tIns="0" bIns="0">
-            <a:spAutoFit/>
-          </a:bodyPr>
-          <a:lstStyle/>
-          <a:p>
-            <a:pPr algn="l">
-              <a:lnSpc>
-                <a:spcPct val="115000"/>
-              </a:lnSpc>
-              <a:spcAft>
-                <a:spcPts val="0"/>
-              </a:spcAft>
-            </a:pPr>
-            <a:r>
-              <a:rPr sz="2600" b="1">
-                <a:solidFill>
-                  <a:srgbClr val="14261F"/>
-                </a:solidFill>
-                <a:latin typeface="Bricolage Grotesque"/>
-              </a:rPr>
-              <a:t>0.4</a:t>
-            </a:r>
-            <a:r>
-              <a:rPr sz="1100" b="1">
-                <a:solidFill>
-                  <a:srgbClr val="5F6D66"/>
-                </a:solidFill>
-                <a:latin typeface="Bricolage Grotesque"/>
-              </a:rPr>
-              <a:t> %</a:t>
-            </a:r>
-          </a:p>
-        </p:txBody>
-      </p:sp>
-      <p:sp>
-        <p:nvSpPr>
-          <p:cNvPr id="52" name="TextBox 51"/>
-          <p:cNvSpPr txBox="1"/>
-          <p:nvPr/>
-        </p:nvSpPr>
-        <p:spPr>
-          <a:xfrm>
-            <a:off x="8219236" y="5687568"/>
-            <a:ext cx="3103778" cy="502920"/>
-          </a:xfrm>
-          <a:prstGeom prst="rect">
-            <a:avLst/>
-          </a:prstGeom>
-          <a:noFill/>
-        </p:spPr>
-        <p:txBody>
-          <a:bodyPr wrap="square" anchor="t" lIns="0" rIns="0" tIns="0" bIns="0">
-            <a:spAutoFit/>
-          </a:bodyPr>
-          <a:lstStyle/>
-          <a:p>
-            <a:pPr algn="l">
-              <a:lnSpc>
-                <a:spcPct val="115000"/>
-              </a:lnSpc>
-              <a:spcAft>
-                <a:spcPts val="0"/>
-              </a:spcAft>
-            </a:pPr>
-            <a:r>
-              <a:rPr sz="950" b="0">
-                <a:solidFill>
-                  <a:srgbClr val="5F6D66"/>
-                </a:solidFill>
-                <a:latin typeface="Instrument Sans"/>
-              </a:rPr>
-              <a:t>of portal users have shared access for a carer. </a:t>
-            </a:r>
-            <a:r>
-              <a:rPr sz="950" b="1">
-                <a:solidFill>
-                  <a:srgbClr val="14261F"/>
-                </a:solidFill>
-                <a:latin typeface="Instrument Sans"/>
-              </a:rPr>
-              <a:t>5 million carers</a:t>
-            </a:r>
-            <a:r>
-              <a:rPr sz="950" b="0">
-                <a:solidFill>
-                  <a:srgbClr val="5F6D66"/>
-                </a:solidFill>
-                <a:latin typeface="Instrument Sans"/>
-              </a:rPr>
-              <a:t> in England and Wales.</a:t>
-            </a:r>
-          </a:p>
-        </p:txBody>
-      </p:sp>
-      <p:sp>
-        <p:nvSpPr>
-          <p:cNvPr id="53" name="TextBox 52"/>
-          <p:cNvSpPr txBox="1"/>
-          <p:nvPr/>
-        </p:nvSpPr>
-        <p:spPr>
-          <a:xfrm>
-            <a:off x="8219236" y="6172200"/>
-            <a:ext cx="3103778" cy="274320"/>
-          </a:xfrm>
-          <a:prstGeom prst="rect">
-            <a:avLst/>
-          </a:prstGeom>
-          <a:noFill/>
-        </p:spPr>
-        <p:txBody>
-          <a:bodyPr wrap="square" anchor="t" lIns="0" rIns="0" tIns="0" bIns="0">
-            <a:spAutoFit/>
-          </a:bodyPr>
-          <a:lstStyle/>
-          <a:p>
-            <a:pPr algn="l">
-              <a:lnSpc>
-                <a:spcPct val="115000"/>
-              </a:lnSpc>
-              <a:spcAft>
-                <a:spcPts val="0"/>
-              </a:spcAft>
-            </a:pPr>
-            <a:r>
-              <a:rPr sz="750" b="0">
-                <a:solidFill>
-                  <a:srgbClr val="5F6D66"/>
-                </a:solidFill>
-                <a:latin typeface="Instrument Sans"/>
-              </a:rPr>
-              <a:t>Wolff 2016 · Census 2021</a:t>
-            </a:r>
-          </a:p>
-        </p:txBody>
-      </p:sp>
-      <p:sp>
-        <p:nvSpPr>
-          <p:cNvPr id="54" name="TextBox 53"/>
-          <p:cNvSpPr txBox="1"/>
-          <p:nvPr/>
-        </p:nvSpPr>
-        <p:spPr>
-          <a:xfrm>
-            <a:off x="731520" y="6309360"/>
-            <a:ext cx="7863840" cy="365760"/>
-          </a:xfrm>
-          <a:prstGeom prst="rect">
-            <a:avLst/>
-          </a:prstGeom>
-          <a:noFill/>
-        </p:spPr>
-        <p:txBody>
-          <a:bodyPr wrap="square" anchor="b" lIns="0" rIns="0" tIns="0" bIns="0">
-            <a:spAutoFit/>
-          </a:bodyPr>
-          <a:lstStyle/>
-          <a:p>
-            <a:pPr algn="l">
-              <a:lnSpc>
-                <a:spcPct val="115000"/>
-              </a:lnSpc>
-              <a:spcAft>
-                <a:spcPts val="0"/>
-              </a:spcAft>
-            </a:pPr>
-            <a:r>
-              <a:rPr sz="850" b="0">
-                <a:solidFill>
-                  <a:srgbClr val="5F6D66"/>
-                </a:solidFill>
-                <a:latin typeface="Instrument Sans"/>
-              </a:rPr>
-              <a:t>Working for every extrapolated figure is in the speaker notes. 12m × 47% = 5.6m; × 12 = 67.7m. 74 min × 28,426 ÷ 60 = 35,059 hours.</a:t>
-            </a:r>
-          </a:p>
-        </p:txBody>
-      </p:sp>
-      <p:sp>
-        <p:nvSpPr>
-          <p:cNvPr id="55" name="TextBox 54"/>
+              <a:t>12m × 47% × 12 months = 67.7m. 74 min per GP a day (Poon 2004) × 28,426 full-time GPs (NHS England, July 2026) = 35,059 hours. Full working and caveats in the notes.</a:t>
+            </a:r>
+          </a:p>
+        </p:txBody>
+      </p:sp>
+      <p:sp>
+        <p:nvSpPr>
+          <p:cNvPr id="20" name="TextBox 19"/>
           <p:cNvSpPr txBox="1"/>
           <p:nvPr/>
         </p:nvSpPr>

</xml_diff>

<commit_message>
docs(pitch): one short line per cause on the why slide
</commit_message>
<xml_diff>
--- a/pitch/CareCircle-pitch.pptx
+++ b/pitch/CareCircle-pitch.pptx
@@ -5896,7 +5896,7 @@
                 </a:solidFill>
                 <a:latin typeface="Instrument Sans"/>
               </a:rPr>
-              <a:t>Results are reviewed one at a time. No one reads the trend.</a:t>
+              <a:t>Each result is read on its own. Nobody reads the trend.</a:t>
             </a:r>
           </a:p>
         </p:txBody>
@@ -6070,7 +6070,7 @@
                 </a:solidFill>
                 <a:latin typeface="Instrument Sans"/>
               </a:rPr>
-              <a:t>No reliable “patient informed” state exists in the record, and nothing routes a result to the people who need to act.</a:t>
+              <a:t>The record never says whether she was told. Nothing chases it.</a:t>
             </a:r>
           </a:p>
         </p:txBody>
@@ -6244,7 +6244,7 @@
                 </a:solidFill>
                 <a:latin typeface="Instrument Sans"/>
               </a:rPr>
-              <a:t>The App shows the number and says ring your GP; only 51% of adults can find the out-of-range value. Proxy access hands a person the whole record after a practice-led setup, and almost nobody has it.</a:t>
+              <a:t>The App shows a number and says ring your GP. Her family sees nothing.</a:t>
             </a:r>
           </a:p>
         </p:txBody>

</xml_diff>

<commit_message>
docs(pitch): distinct headings for the three causes
</commit_message>
<xml_diff>
--- a/pitch/CareCircle-pitch.pptx
+++ b/pitch/CareCircle-pitch.pptx
@@ -5854,7 +5854,7 @@
                 </a:solidFill>
                 <a:latin typeface="Bricolage Grotesque"/>
               </a:rPr>
-              <a:t>Not seen coming</a:t>
+              <a:t>Blind to the trend</a:t>
             </a:r>
           </a:p>
         </p:txBody>
@@ -6028,7 +6028,7 @@
                 </a:solidFill>
                 <a:latin typeface="Bricolage Grotesque"/>
               </a:rPr>
-              <a:t>Not told</a:t>
+              <a:t>No proof she was told</a:t>
             </a:r>
           </a:p>
         </p:txBody>
@@ -6202,7 +6202,7 @@
                 </a:solidFill>
                 <a:latin typeface="Bricolage Grotesque"/>
               </a:rPr>
-              <a:t>Not understood, locked out</a:t>
+              <a:t>Numbers, not meaning</a:t>
             </a:r>
           </a:p>
         </p:txBody>

</xml_diff>

<commit_message>
docs(pitch): solution slide reduced to the sentence and three pillars
</commit_message>
<xml_diff>
--- a/pitch/CareCircle-pitch.pptx
+++ b/pitch/CareCircle-pitch.pptx
@@ -814,7 +814,7 @@
           <a:p/>
           <a:p>
             <a:r>
-              <a:t>- Not seen coming: Stow 2018 as above ("not effective at identifying individuals"). Eleanor's own record is the illustration: four low white cell counts, each filed as "available", none reviewed together.</a:t>
+              <a:t>- Blind to the trend: Stow 2018 as above ("not effective at identifying individuals"). Eleanor's own record is the illustration: four low white cell counts, each filed as "available", none reviewed together.</a:t>
             </a:r>
           </a:p>
           <a:p>
@@ -910,6 +910,12 @@
           <a:p>
             <a:r>
               <a:t>## Slide 4: The solution (30 seconds)</a:t>
+            </a:r>
+          </a:p>
+          <a:p/>
+          <a:p>
+            <a:r>
+              <a:t>Removed from the slide on 12 Sep evening and kept here to say aloud: the eight-step flow (trend engine reads a year of bloods, flags worsening, result lands or trend flagged, has she been told, held or released, her consent for big news, per-person version, act); "if nobody tells her within three days, the agent raises a GP task and phones her landline"; and "on Eleanor's real values the engine flags her liver trend as worsening and her white cells as watch".</a:t>
             </a:r>
           </a:p>
           <a:p/>
@@ -6409,8 +6415,8 @@
         </p:nvSpPr>
         <p:spPr>
           <a:xfrm>
-            <a:off x="731520" y="731520"/>
-            <a:ext cx="10789920" cy="1280160"/>
+            <a:off x="731520" y="822960"/>
+            <a:ext cx="10058400" cy="1463040"/>
           </a:xfrm>
           <a:prstGeom prst="rect">
             <a:avLst/>
@@ -6425,14 +6431,14 @@
           <a:p>
             <a:pPr algn="l">
               <a:lnSpc>
-                <a:spcPct val="105000"/>
+                <a:spcPct val="110000"/>
               </a:lnSpc>
               <a:spcAft>
                 <a:spcPts val="0"/>
               </a:spcAft>
             </a:pPr>
             <a:r>
-              <a:rPr sz="2200" b="1">
+              <a:rPr sz="3000" b="1">
                 <a:solidFill>
                   <a:srgbClr val="14261F"/>
                 </a:solidFill>
@@ -6441,7 +6447,7 @@
               <a:t>CareCircle turns every result into the right explanation and next action for every trusted person, </a:t>
             </a:r>
             <a:r>
-              <a:rPr sz="2200" b="1">
+              <a:rPr sz="3000" b="1">
                 <a:solidFill>
                   <a:srgbClr val="6D2E5B"/>
                 </a:solidFill>
@@ -6460,8 +6466,8 @@
         </p:nvSpPr>
         <p:spPr>
           <a:xfrm>
-            <a:off x="731520" y="2148840"/>
-            <a:ext cx="3423818" cy="1325880"/>
+            <a:off x="731520" y="2834640"/>
+            <a:ext cx="3362858" cy="2194560"/>
           </a:xfrm>
           <a:prstGeom prst="roundRect">
             <a:avLst>
@@ -6508,8 +6514,8 @@
         </p:nvSpPr>
         <p:spPr>
           <a:xfrm>
-            <a:off x="841248" y="2148840"/>
-            <a:ext cx="3204362" cy="38100"/>
+            <a:off x="841248" y="2834640"/>
+            <a:ext cx="3143402" cy="38100"/>
           </a:xfrm>
           <a:prstGeom prst="rect">
             <a:avLst/>
@@ -6552,8 +6558,8 @@
         </p:nvSpPr>
         <p:spPr>
           <a:xfrm>
-            <a:off x="960120" y="2313432"/>
-            <a:ext cx="2966618" cy="502920"/>
+            <a:off x="1051560" y="3108960"/>
+            <a:ext cx="2722778" cy="731520"/>
           </a:xfrm>
           <a:prstGeom prst="rect">
             <a:avLst/>
@@ -6568,14 +6574,14 @@
           <a:p>
             <a:pPr algn="l">
               <a:lnSpc>
-                <a:spcPct val="105000"/>
+                <a:spcPct val="115000"/>
               </a:lnSpc>
               <a:spcAft>
                 <a:spcPts val="0"/>
               </a:spcAft>
             </a:pPr>
             <a:r>
-              <a:rPr sz="1200" b="1">
+              <a:rPr sz="1700" b="1">
                 <a:solidFill>
                   <a:srgbClr val="C2572F"/>
                 </a:solidFill>
@@ -6594,8 +6600,8 @@
         </p:nvSpPr>
         <p:spPr>
           <a:xfrm>
-            <a:off x="960120" y="2862072"/>
-            <a:ext cx="2966618" cy="548640"/>
+            <a:off x="1051560" y="3840480"/>
+            <a:ext cx="2722778" cy="1097280"/>
           </a:xfrm>
           <a:prstGeom prst="rect">
             <a:avLst/>
@@ -6610,20 +6616,20 @@
           <a:p>
             <a:pPr algn="l">
               <a:lnSpc>
-                <a:spcPct val="120000"/>
+                <a:spcPct val="130000"/>
               </a:lnSpc>
               <a:spcAft>
                 <a:spcPts val="0"/>
               </a:spcAft>
             </a:pPr>
             <a:r>
-              <a:rPr sz="1000" b="0">
+              <a:rPr sz="1300" b="0">
                 <a:solidFill>
                   <a:srgbClr val="5F6D66"/>
                 </a:solidFill>
                 <a:latin typeface="Instrument Sans"/>
               </a:rPr>
-              <a:t>Proactive, longitudinal. A year of bloods and a week of watch data become improving, watch, worsening, on the Home boxes and a nine-system Body view.</a:t>
+              <a:t>Reads the whole trend, not one result.</a:t>
             </a:r>
           </a:p>
         </p:txBody>
@@ -6636,8 +6642,8 @@
         </p:nvSpPr>
         <p:spPr>
           <a:xfrm>
-            <a:off x="4383938" y="2148840"/>
-            <a:ext cx="3423818" cy="1325880"/>
+            <a:off x="4414418" y="2834640"/>
+            <a:ext cx="3362858" cy="2194560"/>
           </a:xfrm>
           <a:prstGeom prst="roundRect">
             <a:avLst>
@@ -6684,8 +6690,8 @@
         </p:nvSpPr>
         <p:spPr>
           <a:xfrm>
-            <a:off x="4493666" y="2148840"/>
-            <a:ext cx="3204362" cy="38100"/>
+            <a:off x="4524146" y="2834640"/>
+            <a:ext cx="3143402" cy="38100"/>
           </a:xfrm>
           <a:prstGeom prst="rect">
             <a:avLst/>
@@ -6728,8 +6734,8 @@
         </p:nvSpPr>
         <p:spPr>
           <a:xfrm>
-            <a:off x="4612538" y="2313432"/>
-            <a:ext cx="2966618" cy="502920"/>
+            <a:off x="4734458" y="3108960"/>
+            <a:ext cx="2722778" cy="731520"/>
           </a:xfrm>
           <a:prstGeom prst="rect">
             <a:avLst/>
@@ -6744,14 +6750,14 @@
           <a:p>
             <a:pPr algn="l">
               <a:lnSpc>
-                <a:spcPct val="105000"/>
+                <a:spcPct val="115000"/>
               </a:lnSpc>
               <a:spcAft>
                 <a:spcPts val="0"/>
               </a:spcAft>
             </a:pPr>
             <a:r>
-              <a:rPr sz="1200" b="1">
+              <a:rPr sz="1700" b="1">
                 <a:solidFill>
                   <a:srgbClr val="7A520C"/>
                 </a:solidFill>
@@ -6770,8 +6776,8 @@
         </p:nvSpPr>
         <p:spPr>
           <a:xfrm>
-            <a:off x="4612538" y="2862072"/>
-            <a:ext cx="2966618" cy="548640"/>
+            <a:off x="4734458" y="3840480"/>
+            <a:ext cx="2722778" cy="1097280"/>
           </a:xfrm>
           <a:prstGeom prst="rect">
             <a:avLst/>
@@ -6786,20 +6792,20 @@
           <a:p>
             <a:pPr algn="l">
               <a:lnSpc>
-                <a:spcPct val="120000"/>
+                <a:spcPct val="130000"/>
               </a:lnSpc>
               <a:spcAft>
                 <a:spcPts val="0"/>
               </a:spcAft>
             </a:pPr>
             <a:r>
-              <a:rPr sz="1000" b="0">
+              <a:rPr sz="1300" b="0">
                 <a:solidFill>
                   <a:srgbClr val="5F6D66"/>
                 </a:solidFill>
                 <a:latin typeface="Instrument Sans"/>
               </a:rPr>
-              <a:t>Transparency. The disclosure gate: nothing goes to the family until she has been told.</a:t>
+              <a:t>Nothing reaches the family until she has been told and says yes.</a:t>
             </a:r>
           </a:p>
         </p:txBody>
@@ -6812,8 +6818,8 @@
         </p:nvSpPr>
         <p:spPr>
           <a:xfrm>
-            <a:off x="8036356" y="2148840"/>
-            <a:ext cx="3423818" cy="1325880"/>
+            <a:off x="8097316" y="2834640"/>
+            <a:ext cx="3362858" cy="2194560"/>
           </a:xfrm>
           <a:prstGeom prst="roundRect">
             <a:avLst>
@@ -6860,8 +6866,8 @@
         </p:nvSpPr>
         <p:spPr>
           <a:xfrm>
-            <a:off x="8146084" y="2148840"/>
-            <a:ext cx="3204362" cy="38100"/>
+            <a:off x="8207044" y="2834640"/>
+            <a:ext cx="3143402" cy="38100"/>
           </a:xfrm>
           <a:prstGeom prst="rect">
             <a:avLst/>
@@ -6904,136 +6910,8 @@
         </p:nvSpPr>
         <p:spPr>
           <a:xfrm>
-            <a:off x="8264956" y="2313432"/>
-            <a:ext cx="2966618" cy="502920"/>
-          </a:xfrm>
-          <a:prstGeom prst="rect">
-            <a:avLst/>
-          </a:prstGeom>
-          <a:noFill/>
-        </p:spPr>
-        <p:txBody>
-          <a:bodyPr wrap="square" anchor="t" lIns="0" rIns="0" tIns="0" bIns="0">
-            <a:spAutoFit/>
-          </a:bodyPr>
-          <a:lstStyle/>
-          <a:p>
-            <a:pPr algn="l">
-              <a:lnSpc>
-                <a:spcPct val="105000"/>
-              </a:lnSpc>
-              <a:spcAft>
-                <a:spcPts val="0"/>
-              </a:spcAft>
-            </a:pPr>
-            <a:r>
-              <a:rPr sz="1200" b="1">
-                <a:solidFill>
-                  <a:srgbClr val="6D2E5B"/>
-                </a:solidFill>
-                <a:latin typeface="Bricolage Grotesque"/>
-              </a:rPr>
-              <a:t>3. Tells the right people the right way</a:t>
-            </a:r>
-          </a:p>
-        </p:txBody>
-      </p:sp>
-      <p:sp>
-        <p:nvSpPr>
-          <p:cNvPr id="15" name="TextBox 14"/>
-          <p:cNvSpPr txBox="1"/>
-          <p:nvPr/>
-        </p:nvSpPr>
-        <p:spPr>
-          <a:xfrm>
-            <a:off x="8264956" y="2862072"/>
-            <a:ext cx="2966618" cy="548640"/>
-          </a:xfrm>
-          <a:prstGeom prst="rect">
-            <a:avLst/>
-          </a:prstGeom>
-          <a:noFill/>
-        </p:spPr>
-        <p:txBody>
-          <a:bodyPr wrap="square" anchor="t" lIns="0" rIns="0" tIns="0" bIns="0">
-            <a:spAutoFit/>
-          </a:bodyPr>
-          <a:lstStyle/>
-          <a:p>
-            <a:pPr algn="l">
-              <a:lnSpc>
-                <a:spcPct val="120000"/>
-              </a:lnSpc>
-              <a:spcAft>
-                <a:spcPts val="0"/>
-              </a:spcAft>
-            </a:pPr>
-            <a:r>
-              <a:rPr sz="1000" b="0">
-                <a:solidFill>
-                  <a:srgbClr val="5F6D66"/>
-                </a:solidFill>
-                <a:latin typeface="Instrument Sans"/>
-              </a:rPr>
-              <a:t>Consent. Three levels over six record categories, enforced in every tool call, a version per person.</a:t>
-            </a:r>
-          </a:p>
-        </p:txBody>
-      </p:sp>
-      <p:sp>
-        <p:nvSpPr>
-          <p:cNvPr id="16" name="Rectangle 15"/>
-          <p:cNvSpPr/>
-          <p:nvPr/>
-        </p:nvSpPr>
-        <p:spPr>
-          <a:xfrm>
-            <a:off x="731520" y="3749039"/>
-            <a:ext cx="1181061" cy="38100"/>
-          </a:xfrm>
-          <a:prstGeom prst="rect">
-            <a:avLst/>
-          </a:prstGeom>
-          <a:solidFill>
-            <a:srgbClr val="C2572F"/>
-          </a:solidFill>
-          <a:ln>
-            <a:noFill/>
-          </a:ln>
-          <a:effectLst/>
-        </p:spPr>
-        <p:style>
-          <a:lnRef idx="1">
-            <a:schemeClr val="accent1"/>
-          </a:lnRef>
-          <a:fillRef idx="3">
-            <a:schemeClr val="accent1"/>
-          </a:fillRef>
-          <a:effectRef idx="2">
-            <a:schemeClr val="accent1"/>
-          </a:effectRef>
-          <a:fontRef idx="minor">
-            <a:schemeClr val="lt1"/>
-          </a:fontRef>
-        </p:style>
-        <p:txBody>
-          <a:bodyPr rtlCol="0" anchor="ctr"/>
-          <a:lstStyle/>
-          <a:p>
-            <a:pPr algn="ctr"/>
-          </a:p>
-        </p:txBody>
-      </p:sp>
-      <p:sp>
-        <p:nvSpPr>
-          <p:cNvPr id="17" name="TextBox 16"/>
-          <p:cNvSpPr txBox="1"/>
-          <p:nvPr/>
-        </p:nvSpPr>
-        <p:spPr>
-          <a:xfrm>
-            <a:off x="731520" y="3858767"/>
-            <a:ext cx="1181061" cy="502920"/>
+            <a:off x="8417356" y="3108960"/>
+            <a:ext cx="2722778" cy="731520"/>
           </a:xfrm>
           <a:prstGeom prst="rect">
             <a:avLst/>
@@ -7055,27 +6933,27 @@
               </a:spcAft>
             </a:pPr>
             <a:r>
-              <a:rPr sz="1150" b="1">
-                <a:solidFill>
-                  <a:srgbClr val="C2572F"/>
+              <a:rPr sz="1700" b="1">
+                <a:solidFill>
+                  <a:srgbClr val="6D2E5B"/>
                 </a:solidFill>
                 <a:latin typeface="Bricolage Grotesque"/>
               </a:rPr>
-              <a:t>Trend engine</a:t>
-            </a:r>
-          </a:p>
-        </p:txBody>
-      </p:sp>
-      <p:sp>
-        <p:nvSpPr>
-          <p:cNvPr id="18" name="TextBox 17"/>
+              <a:t>3. Tells the right people the right way</a:t>
+            </a:r>
+          </a:p>
+        </p:txBody>
+      </p:sp>
+      <p:sp>
+        <p:nvSpPr>
+          <p:cNvPr id="15" name="TextBox 14"/>
           <p:cNvSpPr txBox="1"/>
           <p:nvPr/>
         </p:nvSpPr>
         <p:spPr>
           <a:xfrm>
-            <a:off x="731520" y="4315967"/>
-            <a:ext cx="1181061" cy="640080"/>
+            <a:off x="8417356" y="3840480"/>
+            <a:ext cx="2722778" cy="1097280"/>
           </a:xfrm>
           <a:prstGeom prst="rect">
             <a:avLst/>
@@ -7090,34 +6968,34 @@
           <a:p>
             <a:pPr algn="l">
               <a:lnSpc>
-                <a:spcPct val="120000"/>
+                <a:spcPct val="130000"/>
               </a:lnSpc>
               <a:spcAft>
                 <a:spcPts val="0"/>
               </a:spcAft>
             </a:pPr>
             <a:r>
-              <a:rPr sz="950" b="0">
+              <a:rPr sz="1300" b="0">
                 <a:solidFill>
                   <a:srgbClr val="5F6D66"/>
                 </a:solidFill>
                 <a:latin typeface="Instrument Sans"/>
               </a:rPr>
-              <a:t>reads a year of bloods</a:t>
-            </a:r>
-          </a:p>
-        </p:txBody>
-      </p:sp>
-      <p:sp>
-        <p:nvSpPr>
-          <p:cNvPr id="19" name="TextBox 18"/>
+              <a:t>Daughter gets the numbers. Husband gets the lift to arrange. Son gets a yes or no.</a:t>
+            </a:r>
+          </a:p>
+        </p:txBody>
+      </p:sp>
+      <p:sp>
+        <p:nvSpPr>
+          <p:cNvPr id="16" name="TextBox 15"/>
           <p:cNvSpPr txBox="1"/>
           <p:nvPr/>
         </p:nvSpPr>
         <p:spPr>
           <a:xfrm>
-            <a:off x="1921725" y="3822191"/>
-            <a:ext cx="182880" cy="274320"/>
+            <a:off x="731520" y="6309360"/>
+            <a:ext cx="7863840" cy="365760"/>
           </a:xfrm>
           <a:prstGeom prst="rect">
             <a:avLst/>
@@ -7125,7 +7003,7 @@
           <a:noFill/>
         </p:spPr>
         <p:txBody>
-          <a:bodyPr wrap="square" anchor="t" lIns="0" rIns="0" tIns="0" bIns="0">
+          <a:bodyPr wrap="square" anchor="b" lIns="0" rIns="0" tIns="0" bIns="0">
             <a:spAutoFit/>
           </a:bodyPr>
           <a:lstStyle/>
@@ -7139,1308 +7017,12 @@
               </a:spcAft>
             </a:pPr>
             <a:r>
-              <a:rPr sz="1000" b="0">
-                <a:solidFill>
-                  <a:srgbClr val="D8DED9"/>
+              <a:rPr sz="850" b="0">
+                <a:solidFill>
+                  <a:srgbClr val="5F6D66"/>
                 </a:solidFill>
                 <a:latin typeface="Instrument Sans"/>
               </a:rPr>
-              <a:t>→</a:t>
-            </a:r>
-          </a:p>
-        </p:txBody>
-      </p:sp>
-      <p:sp>
-        <p:nvSpPr>
-          <p:cNvPr id="20" name="Rectangle 19"/>
-          <p:cNvSpPr/>
-          <p:nvPr/>
-        </p:nvSpPr>
-        <p:spPr>
-          <a:xfrm>
-            <a:off x="2095461" y="3749039"/>
-            <a:ext cx="1181061" cy="38100"/>
-          </a:xfrm>
-          <a:prstGeom prst="rect">
-            <a:avLst/>
-          </a:prstGeom>
-          <a:solidFill>
-            <a:srgbClr val="C2572F"/>
-          </a:solidFill>
-          <a:ln>
-            <a:noFill/>
-          </a:ln>
-          <a:effectLst/>
-        </p:spPr>
-        <p:style>
-          <a:lnRef idx="1">
-            <a:schemeClr val="accent1"/>
-          </a:lnRef>
-          <a:fillRef idx="3">
-            <a:schemeClr val="accent1"/>
-          </a:fillRef>
-          <a:effectRef idx="2">
-            <a:schemeClr val="accent1"/>
-          </a:effectRef>
-          <a:fontRef idx="minor">
-            <a:schemeClr val="lt1"/>
-          </a:fontRef>
-        </p:style>
-        <p:txBody>
-          <a:bodyPr rtlCol="0" anchor="ctr"/>
-          <a:lstStyle/>
-          <a:p>
-            <a:pPr algn="ctr"/>
-          </a:p>
-        </p:txBody>
-      </p:sp>
-      <p:sp>
-        <p:nvSpPr>
-          <p:cNvPr id="21" name="TextBox 20"/>
-          <p:cNvSpPr txBox="1"/>
-          <p:nvPr/>
-        </p:nvSpPr>
-        <p:spPr>
-          <a:xfrm>
-            <a:off x="2095461" y="3858767"/>
-            <a:ext cx="1181061" cy="502920"/>
-          </a:xfrm>
-          <a:prstGeom prst="rect">
-            <a:avLst/>
-          </a:prstGeom>
-          <a:noFill/>
-        </p:spPr>
-        <p:txBody>
-          <a:bodyPr wrap="square" anchor="t" lIns="0" rIns="0" tIns="0" bIns="0">
-            <a:spAutoFit/>
-          </a:bodyPr>
-          <a:lstStyle/>
-          <a:p>
-            <a:pPr algn="l">
-              <a:lnSpc>
-                <a:spcPct val="115000"/>
-              </a:lnSpc>
-              <a:spcAft>
-                <a:spcPts val="0"/>
-              </a:spcAft>
-            </a:pPr>
-            <a:r>
-              <a:rPr sz="1150" b="1">
-                <a:solidFill>
-                  <a:srgbClr val="C2572F"/>
-                </a:solidFill>
-                <a:latin typeface="Bricolage Grotesque"/>
-              </a:rPr>
-              <a:t>Flags worsening</a:t>
-            </a:r>
-          </a:p>
-        </p:txBody>
-      </p:sp>
-      <p:sp>
-        <p:nvSpPr>
-          <p:cNvPr id="22" name="TextBox 21"/>
-          <p:cNvSpPr txBox="1"/>
-          <p:nvPr/>
-        </p:nvSpPr>
-        <p:spPr>
-          <a:xfrm>
-            <a:off x="2095461" y="4315967"/>
-            <a:ext cx="1181061" cy="640080"/>
-          </a:xfrm>
-          <a:prstGeom prst="rect">
-            <a:avLst/>
-          </a:prstGeom>
-          <a:noFill/>
-        </p:spPr>
-        <p:txBody>
-          <a:bodyPr wrap="square" anchor="t" lIns="0" rIns="0" tIns="0" bIns="0">
-            <a:spAutoFit/>
-          </a:bodyPr>
-          <a:lstStyle/>
-          <a:p>
-            <a:pPr algn="l">
-              <a:lnSpc>
-                <a:spcPct val="120000"/>
-              </a:lnSpc>
-              <a:spcAft>
-                <a:spcPts val="0"/>
-              </a:spcAft>
-            </a:pPr>
-            <a:r>
-              <a:rPr sz="950" b="0">
-                <a:solidFill>
-                  <a:srgbClr val="5F6D66"/>
-                </a:solidFill>
-                <a:latin typeface="Instrument Sans"/>
-              </a:rPr>
-              <a:t>improving, watch, worsening</a:t>
-            </a:r>
-          </a:p>
-        </p:txBody>
-      </p:sp>
-      <p:sp>
-        <p:nvSpPr>
-          <p:cNvPr id="23" name="TextBox 22"/>
-          <p:cNvSpPr txBox="1"/>
-          <p:nvPr/>
-        </p:nvSpPr>
-        <p:spPr>
-          <a:xfrm>
-            <a:off x="3285667" y="3822191"/>
-            <a:ext cx="182880" cy="274320"/>
-          </a:xfrm>
-          <a:prstGeom prst="rect">
-            <a:avLst/>
-          </a:prstGeom>
-          <a:noFill/>
-        </p:spPr>
-        <p:txBody>
-          <a:bodyPr wrap="square" anchor="t" lIns="0" rIns="0" tIns="0" bIns="0">
-            <a:spAutoFit/>
-          </a:bodyPr>
-          <a:lstStyle/>
-          <a:p>
-            <a:pPr algn="l">
-              <a:lnSpc>
-                <a:spcPct val="115000"/>
-              </a:lnSpc>
-              <a:spcAft>
-                <a:spcPts val="0"/>
-              </a:spcAft>
-            </a:pPr>
-            <a:r>
-              <a:rPr sz="1000" b="0">
-                <a:solidFill>
-                  <a:srgbClr val="D8DED9"/>
-                </a:solidFill>
-                <a:latin typeface="Instrument Sans"/>
-              </a:rPr>
-              <a:t>→</a:t>
-            </a:r>
-          </a:p>
-        </p:txBody>
-      </p:sp>
-      <p:sp>
-        <p:nvSpPr>
-          <p:cNvPr id="24" name="Rectangle 23"/>
-          <p:cNvSpPr/>
-          <p:nvPr/>
-        </p:nvSpPr>
-        <p:spPr>
-          <a:xfrm>
-            <a:off x="3459403" y="3749039"/>
-            <a:ext cx="1181061" cy="38100"/>
-          </a:xfrm>
-          <a:prstGeom prst="rect">
-            <a:avLst/>
-          </a:prstGeom>
-          <a:solidFill>
-            <a:srgbClr val="C98A1E"/>
-          </a:solidFill>
-          <a:ln>
-            <a:noFill/>
-          </a:ln>
-          <a:effectLst/>
-        </p:spPr>
-        <p:style>
-          <a:lnRef idx="1">
-            <a:schemeClr val="accent1"/>
-          </a:lnRef>
-          <a:fillRef idx="3">
-            <a:schemeClr val="accent1"/>
-          </a:fillRef>
-          <a:effectRef idx="2">
-            <a:schemeClr val="accent1"/>
-          </a:effectRef>
-          <a:fontRef idx="minor">
-            <a:schemeClr val="lt1"/>
-          </a:fontRef>
-        </p:style>
-        <p:txBody>
-          <a:bodyPr rtlCol="0" anchor="ctr"/>
-          <a:lstStyle/>
-          <a:p>
-            <a:pPr algn="ctr"/>
-          </a:p>
-        </p:txBody>
-      </p:sp>
-      <p:sp>
-        <p:nvSpPr>
-          <p:cNvPr id="25" name="TextBox 24"/>
-          <p:cNvSpPr txBox="1"/>
-          <p:nvPr/>
-        </p:nvSpPr>
-        <p:spPr>
-          <a:xfrm>
-            <a:off x="3459403" y="3858767"/>
-            <a:ext cx="1181061" cy="502920"/>
-          </a:xfrm>
-          <a:prstGeom prst="rect">
-            <a:avLst/>
-          </a:prstGeom>
-          <a:noFill/>
-        </p:spPr>
-        <p:txBody>
-          <a:bodyPr wrap="square" anchor="t" lIns="0" rIns="0" tIns="0" bIns="0">
-            <a:spAutoFit/>
-          </a:bodyPr>
-          <a:lstStyle/>
-          <a:p>
-            <a:pPr algn="l">
-              <a:lnSpc>
-                <a:spcPct val="115000"/>
-              </a:lnSpc>
-              <a:spcAft>
-                <a:spcPts val="0"/>
-              </a:spcAft>
-            </a:pPr>
-            <a:r>
-              <a:rPr sz="1150" b="1">
-                <a:solidFill>
-                  <a:srgbClr val="7A520C"/>
-                </a:solidFill>
-                <a:latin typeface="Bricolage Grotesque"/>
-              </a:rPr>
-              <a:t>Result lands</a:t>
-            </a:r>
-          </a:p>
-        </p:txBody>
-      </p:sp>
-      <p:sp>
-        <p:nvSpPr>
-          <p:cNvPr id="26" name="TextBox 25"/>
-          <p:cNvSpPr txBox="1"/>
-          <p:nvPr/>
-        </p:nvSpPr>
-        <p:spPr>
-          <a:xfrm>
-            <a:off x="3459403" y="4315967"/>
-            <a:ext cx="1181061" cy="640080"/>
-          </a:xfrm>
-          <a:prstGeom prst="rect">
-            <a:avLst/>
-          </a:prstGeom>
-          <a:noFill/>
-        </p:spPr>
-        <p:txBody>
-          <a:bodyPr wrap="square" anchor="t" lIns="0" rIns="0" tIns="0" bIns="0">
-            <a:spAutoFit/>
-          </a:bodyPr>
-          <a:lstStyle/>
-          <a:p>
-            <a:pPr algn="l">
-              <a:lnSpc>
-                <a:spcPct val="120000"/>
-              </a:lnSpc>
-              <a:spcAft>
-                <a:spcPts val="0"/>
-              </a:spcAft>
-            </a:pPr>
-            <a:r>
-              <a:rPr sz="950" b="0">
-                <a:solidFill>
-                  <a:srgbClr val="5F6D66"/>
-                </a:solidFill>
-                <a:latin typeface="Instrument Sans"/>
-              </a:rPr>
-              <a:t>or a trend is flagged</a:t>
-            </a:r>
-          </a:p>
-        </p:txBody>
-      </p:sp>
-      <p:sp>
-        <p:nvSpPr>
-          <p:cNvPr id="27" name="TextBox 26"/>
-          <p:cNvSpPr txBox="1"/>
-          <p:nvPr/>
-        </p:nvSpPr>
-        <p:spPr>
-          <a:xfrm>
-            <a:off x="4649609" y="3822191"/>
-            <a:ext cx="182880" cy="274320"/>
-          </a:xfrm>
-          <a:prstGeom prst="rect">
-            <a:avLst/>
-          </a:prstGeom>
-          <a:noFill/>
-        </p:spPr>
-        <p:txBody>
-          <a:bodyPr wrap="square" anchor="t" lIns="0" rIns="0" tIns="0" bIns="0">
-            <a:spAutoFit/>
-          </a:bodyPr>
-          <a:lstStyle/>
-          <a:p>
-            <a:pPr algn="l">
-              <a:lnSpc>
-                <a:spcPct val="115000"/>
-              </a:lnSpc>
-              <a:spcAft>
-                <a:spcPts val="0"/>
-              </a:spcAft>
-            </a:pPr>
-            <a:r>
-              <a:rPr sz="1000" b="0">
-                <a:solidFill>
-                  <a:srgbClr val="D8DED9"/>
-                </a:solidFill>
-                <a:latin typeface="Instrument Sans"/>
-              </a:rPr>
-              <a:t>→</a:t>
-            </a:r>
-          </a:p>
-        </p:txBody>
-      </p:sp>
-      <p:sp>
-        <p:nvSpPr>
-          <p:cNvPr id="28" name="Rectangle 27"/>
-          <p:cNvSpPr/>
-          <p:nvPr/>
-        </p:nvSpPr>
-        <p:spPr>
-          <a:xfrm>
-            <a:off x="4823345" y="3749039"/>
-            <a:ext cx="1181061" cy="38100"/>
-          </a:xfrm>
-          <a:prstGeom prst="rect">
-            <a:avLst/>
-          </a:prstGeom>
-          <a:solidFill>
-            <a:srgbClr val="C98A1E"/>
-          </a:solidFill>
-          <a:ln>
-            <a:noFill/>
-          </a:ln>
-          <a:effectLst/>
-        </p:spPr>
-        <p:style>
-          <a:lnRef idx="1">
-            <a:schemeClr val="accent1"/>
-          </a:lnRef>
-          <a:fillRef idx="3">
-            <a:schemeClr val="accent1"/>
-          </a:fillRef>
-          <a:effectRef idx="2">
-            <a:schemeClr val="accent1"/>
-          </a:effectRef>
-          <a:fontRef idx="minor">
-            <a:schemeClr val="lt1"/>
-          </a:fontRef>
-        </p:style>
-        <p:txBody>
-          <a:bodyPr rtlCol="0" anchor="ctr"/>
-          <a:lstStyle/>
-          <a:p>
-            <a:pPr algn="ctr"/>
-          </a:p>
-        </p:txBody>
-      </p:sp>
-      <p:sp>
-        <p:nvSpPr>
-          <p:cNvPr id="29" name="TextBox 28"/>
-          <p:cNvSpPr txBox="1"/>
-          <p:nvPr/>
-        </p:nvSpPr>
-        <p:spPr>
-          <a:xfrm>
-            <a:off x="4823345" y="3858767"/>
-            <a:ext cx="1181061" cy="502920"/>
-          </a:xfrm>
-          <a:prstGeom prst="rect">
-            <a:avLst/>
-          </a:prstGeom>
-          <a:noFill/>
-        </p:spPr>
-        <p:txBody>
-          <a:bodyPr wrap="square" anchor="t" lIns="0" rIns="0" tIns="0" bIns="0">
-            <a:spAutoFit/>
-          </a:bodyPr>
-          <a:lstStyle/>
-          <a:p>
-            <a:pPr algn="l">
-              <a:lnSpc>
-                <a:spcPct val="115000"/>
-              </a:lnSpc>
-              <a:spcAft>
-                <a:spcPts val="0"/>
-              </a:spcAft>
-            </a:pPr>
-            <a:r>
-              <a:rPr sz="1150" b="1">
-                <a:solidFill>
-                  <a:srgbClr val="7A520C"/>
-                </a:solidFill>
-                <a:latin typeface="Bricolage Grotesque"/>
-              </a:rPr>
-              <a:t>Has she been told?</a:t>
-            </a:r>
-          </a:p>
-        </p:txBody>
-      </p:sp>
-      <p:sp>
-        <p:nvSpPr>
-          <p:cNvPr id="30" name="TextBox 29"/>
-          <p:cNvSpPr txBox="1"/>
-          <p:nvPr/>
-        </p:nvSpPr>
-        <p:spPr>
-          <a:xfrm>
-            <a:off x="4823345" y="4315967"/>
-            <a:ext cx="1181061" cy="640080"/>
-          </a:xfrm>
-          <a:prstGeom prst="rect">
-            <a:avLst/>
-          </a:prstGeom>
-          <a:noFill/>
-        </p:spPr>
-        <p:txBody>
-          <a:bodyPr wrap="square" anchor="t" lIns="0" rIns="0" tIns="0" bIns="0">
-            <a:spAutoFit/>
-          </a:bodyPr>
-          <a:lstStyle/>
-          <a:p>
-            <a:pPr algn="l">
-              <a:lnSpc>
-                <a:spcPct val="120000"/>
-              </a:lnSpc>
-              <a:spcAft>
-                <a:spcPts val="0"/>
-              </a:spcAft>
-            </a:pPr>
-            <a:r>
-              <a:rPr sz="950" b="0">
-                <a:solidFill>
-                  <a:srgbClr val="5F6D66"/>
-                </a:solidFill>
-                <a:latin typeface="Instrument Sans"/>
-              </a:rPr>
-              <a:t>the gate checks</a:t>
-            </a:r>
-          </a:p>
-        </p:txBody>
-      </p:sp>
-      <p:sp>
-        <p:nvSpPr>
-          <p:cNvPr id="31" name="TextBox 30"/>
-          <p:cNvSpPr txBox="1"/>
-          <p:nvPr/>
-        </p:nvSpPr>
-        <p:spPr>
-          <a:xfrm>
-            <a:off x="6013551" y="3822191"/>
-            <a:ext cx="182880" cy="274320"/>
-          </a:xfrm>
-          <a:prstGeom prst="rect">
-            <a:avLst/>
-          </a:prstGeom>
-          <a:noFill/>
-        </p:spPr>
-        <p:txBody>
-          <a:bodyPr wrap="square" anchor="t" lIns="0" rIns="0" tIns="0" bIns="0">
-            <a:spAutoFit/>
-          </a:bodyPr>
-          <a:lstStyle/>
-          <a:p>
-            <a:pPr algn="l">
-              <a:lnSpc>
-                <a:spcPct val="115000"/>
-              </a:lnSpc>
-              <a:spcAft>
-                <a:spcPts val="0"/>
-              </a:spcAft>
-            </a:pPr>
-            <a:r>
-              <a:rPr sz="1000" b="0">
-                <a:solidFill>
-                  <a:srgbClr val="D8DED9"/>
-                </a:solidFill>
-                <a:latin typeface="Instrument Sans"/>
-              </a:rPr>
-              <a:t>→</a:t>
-            </a:r>
-          </a:p>
-        </p:txBody>
-      </p:sp>
-      <p:sp>
-        <p:nvSpPr>
-          <p:cNvPr id="32" name="Rectangle 31"/>
-          <p:cNvSpPr/>
-          <p:nvPr/>
-        </p:nvSpPr>
-        <p:spPr>
-          <a:xfrm>
-            <a:off x="6187287" y="3749039"/>
-            <a:ext cx="1181061" cy="38100"/>
-          </a:xfrm>
-          <a:prstGeom prst="rect">
-            <a:avLst/>
-          </a:prstGeom>
-          <a:solidFill>
-            <a:srgbClr val="C98A1E"/>
-          </a:solidFill>
-          <a:ln>
-            <a:noFill/>
-          </a:ln>
-          <a:effectLst/>
-        </p:spPr>
-        <p:style>
-          <a:lnRef idx="1">
-            <a:schemeClr val="accent1"/>
-          </a:lnRef>
-          <a:fillRef idx="3">
-            <a:schemeClr val="accent1"/>
-          </a:fillRef>
-          <a:effectRef idx="2">
-            <a:schemeClr val="accent1"/>
-          </a:effectRef>
-          <a:fontRef idx="minor">
-            <a:schemeClr val="lt1"/>
-          </a:fontRef>
-        </p:style>
-        <p:txBody>
-          <a:bodyPr rtlCol="0" anchor="ctr"/>
-          <a:lstStyle/>
-          <a:p>
-            <a:pPr algn="ctr"/>
-          </a:p>
-        </p:txBody>
-      </p:sp>
-      <p:sp>
-        <p:nvSpPr>
-          <p:cNvPr id="33" name="TextBox 32"/>
-          <p:cNvSpPr txBox="1"/>
-          <p:nvPr/>
-        </p:nvSpPr>
-        <p:spPr>
-          <a:xfrm>
-            <a:off x="6187287" y="3858767"/>
-            <a:ext cx="1181061" cy="502920"/>
-          </a:xfrm>
-          <a:prstGeom prst="rect">
-            <a:avLst/>
-          </a:prstGeom>
-          <a:noFill/>
-        </p:spPr>
-        <p:txBody>
-          <a:bodyPr wrap="square" anchor="t" lIns="0" rIns="0" tIns="0" bIns="0">
-            <a:spAutoFit/>
-          </a:bodyPr>
-          <a:lstStyle/>
-          <a:p>
-            <a:pPr algn="l">
-              <a:lnSpc>
-                <a:spcPct val="115000"/>
-              </a:lnSpc>
-              <a:spcAft>
-                <a:spcPts val="0"/>
-              </a:spcAft>
-            </a:pPr>
-            <a:r>
-              <a:rPr sz="1150" b="1">
-                <a:solidFill>
-                  <a:srgbClr val="7A520C"/>
-                </a:solidFill>
-                <a:latin typeface="Bricolage Grotesque"/>
-              </a:rPr>
-              <a:t>Held / Released</a:t>
-            </a:r>
-          </a:p>
-        </p:txBody>
-      </p:sp>
-      <p:sp>
-        <p:nvSpPr>
-          <p:cNvPr id="34" name="TextBox 33"/>
-          <p:cNvSpPr txBox="1"/>
-          <p:nvPr/>
-        </p:nvSpPr>
-        <p:spPr>
-          <a:xfrm>
-            <a:off x="6187287" y="4315967"/>
-            <a:ext cx="1181061" cy="640080"/>
-          </a:xfrm>
-          <a:prstGeom prst="rect">
-            <a:avLst/>
-          </a:prstGeom>
-          <a:noFill/>
-        </p:spPr>
-        <p:txBody>
-          <a:bodyPr wrap="square" anchor="t" lIns="0" rIns="0" tIns="0" bIns="0">
-            <a:spAutoFit/>
-          </a:bodyPr>
-          <a:lstStyle/>
-          <a:p>
-            <a:pPr algn="l">
-              <a:lnSpc>
-                <a:spcPct val="120000"/>
-              </a:lnSpc>
-              <a:spcAft>
-                <a:spcPts val="0"/>
-              </a:spcAft>
-            </a:pPr>
-            <a:r>
-              <a:rPr sz="950" b="0">
-                <a:solidFill>
-                  <a:srgbClr val="5F6D66"/>
-                </a:solidFill>
-                <a:latin typeface="Instrument Sans"/>
-              </a:rPr>
-              <a:t>held until she has been talked through it</a:t>
-            </a:r>
-          </a:p>
-        </p:txBody>
-      </p:sp>
-      <p:sp>
-        <p:nvSpPr>
-          <p:cNvPr id="35" name="TextBox 34"/>
-          <p:cNvSpPr txBox="1"/>
-          <p:nvPr/>
-        </p:nvSpPr>
-        <p:spPr>
-          <a:xfrm>
-            <a:off x="7377493" y="3822191"/>
-            <a:ext cx="182880" cy="274320"/>
-          </a:xfrm>
-          <a:prstGeom prst="rect">
-            <a:avLst/>
-          </a:prstGeom>
-          <a:noFill/>
-        </p:spPr>
-        <p:txBody>
-          <a:bodyPr wrap="square" anchor="t" lIns="0" rIns="0" tIns="0" bIns="0">
-            <a:spAutoFit/>
-          </a:bodyPr>
-          <a:lstStyle/>
-          <a:p>
-            <a:pPr algn="l">
-              <a:lnSpc>
-                <a:spcPct val="115000"/>
-              </a:lnSpc>
-              <a:spcAft>
-                <a:spcPts val="0"/>
-              </a:spcAft>
-            </a:pPr>
-            <a:r>
-              <a:rPr sz="1000" b="0">
-                <a:solidFill>
-                  <a:srgbClr val="D8DED9"/>
-                </a:solidFill>
-                <a:latin typeface="Instrument Sans"/>
-              </a:rPr>
-              <a:t>→</a:t>
-            </a:r>
-          </a:p>
-        </p:txBody>
-      </p:sp>
-      <p:sp>
-        <p:nvSpPr>
-          <p:cNvPr id="36" name="Rectangle 35"/>
-          <p:cNvSpPr/>
-          <p:nvPr/>
-        </p:nvSpPr>
-        <p:spPr>
-          <a:xfrm>
-            <a:off x="7551229" y="3749039"/>
-            <a:ext cx="1181061" cy="38100"/>
-          </a:xfrm>
-          <a:prstGeom prst="rect">
-            <a:avLst/>
-          </a:prstGeom>
-          <a:solidFill>
-            <a:srgbClr val="6D2E5B"/>
-          </a:solidFill>
-          <a:ln>
-            <a:noFill/>
-          </a:ln>
-          <a:effectLst/>
-        </p:spPr>
-        <p:style>
-          <a:lnRef idx="1">
-            <a:schemeClr val="accent1"/>
-          </a:lnRef>
-          <a:fillRef idx="3">
-            <a:schemeClr val="accent1"/>
-          </a:fillRef>
-          <a:effectRef idx="2">
-            <a:schemeClr val="accent1"/>
-          </a:effectRef>
-          <a:fontRef idx="minor">
-            <a:schemeClr val="lt1"/>
-          </a:fontRef>
-        </p:style>
-        <p:txBody>
-          <a:bodyPr rtlCol="0" anchor="ctr"/>
-          <a:lstStyle/>
-          <a:p>
-            <a:pPr algn="ctr"/>
-          </a:p>
-        </p:txBody>
-      </p:sp>
-      <p:sp>
-        <p:nvSpPr>
-          <p:cNvPr id="37" name="TextBox 36"/>
-          <p:cNvSpPr txBox="1"/>
-          <p:nvPr/>
-        </p:nvSpPr>
-        <p:spPr>
-          <a:xfrm>
-            <a:off x="7551229" y="3858767"/>
-            <a:ext cx="1181061" cy="502920"/>
-          </a:xfrm>
-          <a:prstGeom prst="rect">
-            <a:avLst/>
-          </a:prstGeom>
-          <a:noFill/>
-        </p:spPr>
-        <p:txBody>
-          <a:bodyPr wrap="square" anchor="t" lIns="0" rIns="0" tIns="0" bIns="0">
-            <a:spAutoFit/>
-          </a:bodyPr>
-          <a:lstStyle/>
-          <a:p>
-            <a:pPr algn="l">
-              <a:lnSpc>
-                <a:spcPct val="115000"/>
-              </a:lnSpc>
-              <a:spcAft>
-                <a:spcPts val="0"/>
-              </a:spcAft>
-            </a:pPr>
-            <a:r>
-              <a:rPr sz="1150" b="1">
-                <a:solidFill>
-                  <a:srgbClr val="6D2E5B"/>
-                </a:solidFill>
-                <a:latin typeface="Bricolage Grotesque"/>
-              </a:rPr>
-              <a:t>Her consent</a:t>
-            </a:r>
-          </a:p>
-        </p:txBody>
-      </p:sp>
-      <p:sp>
-        <p:nvSpPr>
-          <p:cNvPr id="38" name="TextBox 37"/>
-          <p:cNvSpPr txBox="1"/>
-          <p:nvPr/>
-        </p:nvSpPr>
-        <p:spPr>
-          <a:xfrm>
-            <a:off x="7551229" y="4315967"/>
-            <a:ext cx="1181061" cy="640080"/>
-          </a:xfrm>
-          <a:prstGeom prst="rect">
-            <a:avLst/>
-          </a:prstGeom>
-          <a:noFill/>
-        </p:spPr>
-        <p:txBody>
-          <a:bodyPr wrap="square" anchor="t" lIns="0" rIns="0" tIns="0" bIns="0">
-            <a:spAutoFit/>
-          </a:bodyPr>
-          <a:lstStyle/>
-          <a:p>
-            <a:pPr algn="l">
-              <a:lnSpc>
-                <a:spcPct val="120000"/>
-              </a:lnSpc>
-              <a:spcAft>
-                <a:spcPts val="0"/>
-              </a:spcAft>
-            </a:pPr>
-            <a:r>
-              <a:rPr sz="950" b="0">
-                <a:solidFill>
-                  <a:srgbClr val="5F6D66"/>
-                </a:solidFill>
-                <a:latin typeface="Instrument Sans"/>
-              </a:rPr>
-              <a:t>big news waits for her yes</a:t>
-            </a:r>
-          </a:p>
-        </p:txBody>
-      </p:sp>
-      <p:sp>
-        <p:nvSpPr>
-          <p:cNvPr id="39" name="TextBox 38"/>
-          <p:cNvSpPr txBox="1"/>
-          <p:nvPr/>
-        </p:nvSpPr>
-        <p:spPr>
-          <a:xfrm>
-            <a:off x="8741435" y="3822191"/>
-            <a:ext cx="182880" cy="274320"/>
-          </a:xfrm>
-          <a:prstGeom prst="rect">
-            <a:avLst/>
-          </a:prstGeom>
-          <a:noFill/>
-        </p:spPr>
-        <p:txBody>
-          <a:bodyPr wrap="square" anchor="t" lIns="0" rIns="0" tIns="0" bIns="0">
-            <a:spAutoFit/>
-          </a:bodyPr>
-          <a:lstStyle/>
-          <a:p>
-            <a:pPr algn="l">
-              <a:lnSpc>
-                <a:spcPct val="115000"/>
-              </a:lnSpc>
-              <a:spcAft>
-                <a:spcPts val="0"/>
-              </a:spcAft>
-            </a:pPr>
-            <a:r>
-              <a:rPr sz="1000" b="0">
-                <a:solidFill>
-                  <a:srgbClr val="D8DED9"/>
-                </a:solidFill>
-                <a:latin typeface="Instrument Sans"/>
-              </a:rPr>
-              <a:t>→</a:t>
-            </a:r>
-          </a:p>
-        </p:txBody>
-      </p:sp>
-      <p:sp>
-        <p:nvSpPr>
-          <p:cNvPr id="40" name="Rectangle 39"/>
-          <p:cNvSpPr/>
-          <p:nvPr/>
-        </p:nvSpPr>
-        <p:spPr>
-          <a:xfrm>
-            <a:off x="8915171" y="3749039"/>
-            <a:ext cx="1181061" cy="38100"/>
-          </a:xfrm>
-          <a:prstGeom prst="rect">
-            <a:avLst/>
-          </a:prstGeom>
-          <a:solidFill>
-            <a:srgbClr val="6D2E5B"/>
-          </a:solidFill>
-          <a:ln>
-            <a:noFill/>
-          </a:ln>
-          <a:effectLst/>
-        </p:spPr>
-        <p:style>
-          <a:lnRef idx="1">
-            <a:schemeClr val="accent1"/>
-          </a:lnRef>
-          <a:fillRef idx="3">
-            <a:schemeClr val="accent1"/>
-          </a:fillRef>
-          <a:effectRef idx="2">
-            <a:schemeClr val="accent1"/>
-          </a:effectRef>
-          <a:fontRef idx="minor">
-            <a:schemeClr val="lt1"/>
-          </a:fontRef>
-        </p:style>
-        <p:txBody>
-          <a:bodyPr rtlCol="0" anchor="ctr"/>
-          <a:lstStyle/>
-          <a:p>
-            <a:pPr algn="ctr"/>
-          </a:p>
-        </p:txBody>
-      </p:sp>
-      <p:sp>
-        <p:nvSpPr>
-          <p:cNvPr id="41" name="TextBox 40"/>
-          <p:cNvSpPr txBox="1"/>
-          <p:nvPr/>
-        </p:nvSpPr>
-        <p:spPr>
-          <a:xfrm>
-            <a:off x="8915171" y="3858767"/>
-            <a:ext cx="1181061" cy="502920"/>
-          </a:xfrm>
-          <a:prstGeom prst="rect">
-            <a:avLst/>
-          </a:prstGeom>
-          <a:noFill/>
-        </p:spPr>
-        <p:txBody>
-          <a:bodyPr wrap="square" anchor="t" lIns="0" rIns="0" tIns="0" bIns="0">
-            <a:spAutoFit/>
-          </a:bodyPr>
-          <a:lstStyle/>
-          <a:p>
-            <a:pPr algn="l">
-              <a:lnSpc>
-                <a:spcPct val="115000"/>
-              </a:lnSpc>
-              <a:spcAft>
-                <a:spcPts val="0"/>
-              </a:spcAft>
-            </a:pPr>
-            <a:r>
-              <a:rPr sz="1150" b="1">
-                <a:solidFill>
-                  <a:srgbClr val="6D2E5B"/>
-                </a:solidFill>
-                <a:latin typeface="Bricolage Grotesque"/>
-              </a:rPr>
-              <a:t>Per-person version</a:t>
-            </a:r>
-          </a:p>
-        </p:txBody>
-      </p:sp>
-      <p:sp>
-        <p:nvSpPr>
-          <p:cNvPr id="42" name="TextBox 41"/>
-          <p:cNvSpPr txBox="1"/>
-          <p:nvPr/>
-        </p:nvSpPr>
-        <p:spPr>
-          <a:xfrm>
-            <a:off x="8915171" y="4315967"/>
-            <a:ext cx="1181061" cy="640080"/>
-          </a:xfrm>
-          <a:prstGeom prst="rect">
-            <a:avLst/>
-          </a:prstGeom>
-          <a:noFill/>
-        </p:spPr>
-        <p:txBody>
-          <a:bodyPr wrap="square" anchor="t" lIns="0" rIns="0" tIns="0" bIns="0">
-            <a:spAutoFit/>
-          </a:bodyPr>
-          <a:lstStyle/>
-          <a:p>
-            <a:pPr algn="l">
-              <a:lnSpc>
-                <a:spcPct val="120000"/>
-              </a:lnSpc>
-              <a:spcAft>
-                <a:spcPts val="0"/>
-              </a:spcAft>
-            </a:pPr>
-            <a:r>
-              <a:rPr sz="950" b="0">
-                <a:solidFill>
-                  <a:srgbClr val="5F6D66"/>
-                </a:solidFill>
-                <a:latin typeface="Instrument Sans"/>
-              </a:rPr>
-              <a:t>Grace numbers, Idris logistics, Thomas yes/no</a:t>
-            </a:r>
-          </a:p>
-        </p:txBody>
-      </p:sp>
-      <p:sp>
-        <p:nvSpPr>
-          <p:cNvPr id="43" name="TextBox 42"/>
-          <p:cNvSpPr txBox="1"/>
-          <p:nvPr/>
-        </p:nvSpPr>
-        <p:spPr>
-          <a:xfrm>
-            <a:off x="10105377" y="3822191"/>
-            <a:ext cx="182880" cy="274320"/>
-          </a:xfrm>
-          <a:prstGeom prst="rect">
-            <a:avLst/>
-          </a:prstGeom>
-          <a:noFill/>
-        </p:spPr>
-        <p:txBody>
-          <a:bodyPr wrap="square" anchor="t" lIns="0" rIns="0" tIns="0" bIns="0">
-            <a:spAutoFit/>
-          </a:bodyPr>
-          <a:lstStyle/>
-          <a:p>
-            <a:pPr algn="l">
-              <a:lnSpc>
-                <a:spcPct val="115000"/>
-              </a:lnSpc>
-              <a:spcAft>
-                <a:spcPts val="0"/>
-              </a:spcAft>
-            </a:pPr>
-            <a:r>
-              <a:rPr sz="1000" b="0">
-                <a:solidFill>
-                  <a:srgbClr val="D8DED9"/>
-                </a:solidFill>
-                <a:latin typeface="Instrument Sans"/>
-              </a:rPr>
-              <a:t>→</a:t>
-            </a:r>
-          </a:p>
-        </p:txBody>
-      </p:sp>
-      <p:sp>
-        <p:nvSpPr>
-          <p:cNvPr id="44" name="Rectangle 43"/>
-          <p:cNvSpPr/>
-          <p:nvPr/>
-        </p:nvSpPr>
-        <p:spPr>
-          <a:xfrm>
-            <a:off x="10279113" y="3749039"/>
-            <a:ext cx="1181061" cy="38100"/>
-          </a:xfrm>
-          <a:prstGeom prst="rect">
-            <a:avLst/>
-          </a:prstGeom>
-          <a:solidFill>
-            <a:srgbClr val="2F6B4F"/>
-          </a:solidFill>
-          <a:ln>
-            <a:noFill/>
-          </a:ln>
-          <a:effectLst/>
-        </p:spPr>
-        <p:style>
-          <a:lnRef idx="1">
-            <a:schemeClr val="accent1"/>
-          </a:lnRef>
-          <a:fillRef idx="3">
-            <a:schemeClr val="accent1"/>
-          </a:fillRef>
-          <a:effectRef idx="2">
-            <a:schemeClr val="accent1"/>
-          </a:effectRef>
-          <a:fontRef idx="minor">
-            <a:schemeClr val="lt1"/>
-          </a:fontRef>
-        </p:style>
-        <p:txBody>
-          <a:bodyPr rtlCol="0" anchor="ctr"/>
-          <a:lstStyle/>
-          <a:p>
-            <a:pPr algn="ctr"/>
-          </a:p>
-        </p:txBody>
-      </p:sp>
-      <p:sp>
-        <p:nvSpPr>
-          <p:cNvPr id="45" name="TextBox 44"/>
-          <p:cNvSpPr txBox="1"/>
-          <p:nvPr/>
-        </p:nvSpPr>
-        <p:spPr>
-          <a:xfrm>
-            <a:off x="10279113" y="3858767"/>
-            <a:ext cx="1181061" cy="502920"/>
-          </a:xfrm>
-          <a:prstGeom prst="rect">
-            <a:avLst/>
-          </a:prstGeom>
-          <a:noFill/>
-        </p:spPr>
-        <p:txBody>
-          <a:bodyPr wrap="square" anchor="t" lIns="0" rIns="0" tIns="0" bIns="0">
-            <a:spAutoFit/>
-          </a:bodyPr>
-          <a:lstStyle/>
-          <a:p>
-            <a:pPr algn="l">
-              <a:lnSpc>
-                <a:spcPct val="115000"/>
-              </a:lnSpc>
-              <a:spcAft>
-                <a:spcPts val="0"/>
-              </a:spcAft>
-            </a:pPr>
-            <a:r>
-              <a:rPr sz="1150" b="1">
-                <a:solidFill>
-                  <a:srgbClr val="1E4A36"/>
-                </a:solidFill>
-                <a:latin typeface="Bricolage Grotesque"/>
-              </a:rPr>
-              <a:t>Act</a:t>
-            </a:r>
-          </a:p>
-        </p:txBody>
-      </p:sp>
-      <p:sp>
-        <p:nvSpPr>
-          <p:cNvPr id="46" name="TextBox 45"/>
-          <p:cNvSpPr txBox="1"/>
-          <p:nvPr/>
-        </p:nvSpPr>
-        <p:spPr>
-          <a:xfrm>
-            <a:off x="10279113" y="4315967"/>
-            <a:ext cx="1181061" cy="640080"/>
-          </a:xfrm>
-          <a:prstGeom prst="rect">
-            <a:avLst/>
-          </a:prstGeom>
-          <a:noFill/>
-        </p:spPr>
-        <p:txBody>
-          <a:bodyPr wrap="square" anchor="t" lIns="0" rIns="0" tIns="0" bIns="0">
-            <a:spAutoFit/>
-          </a:bodyPr>
-          <a:lstStyle/>
-          <a:p>
-            <a:pPr algn="l">
-              <a:lnSpc>
-                <a:spcPct val="120000"/>
-              </a:lnSpc>
-              <a:spcAft>
-                <a:spcPts val="0"/>
-              </a:spcAft>
-            </a:pPr>
-            <a:r>
-              <a:rPr sz="950" b="0">
-                <a:solidFill>
-                  <a:srgbClr val="5F6D66"/>
-                </a:solidFill>
-                <a:latin typeface="Instrument Sans"/>
-              </a:rPr>
-              <a:t>explain, notify, or raise a task</a:t>
-            </a:r>
-          </a:p>
-        </p:txBody>
-      </p:sp>
-      <p:sp>
-        <p:nvSpPr>
-          <p:cNvPr id="47" name="TextBox 46"/>
-          <p:cNvSpPr txBox="1"/>
-          <p:nvPr/>
-        </p:nvSpPr>
-        <p:spPr>
-          <a:xfrm>
-            <a:off x="731520" y="5166360"/>
-            <a:ext cx="10789920" cy="1005840"/>
-          </a:xfrm>
-          <a:prstGeom prst="rect">
-            <a:avLst/>
-          </a:prstGeom>
-          <a:noFill/>
-        </p:spPr>
-        <p:txBody>
-          <a:bodyPr wrap="square" anchor="t" lIns="0" rIns="0" tIns="0" bIns="0">
-            <a:spAutoFit/>
-          </a:bodyPr>
-          <a:lstStyle/>
-          <a:p>
-            <a:pPr algn="l">
-              <a:lnSpc>
-                <a:spcPct val="130000"/>
-              </a:lnSpc>
-              <a:spcAft>
-                <a:spcPts val="600"/>
-              </a:spcAft>
-            </a:pPr>
-            <a:r>
-              <a:rPr sz="1300" b="1">
-                <a:solidFill>
-                  <a:srgbClr val="14261F"/>
-                </a:solidFill>
-                <a:latin typeface="Instrument Sans"/>
-              </a:rPr>
-              <a:t>If nobody tells her within three days, </a:t>
-            </a:r>
-            <a:r>
-              <a:rPr sz="1300" b="0">
-                <a:solidFill>
-                  <a:srgbClr val="5F6D66"/>
-                </a:solidFill>
-                <a:latin typeface="Instrument Sans"/>
-              </a:rPr>
-              <a:t>the agent raises a GP task and phones her landline.</a:t>
-            </a:r>
-          </a:p>
-          <a:p>
-            <a:pPr algn="l">
-              <a:lnSpc>
-                <a:spcPct val="130000"/>
-              </a:lnSpc>
-              <a:spcAft>
-                <a:spcPts val="600"/>
-              </a:spcAft>
-            </a:pPr>
-            <a:r>
-              <a:rPr sz="1300" b="0">
-                <a:solidFill>
-                  <a:srgbClr val="5F6D66"/>
-                </a:solidFill>
-                <a:latin typeface="Instrument Sans"/>
-              </a:rPr>
-              <a:t>On Eleanor's real values the engine flags her liver trend as </a:t>
-            </a:r>
-            <a:r>
-              <a:rPr sz="1300" b="0">
-                <a:solidFill>
-                  <a:srgbClr val="C2572F"/>
-                </a:solidFill>
-                <a:latin typeface="JetBrains Mono"/>
-              </a:rPr>
-              <a:t>worsening</a:t>
-            </a:r>
-            <a:r>
-              <a:rPr sz="1300" b="0">
-                <a:solidFill>
-                  <a:srgbClr val="5F6D66"/>
-                </a:solidFill>
-                <a:latin typeface="Instrument Sans"/>
-              </a:rPr>
-              <a:t> and her white cells as </a:t>
-            </a:r>
-            <a:r>
-              <a:rPr sz="1300" b="0">
-                <a:solidFill>
-                  <a:srgbClr val="7A520C"/>
-                </a:solidFill>
-                <a:latin typeface="JetBrains Mono"/>
-              </a:rPr>
-              <a:t>watch</a:t>
-            </a:r>
-            <a:r>
-              <a:rPr sz="1300" b="0">
-                <a:solidFill>
-                  <a:srgbClr val="5F6D66"/>
-                </a:solidFill>
-                <a:latin typeface="Instrument Sans"/>
-              </a:rPr>
-              <a:t>.</a:t>
-            </a:r>
-          </a:p>
-        </p:txBody>
-      </p:sp>
-      <p:sp>
-        <p:nvSpPr>
-          <p:cNvPr id="48" name="TextBox 47"/>
-          <p:cNvSpPr txBox="1"/>
-          <p:nvPr/>
-        </p:nvSpPr>
-        <p:spPr>
-          <a:xfrm>
-            <a:off x="731520" y="6309360"/>
-            <a:ext cx="7863840" cy="365760"/>
-          </a:xfrm>
-          <a:prstGeom prst="rect">
-            <a:avLst/>
-          </a:prstGeom>
-          <a:noFill/>
-        </p:spPr>
-        <p:txBody>
-          <a:bodyPr wrap="square" anchor="b" lIns="0" rIns="0" tIns="0" bIns="0">
-            <a:spAutoFit/>
-          </a:bodyPr>
-          <a:lstStyle/>
-          <a:p>
-            <a:pPr algn="l">
-              <a:lnSpc>
-                <a:spcPct val="115000"/>
-              </a:lnSpc>
-              <a:spcAft>
-                <a:spcPts val="0"/>
-              </a:spcAft>
-            </a:pPr>
-            <a:r>
-              <a:rPr sz="850" b="0">
-                <a:solidFill>
-                  <a:srgbClr val="5F6D66"/>
-                </a:solidFill>
-                <a:latin typeface="Instrument Sans"/>
-              </a:rPr>
               <a:t>Proxy access gives a person the record. CareCircle gives each person their role.</a:t>
             </a:r>
           </a:p>
@@ -8448,7 +7030,7 @@
       </p:sp>
       <p:sp>
         <p:nvSpPr>
-          <p:cNvPr id="49" name="TextBox 48"/>
+          <p:cNvPr id="17" name="TextBox 16"/>
           <p:cNvSpPr txBox="1"/>
           <p:nvPr/>
         </p:nvSpPr>

</xml_diff>

<commit_message>
docs(pitch): add an After CareCircle slide, Eleanor before and after
</commit_message>
<xml_diff>
--- a/pitch/CareCircle-pitch.pptx
+++ b/pitch/CareCircle-pitch.pptx
@@ -12,6 +12,7 @@
     <p:sldId id="260" r:id="rId12"/>
     <p:sldId id="261" r:id="rId13"/>
     <p:sldId id="262" r:id="rId14"/>
+    <p:sldId id="263" r:id="rId15"/>
   </p:sldIdLst>
   <p:sldSz cx="12191695" cy="6858000" type="screen4x3"/>
   <p:notesSz cx="6858000" cy="9144000"/>
@@ -1024,46 +1025,25 @@
           <a:lstStyle/>
           <a:p>
             <a:r>
-              <a:t>## Slide 5: The demo (90 seconds)</a:t>
+              <a:t>## Slide 4b: After CareCircle (15 seconds)</a:t>
             </a:r>
           </a:p>
           <a:p/>
           <a:p>
             <a:r>
-              <a:t>**Script, while clicking**</a:t>
+              <a:t>"So what changes for Eleanor. Her white cells were filed four times; now the trend is flagged the second time, in July. A result lands; instead of sitting there, it is held until the practice has talked her through it, and she says yes. Her daughter gets the numbers, her husband gets the lift to arrange, her son gets nothing-needed-this-week. And if nobody confirms within three days, a GP task is raised and her landline rings."</a:t>
             </a:r>
           </a:p>
           <a:p/>
           <a:p>
             <a:r>
-              <a:t>"Ninety seconds, live against Anima. Step zero: Eleanor's trend cards. Improving, watch, worsening, generated from her real panel history, live from the prototype. Liver worsening, white cells watch, sugar control improving. Step one: I order a liver function test in Anima and advance the clock 121 minutes. The result lands as a real state change; we detect it, we do not mock it. Step two: held. Eleanor's phone gets one message, a result has arrived and your practice will talk you through it. The family view shows nothing. Step three: the practice marks it discussed, it is flagged, so Eleanor is asked: do you want your circle to know? She says yes. Three versions go out: Grace sees bilirubin and albumin with the ranges, Idris sees the follow-up to arrange, Thomas sees nothing needed this week. A task now exists in Anima's own activity trail. Step four, in the Kindred app: Grace asks about a result she cannot see. NOT_SHARED. Kindred says Eleanor has not shared her test results, with no hint of what they say. Grace asks for access, Eleanor approves from a card, and the GP consent view updates live. Step five: the morning check reads the half past eight appointment from the record and posts to the family group: who can give Eleanor a lift?"</a:t>
+              <a:t>Timing: take these 15 seconds from the demo (90 to 75) so the total stays at three minutes.</a:t>
             </a:r>
           </a:p>
           <a:p/>
           <a:p>
             <a:r>
-              <a:t>**Notes**</a:t>
-            </a:r>
-          </a:p>
-          <a:p/>
-          <a:p>
-            <a:r>
-              <a:t>- Steps 0 to 3 run in the prototype (`server.mjs`) against the remote Anima world: `GET /api/insights` for the cards; one LFT order, one clock advance and one task per run.</a:t>
-            </a:r>
-          </a:p>
-          <a:p>
-            <a:r>
-              <a:t>- Steps 4 and 5 run in the Kindred app (`web/` plus `sim-app/`). The morning check picks up appointments in the next seven days not yet announced (sim clock 08:00, appointment 08:30), posts with category "appointments", so Grace, Thomas and Idris all see it, and adds the next action "Arrange to accompany Eleanor to practice follow-up".</a:t>
-            </a:r>
-          </a:p>
-          <a:p>
-            <a:r>
-              <a:t>- Visibly simulated, and say so if asked: WhatsApp delivery, relative identity checks, the clinician's "discussed with patient" tap, and the persona switcher standing in for sign-in. Consent writes go to the companion backend, not native FHIR Consent on the remote simulator.</a:t>
-            </a:r>
-          </a:p>
-          <a:p>
-            <a:r>
-              <a:t>- If the sim is slow, the held state is the moment to talk through the gate; the release is the payoff.</a:t>
+              <a:t>Honesty: the right-hand column is what the demo shows across the app and the prototype; see the code-ownership table at the top. "Flagged in July" is the second low panel (14 July 2026, white cells 1.6) in the remote Anima record; the prototype's trend rule needs two consecutive out-of-range values, so July is the earliest it fires on her real data.</a:t>
             </a:r>
           </a:p>
         </p:txBody>
@@ -1133,62 +1113,46 @@
           <a:lstStyle/>
           <a:p>
             <a:r>
-              <a:t>## Slide 6: 10 Year Health Plan fit (10 seconds)</a:t>
+              <a:t>## Slide 5: The demo (90 seconds)</a:t>
             </a:r>
           </a:p>
           <a:p/>
           <a:p>
             <a:r>
-              <a:t>**Script**</a:t>
+              <a:t>**Script, while clicking**</a:t>
             </a:r>
           </a:p>
           <a:p/>
           <a:p>
             <a:r>
-              <a:t>"This is what the 10 Year Health Plan asks for. One core purpose: power in patients' hands. Patients control whether their data is shared, and My Carer gives carers access on their loved one's behalf. And poor communication is the most common complaint. Chapters 2, 3 and 6."</a:t>
+              <a:t>"Ninety seconds, live against Anima. Step zero: Eleanor's trend cards. Improving, watch, worsening, generated from her real panel history, live from the prototype. Liver worsening, white cells watch, sugar control improving. Step one: I order a liver function test in Anima and advance the clock 121 minutes. The result lands as a real state change; we detect it, we do not mock it. Step two: held. Eleanor's phone gets one message, a result has arrived and your practice will talk you through it. The family view shows nothing. Step three: the practice marks it discussed, it is flagged, so Eleanor is asked: do you want your circle to know? She says yes. Three versions go out: Grace sees bilirubin and albumin with the ranges, Idris sees the follow-up to arrange, Thomas sees nothing needed this week. A task now exists in Anima's own activity trail. Step four, in the Kindred app: Grace asks about a result she cannot see. NOT_SHARED. Kindred says Eleanor has not shared her test results, with no hint of what they say. Grace asks for access, Eleanor approves from a card, and the GP consent view updates live. Step five: the morning check reads the half past eight appointment from the record and posts to the family group: who can give Eleanor a lift?"</a:t>
             </a:r>
           </a:p>
           <a:p/>
           <a:p>
             <a:r>
-              <a:t>**Citations** (Fit for the Future: The 10 Year Health Plan for England, CP 1350, DHSC, July 2025, corrected 15 July 2025; printed page numbers, PDF page = printed page + 2)</a:t>
+              <a:t>**Notes**</a:t>
             </a:r>
           </a:p>
           <a:p/>
           <a:p>
             <a:r>
-              <a:t>- Chapter 1, p22: "There are 3 shifts, but only one core purpose: to put power in patients' hands."</a:t>
-            </a:r>
-          </a:p>
-          <a:p>
-            <a:r>
-              <a:t>- Chapter 3, p51: "Patients will have control over whether this data is shared in real-time with their care team, so they can proactively monitor their health and step in if needed." Context, pp50 to 51: the My Health tool "will connect to the results of recent tests and investigations."</a:t>
-            </a:r>
-          </a:p>
-          <a:p>
-            <a:r>
-              <a:t>- Chapter 3, p51: "My Carer will allow people to securely prove they are providing care, often for an older family member, and gain access to the App on their behalf."</a:t>
-            </a:r>
-          </a:p>
-          <a:p>
-            <a:r>
-              <a:t>- Chapter 6, p89: "The problem is that the NHS doesn't listen well enough. The most common reasons for complaints is poor communication." (The plan's own grammar.)</a:t>
-            </a:r>
-          </a:p>
-          <a:p>
-            <a:r>
-              <a:t>- Chapter 2, p34: "Unpaid carers will also be actively involved in care planning." This is the Chapter 2 hook behind "Chapters 2, 3 and 6".</a:t>
-            </a:r>
-          </a:p>
-          <a:p>
-            <a:r>
-              <a:t>- Chapter 1, p21, for pillar 1 if asked: "This AI will also be an early warning system, detecting subtle signs of health changes by analysing data from wearables, lifestyle and medical records to trigger timely interventions".</a:t>
-            </a:r>
-          </a:p>
-          <a:p/>
-          <a:p>
-            <a:r>
-              <a:t>Note: the plan contains no sentence about uncommunicated test results. Do not attribute the HSIB finding to the plan.</a:t>
+              <a:t>- Steps 0 to 3 run in the prototype (`server.mjs`) against the remote Anima world: `GET /api/insights` for the cards; one LFT order, one clock advance and one task per run.</a:t>
+            </a:r>
+          </a:p>
+          <a:p>
+            <a:r>
+              <a:t>- Steps 4 and 5 run in the Kindred app (`web/` plus `sim-app/`). The morning check picks up appointments in the next seven days not yet announced (sim clock 08:00, appointment 08:30), posts with category "appointments", so Grace, Thomas and Idris all see it, and adds the next action "Arrange to accompany Eleanor to practice follow-up".</a:t>
+            </a:r>
+          </a:p>
+          <a:p>
+            <a:r>
+              <a:t>- Visibly simulated, and say so if asked: WhatsApp delivery, relative identity checks, the clinician's "discussed with patient" tap, and the persona switcher standing in for sign-in. Consent writes go to the companion backend, not native FHIR Consent on the remote simulator.</a:t>
+            </a:r>
+          </a:p>
+          <a:p>
+            <a:r>
+              <a:t>- If the sim is slow, the held state is the moment to talk through the gate; the release is the payoff.</a:t>
             </a:r>
           </a:p>
         </p:txBody>
@@ -1214,6 +1178,131 @@
 </file>
 
 <file path=ppt/notesSlides/notesSlide7.xml><?xml version="1.0" encoding="utf-8"?>
+<p:notes xmlns:a="http://schemas.openxmlformats.org/drawingml/2006/main" xmlns:p="http://schemas.openxmlformats.org/presentationml/2006/main" xmlns:r="http://schemas.openxmlformats.org/officeDocument/2006/relationships">
+  <p:cSld>
+    <p:spTree>
+      <p:nvGrpSpPr>
+        <p:cNvPr id="1" name=""/>
+        <p:cNvGrpSpPr/>
+        <p:nvPr/>
+      </p:nvGrpSpPr>
+      <p:grpSpPr>
+        <a:xfrm>
+          <a:off x="0" y="0"/>
+          <a:ext cx="0" cy="0"/>
+          <a:chOff x="0" y="0"/>
+          <a:chExt cx="0" cy="0"/>
+        </a:xfrm>
+      </p:grpSpPr>
+      <p:sp>
+        <p:nvSpPr>
+          <p:cNvPr id="2" name="Slide Image Placeholder 1"/>
+          <p:cNvSpPr>
+            <a:spLocks noGrp="1"/>
+          </p:cNvSpPr>
+          <p:nvPr>
+            <p:ph type="sldImg" idx="2"/>
+          </p:nvPr>
+        </p:nvSpPr>
+        <p:spPr/>
+      </p:sp>
+      <p:sp>
+        <p:nvSpPr>
+          <p:cNvPr id="3" name="Notes Placeholder 2"/>
+          <p:cNvSpPr>
+            <a:spLocks noGrp="1"/>
+          </p:cNvSpPr>
+          <p:nvPr>
+            <p:ph type="body" idx="3" sz="quarter"/>
+          </p:nvPr>
+        </p:nvSpPr>
+        <p:spPr/>
+        <p:txBody>
+          <a:bodyPr/>
+          <a:lstStyle/>
+          <a:p>
+            <a:r>
+              <a:t>## Slide 6: 10 Year Health Plan fit (10 seconds)</a:t>
+            </a:r>
+          </a:p>
+          <a:p/>
+          <a:p>
+            <a:r>
+              <a:t>**Script**</a:t>
+            </a:r>
+          </a:p>
+          <a:p/>
+          <a:p>
+            <a:r>
+              <a:t>"This is what the 10 Year Health Plan asks for. One core purpose: power in patients' hands. Patients control whether their data is shared, and My Carer gives carers access on their loved one's behalf. And poor communication is the most common complaint. Chapters 2, 3 and 6."</a:t>
+            </a:r>
+          </a:p>
+          <a:p/>
+          <a:p>
+            <a:r>
+              <a:t>**Citations** (Fit for the Future: The 10 Year Health Plan for England, CP 1350, DHSC, July 2025, corrected 15 July 2025; printed page numbers, PDF page = printed page + 2)</a:t>
+            </a:r>
+          </a:p>
+          <a:p/>
+          <a:p>
+            <a:r>
+              <a:t>- Chapter 1, p22: "There are 3 shifts, but only one core purpose: to put power in patients' hands."</a:t>
+            </a:r>
+          </a:p>
+          <a:p>
+            <a:r>
+              <a:t>- Chapter 3, p51: "Patients will have control over whether this data is shared in real-time with their care team, so they can proactively monitor their health and step in if needed." Context, pp50 to 51: the My Health tool "will connect to the results of recent tests and investigations."</a:t>
+            </a:r>
+          </a:p>
+          <a:p>
+            <a:r>
+              <a:t>- Chapter 3, p51: "My Carer will allow people to securely prove they are providing care, often for an older family member, and gain access to the App on their behalf."</a:t>
+            </a:r>
+          </a:p>
+          <a:p>
+            <a:r>
+              <a:t>- Chapter 6, p89: "The problem is that the NHS doesn't listen well enough. The most common reasons for complaints is poor communication." (The plan's own grammar.)</a:t>
+            </a:r>
+          </a:p>
+          <a:p>
+            <a:r>
+              <a:t>- Chapter 2, p34: "Unpaid carers will also be actively involved in care planning." This is the Chapter 2 hook behind "Chapters 2, 3 and 6".</a:t>
+            </a:r>
+          </a:p>
+          <a:p>
+            <a:r>
+              <a:t>- Chapter 1, p21, for pillar 1 if asked: "This AI will also be an early warning system, detecting subtle signs of health changes by analysing data from wearables, lifestyle and medical records to trigger timely interventions".</a:t>
+            </a:r>
+          </a:p>
+          <a:p/>
+          <a:p>
+            <a:r>
+              <a:t>Note: the plan contains no sentence about uncommunicated test results. Do not attribute the HSIB finding to the plan.</a:t>
+            </a:r>
+          </a:p>
+        </p:txBody>
+      </p:sp>
+      <p:sp>
+        <p:nvSpPr>
+          <p:cNvPr id="4" name="Slide Number Placeholder 3"/>
+          <p:cNvSpPr>
+            <a:spLocks noGrp="1"/>
+          </p:cNvSpPr>
+          <p:nvPr>
+            <p:ph type="sldNum" idx="5" sz="quarter"/>
+          </p:nvPr>
+        </p:nvSpPr>
+        <p:spPr/>
+      </p:sp>
+    </p:spTree>
+  </p:cSld>
+  <p:clrMapOvr>
+    <a:masterClrMapping/>
+  </p:clrMapOvr>
+</p:notes>
+</file>
+
+<file path=ppt/notesSlides/notesSlide8.xml><?xml version="1.0" encoding="utf-8"?>
 <p:notes xmlns:a="http://schemas.openxmlformats.org/drawingml/2006/main" xmlns:p="http://schemas.openxmlformats.org/presentationml/2006/main" xmlns:r="http://schemas.openxmlformats.org/officeDocument/2006/relationships">
   <p:cSld>
     <p:spTree>
@@ -7133,7 +7222,7 @@
                 </a:solidFill>
                 <a:latin typeface="Instrument Sans"/>
               </a:rPr>
-              <a:t>THE DEMO</a:t>
+              <a:t>AFTER CARECIRCLE</a:t>
             </a:r>
           </a:p>
         </p:txBody>
@@ -7146,8 +7235,8 @@
         </p:nvSpPr>
         <p:spPr>
           <a:xfrm>
-            <a:off x="731520" y="868680"/>
-            <a:ext cx="9144000" cy="731520"/>
+            <a:off x="731520" y="777240"/>
+            <a:ext cx="10058400" cy="731520"/>
           </a:xfrm>
           <a:prstGeom prst="rect">
             <a:avLst/>
@@ -7169,36 +7258,124 @@
               </a:spcAft>
             </a:pPr>
             <a:r>
-              <a:rPr sz="3600" b="1">
+              <a:rPr sz="3400" b="1">
                 <a:solidFill>
                   <a:srgbClr val="14261F"/>
                 </a:solidFill>
                 <a:latin typeface="Bricolage Grotesque"/>
               </a:rPr>
-              <a:t>90 seconds, live against Anima.</a:t>
-            </a:r>
-          </a:p>
-        </p:txBody>
-      </p:sp>
-      <p:sp>
-        <p:nvSpPr>
-          <p:cNvPr id="4" name="Oval 3"/>
+              <a:t>What happens to Eleanor now.</a:t>
+            </a:r>
+          </a:p>
+        </p:txBody>
+      </p:sp>
+      <p:sp>
+        <p:nvSpPr>
+          <p:cNvPr id="4" name="TextBox 3"/>
+          <p:cNvSpPr txBox="1"/>
+          <p:nvPr/>
+        </p:nvSpPr>
+        <p:spPr>
+          <a:xfrm>
+            <a:off x="731520" y="1600200"/>
+            <a:ext cx="4754880" cy="274320"/>
+          </a:xfrm>
+          <a:prstGeom prst="rect">
+            <a:avLst/>
+          </a:prstGeom>
+          <a:noFill/>
+        </p:spPr>
+        <p:txBody>
+          <a:bodyPr wrap="square" anchor="t" lIns="0" rIns="0" tIns="0" bIns="0">
+            <a:spAutoFit/>
+          </a:bodyPr>
+          <a:lstStyle/>
+          <a:p>
+            <a:pPr algn="l">
+              <a:lnSpc>
+                <a:spcPct val="115000"/>
+              </a:lnSpc>
+              <a:spcAft>
+                <a:spcPts val="0"/>
+              </a:spcAft>
+            </a:pPr>
+            <a:r>
+              <a:rPr sz="800" b="1">
+                <a:solidFill>
+                  <a:srgbClr val="5F6D66"/>
+                </a:solidFill>
+                <a:latin typeface="Instrument Sans"/>
+              </a:rPr>
+              <a:t>TODAY</a:t>
+            </a:r>
+          </a:p>
+        </p:txBody>
+      </p:sp>
+      <p:sp>
+        <p:nvSpPr>
+          <p:cNvPr id="5" name="TextBox 4"/>
+          <p:cNvSpPr txBox="1"/>
+          <p:nvPr/>
+        </p:nvSpPr>
+        <p:spPr>
+          <a:xfrm>
+            <a:off x="6035040" y="1600200"/>
+            <a:ext cx="5394960" cy="274320"/>
+          </a:xfrm>
+          <a:prstGeom prst="rect">
+            <a:avLst/>
+          </a:prstGeom>
+          <a:noFill/>
+        </p:spPr>
+        <p:txBody>
+          <a:bodyPr wrap="square" anchor="t" lIns="0" rIns="0" tIns="0" bIns="0">
+            <a:spAutoFit/>
+          </a:bodyPr>
+          <a:lstStyle/>
+          <a:p>
+            <a:pPr algn="l">
+              <a:lnSpc>
+                <a:spcPct val="115000"/>
+              </a:lnSpc>
+              <a:spcAft>
+                <a:spcPts val="0"/>
+              </a:spcAft>
+            </a:pPr>
+            <a:r>
+              <a:rPr sz="800" b="1">
+                <a:solidFill>
+                  <a:srgbClr val="6D2E5B"/>
+                </a:solidFill>
+                <a:latin typeface="Instrument Sans"/>
+              </a:rPr>
+              <a:t>WITH CARECIRCLE</a:t>
+            </a:r>
+          </a:p>
+        </p:txBody>
+      </p:sp>
+      <p:sp>
+        <p:nvSpPr>
+          <p:cNvPr id="6" name="Rounded Rectangle 5"/>
           <p:cNvSpPr/>
           <p:nvPr/>
         </p:nvSpPr>
         <p:spPr>
           <a:xfrm>
-            <a:off x="731520" y="1965959"/>
-            <a:ext cx="128016" cy="128016"/>
-          </a:xfrm>
-          <a:prstGeom prst="ellipse">
-            <a:avLst/>
+            <a:off x="731520" y="1920240"/>
+            <a:ext cx="4754880" cy="868680"/>
+          </a:xfrm>
+          <a:prstGeom prst="roundRect">
+            <a:avLst>
+              <a:gd name="adj" fmla="val 6000"/>
+            </a:avLst>
           </a:prstGeom>
           <a:solidFill>
-            <a:srgbClr val="2F6B4F"/>
+            <a:srgbClr val="FFFFFF"/>
           </a:solidFill>
-          <a:ln>
-            <a:noFill/>
+          <a:ln w="9525">
+            <a:solidFill>
+              <a:srgbClr val="D8DED9"/>
+            </a:solidFill>
           </a:ln>
           <a:effectLst/>
         </p:spPr>
@@ -7226,14 +7403,14 @@
       </p:sp>
       <p:sp>
         <p:nvSpPr>
-          <p:cNvPr id="5" name="TextBox 4"/>
+          <p:cNvPr id="7" name="TextBox 6"/>
           <p:cNvSpPr txBox="1"/>
           <p:nvPr/>
         </p:nvSpPr>
         <p:spPr>
           <a:xfrm>
-            <a:off x="1097280" y="1874519"/>
-            <a:ext cx="9875520" cy="640080"/>
+            <a:off x="914400" y="2029968"/>
+            <a:ext cx="4389120" cy="685800"/>
           </a:xfrm>
           <a:prstGeom prst="rect">
             <a:avLst/>
@@ -7255,54 +7432,82 @@
               </a:spcAft>
             </a:pPr>
             <a:r>
-              <a:rPr sz="1450" b="1">
-                <a:solidFill>
-                  <a:srgbClr val="14261F"/>
+              <a:rPr sz="1200" b="0">
+                <a:solidFill>
+                  <a:srgbClr val="5F6D66"/>
                 </a:solidFill>
                 <a:latin typeface="Instrument Sans"/>
               </a:rPr>
-              <a:t>Eleanor's body. </a:t>
-            </a:r>
-            <a:r>
-              <a:rPr sz="1450" b="0">
-                <a:solidFill>
-                  <a:srgbClr val="5F6D66"/>
-                </a:solidFill>
-                <a:latin typeface="Instrument Sans"/>
-              </a:rPr>
-              <a:t>Nine systems coloured from her live record in the Body tab, consent-gated per system; the Home boxes say what needs watching. Trend cards  </a:t>
-            </a:r>
-            <a:r>
-              <a:rPr sz="850" b="1">
-                <a:solidFill>
-                  <a:srgbClr val="1E4A36"/>
-                </a:solidFill>
-                <a:latin typeface="Instrument Sans"/>
-              </a:rPr>
-              <a:t>LIVE FROM THE PROTOTYPE</a:t>
-            </a:r>
-          </a:p>
-        </p:txBody>
-      </p:sp>
-      <p:sp>
-        <p:nvSpPr>
-          <p:cNvPr id="6" name="Oval 5"/>
+              <a:t>Four low white cell counts since May, each filed on its own.</a:t>
+            </a:r>
+          </a:p>
+        </p:txBody>
+      </p:sp>
+      <p:sp>
+        <p:nvSpPr>
+          <p:cNvPr id="8" name="TextBox 7"/>
+          <p:cNvSpPr txBox="1"/>
+          <p:nvPr/>
+        </p:nvSpPr>
+        <p:spPr>
+          <a:xfrm>
+            <a:off x="5486400" y="2148840"/>
+            <a:ext cx="548640" cy="457200"/>
+          </a:xfrm>
+          <a:prstGeom prst="rect">
+            <a:avLst/>
+          </a:prstGeom>
+          <a:noFill/>
+        </p:spPr>
+        <p:txBody>
+          <a:bodyPr wrap="square" anchor="t" lIns="0" rIns="0" tIns="0" bIns="0">
+            <a:spAutoFit/>
+          </a:bodyPr>
+          <a:lstStyle/>
+          <a:p>
+            <a:pPr algn="ctr">
+              <a:lnSpc>
+                <a:spcPct val="115000"/>
+              </a:lnSpc>
+              <a:spcAft>
+                <a:spcPts val="0"/>
+              </a:spcAft>
+            </a:pPr>
+            <a:r>
+              <a:rPr sz="1800" b="1">
+                <a:solidFill>
+                  <a:srgbClr val="6D2E5B"/>
+                </a:solidFill>
+                <a:latin typeface="Bricolage Grotesque"/>
+              </a:rPr>
+              <a:t>→</a:t>
+            </a:r>
+          </a:p>
+        </p:txBody>
+      </p:sp>
+      <p:sp>
+        <p:nvSpPr>
+          <p:cNvPr id="9" name="Rounded Rectangle 8"/>
           <p:cNvSpPr/>
           <p:nvPr/>
         </p:nvSpPr>
         <p:spPr>
           <a:xfrm>
-            <a:off x="731520" y="2624327"/>
-            <a:ext cx="128016" cy="128016"/>
-          </a:xfrm>
-          <a:prstGeom prst="ellipse">
-            <a:avLst/>
+            <a:off x="6035040" y="1920240"/>
+            <a:ext cx="5394960" cy="868680"/>
+          </a:xfrm>
+          <a:prstGeom prst="roundRect">
+            <a:avLst>
+              <a:gd name="adj" fmla="val 6000"/>
+            </a:avLst>
           </a:prstGeom>
           <a:solidFill>
-            <a:srgbClr val="2F6B4F"/>
+            <a:srgbClr val="F1E4EC"/>
           </a:solidFill>
-          <a:ln>
-            <a:noFill/>
+          <a:ln w="9525">
+            <a:solidFill>
+              <a:srgbClr val="6D2E5B"/>
+            </a:solidFill>
           </a:ln>
           <a:effectLst/>
         </p:spPr>
@@ -7330,14 +7535,14 @@
       </p:sp>
       <p:sp>
         <p:nvSpPr>
-          <p:cNvPr id="7" name="TextBox 6"/>
+          <p:cNvPr id="10" name="TextBox 9"/>
           <p:cNvSpPr txBox="1"/>
           <p:nvPr/>
         </p:nvSpPr>
         <p:spPr>
           <a:xfrm>
-            <a:off x="1097280" y="2532887"/>
-            <a:ext cx="9875520" cy="640080"/>
+            <a:off x="6217920" y="2029968"/>
+            <a:ext cx="5029200" cy="685800"/>
           </a:xfrm>
           <a:prstGeom prst="rect">
             <a:avLst/>
@@ -7359,45 +7564,40 @@
               </a:spcAft>
             </a:pPr>
             <a:r>
-              <a:rPr sz="1450" b="1">
+              <a:rPr sz="1200" b="0">
                 <a:solidFill>
                   <a:srgbClr val="14261F"/>
                 </a:solidFill>
                 <a:latin typeface="Instrument Sans"/>
               </a:rPr>
-              <a:t>Order the LFT in Anima; advance the clock 121 minutes. </a:t>
-            </a:r>
-            <a:r>
-              <a:rPr sz="1450" b="0">
-                <a:solidFill>
-                  <a:srgbClr val="5F6D66"/>
-                </a:solidFill>
-                <a:latin typeface="Instrument Sans"/>
-              </a:rPr>
-              <a:t>The result lands as a real state change.</a:t>
-            </a:r>
-          </a:p>
-        </p:txBody>
-      </p:sp>
-      <p:sp>
-        <p:nvSpPr>
-          <p:cNvPr id="8" name="Oval 7"/>
+              <a:t>The trend is flagged as worsening the second time, in July, not filed a fourth time.</a:t>
+            </a:r>
+          </a:p>
+        </p:txBody>
+      </p:sp>
+      <p:sp>
+        <p:nvSpPr>
+          <p:cNvPr id="11" name="Rounded Rectangle 10"/>
           <p:cNvSpPr/>
           <p:nvPr/>
         </p:nvSpPr>
         <p:spPr>
           <a:xfrm>
-            <a:off x="731520" y="3282695"/>
-            <a:ext cx="128016" cy="128016"/>
-          </a:xfrm>
-          <a:prstGeom prst="ellipse">
-            <a:avLst/>
+            <a:off x="731520" y="2926080"/>
+            <a:ext cx="4754880" cy="868680"/>
+          </a:xfrm>
+          <a:prstGeom prst="roundRect">
+            <a:avLst>
+              <a:gd name="adj" fmla="val 6000"/>
+            </a:avLst>
           </a:prstGeom>
           <a:solidFill>
-            <a:srgbClr val="2F6B4F"/>
+            <a:srgbClr val="FFFFFF"/>
           </a:solidFill>
-          <a:ln>
-            <a:noFill/>
+          <a:ln w="9525">
+            <a:solidFill>
+              <a:srgbClr val="D8DED9"/>
+            </a:solidFill>
           </a:ln>
           <a:effectLst/>
         </p:spPr>
@@ -7425,14 +7625,14 @@
       </p:sp>
       <p:sp>
         <p:nvSpPr>
-          <p:cNvPr id="9" name="TextBox 8"/>
+          <p:cNvPr id="12" name="TextBox 11"/>
           <p:cNvSpPr txBox="1"/>
           <p:nvPr/>
         </p:nvSpPr>
         <p:spPr>
           <a:xfrm>
-            <a:off x="1097280" y="3191255"/>
-            <a:ext cx="9875520" cy="640080"/>
+            <a:off x="914400" y="3035808"/>
+            <a:ext cx="4389120" cy="685800"/>
           </a:xfrm>
           <a:prstGeom prst="rect">
             <a:avLst/>
@@ -7454,45 +7654,82 @@
               </a:spcAft>
             </a:pPr>
             <a:r>
-              <a:rPr sz="1450" b="1">
-                <a:solidFill>
-                  <a:srgbClr val="14261F"/>
+              <a:rPr sz="1200" b="0">
+                <a:solidFill>
+                  <a:srgbClr val="5F6D66"/>
                 </a:solidFill>
                 <a:latin typeface="Instrument Sans"/>
               </a:rPr>
-              <a:t>Held. </a:t>
-            </a:r>
-            <a:r>
-              <a:rPr sz="1450" b="0">
-                <a:solidFill>
-                  <a:srgbClr val="5F6D66"/>
-                </a:solidFill>
-                <a:latin typeface="Instrument Sans"/>
-              </a:rPr>
-              <a:t>Eleanor's phone: a result has arrived and the practice will talk her through it. Family sees nothing.</a:t>
-            </a:r>
-          </a:p>
-        </p:txBody>
-      </p:sp>
-      <p:sp>
-        <p:nvSpPr>
-          <p:cNvPr id="10" name="Oval 9"/>
+              <a:t>A result lands in the record. Nobody knows if she has been told.</a:t>
+            </a:r>
+          </a:p>
+        </p:txBody>
+      </p:sp>
+      <p:sp>
+        <p:nvSpPr>
+          <p:cNvPr id="13" name="TextBox 12"/>
+          <p:cNvSpPr txBox="1"/>
+          <p:nvPr/>
+        </p:nvSpPr>
+        <p:spPr>
+          <a:xfrm>
+            <a:off x="5486400" y="3154680"/>
+            <a:ext cx="548640" cy="457200"/>
+          </a:xfrm>
+          <a:prstGeom prst="rect">
+            <a:avLst/>
+          </a:prstGeom>
+          <a:noFill/>
+        </p:spPr>
+        <p:txBody>
+          <a:bodyPr wrap="square" anchor="t" lIns="0" rIns="0" tIns="0" bIns="0">
+            <a:spAutoFit/>
+          </a:bodyPr>
+          <a:lstStyle/>
+          <a:p>
+            <a:pPr algn="ctr">
+              <a:lnSpc>
+                <a:spcPct val="115000"/>
+              </a:lnSpc>
+              <a:spcAft>
+                <a:spcPts val="0"/>
+              </a:spcAft>
+            </a:pPr>
+            <a:r>
+              <a:rPr sz="1800" b="1">
+                <a:solidFill>
+                  <a:srgbClr val="6D2E5B"/>
+                </a:solidFill>
+                <a:latin typeface="Bricolage Grotesque"/>
+              </a:rPr>
+              <a:t>→</a:t>
+            </a:r>
+          </a:p>
+        </p:txBody>
+      </p:sp>
+      <p:sp>
+        <p:nvSpPr>
+          <p:cNvPr id="14" name="Rounded Rectangle 13"/>
           <p:cNvSpPr/>
           <p:nvPr/>
         </p:nvSpPr>
         <p:spPr>
           <a:xfrm>
-            <a:off x="731520" y="3941063"/>
-            <a:ext cx="128016" cy="128016"/>
-          </a:xfrm>
-          <a:prstGeom prst="ellipse">
-            <a:avLst/>
+            <a:off x="6035040" y="2926080"/>
+            <a:ext cx="5394960" cy="868680"/>
+          </a:xfrm>
+          <a:prstGeom prst="roundRect">
+            <a:avLst>
+              <a:gd name="adj" fmla="val 6000"/>
+            </a:avLst>
           </a:prstGeom>
           <a:solidFill>
-            <a:srgbClr val="2F6B4F"/>
+            <a:srgbClr val="F1E4EC"/>
           </a:solidFill>
-          <a:ln>
-            <a:noFill/>
+          <a:ln w="9525">
+            <a:solidFill>
+              <a:srgbClr val="6D2E5B"/>
+            </a:solidFill>
           </a:ln>
           <a:effectLst/>
         </p:spPr>
@@ -7520,14 +7757,14 @@
       </p:sp>
       <p:sp>
         <p:nvSpPr>
-          <p:cNvPr id="11" name="TextBox 10"/>
+          <p:cNvPr id="15" name="TextBox 14"/>
           <p:cNvSpPr txBox="1"/>
           <p:nvPr/>
         </p:nvSpPr>
         <p:spPr>
           <a:xfrm>
-            <a:off x="1097280" y="3849623"/>
-            <a:ext cx="9875520" cy="640080"/>
+            <a:off x="6217920" y="3035808"/>
+            <a:ext cx="5029200" cy="685800"/>
           </a:xfrm>
           <a:prstGeom prst="rect">
             <a:avLst/>
@@ -7549,45 +7786,40 @@
               </a:spcAft>
             </a:pPr>
             <a:r>
-              <a:rPr sz="1450" b="1">
+              <a:rPr sz="1200" b="0">
                 <a:solidFill>
                   <a:srgbClr val="14261F"/>
                 </a:solidFill>
                 <a:latin typeface="Instrument Sans"/>
               </a:rPr>
-              <a:t>Her yes. </a:t>
-            </a:r>
-            <a:r>
-              <a:rPr sz="1450" b="0">
-                <a:solidFill>
-                  <a:srgbClr val="5F6D66"/>
-                </a:solidFill>
-                <a:latin typeface="Instrument Sans"/>
-              </a:rPr>
-              <a:t>Three versions go out: Grace numbers, Idris logistics, Thomas yes/no. A task appears in Anima's activity trail.</a:t>
-            </a:r>
-          </a:p>
-        </p:txBody>
-      </p:sp>
-      <p:sp>
-        <p:nvSpPr>
-          <p:cNvPr id="12" name="Oval 11"/>
+              <a:t>The result is held. The practice talks her through it. She says yes.</a:t>
+            </a:r>
+          </a:p>
+        </p:txBody>
+      </p:sp>
+      <p:sp>
+        <p:nvSpPr>
+          <p:cNvPr id="16" name="Rounded Rectangle 15"/>
           <p:cNvSpPr/>
           <p:nvPr/>
         </p:nvSpPr>
         <p:spPr>
           <a:xfrm>
-            <a:off x="731520" y="4599431"/>
-            <a:ext cx="128016" cy="128016"/>
-          </a:xfrm>
-          <a:prstGeom prst="ellipse">
-            <a:avLst/>
+            <a:off x="731520" y="3931920"/>
+            <a:ext cx="4754880" cy="868680"/>
+          </a:xfrm>
+          <a:prstGeom prst="roundRect">
+            <a:avLst>
+              <a:gd name="adj" fmla="val 6000"/>
+            </a:avLst>
           </a:prstGeom>
           <a:solidFill>
-            <a:srgbClr val="2F6B4F"/>
+            <a:srgbClr val="FFFFFF"/>
           </a:solidFill>
-          <a:ln>
-            <a:noFill/>
+          <a:ln w="9525">
+            <a:solidFill>
+              <a:srgbClr val="D8DED9"/>
+            </a:solidFill>
           </a:ln>
           <a:effectLst/>
         </p:spPr>
@@ -7615,14 +7847,14 @@
       </p:sp>
       <p:sp>
         <p:nvSpPr>
-          <p:cNvPr id="13" name="TextBox 12"/>
+          <p:cNvPr id="17" name="TextBox 16"/>
           <p:cNvSpPr txBox="1"/>
           <p:nvPr/>
         </p:nvSpPr>
         <p:spPr>
           <a:xfrm>
-            <a:off x="1097280" y="4507991"/>
-            <a:ext cx="9875520" cy="640080"/>
+            <a:off x="914400" y="4041648"/>
+            <a:ext cx="4389120" cy="685800"/>
           </a:xfrm>
           <a:prstGeom prst="rect">
             <a:avLst/>
@@ -7644,54 +7876,82 @@
               </a:spcAft>
             </a:pPr>
             <a:r>
-              <a:rPr sz="1450" b="1">
-                <a:solidFill>
-                  <a:srgbClr val="14261F"/>
+              <a:rPr sz="1200" b="0">
+                <a:solidFill>
+                  <a:srgbClr val="5F6D66"/>
                 </a:solidFill>
                 <a:latin typeface="Instrument Sans"/>
               </a:rPr>
-              <a:t>Grace asks about a result she cannot see. </a:t>
-            </a:r>
-            <a:r>
-              <a:rPr sz="1450" b="0">
+              <a:t>Her family knows nothing. She is the messenger.</a:t>
+            </a:r>
+          </a:p>
+        </p:txBody>
+      </p:sp>
+      <p:sp>
+        <p:nvSpPr>
+          <p:cNvPr id="18" name="TextBox 17"/>
+          <p:cNvSpPr txBox="1"/>
+          <p:nvPr/>
+        </p:nvSpPr>
+        <p:spPr>
+          <a:xfrm>
+            <a:off x="5486400" y="4160520"/>
+            <a:ext cx="548640" cy="457200"/>
+          </a:xfrm>
+          <a:prstGeom prst="rect">
+            <a:avLst/>
+          </a:prstGeom>
+          <a:noFill/>
+        </p:spPr>
+        <p:txBody>
+          <a:bodyPr wrap="square" anchor="t" lIns="0" rIns="0" tIns="0" bIns="0">
+            <a:spAutoFit/>
+          </a:bodyPr>
+          <a:lstStyle/>
+          <a:p>
+            <a:pPr algn="ctr">
+              <a:lnSpc>
+                <a:spcPct val="115000"/>
+              </a:lnSpc>
+              <a:spcAft>
+                <a:spcPts val="0"/>
+              </a:spcAft>
+            </a:pPr>
+            <a:r>
+              <a:rPr sz="1800" b="1">
                 <a:solidFill>
                   <a:srgbClr val="6D2E5B"/>
                 </a:solidFill>
-                <a:latin typeface="JetBrains Mono"/>
-              </a:rPr>
-              <a:t>NOT_SHARED</a:t>
-            </a:r>
-            <a:r>
-              <a:rPr sz="1450" b="0">
-                <a:solidFill>
-                  <a:srgbClr val="5F6D66"/>
-                </a:solidFill>
-                <a:latin typeface="Instrument Sans"/>
-              </a:rPr>
-              <a:t>, no hint. She asks for access; Eleanor approves from a card; the GP consent view updates live.</a:t>
-            </a:r>
-          </a:p>
-        </p:txBody>
-      </p:sp>
-      <p:sp>
-        <p:nvSpPr>
-          <p:cNvPr id="14" name="Oval 13"/>
+                <a:latin typeface="Bricolage Grotesque"/>
+              </a:rPr>
+              <a:t>→</a:t>
+            </a:r>
+          </a:p>
+        </p:txBody>
+      </p:sp>
+      <p:sp>
+        <p:nvSpPr>
+          <p:cNvPr id="19" name="Rounded Rectangle 18"/>
           <p:cNvSpPr/>
           <p:nvPr/>
         </p:nvSpPr>
         <p:spPr>
           <a:xfrm>
-            <a:off x="731520" y="5257799"/>
-            <a:ext cx="128016" cy="128016"/>
-          </a:xfrm>
-          <a:prstGeom prst="ellipse">
-            <a:avLst/>
+            <a:off x="6035040" y="3931920"/>
+            <a:ext cx="5394960" cy="868680"/>
+          </a:xfrm>
+          <a:prstGeom prst="roundRect">
+            <a:avLst>
+              <a:gd name="adj" fmla="val 6000"/>
+            </a:avLst>
           </a:prstGeom>
           <a:solidFill>
-            <a:srgbClr val="2F6B4F"/>
+            <a:srgbClr val="F1E4EC"/>
           </a:solidFill>
-          <a:ln>
-            <a:noFill/>
+          <a:ln w="9525">
+            <a:solidFill>
+              <a:srgbClr val="6D2E5B"/>
+            </a:solidFill>
           </a:ln>
           <a:effectLst/>
         </p:spPr>
@@ -7719,14 +7979,14 @@
       </p:sp>
       <p:sp>
         <p:nvSpPr>
-          <p:cNvPr id="15" name="TextBox 14"/>
+          <p:cNvPr id="20" name="TextBox 19"/>
           <p:cNvSpPr txBox="1"/>
           <p:nvPr/>
         </p:nvSpPr>
         <p:spPr>
           <a:xfrm>
-            <a:off x="1097280" y="5166359"/>
-            <a:ext cx="9875520" cy="640080"/>
+            <a:off x="6217920" y="4041648"/>
+            <a:ext cx="5029200" cy="685800"/>
           </a:xfrm>
           <a:prstGeom prst="rect">
             <a:avLst/>
@@ -7748,29 +8008,242 @@
               </a:spcAft>
             </a:pPr>
             <a:r>
-              <a:rPr sz="1450" b="1">
+              <a:rPr sz="1200" b="0">
                 <a:solidFill>
                   <a:srgbClr val="14261F"/>
                 </a:solidFill>
                 <a:latin typeface="Instrument Sans"/>
               </a:rPr>
-              <a:t>The morning check </a:t>
-            </a:r>
-            <a:r>
-              <a:rPr sz="1450" b="0">
+              <a:t>Grace gets the numbers. Idris gets the lift to arrange. Thomas gets “nothing needed this week”.</a:t>
+            </a:r>
+          </a:p>
+        </p:txBody>
+      </p:sp>
+      <p:sp>
+        <p:nvSpPr>
+          <p:cNvPr id="21" name="Rounded Rectangle 20"/>
+          <p:cNvSpPr/>
+          <p:nvPr/>
+        </p:nvSpPr>
+        <p:spPr>
+          <a:xfrm>
+            <a:off x="731520" y="4937760"/>
+            <a:ext cx="4754880" cy="868680"/>
+          </a:xfrm>
+          <a:prstGeom prst="roundRect">
+            <a:avLst>
+              <a:gd name="adj" fmla="val 6000"/>
+            </a:avLst>
+          </a:prstGeom>
+          <a:solidFill>
+            <a:srgbClr val="FFFFFF"/>
+          </a:solidFill>
+          <a:ln w="9525">
+            <a:solidFill>
+              <a:srgbClr val="D8DED9"/>
+            </a:solidFill>
+          </a:ln>
+          <a:effectLst/>
+        </p:spPr>
+        <p:style>
+          <a:lnRef idx="1">
+            <a:schemeClr val="accent1"/>
+          </a:lnRef>
+          <a:fillRef idx="3">
+            <a:schemeClr val="accent1"/>
+          </a:fillRef>
+          <a:effectRef idx="2">
+            <a:schemeClr val="accent1"/>
+          </a:effectRef>
+          <a:fontRef idx="minor">
+            <a:schemeClr val="lt1"/>
+          </a:fontRef>
+        </p:style>
+        <p:txBody>
+          <a:bodyPr rtlCol="0" anchor="ctr"/>
+          <a:lstStyle/>
+          <a:p>
+            <a:pPr algn="ctr"/>
+          </a:p>
+        </p:txBody>
+      </p:sp>
+      <p:sp>
+        <p:nvSpPr>
+          <p:cNvPr id="22" name="TextBox 21"/>
+          <p:cNvSpPr txBox="1"/>
+          <p:nvPr/>
+        </p:nvSpPr>
+        <p:spPr>
+          <a:xfrm>
+            <a:off x="914400" y="5047488"/>
+            <a:ext cx="4389120" cy="685800"/>
+          </a:xfrm>
+          <a:prstGeom prst="rect">
+            <a:avLst/>
+          </a:prstGeom>
+          <a:noFill/>
+        </p:spPr>
+        <p:txBody>
+          <a:bodyPr wrap="square" anchor="t" lIns="0" rIns="0" tIns="0" bIns="0">
+            <a:spAutoFit/>
+          </a:bodyPr>
+          <a:lstStyle/>
+          <a:p>
+            <a:pPr algn="l">
+              <a:lnSpc>
+                <a:spcPct val="125000"/>
+              </a:lnSpc>
+              <a:spcAft>
+                <a:spcPts val="0"/>
+              </a:spcAft>
+            </a:pPr>
+            <a:r>
+              <a:rPr sz="1200" b="0">
                 <a:solidFill>
                   <a:srgbClr val="5F6D66"/>
                 </a:solidFill>
                 <a:latin typeface="Instrument Sans"/>
               </a:rPr>
-              <a:t>reads the 08:30 appointment from the record and posts to the family group: who can give Eleanor a lift?</a:t>
-            </a:r>
-          </a:p>
-        </p:txBody>
-      </p:sp>
-      <p:sp>
-        <p:nvSpPr>
-          <p:cNvPr id="16" name="TextBox 15"/>
+              <a:t>Nobody follows up. Nothing chases it.</a:t>
+            </a:r>
+          </a:p>
+        </p:txBody>
+      </p:sp>
+      <p:sp>
+        <p:nvSpPr>
+          <p:cNvPr id="23" name="TextBox 22"/>
+          <p:cNvSpPr txBox="1"/>
+          <p:nvPr/>
+        </p:nvSpPr>
+        <p:spPr>
+          <a:xfrm>
+            <a:off x="5486400" y="5166360"/>
+            <a:ext cx="548640" cy="457200"/>
+          </a:xfrm>
+          <a:prstGeom prst="rect">
+            <a:avLst/>
+          </a:prstGeom>
+          <a:noFill/>
+        </p:spPr>
+        <p:txBody>
+          <a:bodyPr wrap="square" anchor="t" lIns="0" rIns="0" tIns="0" bIns="0">
+            <a:spAutoFit/>
+          </a:bodyPr>
+          <a:lstStyle/>
+          <a:p>
+            <a:pPr algn="ctr">
+              <a:lnSpc>
+                <a:spcPct val="115000"/>
+              </a:lnSpc>
+              <a:spcAft>
+                <a:spcPts val="0"/>
+              </a:spcAft>
+            </a:pPr>
+            <a:r>
+              <a:rPr sz="1800" b="1">
+                <a:solidFill>
+                  <a:srgbClr val="6D2E5B"/>
+                </a:solidFill>
+                <a:latin typeface="Bricolage Grotesque"/>
+              </a:rPr>
+              <a:t>→</a:t>
+            </a:r>
+          </a:p>
+        </p:txBody>
+      </p:sp>
+      <p:sp>
+        <p:nvSpPr>
+          <p:cNvPr id="24" name="Rounded Rectangle 23"/>
+          <p:cNvSpPr/>
+          <p:nvPr/>
+        </p:nvSpPr>
+        <p:spPr>
+          <a:xfrm>
+            <a:off x="6035040" y="4937760"/>
+            <a:ext cx="5394960" cy="868680"/>
+          </a:xfrm>
+          <a:prstGeom prst="roundRect">
+            <a:avLst>
+              <a:gd name="adj" fmla="val 6000"/>
+            </a:avLst>
+          </a:prstGeom>
+          <a:solidFill>
+            <a:srgbClr val="F1E4EC"/>
+          </a:solidFill>
+          <a:ln w="9525">
+            <a:solidFill>
+              <a:srgbClr val="6D2E5B"/>
+            </a:solidFill>
+          </a:ln>
+          <a:effectLst/>
+        </p:spPr>
+        <p:style>
+          <a:lnRef idx="1">
+            <a:schemeClr val="accent1"/>
+          </a:lnRef>
+          <a:fillRef idx="3">
+            <a:schemeClr val="accent1"/>
+          </a:fillRef>
+          <a:effectRef idx="2">
+            <a:schemeClr val="accent1"/>
+          </a:effectRef>
+          <a:fontRef idx="minor">
+            <a:schemeClr val="lt1"/>
+          </a:fontRef>
+        </p:style>
+        <p:txBody>
+          <a:bodyPr rtlCol="0" anchor="ctr"/>
+          <a:lstStyle/>
+          <a:p>
+            <a:pPr algn="ctr"/>
+          </a:p>
+        </p:txBody>
+      </p:sp>
+      <p:sp>
+        <p:nvSpPr>
+          <p:cNvPr id="25" name="TextBox 24"/>
+          <p:cNvSpPr txBox="1"/>
+          <p:nvPr/>
+        </p:nvSpPr>
+        <p:spPr>
+          <a:xfrm>
+            <a:off x="6217920" y="5047488"/>
+            <a:ext cx="5029200" cy="685800"/>
+          </a:xfrm>
+          <a:prstGeom prst="rect">
+            <a:avLst/>
+          </a:prstGeom>
+          <a:noFill/>
+        </p:spPr>
+        <p:txBody>
+          <a:bodyPr wrap="square" anchor="t" lIns="0" rIns="0" tIns="0" bIns="0">
+            <a:spAutoFit/>
+          </a:bodyPr>
+          <a:lstStyle/>
+          <a:p>
+            <a:pPr algn="l">
+              <a:lnSpc>
+                <a:spcPct val="125000"/>
+              </a:lnSpc>
+              <a:spcAft>
+                <a:spcPts val="0"/>
+              </a:spcAft>
+            </a:pPr>
+            <a:r>
+              <a:rPr sz="1200" b="0">
+                <a:solidFill>
+                  <a:srgbClr val="14261F"/>
+                </a:solidFill>
+                <a:latin typeface="Instrument Sans"/>
+              </a:rPr>
+              <a:t>Three days with no confirmation: a GP task is raised and her landline rings.</a:t>
+            </a:r>
+          </a:p>
+        </p:txBody>
+      </p:sp>
+      <p:sp>
+        <p:nvSpPr>
+          <p:cNvPr id="26" name="TextBox 25"/>
           <p:cNvSpPr txBox="1"/>
           <p:nvPr/>
         </p:nvSpPr>
@@ -7805,14 +8278,14 @@
                 </a:solidFill>
                 <a:latin typeface="Instrument Sans"/>
               </a:rPr>
-              <a:t>Visibly simulated: WhatsApp delivery, relative identity checks, the clinician's “discussed with patient” tap, the persona switcher. Consent writes go to the companion backend, not native FHIR Consent on the remote simulator.</a:t>
-            </a:r>
-          </a:p>
-        </p:txBody>
-      </p:sp>
-      <p:sp>
-        <p:nvSpPr>
-          <p:cNvPr id="17" name="TextBox 16"/>
+              <a:t>Every line on the right is something the demo shows. All patient data synthetic.</a:t>
+            </a:r>
+          </a:p>
+        </p:txBody>
+      </p:sp>
+      <p:sp>
+        <p:nvSpPr>
+          <p:cNvPr id="27" name="TextBox 26"/>
           <p:cNvSpPr txBox="1"/>
           <p:nvPr/>
         </p:nvSpPr>
@@ -7915,7 +8388,7 @@
                 </a:solidFill>
                 <a:latin typeface="Instrument Sans"/>
               </a:rPr>
-              <a:t>10 YEAR HEALTH PLAN FIT</a:t>
+              <a:t>THE DEMO</a:t>
             </a:r>
           </a:p>
         </p:txBody>
@@ -7928,8 +8401,8 @@
         </p:nvSpPr>
         <p:spPr>
           <a:xfrm>
-            <a:off x="731520" y="1188720"/>
-            <a:ext cx="10515600" cy="822960"/>
+            <a:off x="731520" y="868680"/>
+            <a:ext cx="9144000" cy="731520"/>
           </a:xfrm>
           <a:prstGeom prst="rect">
             <a:avLst/>
@@ -7951,45 +8424,615 @@
               </a:spcAft>
             </a:pPr>
             <a:r>
-              <a:rPr sz="2400" b="1">
+              <a:rPr sz="3600" b="1">
+                <a:solidFill>
+                  <a:srgbClr val="14261F"/>
+                </a:solidFill>
+                <a:latin typeface="Bricolage Grotesque"/>
+              </a:rPr>
+              <a:t>90 seconds, live against Anima.</a:t>
+            </a:r>
+          </a:p>
+        </p:txBody>
+      </p:sp>
+      <p:sp>
+        <p:nvSpPr>
+          <p:cNvPr id="4" name="Oval 3"/>
+          <p:cNvSpPr/>
+          <p:nvPr/>
+        </p:nvSpPr>
+        <p:spPr>
+          <a:xfrm>
+            <a:off x="731520" y="1965959"/>
+            <a:ext cx="128016" cy="128016"/>
+          </a:xfrm>
+          <a:prstGeom prst="ellipse">
+            <a:avLst/>
+          </a:prstGeom>
+          <a:solidFill>
+            <a:srgbClr val="2F6B4F"/>
+          </a:solidFill>
+          <a:ln>
+            <a:noFill/>
+          </a:ln>
+          <a:effectLst/>
+        </p:spPr>
+        <p:style>
+          <a:lnRef idx="1">
+            <a:schemeClr val="accent1"/>
+          </a:lnRef>
+          <a:fillRef idx="3">
+            <a:schemeClr val="accent1"/>
+          </a:fillRef>
+          <a:effectRef idx="2">
+            <a:schemeClr val="accent1"/>
+          </a:effectRef>
+          <a:fontRef idx="minor">
+            <a:schemeClr val="lt1"/>
+          </a:fontRef>
+        </p:style>
+        <p:txBody>
+          <a:bodyPr rtlCol="0" anchor="ctr"/>
+          <a:lstStyle/>
+          <a:p>
+            <a:pPr algn="ctr"/>
+          </a:p>
+        </p:txBody>
+      </p:sp>
+      <p:sp>
+        <p:nvSpPr>
+          <p:cNvPr id="5" name="TextBox 4"/>
+          <p:cNvSpPr txBox="1"/>
+          <p:nvPr/>
+        </p:nvSpPr>
+        <p:spPr>
+          <a:xfrm>
+            <a:off x="1097280" y="1874519"/>
+            <a:ext cx="9875520" cy="640080"/>
+          </a:xfrm>
+          <a:prstGeom prst="rect">
+            <a:avLst/>
+          </a:prstGeom>
+          <a:noFill/>
+        </p:spPr>
+        <p:txBody>
+          <a:bodyPr wrap="square" anchor="t" lIns="0" rIns="0" tIns="0" bIns="0">
+            <a:spAutoFit/>
+          </a:bodyPr>
+          <a:lstStyle/>
+          <a:p>
+            <a:pPr algn="l">
+              <a:lnSpc>
+                <a:spcPct val="125000"/>
+              </a:lnSpc>
+              <a:spcAft>
+                <a:spcPts val="0"/>
+              </a:spcAft>
+            </a:pPr>
+            <a:r>
+              <a:rPr sz="1450" b="1">
+                <a:solidFill>
+                  <a:srgbClr val="14261F"/>
+                </a:solidFill>
+                <a:latin typeface="Instrument Sans"/>
+              </a:rPr>
+              <a:t>Eleanor's body. </a:t>
+            </a:r>
+            <a:r>
+              <a:rPr sz="1450" b="0">
+                <a:solidFill>
+                  <a:srgbClr val="5F6D66"/>
+                </a:solidFill>
+                <a:latin typeface="Instrument Sans"/>
+              </a:rPr>
+              <a:t>Nine systems coloured from her live record in the Body tab, consent-gated per system; the Home boxes say what needs watching. Trend cards  </a:t>
+            </a:r>
+            <a:r>
+              <a:rPr sz="850" b="1">
+                <a:solidFill>
+                  <a:srgbClr val="1E4A36"/>
+                </a:solidFill>
+                <a:latin typeface="Instrument Sans"/>
+              </a:rPr>
+              <a:t>LIVE FROM THE PROTOTYPE</a:t>
+            </a:r>
+          </a:p>
+        </p:txBody>
+      </p:sp>
+      <p:sp>
+        <p:nvSpPr>
+          <p:cNvPr id="6" name="Oval 5"/>
+          <p:cNvSpPr/>
+          <p:nvPr/>
+        </p:nvSpPr>
+        <p:spPr>
+          <a:xfrm>
+            <a:off x="731520" y="2624327"/>
+            <a:ext cx="128016" cy="128016"/>
+          </a:xfrm>
+          <a:prstGeom prst="ellipse">
+            <a:avLst/>
+          </a:prstGeom>
+          <a:solidFill>
+            <a:srgbClr val="2F6B4F"/>
+          </a:solidFill>
+          <a:ln>
+            <a:noFill/>
+          </a:ln>
+          <a:effectLst/>
+        </p:spPr>
+        <p:style>
+          <a:lnRef idx="1">
+            <a:schemeClr val="accent1"/>
+          </a:lnRef>
+          <a:fillRef idx="3">
+            <a:schemeClr val="accent1"/>
+          </a:fillRef>
+          <a:effectRef idx="2">
+            <a:schemeClr val="accent1"/>
+          </a:effectRef>
+          <a:fontRef idx="minor">
+            <a:schemeClr val="lt1"/>
+          </a:fontRef>
+        </p:style>
+        <p:txBody>
+          <a:bodyPr rtlCol="0" anchor="ctr"/>
+          <a:lstStyle/>
+          <a:p>
+            <a:pPr algn="ctr"/>
+          </a:p>
+        </p:txBody>
+      </p:sp>
+      <p:sp>
+        <p:nvSpPr>
+          <p:cNvPr id="7" name="TextBox 6"/>
+          <p:cNvSpPr txBox="1"/>
+          <p:nvPr/>
+        </p:nvSpPr>
+        <p:spPr>
+          <a:xfrm>
+            <a:off x="1097280" y="2532887"/>
+            <a:ext cx="9875520" cy="640080"/>
+          </a:xfrm>
+          <a:prstGeom prst="rect">
+            <a:avLst/>
+          </a:prstGeom>
+          <a:noFill/>
+        </p:spPr>
+        <p:txBody>
+          <a:bodyPr wrap="square" anchor="t" lIns="0" rIns="0" tIns="0" bIns="0">
+            <a:spAutoFit/>
+          </a:bodyPr>
+          <a:lstStyle/>
+          <a:p>
+            <a:pPr algn="l">
+              <a:lnSpc>
+                <a:spcPct val="125000"/>
+              </a:lnSpc>
+              <a:spcAft>
+                <a:spcPts val="0"/>
+              </a:spcAft>
+            </a:pPr>
+            <a:r>
+              <a:rPr sz="1450" b="1">
+                <a:solidFill>
+                  <a:srgbClr val="14261F"/>
+                </a:solidFill>
+                <a:latin typeface="Instrument Sans"/>
+              </a:rPr>
+              <a:t>Order the LFT in Anima; advance the clock 121 minutes. </a:t>
+            </a:r>
+            <a:r>
+              <a:rPr sz="1450" b="0">
+                <a:solidFill>
+                  <a:srgbClr val="5F6D66"/>
+                </a:solidFill>
+                <a:latin typeface="Instrument Sans"/>
+              </a:rPr>
+              <a:t>The result lands as a real state change.</a:t>
+            </a:r>
+          </a:p>
+        </p:txBody>
+      </p:sp>
+      <p:sp>
+        <p:nvSpPr>
+          <p:cNvPr id="8" name="Oval 7"/>
+          <p:cNvSpPr/>
+          <p:nvPr/>
+        </p:nvSpPr>
+        <p:spPr>
+          <a:xfrm>
+            <a:off x="731520" y="3282695"/>
+            <a:ext cx="128016" cy="128016"/>
+          </a:xfrm>
+          <a:prstGeom prst="ellipse">
+            <a:avLst/>
+          </a:prstGeom>
+          <a:solidFill>
+            <a:srgbClr val="2F6B4F"/>
+          </a:solidFill>
+          <a:ln>
+            <a:noFill/>
+          </a:ln>
+          <a:effectLst/>
+        </p:spPr>
+        <p:style>
+          <a:lnRef idx="1">
+            <a:schemeClr val="accent1"/>
+          </a:lnRef>
+          <a:fillRef idx="3">
+            <a:schemeClr val="accent1"/>
+          </a:fillRef>
+          <a:effectRef idx="2">
+            <a:schemeClr val="accent1"/>
+          </a:effectRef>
+          <a:fontRef idx="minor">
+            <a:schemeClr val="lt1"/>
+          </a:fontRef>
+        </p:style>
+        <p:txBody>
+          <a:bodyPr rtlCol="0" anchor="ctr"/>
+          <a:lstStyle/>
+          <a:p>
+            <a:pPr algn="ctr"/>
+          </a:p>
+        </p:txBody>
+      </p:sp>
+      <p:sp>
+        <p:nvSpPr>
+          <p:cNvPr id="9" name="TextBox 8"/>
+          <p:cNvSpPr txBox="1"/>
+          <p:nvPr/>
+        </p:nvSpPr>
+        <p:spPr>
+          <a:xfrm>
+            <a:off x="1097280" y="3191255"/>
+            <a:ext cx="9875520" cy="640080"/>
+          </a:xfrm>
+          <a:prstGeom prst="rect">
+            <a:avLst/>
+          </a:prstGeom>
+          <a:noFill/>
+        </p:spPr>
+        <p:txBody>
+          <a:bodyPr wrap="square" anchor="t" lIns="0" rIns="0" tIns="0" bIns="0">
+            <a:spAutoFit/>
+          </a:bodyPr>
+          <a:lstStyle/>
+          <a:p>
+            <a:pPr algn="l">
+              <a:lnSpc>
+                <a:spcPct val="125000"/>
+              </a:lnSpc>
+              <a:spcAft>
+                <a:spcPts val="0"/>
+              </a:spcAft>
+            </a:pPr>
+            <a:r>
+              <a:rPr sz="1450" b="1">
+                <a:solidFill>
+                  <a:srgbClr val="14261F"/>
+                </a:solidFill>
+                <a:latin typeface="Instrument Sans"/>
+              </a:rPr>
+              <a:t>Held. </a:t>
+            </a:r>
+            <a:r>
+              <a:rPr sz="1450" b="0">
+                <a:solidFill>
+                  <a:srgbClr val="5F6D66"/>
+                </a:solidFill>
+                <a:latin typeface="Instrument Sans"/>
+              </a:rPr>
+              <a:t>Eleanor's phone: a result has arrived and the practice will talk her through it. Family sees nothing.</a:t>
+            </a:r>
+          </a:p>
+        </p:txBody>
+      </p:sp>
+      <p:sp>
+        <p:nvSpPr>
+          <p:cNvPr id="10" name="Oval 9"/>
+          <p:cNvSpPr/>
+          <p:nvPr/>
+        </p:nvSpPr>
+        <p:spPr>
+          <a:xfrm>
+            <a:off x="731520" y="3941063"/>
+            <a:ext cx="128016" cy="128016"/>
+          </a:xfrm>
+          <a:prstGeom prst="ellipse">
+            <a:avLst/>
+          </a:prstGeom>
+          <a:solidFill>
+            <a:srgbClr val="2F6B4F"/>
+          </a:solidFill>
+          <a:ln>
+            <a:noFill/>
+          </a:ln>
+          <a:effectLst/>
+        </p:spPr>
+        <p:style>
+          <a:lnRef idx="1">
+            <a:schemeClr val="accent1"/>
+          </a:lnRef>
+          <a:fillRef idx="3">
+            <a:schemeClr val="accent1"/>
+          </a:fillRef>
+          <a:effectRef idx="2">
+            <a:schemeClr val="accent1"/>
+          </a:effectRef>
+          <a:fontRef idx="minor">
+            <a:schemeClr val="lt1"/>
+          </a:fontRef>
+        </p:style>
+        <p:txBody>
+          <a:bodyPr rtlCol="0" anchor="ctr"/>
+          <a:lstStyle/>
+          <a:p>
+            <a:pPr algn="ctr"/>
+          </a:p>
+        </p:txBody>
+      </p:sp>
+      <p:sp>
+        <p:nvSpPr>
+          <p:cNvPr id="11" name="TextBox 10"/>
+          <p:cNvSpPr txBox="1"/>
+          <p:nvPr/>
+        </p:nvSpPr>
+        <p:spPr>
+          <a:xfrm>
+            <a:off x="1097280" y="3849623"/>
+            <a:ext cx="9875520" cy="640080"/>
+          </a:xfrm>
+          <a:prstGeom prst="rect">
+            <a:avLst/>
+          </a:prstGeom>
+          <a:noFill/>
+        </p:spPr>
+        <p:txBody>
+          <a:bodyPr wrap="square" anchor="t" lIns="0" rIns="0" tIns="0" bIns="0">
+            <a:spAutoFit/>
+          </a:bodyPr>
+          <a:lstStyle/>
+          <a:p>
+            <a:pPr algn="l">
+              <a:lnSpc>
+                <a:spcPct val="125000"/>
+              </a:lnSpc>
+              <a:spcAft>
+                <a:spcPts val="0"/>
+              </a:spcAft>
+            </a:pPr>
+            <a:r>
+              <a:rPr sz="1450" b="1">
+                <a:solidFill>
+                  <a:srgbClr val="14261F"/>
+                </a:solidFill>
+                <a:latin typeface="Instrument Sans"/>
+              </a:rPr>
+              <a:t>Her yes. </a:t>
+            </a:r>
+            <a:r>
+              <a:rPr sz="1450" b="0">
+                <a:solidFill>
+                  <a:srgbClr val="5F6D66"/>
+                </a:solidFill>
+                <a:latin typeface="Instrument Sans"/>
+              </a:rPr>
+              <a:t>Three versions go out: Grace numbers, Idris logistics, Thomas yes/no. A task appears in Anima's activity trail.</a:t>
+            </a:r>
+          </a:p>
+        </p:txBody>
+      </p:sp>
+      <p:sp>
+        <p:nvSpPr>
+          <p:cNvPr id="12" name="Oval 11"/>
+          <p:cNvSpPr/>
+          <p:nvPr/>
+        </p:nvSpPr>
+        <p:spPr>
+          <a:xfrm>
+            <a:off x="731520" y="4599431"/>
+            <a:ext cx="128016" cy="128016"/>
+          </a:xfrm>
+          <a:prstGeom prst="ellipse">
+            <a:avLst/>
+          </a:prstGeom>
+          <a:solidFill>
+            <a:srgbClr val="2F6B4F"/>
+          </a:solidFill>
+          <a:ln>
+            <a:noFill/>
+          </a:ln>
+          <a:effectLst/>
+        </p:spPr>
+        <p:style>
+          <a:lnRef idx="1">
+            <a:schemeClr val="accent1"/>
+          </a:lnRef>
+          <a:fillRef idx="3">
+            <a:schemeClr val="accent1"/>
+          </a:fillRef>
+          <a:effectRef idx="2">
+            <a:schemeClr val="accent1"/>
+          </a:effectRef>
+          <a:fontRef idx="minor">
+            <a:schemeClr val="lt1"/>
+          </a:fontRef>
+        </p:style>
+        <p:txBody>
+          <a:bodyPr rtlCol="0" anchor="ctr"/>
+          <a:lstStyle/>
+          <a:p>
+            <a:pPr algn="ctr"/>
+          </a:p>
+        </p:txBody>
+      </p:sp>
+      <p:sp>
+        <p:nvSpPr>
+          <p:cNvPr id="13" name="TextBox 12"/>
+          <p:cNvSpPr txBox="1"/>
+          <p:nvPr/>
+        </p:nvSpPr>
+        <p:spPr>
+          <a:xfrm>
+            <a:off x="1097280" y="4507991"/>
+            <a:ext cx="9875520" cy="640080"/>
+          </a:xfrm>
+          <a:prstGeom prst="rect">
+            <a:avLst/>
+          </a:prstGeom>
+          <a:noFill/>
+        </p:spPr>
+        <p:txBody>
+          <a:bodyPr wrap="square" anchor="t" lIns="0" rIns="0" tIns="0" bIns="0">
+            <a:spAutoFit/>
+          </a:bodyPr>
+          <a:lstStyle/>
+          <a:p>
+            <a:pPr algn="l">
+              <a:lnSpc>
+                <a:spcPct val="125000"/>
+              </a:lnSpc>
+              <a:spcAft>
+                <a:spcPts val="0"/>
+              </a:spcAft>
+            </a:pPr>
+            <a:r>
+              <a:rPr sz="1450" b="1">
+                <a:solidFill>
+                  <a:srgbClr val="14261F"/>
+                </a:solidFill>
+                <a:latin typeface="Instrument Sans"/>
+              </a:rPr>
+              <a:t>Grace asks about a result she cannot see. </a:t>
+            </a:r>
+            <a:r>
+              <a:rPr sz="1450" b="0">
                 <a:solidFill>
                   <a:srgbClr val="6D2E5B"/>
                 </a:solidFill>
-                <a:latin typeface="Bricolage Grotesque"/>
-              </a:rPr>
-              <a:t>“</a:t>
-            </a:r>
-            <a:r>
-              <a:rPr sz="2400" b="1">
+                <a:latin typeface="JetBrains Mono"/>
+              </a:rPr>
+              <a:t>NOT_SHARED</a:t>
+            </a:r>
+            <a:r>
+              <a:rPr sz="1450" b="0">
+                <a:solidFill>
+                  <a:srgbClr val="5F6D66"/>
+                </a:solidFill>
+                <a:latin typeface="Instrument Sans"/>
+              </a:rPr>
+              <a:t>, no hint. She asks for access; Eleanor approves from a card; the GP consent view updates live.</a:t>
+            </a:r>
+          </a:p>
+        </p:txBody>
+      </p:sp>
+      <p:sp>
+        <p:nvSpPr>
+          <p:cNvPr id="14" name="Oval 13"/>
+          <p:cNvSpPr/>
+          <p:nvPr/>
+        </p:nvSpPr>
+        <p:spPr>
+          <a:xfrm>
+            <a:off x="731520" y="5257799"/>
+            <a:ext cx="128016" cy="128016"/>
+          </a:xfrm>
+          <a:prstGeom prst="ellipse">
+            <a:avLst/>
+          </a:prstGeom>
+          <a:solidFill>
+            <a:srgbClr val="2F6B4F"/>
+          </a:solidFill>
+          <a:ln>
+            <a:noFill/>
+          </a:ln>
+          <a:effectLst/>
+        </p:spPr>
+        <p:style>
+          <a:lnRef idx="1">
+            <a:schemeClr val="accent1"/>
+          </a:lnRef>
+          <a:fillRef idx="3">
+            <a:schemeClr val="accent1"/>
+          </a:fillRef>
+          <a:effectRef idx="2">
+            <a:schemeClr val="accent1"/>
+          </a:effectRef>
+          <a:fontRef idx="minor">
+            <a:schemeClr val="lt1"/>
+          </a:fontRef>
+        </p:style>
+        <p:txBody>
+          <a:bodyPr rtlCol="0" anchor="ctr"/>
+          <a:lstStyle/>
+          <a:p>
+            <a:pPr algn="ctr"/>
+          </a:p>
+        </p:txBody>
+      </p:sp>
+      <p:sp>
+        <p:nvSpPr>
+          <p:cNvPr id="15" name="TextBox 14"/>
+          <p:cNvSpPr txBox="1"/>
+          <p:nvPr/>
+        </p:nvSpPr>
+        <p:spPr>
+          <a:xfrm>
+            <a:off x="1097280" y="5166359"/>
+            <a:ext cx="9875520" cy="640080"/>
+          </a:xfrm>
+          <a:prstGeom prst="rect">
+            <a:avLst/>
+          </a:prstGeom>
+          <a:noFill/>
+        </p:spPr>
+        <p:txBody>
+          <a:bodyPr wrap="square" anchor="t" lIns="0" rIns="0" tIns="0" bIns="0">
+            <a:spAutoFit/>
+          </a:bodyPr>
+          <a:lstStyle/>
+          <a:p>
+            <a:pPr algn="l">
+              <a:lnSpc>
+                <a:spcPct val="125000"/>
+              </a:lnSpc>
+              <a:spcAft>
+                <a:spcPts val="0"/>
+              </a:spcAft>
+            </a:pPr>
+            <a:r>
+              <a:rPr sz="1450" b="1">
                 <a:solidFill>
                   <a:srgbClr val="14261F"/>
                 </a:solidFill>
-                <a:latin typeface="Bricolage Grotesque"/>
-              </a:rPr>
-              <a:t>There are 3 shifts, but only one core purpose: to put power in patients' hands.</a:t>
-            </a:r>
-            <a:r>
-              <a:rPr sz="2400" b="1">
-                <a:solidFill>
-                  <a:srgbClr val="6D2E5B"/>
-                </a:solidFill>
-                <a:latin typeface="Bricolage Grotesque"/>
-              </a:rPr>
-              <a:t>”</a:t>
-            </a:r>
-          </a:p>
-        </p:txBody>
-      </p:sp>
-      <p:sp>
-        <p:nvSpPr>
-          <p:cNvPr id="4" name="TextBox 3"/>
+                <a:latin typeface="Instrument Sans"/>
+              </a:rPr>
+              <a:t>The morning check </a:t>
+            </a:r>
+            <a:r>
+              <a:rPr sz="1450" b="0">
+                <a:solidFill>
+                  <a:srgbClr val="5F6D66"/>
+                </a:solidFill>
+                <a:latin typeface="Instrument Sans"/>
+              </a:rPr>
+              <a:t>reads the 08:30 appointment from the record and posts to the family group: who can give Eleanor a lift?</a:t>
+            </a:r>
+          </a:p>
+        </p:txBody>
+      </p:sp>
+      <p:sp>
+        <p:nvSpPr>
+          <p:cNvPr id="16" name="TextBox 15"/>
           <p:cNvSpPr txBox="1"/>
           <p:nvPr/>
         </p:nvSpPr>
         <p:spPr>
           <a:xfrm>
-            <a:off x="731520" y="2057400"/>
-            <a:ext cx="10515600" cy="320040"/>
+            <a:off x="731520" y="6309360"/>
+            <a:ext cx="7863840" cy="365760"/>
           </a:xfrm>
           <a:prstGeom prst="rect">
             <a:avLst/>
@@ -7997,7 +9040,7 @@
           <a:noFill/>
         </p:spPr>
         <p:txBody>
-          <a:bodyPr wrap="square" anchor="t" lIns="0" rIns="0" tIns="0" bIns="0">
+          <a:bodyPr wrap="square" anchor="b" lIns="0" rIns="0" tIns="0" bIns="0">
             <a:spAutoFit/>
           </a:bodyPr>
           <a:lstStyle/>
@@ -8011,308 +9054,20 @@
               </a:spcAft>
             </a:pPr>
             <a:r>
-              <a:rPr sz="1050" b="0">
+              <a:rPr sz="850" b="0">
                 <a:solidFill>
                   <a:srgbClr val="5F6D66"/>
                 </a:solidFill>
                 <a:latin typeface="Instrument Sans"/>
               </a:rPr>
-              <a:t>Chapter 1, p22</a:t>
-            </a:r>
-          </a:p>
-        </p:txBody>
-      </p:sp>
-      <p:sp>
-        <p:nvSpPr>
-          <p:cNvPr id="5" name="TextBox 4"/>
-          <p:cNvSpPr txBox="1"/>
-          <p:nvPr/>
-        </p:nvSpPr>
-        <p:spPr>
-          <a:xfrm>
-            <a:off x="731520" y="2651760"/>
-            <a:ext cx="10515600" cy="822960"/>
-          </a:xfrm>
-          <a:prstGeom prst="rect">
-            <a:avLst/>
-          </a:prstGeom>
-          <a:noFill/>
-        </p:spPr>
-        <p:txBody>
-          <a:bodyPr wrap="square" anchor="t" lIns="0" rIns="0" tIns="0" bIns="0">
-            <a:spAutoFit/>
-          </a:bodyPr>
-          <a:lstStyle/>
-          <a:p>
-            <a:pPr algn="l">
-              <a:lnSpc>
-                <a:spcPct val="115000"/>
-              </a:lnSpc>
-              <a:spcAft>
-                <a:spcPts val="0"/>
-              </a:spcAft>
-            </a:pPr>
-            <a:r>
-              <a:rPr sz="2400" b="1">
-                <a:solidFill>
-                  <a:srgbClr val="6D2E5B"/>
-                </a:solidFill>
-                <a:latin typeface="Bricolage Grotesque"/>
-              </a:rPr>
-              <a:t>“</a:t>
-            </a:r>
-            <a:r>
-              <a:rPr sz="2400" b="1">
-                <a:solidFill>
-                  <a:srgbClr val="14261F"/>
-                </a:solidFill>
-                <a:latin typeface="Bricolage Grotesque"/>
-              </a:rPr>
-              <a:t>Patients will have control over whether this data is shared.</a:t>
-            </a:r>
-            <a:r>
-              <a:rPr sz="2400" b="1">
-                <a:solidFill>
-                  <a:srgbClr val="6D2E5B"/>
-                </a:solidFill>
-                <a:latin typeface="Bricolage Grotesque"/>
-              </a:rPr>
-              <a:t>”</a:t>
-            </a:r>
-          </a:p>
-        </p:txBody>
-      </p:sp>
-      <p:sp>
-        <p:nvSpPr>
-          <p:cNvPr id="6" name="TextBox 5"/>
-          <p:cNvSpPr txBox="1"/>
-          <p:nvPr/>
-        </p:nvSpPr>
-        <p:spPr>
-          <a:xfrm>
-            <a:off x="731520" y="3520440"/>
-            <a:ext cx="10515600" cy="320040"/>
-          </a:xfrm>
-          <a:prstGeom prst="rect">
-            <a:avLst/>
-          </a:prstGeom>
-          <a:noFill/>
-        </p:spPr>
-        <p:txBody>
-          <a:bodyPr wrap="square" anchor="t" lIns="0" rIns="0" tIns="0" bIns="0">
-            <a:spAutoFit/>
-          </a:bodyPr>
-          <a:lstStyle/>
-          <a:p>
-            <a:pPr algn="l">
-              <a:lnSpc>
-                <a:spcPct val="115000"/>
-              </a:lnSpc>
-              <a:spcAft>
-                <a:spcPts val="0"/>
-              </a:spcAft>
-            </a:pPr>
-            <a:r>
-              <a:rPr sz="1050" b="0">
-                <a:solidFill>
-                  <a:srgbClr val="5F6D66"/>
-                </a:solidFill>
-                <a:latin typeface="Instrument Sans"/>
-              </a:rPr>
-              <a:t>Chapter 3, My Health, pp50 to 51. And My Carer, p51: carers gain access to the App on their loved one's behalf.</a:t>
-            </a:r>
-          </a:p>
-        </p:txBody>
-      </p:sp>
-      <p:sp>
-        <p:nvSpPr>
-          <p:cNvPr id="7" name="TextBox 6"/>
-          <p:cNvSpPr txBox="1"/>
-          <p:nvPr/>
-        </p:nvSpPr>
-        <p:spPr>
-          <a:xfrm>
-            <a:off x="731520" y="4114800"/>
-            <a:ext cx="10515600" cy="822960"/>
-          </a:xfrm>
-          <a:prstGeom prst="rect">
-            <a:avLst/>
-          </a:prstGeom>
-          <a:noFill/>
-        </p:spPr>
-        <p:txBody>
-          <a:bodyPr wrap="square" anchor="t" lIns="0" rIns="0" tIns="0" bIns="0">
-            <a:spAutoFit/>
-          </a:bodyPr>
-          <a:lstStyle/>
-          <a:p>
-            <a:pPr algn="l">
-              <a:lnSpc>
-                <a:spcPct val="115000"/>
-              </a:lnSpc>
-              <a:spcAft>
-                <a:spcPts val="0"/>
-              </a:spcAft>
-            </a:pPr>
-            <a:r>
-              <a:rPr sz="2400" b="1">
-                <a:solidFill>
-                  <a:srgbClr val="6D2E5B"/>
-                </a:solidFill>
-                <a:latin typeface="Bricolage Grotesque"/>
-              </a:rPr>
-              <a:t>“</a:t>
-            </a:r>
-            <a:r>
-              <a:rPr sz="2400" b="1">
-                <a:solidFill>
-                  <a:srgbClr val="14261F"/>
-                </a:solidFill>
-                <a:latin typeface="Bricolage Grotesque"/>
-              </a:rPr>
-              <a:t>The most common reasons for complaints is poor communication.</a:t>
-            </a:r>
-            <a:r>
-              <a:rPr sz="2400" b="1">
-                <a:solidFill>
-                  <a:srgbClr val="6D2E5B"/>
-                </a:solidFill>
-                <a:latin typeface="Bricolage Grotesque"/>
-              </a:rPr>
-              <a:t>”</a:t>
-            </a:r>
-          </a:p>
-        </p:txBody>
-      </p:sp>
-      <p:sp>
-        <p:nvSpPr>
-          <p:cNvPr id="8" name="TextBox 7"/>
-          <p:cNvSpPr txBox="1"/>
-          <p:nvPr/>
-        </p:nvSpPr>
-        <p:spPr>
-          <a:xfrm>
-            <a:off x="731520" y="4983480"/>
-            <a:ext cx="10515600" cy="320040"/>
-          </a:xfrm>
-          <a:prstGeom prst="rect">
-            <a:avLst/>
-          </a:prstGeom>
-          <a:noFill/>
-        </p:spPr>
-        <p:txBody>
-          <a:bodyPr wrap="square" anchor="t" lIns="0" rIns="0" tIns="0" bIns="0">
-            <a:spAutoFit/>
-          </a:bodyPr>
-          <a:lstStyle/>
-          <a:p>
-            <a:pPr algn="l">
-              <a:lnSpc>
-                <a:spcPct val="115000"/>
-              </a:lnSpc>
-              <a:spcAft>
-                <a:spcPts val="0"/>
-              </a:spcAft>
-            </a:pPr>
-            <a:r>
-              <a:rPr sz="1050" b="0">
-                <a:solidFill>
-                  <a:srgbClr val="5F6D66"/>
-                </a:solidFill>
-                <a:latin typeface="Instrument Sans"/>
-              </a:rPr>
-              <a:t>Chapter 6, p89</a:t>
-            </a:r>
-          </a:p>
-        </p:txBody>
-      </p:sp>
-      <p:sp>
-        <p:nvSpPr>
-          <p:cNvPr id="9" name="TextBox 8"/>
-          <p:cNvSpPr txBox="1"/>
-          <p:nvPr/>
-        </p:nvSpPr>
-        <p:spPr>
-          <a:xfrm>
-            <a:off x="731520" y="5623560"/>
-            <a:ext cx="5486400" cy="365760"/>
-          </a:xfrm>
-          <a:prstGeom prst="rect">
-            <a:avLst/>
-          </a:prstGeom>
-          <a:noFill/>
-        </p:spPr>
-        <p:txBody>
-          <a:bodyPr wrap="square" anchor="t" lIns="0" rIns="0" tIns="0" bIns="0">
-            <a:spAutoFit/>
-          </a:bodyPr>
-          <a:lstStyle/>
-          <a:p>
-            <a:pPr algn="l">
-              <a:lnSpc>
-                <a:spcPct val="115000"/>
-              </a:lnSpc>
-              <a:spcAft>
-                <a:spcPts val="0"/>
-              </a:spcAft>
-            </a:pPr>
-            <a:r>
-              <a:rPr sz="1600" b="1">
-                <a:solidFill>
-                  <a:srgbClr val="6D2E5B"/>
-                </a:solidFill>
-                <a:latin typeface="Bricolage Grotesque"/>
-              </a:rPr>
-              <a:t>Chapters 2, 3 and 6.</a:t>
-            </a:r>
-          </a:p>
-        </p:txBody>
-      </p:sp>
-      <p:sp>
-        <p:nvSpPr>
-          <p:cNvPr id="10" name="TextBox 9"/>
-          <p:cNvSpPr txBox="1"/>
-          <p:nvPr/>
-        </p:nvSpPr>
-        <p:spPr>
-          <a:xfrm>
-            <a:off x="731520" y="6309360"/>
-            <a:ext cx="7863840" cy="365760"/>
-          </a:xfrm>
-          <a:prstGeom prst="rect">
-            <a:avLst/>
-          </a:prstGeom>
-          <a:noFill/>
-        </p:spPr>
-        <p:txBody>
-          <a:bodyPr wrap="square" anchor="b" lIns="0" rIns="0" tIns="0" bIns="0">
-            <a:spAutoFit/>
-          </a:bodyPr>
-          <a:lstStyle/>
-          <a:p>
-            <a:pPr algn="l">
-              <a:lnSpc>
-                <a:spcPct val="115000"/>
-              </a:lnSpc>
-              <a:spcAft>
-                <a:spcPts val="0"/>
-              </a:spcAft>
-            </a:pPr>
-            <a:r>
-              <a:rPr sz="850" b="0">
-                <a:solidFill>
-                  <a:srgbClr val="5F6D66"/>
-                </a:solidFill>
-                <a:latin typeface="Instrument Sans"/>
-              </a:rPr>
-              <a:t>Fit for the Future: the 10 Year Health Plan for England, July 2025.</a:t>
-            </a:r>
-          </a:p>
-        </p:txBody>
-      </p:sp>
-      <p:sp>
-        <p:nvSpPr>
-          <p:cNvPr id="11" name="TextBox 10"/>
+              <a:t>Visibly simulated: WhatsApp delivery, relative identity checks, the clinician's “discussed with patient” tap, the persona switcher. Consent writes go to the companion backend, not native FHIR Consent on the remote simulator.</a:t>
+            </a:r>
+          </a:p>
+        </p:txBody>
+      </p:sp>
+      <p:sp>
+        <p:nvSpPr>
+          <p:cNvPr id="17" name="TextBox 16"/>
           <p:cNvSpPr txBox="1"/>
           <p:nvPr/>
         </p:nvSpPr>
@@ -8361,6 +9116,506 @@
 </file>
 
 <file path=ppt/slides/slide7.xml><?xml version="1.0" encoding="utf-8"?>
+<p:sld xmlns:a="http://schemas.openxmlformats.org/drawingml/2006/main" xmlns:p="http://schemas.openxmlformats.org/presentationml/2006/main" xmlns:r="http://schemas.openxmlformats.org/officeDocument/2006/relationships">
+  <p:cSld>
+    <p:bg>
+      <p:bgPr>
+        <a:solidFill>
+          <a:srgbClr val="F2F4F1"/>
+        </a:solidFill>
+        <a:effectLst/>
+      </p:bgPr>
+    </p:bg>
+    <p:spTree>
+      <p:nvGrpSpPr>
+        <p:cNvPr id="1" name=""/>
+        <p:cNvGrpSpPr/>
+        <p:nvPr/>
+      </p:nvGrpSpPr>
+      <p:grpSpPr/>
+      <p:sp>
+        <p:nvSpPr>
+          <p:cNvPr id="2" name="TextBox 1"/>
+          <p:cNvSpPr txBox="1"/>
+          <p:nvPr/>
+        </p:nvSpPr>
+        <p:spPr>
+          <a:xfrm>
+            <a:off x="731520" y="411480"/>
+            <a:ext cx="10728655" cy="274320"/>
+          </a:xfrm>
+          <a:prstGeom prst="rect">
+            <a:avLst/>
+          </a:prstGeom>
+          <a:noFill/>
+        </p:spPr>
+        <p:txBody>
+          <a:bodyPr wrap="square" anchor="t" lIns="0" rIns="0" tIns="0" bIns="0">
+            <a:spAutoFit/>
+          </a:bodyPr>
+          <a:lstStyle/>
+          <a:p>
+            <a:pPr algn="l">
+              <a:lnSpc>
+                <a:spcPct val="115000"/>
+              </a:lnSpc>
+              <a:spcAft>
+                <a:spcPts val="0"/>
+              </a:spcAft>
+            </a:pPr>
+            <a:r>
+              <a:rPr sz="900" b="1">
+                <a:solidFill>
+                  <a:srgbClr val="5F6D66"/>
+                </a:solidFill>
+                <a:latin typeface="Instrument Sans"/>
+              </a:rPr>
+              <a:t>10 YEAR HEALTH PLAN FIT</a:t>
+            </a:r>
+          </a:p>
+        </p:txBody>
+      </p:sp>
+      <p:sp>
+        <p:nvSpPr>
+          <p:cNvPr id="3" name="TextBox 2"/>
+          <p:cNvSpPr txBox="1"/>
+          <p:nvPr/>
+        </p:nvSpPr>
+        <p:spPr>
+          <a:xfrm>
+            <a:off x="731520" y="1188720"/>
+            <a:ext cx="10515600" cy="822960"/>
+          </a:xfrm>
+          <a:prstGeom prst="rect">
+            <a:avLst/>
+          </a:prstGeom>
+          <a:noFill/>
+        </p:spPr>
+        <p:txBody>
+          <a:bodyPr wrap="square" anchor="t" lIns="0" rIns="0" tIns="0" bIns="0">
+            <a:spAutoFit/>
+          </a:bodyPr>
+          <a:lstStyle/>
+          <a:p>
+            <a:pPr algn="l">
+              <a:lnSpc>
+                <a:spcPct val="115000"/>
+              </a:lnSpc>
+              <a:spcAft>
+                <a:spcPts val="0"/>
+              </a:spcAft>
+            </a:pPr>
+            <a:r>
+              <a:rPr sz="2400" b="1">
+                <a:solidFill>
+                  <a:srgbClr val="6D2E5B"/>
+                </a:solidFill>
+                <a:latin typeface="Bricolage Grotesque"/>
+              </a:rPr>
+              <a:t>“</a:t>
+            </a:r>
+            <a:r>
+              <a:rPr sz="2400" b="1">
+                <a:solidFill>
+                  <a:srgbClr val="14261F"/>
+                </a:solidFill>
+                <a:latin typeface="Bricolage Grotesque"/>
+              </a:rPr>
+              <a:t>There are 3 shifts, but only one core purpose: to put power in patients' hands.</a:t>
+            </a:r>
+            <a:r>
+              <a:rPr sz="2400" b="1">
+                <a:solidFill>
+                  <a:srgbClr val="6D2E5B"/>
+                </a:solidFill>
+                <a:latin typeface="Bricolage Grotesque"/>
+              </a:rPr>
+              <a:t>”</a:t>
+            </a:r>
+          </a:p>
+        </p:txBody>
+      </p:sp>
+      <p:sp>
+        <p:nvSpPr>
+          <p:cNvPr id="4" name="TextBox 3"/>
+          <p:cNvSpPr txBox="1"/>
+          <p:nvPr/>
+        </p:nvSpPr>
+        <p:spPr>
+          <a:xfrm>
+            <a:off x="731520" y="2057400"/>
+            <a:ext cx="10515600" cy="320040"/>
+          </a:xfrm>
+          <a:prstGeom prst="rect">
+            <a:avLst/>
+          </a:prstGeom>
+          <a:noFill/>
+        </p:spPr>
+        <p:txBody>
+          <a:bodyPr wrap="square" anchor="t" lIns="0" rIns="0" tIns="0" bIns="0">
+            <a:spAutoFit/>
+          </a:bodyPr>
+          <a:lstStyle/>
+          <a:p>
+            <a:pPr algn="l">
+              <a:lnSpc>
+                <a:spcPct val="115000"/>
+              </a:lnSpc>
+              <a:spcAft>
+                <a:spcPts val="0"/>
+              </a:spcAft>
+            </a:pPr>
+            <a:r>
+              <a:rPr sz="1050" b="0">
+                <a:solidFill>
+                  <a:srgbClr val="5F6D66"/>
+                </a:solidFill>
+                <a:latin typeface="Instrument Sans"/>
+              </a:rPr>
+              <a:t>Chapter 1, p22</a:t>
+            </a:r>
+          </a:p>
+        </p:txBody>
+      </p:sp>
+      <p:sp>
+        <p:nvSpPr>
+          <p:cNvPr id="5" name="TextBox 4"/>
+          <p:cNvSpPr txBox="1"/>
+          <p:nvPr/>
+        </p:nvSpPr>
+        <p:spPr>
+          <a:xfrm>
+            <a:off x="731520" y="2651760"/>
+            <a:ext cx="10515600" cy="822960"/>
+          </a:xfrm>
+          <a:prstGeom prst="rect">
+            <a:avLst/>
+          </a:prstGeom>
+          <a:noFill/>
+        </p:spPr>
+        <p:txBody>
+          <a:bodyPr wrap="square" anchor="t" lIns="0" rIns="0" tIns="0" bIns="0">
+            <a:spAutoFit/>
+          </a:bodyPr>
+          <a:lstStyle/>
+          <a:p>
+            <a:pPr algn="l">
+              <a:lnSpc>
+                <a:spcPct val="115000"/>
+              </a:lnSpc>
+              <a:spcAft>
+                <a:spcPts val="0"/>
+              </a:spcAft>
+            </a:pPr>
+            <a:r>
+              <a:rPr sz="2400" b="1">
+                <a:solidFill>
+                  <a:srgbClr val="6D2E5B"/>
+                </a:solidFill>
+                <a:latin typeface="Bricolage Grotesque"/>
+              </a:rPr>
+              <a:t>“</a:t>
+            </a:r>
+            <a:r>
+              <a:rPr sz="2400" b="1">
+                <a:solidFill>
+                  <a:srgbClr val="14261F"/>
+                </a:solidFill>
+                <a:latin typeface="Bricolage Grotesque"/>
+              </a:rPr>
+              <a:t>Patients will have control over whether this data is shared.</a:t>
+            </a:r>
+            <a:r>
+              <a:rPr sz="2400" b="1">
+                <a:solidFill>
+                  <a:srgbClr val="6D2E5B"/>
+                </a:solidFill>
+                <a:latin typeface="Bricolage Grotesque"/>
+              </a:rPr>
+              <a:t>”</a:t>
+            </a:r>
+          </a:p>
+        </p:txBody>
+      </p:sp>
+      <p:sp>
+        <p:nvSpPr>
+          <p:cNvPr id="6" name="TextBox 5"/>
+          <p:cNvSpPr txBox="1"/>
+          <p:nvPr/>
+        </p:nvSpPr>
+        <p:spPr>
+          <a:xfrm>
+            <a:off x="731520" y="3520440"/>
+            <a:ext cx="10515600" cy="320040"/>
+          </a:xfrm>
+          <a:prstGeom prst="rect">
+            <a:avLst/>
+          </a:prstGeom>
+          <a:noFill/>
+        </p:spPr>
+        <p:txBody>
+          <a:bodyPr wrap="square" anchor="t" lIns="0" rIns="0" tIns="0" bIns="0">
+            <a:spAutoFit/>
+          </a:bodyPr>
+          <a:lstStyle/>
+          <a:p>
+            <a:pPr algn="l">
+              <a:lnSpc>
+                <a:spcPct val="115000"/>
+              </a:lnSpc>
+              <a:spcAft>
+                <a:spcPts val="0"/>
+              </a:spcAft>
+            </a:pPr>
+            <a:r>
+              <a:rPr sz="1050" b="0">
+                <a:solidFill>
+                  <a:srgbClr val="5F6D66"/>
+                </a:solidFill>
+                <a:latin typeface="Instrument Sans"/>
+              </a:rPr>
+              <a:t>Chapter 3, My Health, pp50 to 51. And My Carer, p51: carers gain access to the App on their loved one's behalf.</a:t>
+            </a:r>
+          </a:p>
+        </p:txBody>
+      </p:sp>
+      <p:sp>
+        <p:nvSpPr>
+          <p:cNvPr id="7" name="TextBox 6"/>
+          <p:cNvSpPr txBox="1"/>
+          <p:nvPr/>
+        </p:nvSpPr>
+        <p:spPr>
+          <a:xfrm>
+            <a:off x="731520" y="4114800"/>
+            <a:ext cx="10515600" cy="822960"/>
+          </a:xfrm>
+          <a:prstGeom prst="rect">
+            <a:avLst/>
+          </a:prstGeom>
+          <a:noFill/>
+        </p:spPr>
+        <p:txBody>
+          <a:bodyPr wrap="square" anchor="t" lIns="0" rIns="0" tIns="0" bIns="0">
+            <a:spAutoFit/>
+          </a:bodyPr>
+          <a:lstStyle/>
+          <a:p>
+            <a:pPr algn="l">
+              <a:lnSpc>
+                <a:spcPct val="115000"/>
+              </a:lnSpc>
+              <a:spcAft>
+                <a:spcPts val="0"/>
+              </a:spcAft>
+            </a:pPr>
+            <a:r>
+              <a:rPr sz="2400" b="1">
+                <a:solidFill>
+                  <a:srgbClr val="6D2E5B"/>
+                </a:solidFill>
+                <a:latin typeface="Bricolage Grotesque"/>
+              </a:rPr>
+              <a:t>“</a:t>
+            </a:r>
+            <a:r>
+              <a:rPr sz="2400" b="1">
+                <a:solidFill>
+                  <a:srgbClr val="14261F"/>
+                </a:solidFill>
+                <a:latin typeface="Bricolage Grotesque"/>
+              </a:rPr>
+              <a:t>The most common reasons for complaints is poor communication.</a:t>
+            </a:r>
+            <a:r>
+              <a:rPr sz="2400" b="1">
+                <a:solidFill>
+                  <a:srgbClr val="6D2E5B"/>
+                </a:solidFill>
+                <a:latin typeface="Bricolage Grotesque"/>
+              </a:rPr>
+              <a:t>”</a:t>
+            </a:r>
+          </a:p>
+        </p:txBody>
+      </p:sp>
+      <p:sp>
+        <p:nvSpPr>
+          <p:cNvPr id="8" name="TextBox 7"/>
+          <p:cNvSpPr txBox="1"/>
+          <p:nvPr/>
+        </p:nvSpPr>
+        <p:spPr>
+          <a:xfrm>
+            <a:off x="731520" y="4983480"/>
+            <a:ext cx="10515600" cy="320040"/>
+          </a:xfrm>
+          <a:prstGeom prst="rect">
+            <a:avLst/>
+          </a:prstGeom>
+          <a:noFill/>
+        </p:spPr>
+        <p:txBody>
+          <a:bodyPr wrap="square" anchor="t" lIns="0" rIns="0" tIns="0" bIns="0">
+            <a:spAutoFit/>
+          </a:bodyPr>
+          <a:lstStyle/>
+          <a:p>
+            <a:pPr algn="l">
+              <a:lnSpc>
+                <a:spcPct val="115000"/>
+              </a:lnSpc>
+              <a:spcAft>
+                <a:spcPts val="0"/>
+              </a:spcAft>
+            </a:pPr>
+            <a:r>
+              <a:rPr sz="1050" b="0">
+                <a:solidFill>
+                  <a:srgbClr val="5F6D66"/>
+                </a:solidFill>
+                <a:latin typeface="Instrument Sans"/>
+              </a:rPr>
+              <a:t>Chapter 6, p89</a:t>
+            </a:r>
+          </a:p>
+        </p:txBody>
+      </p:sp>
+      <p:sp>
+        <p:nvSpPr>
+          <p:cNvPr id="9" name="TextBox 8"/>
+          <p:cNvSpPr txBox="1"/>
+          <p:nvPr/>
+        </p:nvSpPr>
+        <p:spPr>
+          <a:xfrm>
+            <a:off x="731520" y="5623560"/>
+            <a:ext cx="5486400" cy="365760"/>
+          </a:xfrm>
+          <a:prstGeom prst="rect">
+            <a:avLst/>
+          </a:prstGeom>
+          <a:noFill/>
+        </p:spPr>
+        <p:txBody>
+          <a:bodyPr wrap="square" anchor="t" lIns="0" rIns="0" tIns="0" bIns="0">
+            <a:spAutoFit/>
+          </a:bodyPr>
+          <a:lstStyle/>
+          <a:p>
+            <a:pPr algn="l">
+              <a:lnSpc>
+                <a:spcPct val="115000"/>
+              </a:lnSpc>
+              <a:spcAft>
+                <a:spcPts val="0"/>
+              </a:spcAft>
+            </a:pPr>
+            <a:r>
+              <a:rPr sz="1600" b="1">
+                <a:solidFill>
+                  <a:srgbClr val="6D2E5B"/>
+                </a:solidFill>
+                <a:latin typeface="Bricolage Grotesque"/>
+              </a:rPr>
+              <a:t>Chapters 2, 3 and 6.</a:t>
+            </a:r>
+          </a:p>
+        </p:txBody>
+      </p:sp>
+      <p:sp>
+        <p:nvSpPr>
+          <p:cNvPr id="10" name="TextBox 9"/>
+          <p:cNvSpPr txBox="1"/>
+          <p:nvPr/>
+        </p:nvSpPr>
+        <p:spPr>
+          <a:xfrm>
+            <a:off x="731520" y="6309360"/>
+            <a:ext cx="7863840" cy="365760"/>
+          </a:xfrm>
+          <a:prstGeom prst="rect">
+            <a:avLst/>
+          </a:prstGeom>
+          <a:noFill/>
+        </p:spPr>
+        <p:txBody>
+          <a:bodyPr wrap="square" anchor="b" lIns="0" rIns="0" tIns="0" bIns="0">
+            <a:spAutoFit/>
+          </a:bodyPr>
+          <a:lstStyle/>
+          <a:p>
+            <a:pPr algn="l">
+              <a:lnSpc>
+                <a:spcPct val="115000"/>
+              </a:lnSpc>
+              <a:spcAft>
+                <a:spcPts val="0"/>
+              </a:spcAft>
+            </a:pPr>
+            <a:r>
+              <a:rPr sz="850" b="0">
+                <a:solidFill>
+                  <a:srgbClr val="5F6D66"/>
+                </a:solidFill>
+                <a:latin typeface="Instrument Sans"/>
+              </a:rPr>
+              <a:t>Fit for the Future: the 10 Year Health Plan for England, July 2025.</a:t>
+            </a:r>
+          </a:p>
+        </p:txBody>
+      </p:sp>
+      <p:sp>
+        <p:nvSpPr>
+          <p:cNvPr id="11" name="TextBox 10"/>
+          <p:cNvSpPr txBox="1"/>
+          <p:nvPr/>
+        </p:nvSpPr>
+        <p:spPr>
+          <a:xfrm>
+            <a:off x="7345375" y="6309360"/>
+            <a:ext cx="4114800" cy="365760"/>
+          </a:xfrm>
+          <a:prstGeom prst="rect">
+            <a:avLst/>
+          </a:prstGeom>
+          <a:noFill/>
+        </p:spPr>
+        <p:txBody>
+          <a:bodyPr wrap="square" anchor="b" lIns="0" rIns="0" tIns="0" bIns="0">
+            <a:spAutoFit/>
+          </a:bodyPr>
+          <a:lstStyle/>
+          <a:p>
+            <a:pPr algn="r">
+              <a:lnSpc>
+                <a:spcPct val="115000"/>
+              </a:lnSpc>
+              <a:spcAft>
+                <a:spcPts val="0"/>
+              </a:spcAft>
+            </a:pPr>
+            <a:r>
+              <a:rPr sz="850" b="0">
+                <a:solidFill>
+                  <a:srgbClr val="5F6D66"/>
+                </a:solidFill>
+                <a:latin typeface="Instrument Sans"/>
+              </a:rPr>
+              <a:t>All patient data synthetic · Fictional demo, not an official NHS product</a:t>
+            </a:r>
+          </a:p>
+        </p:txBody>
+      </p:sp>
+    </p:spTree>
+  </p:cSld>
+  <p:clrMapOvr>
+    <a:masterClrMapping/>
+  </p:clrMapOvr>
+</p:sld>
+</file>
+
+<file path=ppt/slides/slide8.xml><?xml version="1.0" encoding="utf-8"?>
 <p:sld xmlns:a="http://schemas.openxmlformats.org/drawingml/2006/main" xmlns:p="http://schemas.openxmlformats.org/presentationml/2006/main" xmlns:r="http://schemas.openxmlformats.org/officeDocument/2006/relationships">
   <p:cSld>
     <p:bg>

</xml_diff>

<commit_message>
docs(pitch): end the deck on What happens to Eleanor now, five slides
</commit_message>
<xml_diff>
--- a/pitch/CareCircle-pitch.pptx
+++ b/pitch/CareCircle-pitch.pptx
@@ -10,9 +10,6 @@
     <p:sldId id="258" r:id="rId10"/>
     <p:sldId id="259" r:id="rId11"/>
     <p:sldId id="260" r:id="rId12"/>
-    <p:sldId id="261" r:id="rId13"/>
-    <p:sldId id="262" r:id="rId14"/>
-    <p:sldId id="263" r:id="rId15"/>
   </p:sldIdLst>
   <p:sldSz cx="12191695" cy="6858000" type="screen4x3"/>
   <p:notesSz cx="6858000" cy="9144000"/>
@@ -1044,448 +1041,6 @@
           <a:p>
             <a:r>
               <a:t>Honesty: the right-hand column is what the demo shows across the app and the prototype; see the code-ownership table at the top. "Flagged in July" is the second low panel (14 July 2026, white cells 1.6) in the remote Anima record; the prototype's trend rule needs two consecutive out-of-range values, so July is the earliest it fires on her real data.</a:t>
-            </a:r>
-          </a:p>
-        </p:txBody>
-      </p:sp>
-      <p:sp>
-        <p:nvSpPr>
-          <p:cNvPr id="4" name="Slide Number Placeholder 3"/>
-          <p:cNvSpPr>
-            <a:spLocks noGrp="1"/>
-          </p:cNvSpPr>
-          <p:nvPr>
-            <p:ph type="sldNum" idx="5" sz="quarter"/>
-          </p:nvPr>
-        </p:nvSpPr>
-        <p:spPr/>
-      </p:sp>
-    </p:spTree>
-  </p:cSld>
-  <p:clrMapOvr>
-    <a:masterClrMapping/>
-  </p:clrMapOvr>
-</p:notes>
-</file>
-
-<file path=ppt/notesSlides/notesSlide6.xml><?xml version="1.0" encoding="utf-8"?>
-<p:notes xmlns:a="http://schemas.openxmlformats.org/drawingml/2006/main" xmlns:p="http://schemas.openxmlformats.org/presentationml/2006/main" xmlns:r="http://schemas.openxmlformats.org/officeDocument/2006/relationships">
-  <p:cSld>
-    <p:spTree>
-      <p:nvGrpSpPr>
-        <p:cNvPr id="1" name=""/>
-        <p:cNvGrpSpPr/>
-        <p:nvPr/>
-      </p:nvGrpSpPr>
-      <p:grpSpPr>
-        <a:xfrm>
-          <a:off x="0" y="0"/>
-          <a:ext cx="0" cy="0"/>
-          <a:chOff x="0" y="0"/>
-          <a:chExt cx="0" cy="0"/>
-        </a:xfrm>
-      </p:grpSpPr>
-      <p:sp>
-        <p:nvSpPr>
-          <p:cNvPr id="2" name="Slide Image Placeholder 1"/>
-          <p:cNvSpPr>
-            <a:spLocks noGrp="1"/>
-          </p:cNvSpPr>
-          <p:nvPr>
-            <p:ph type="sldImg" idx="2"/>
-          </p:nvPr>
-        </p:nvSpPr>
-        <p:spPr/>
-      </p:sp>
-      <p:sp>
-        <p:nvSpPr>
-          <p:cNvPr id="3" name="Notes Placeholder 2"/>
-          <p:cNvSpPr>
-            <a:spLocks noGrp="1"/>
-          </p:cNvSpPr>
-          <p:nvPr>
-            <p:ph type="body" idx="3" sz="quarter"/>
-          </p:nvPr>
-        </p:nvSpPr>
-        <p:spPr/>
-        <p:txBody>
-          <a:bodyPr/>
-          <a:lstStyle/>
-          <a:p>
-            <a:r>
-              <a:t>## Slide 5: The demo (90 seconds)</a:t>
-            </a:r>
-          </a:p>
-          <a:p/>
-          <a:p>
-            <a:r>
-              <a:t>**Script, while clicking**</a:t>
-            </a:r>
-          </a:p>
-          <a:p/>
-          <a:p>
-            <a:r>
-              <a:t>"Ninety seconds, live against Anima. Step zero: Eleanor's trend cards. Improving, watch, worsening, generated from her real panel history, live from the prototype. Liver worsening, white cells watch, sugar control improving. Step one: I order a liver function test in Anima and advance the clock 121 minutes. The result lands as a real state change; we detect it, we do not mock it. Step two: held. Eleanor's phone gets one message, a result has arrived and your practice will talk you through it. The family view shows nothing. Step three: the practice marks it discussed, it is flagged, so Eleanor is asked: do you want your circle to know? She says yes. Three versions go out: Grace sees bilirubin and albumin with the ranges, Idris sees the follow-up to arrange, Thomas sees nothing needed this week. A task now exists in Anima's own activity trail. Step four, in the Kindred app: Grace asks about a result she cannot see. NOT_SHARED. Kindred says Eleanor has not shared her test results, with no hint of what they say. Grace asks for access, Eleanor approves from a card, and the GP consent view updates live. Step five: the morning check reads the half past eight appointment from the record and posts to the family group: who can give Eleanor a lift?"</a:t>
-            </a:r>
-          </a:p>
-          <a:p/>
-          <a:p>
-            <a:r>
-              <a:t>**Notes**</a:t>
-            </a:r>
-          </a:p>
-          <a:p/>
-          <a:p>
-            <a:r>
-              <a:t>- Steps 0 to 3 run in the prototype (`server.mjs`) against the remote Anima world: `GET /api/insights` for the cards; one LFT order, one clock advance and one task per run.</a:t>
-            </a:r>
-          </a:p>
-          <a:p>
-            <a:r>
-              <a:t>- Steps 4 and 5 run in the Kindred app (`web/` plus `sim-app/`). The morning check picks up appointments in the next seven days not yet announced (sim clock 08:00, appointment 08:30), posts with category "appointments", so Grace, Thomas and Idris all see it, and adds the next action "Arrange to accompany Eleanor to practice follow-up".</a:t>
-            </a:r>
-          </a:p>
-          <a:p>
-            <a:r>
-              <a:t>- Visibly simulated, and say so if asked: WhatsApp delivery, relative identity checks, the clinician's "discussed with patient" tap, and the persona switcher standing in for sign-in. Consent writes go to the companion backend, not native FHIR Consent on the remote simulator.</a:t>
-            </a:r>
-          </a:p>
-          <a:p>
-            <a:r>
-              <a:t>- If the sim is slow, the held state is the moment to talk through the gate; the release is the payoff.</a:t>
-            </a:r>
-          </a:p>
-        </p:txBody>
-      </p:sp>
-      <p:sp>
-        <p:nvSpPr>
-          <p:cNvPr id="4" name="Slide Number Placeholder 3"/>
-          <p:cNvSpPr>
-            <a:spLocks noGrp="1"/>
-          </p:cNvSpPr>
-          <p:nvPr>
-            <p:ph type="sldNum" idx="5" sz="quarter"/>
-          </p:nvPr>
-        </p:nvSpPr>
-        <p:spPr/>
-      </p:sp>
-    </p:spTree>
-  </p:cSld>
-  <p:clrMapOvr>
-    <a:masterClrMapping/>
-  </p:clrMapOvr>
-</p:notes>
-</file>
-
-<file path=ppt/notesSlides/notesSlide7.xml><?xml version="1.0" encoding="utf-8"?>
-<p:notes xmlns:a="http://schemas.openxmlformats.org/drawingml/2006/main" xmlns:p="http://schemas.openxmlformats.org/presentationml/2006/main" xmlns:r="http://schemas.openxmlformats.org/officeDocument/2006/relationships">
-  <p:cSld>
-    <p:spTree>
-      <p:nvGrpSpPr>
-        <p:cNvPr id="1" name=""/>
-        <p:cNvGrpSpPr/>
-        <p:nvPr/>
-      </p:nvGrpSpPr>
-      <p:grpSpPr>
-        <a:xfrm>
-          <a:off x="0" y="0"/>
-          <a:ext cx="0" cy="0"/>
-          <a:chOff x="0" y="0"/>
-          <a:chExt cx="0" cy="0"/>
-        </a:xfrm>
-      </p:grpSpPr>
-      <p:sp>
-        <p:nvSpPr>
-          <p:cNvPr id="2" name="Slide Image Placeholder 1"/>
-          <p:cNvSpPr>
-            <a:spLocks noGrp="1"/>
-          </p:cNvSpPr>
-          <p:nvPr>
-            <p:ph type="sldImg" idx="2"/>
-          </p:nvPr>
-        </p:nvSpPr>
-        <p:spPr/>
-      </p:sp>
-      <p:sp>
-        <p:nvSpPr>
-          <p:cNvPr id="3" name="Notes Placeholder 2"/>
-          <p:cNvSpPr>
-            <a:spLocks noGrp="1"/>
-          </p:cNvSpPr>
-          <p:nvPr>
-            <p:ph type="body" idx="3" sz="quarter"/>
-          </p:nvPr>
-        </p:nvSpPr>
-        <p:spPr/>
-        <p:txBody>
-          <a:bodyPr/>
-          <a:lstStyle/>
-          <a:p>
-            <a:r>
-              <a:t>## Slide 6: 10 Year Health Plan fit (10 seconds)</a:t>
-            </a:r>
-          </a:p>
-          <a:p/>
-          <a:p>
-            <a:r>
-              <a:t>**Script**</a:t>
-            </a:r>
-          </a:p>
-          <a:p/>
-          <a:p>
-            <a:r>
-              <a:t>"This is what the 10 Year Health Plan asks for. One core purpose: power in patients' hands. Patients control whether their data is shared, and My Carer gives carers access on their loved one's behalf. And poor communication is the most common complaint. Chapters 2, 3 and 6."</a:t>
-            </a:r>
-          </a:p>
-          <a:p/>
-          <a:p>
-            <a:r>
-              <a:t>**Citations** (Fit for the Future: The 10 Year Health Plan for England, CP 1350, DHSC, July 2025, corrected 15 July 2025; printed page numbers, PDF page = printed page + 2)</a:t>
-            </a:r>
-          </a:p>
-          <a:p/>
-          <a:p>
-            <a:r>
-              <a:t>- Chapter 1, p22: "There are 3 shifts, but only one core purpose: to put power in patients' hands."</a:t>
-            </a:r>
-          </a:p>
-          <a:p>
-            <a:r>
-              <a:t>- Chapter 3, p51: "Patients will have control over whether this data is shared in real-time with their care team, so they can proactively monitor their health and step in if needed." Context, pp50 to 51: the My Health tool "will connect to the results of recent tests and investigations."</a:t>
-            </a:r>
-          </a:p>
-          <a:p>
-            <a:r>
-              <a:t>- Chapter 3, p51: "My Carer will allow people to securely prove they are providing care, often for an older family member, and gain access to the App on their behalf."</a:t>
-            </a:r>
-          </a:p>
-          <a:p>
-            <a:r>
-              <a:t>- Chapter 6, p89: "The problem is that the NHS doesn't listen well enough. The most common reasons for complaints is poor communication." (The plan's own grammar.)</a:t>
-            </a:r>
-          </a:p>
-          <a:p>
-            <a:r>
-              <a:t>- Chapter 2, p34: "Unpaid carers will also be actively involved in care planning." This is the Chapter 2 hook behind "Chapters 2, 3 and 6".</a:t>
-            </a:r>
-          </a:p>
-          <a:p>
-            <a:r>
-              <a:t>- Chapter 1, p21, for pillar 1 if asked: "This AI will also be an early warning system, detecting subtle signs of health changes by analysing data from wearables, lifestyle and medical records to trigger timely interventions".</a:t>
-            </a:r>
-          </a:p>
-          <a:p/>
-          <a:p>
-            <a:r>
-              <a:t>Note: the plan contains no sentence about uncommunicated test results. Do not attribute the HSIB finding to the plan.</a:t>
-            </a:r>
-          </a:p>
-        </p:txBody>
-      </p:sp>
-      <p:sp>
-        <p:nvSpPr>
-          <p:cNvPr id="4" name="Slide Number Placeholder 3"/>
-          <p:cNvSpPr>
-            <a:spLocks noGrp="1"/>
-          </p:cNvSpPr>
-          <p:nvPr>
-            <p:ph type="sldNum" idx="5" sz="quarter"/>
-          </p:nvPr>
-        </p:nvSpPr>
-        <p:spPr/>
-      </p:sp>
-    </p:spTree>
-  </p:cSld>
-  <p:clrMapOvr>
-    <a:masterClrMapping/>
-  </p:clrMapOvr>
-</p:notes>
-</file>
-
-<file path=ppt/notesSlides/notesSlide8.xml><?xml version="1.0" encoding="utf-8"?>
-<p:notes xmlns:a="http://schemas.openxmlformats.org/drawingml/2006/main" xmlns:p="http://schemas.openxmlformats.org/presentationml/2006/main" xmlns:r="http://schemas.openxmlformats.org/officeDocument/2006/relationships">
-  <p:cSld>
-    <p:spTree>
-      <p:nvGrpSpPr>
-        <p:cNvPr id="1" name=""/>
-        <p:cNvGrpSpPr/>
-        <p:nvPr/>
-      </p:nvGrpSpPr>
-      <p:grpSpPr>
-        <a:xfrm>
-          <a:off x="0" y="0"/>
-          <a:ext cx="0" cy="0"/>
-          <a:chOff x="0" y="0"/>
-          <a:chExt cx="0" cy="0"/>
-        </a:xfrm>
-      </p:grpSpPr>
-      <p:sp>
-        <p:nvSpPr>
-          <p:cNvPr id="2" name="Slide Image Placeholder 1"/>
-          <p:cNvSpPr>
-            <a:spLocks noGrp="1"/>
-          </p:cNvSpPr>
-          <p:nvPr>
-            <p:ph type="sldImg" idx="2"/>
-          </p:nvPr>
-        </p:nvSpPr>
-        <p:spPr/>
-      </p:sp>
-      <p:sp>
-        <p:nvSpPr>
-          <p:cNvPr id="3" name="Notes Placeholder 2"/>
-          <p:cNvSpPr>
-            <a:spLocks noGrp="1"/>
-          </p:cNvSpPr>
-          <p:nvPr>
-            <p:ph type="body" idx="3" sz="quarter"/>
-          </p:nvPr>
-        </p:nvSpPr>
-        <p:spPr/>
-        <p:txBody>
-          <a:bodyPr/>
-          <a:lstStyle/>
-          <a:p>
-            <a:r>
-              <a:t>## Slide 7: Close and proof (15 seconds)</a:t>
-            </a:r>
-          </a:p>
-          <a:p/>
-          <a:p>
-            <a:r>
-              <a:t>**Script**</a:t>
-            </a:r>
-          </a:p>
-          <a:p/>
-          <a:p>
-            <a:r>
-              <a:t>"No result ever sits uncommunicated. And when it is communicated, every trusted person gets the right version, in their words, under her control. Three sharing levels over six record categories. Every agent tool call checks consent and is audited. Six plain-English trend cards from a year of bloods and her watch data. One transaction mirrors each consent change to her GP. Next: fold the trend engine, the gate and the escalation into the app, pilot at one practice, and wire consent to NHS App proxy access. We are Team 5. Thank you."</a:t>
-            </a:r>
-          </a:p>
-          <a:p/>
-          <a:p>
-            <a:r>
-              <a:t>**Proof behind the strip**</a:t>
-            </a:r>
-          </a:p>
-          <a:p/>
-          <a:p>
-            <a:r>
-              <a:t>- 3 x 6, Every, 1: Kindred app facts (`web/src/lib/levels.ts`, `web/src/lib/agent/tools.ts`, README "What's connected": consent changes "update the GP observation and consent audit in one PostgreSQL transaction").</a:t>
-            </a:r>
-          </a:p>
-          <a:p>
-            <a:r>
-              <a:t>- 6 cards: prototype fact, `lib/insights.mjs` on Eleanor's fixture (`test/fixtures/p6-gp.json` and `p6-community.json`), asserted by `test/insights.test.mjs` ("cards are sorted worsening, watch, improving, stable and capped at 6"). The watch data is genuinely in the simulator record (community and wearables site).</a:t>
-            </a:r>
-          </a:p>
-          <a:p/>
-          <a:p>
-            <a:r>
-              <a:t>**Prototype proof (say only under the "prototyped today" label)**</a:t>
-            </a:r>
-          </a:p>
-          <a:p/>
-          <a:p>
-            <a:r>
-              <a:t>- 3 real Anima actions per run: order the test, advance the clock, raise the task.</a:t>
-            </a:r>
-          </a:p>
-          <a:p>
-            <a:r>
-              <a:t>- 29 tests, 29 pass: `node --test test/gate.test.mjs test/insights.test.mjs` on 12 Sep 2026 reports tests 29, pass 29, fail 0. 18 on the gate and consent, 11 on the trend cards.</a:t>
-            </a:r>
-          </a:p>
-          <a:p>
-            <a:r>
-              <a:t>- "The son never receives a value" is asserted by this test in `test/gate.test.mjs`:</a:t>
-            </a:r>
-          </a:p>
-          <a:p/>
-          <a:p>
-            <a:r>
-              <a:t>  ```</a:t>
-            </a:r>
-          </a:p>
-          <a:p>
-            <a:r>
-              <a:t>  test("no analyte values ever appear in a message to a person with results:false", () =&gt; {</a:t>
-            </a:r>
-          </a:p>
-          <a:p>
-            <a:r>
-              <a:t>    ...</a:t>
-            </a:r>
-          </a:p>
-          <a:p>
-            <a:r>
-              <a:t>    for (const person of ["john", "tom"]) {</a:t>
-            </a:r>
-          </a:p>
-          <a:p>
-            <a:r>
-              <a:t>      assert.equal(s.consent[person].results, false);</a:t>
-            </a:r>
-          </a:p>
-          <a:p>
-            <a:r>
-              <a:t>      const ctx = gate.visibleContextFor(person, s);</a:t>
-            </a:r>
-          </a:p>
-          <a:p>
-            <a:r>
-              <a:t>      assert.equal(ctx.analytes, null, `${person} context must not carry analytes`);</a:t>
-            </a:r>
-          </a:p>
-          <a:p>
-            <a:r>
-              <a:t>      assert.equal(ctx.abnormal, null);</a:t>
-            </a:r>
-          </a:p>
-          <a:p>
-            <a:r>
-              <a:t>      const text = allMessagesTo(s, person) + "\n" + allMessagesTo(s, "family");</a:t>
-            </a:r>
-          </a:p>
-          <a:p>
-            <a:r>
-              <a:t>      assert.equal(gate.containsAnalyteValues(text, s.gate.analytes), false, `${person} saw a value: ${text}`);</a:t>
-            </a:r>
-          </a:p>
-          <a:p>
-            <a:r>
-              <a:t>      for (const a of s.gate.analytes) assert.equal(text.includes(a.name), false, `${person} saw analyte name ${a.name}`);</a:t>
-            </a:r>
-          </a:p>
-          <a:p>
-            <a:r>
-              <a:t>      const refusal = askTemplate(ctx, "What were her liver results?");</a:t>
-            </a:r>
-          </a:p>
-          <a:p>
-            <a:r>
-              <a:t>      assert.match(refusal.text, /not shared/);</a:t>
-            </a:r>
-          </a:p>
-          <a:p>
-            <a:r>
-              <a:t>      assert.equal(gate.containsAnalyteValues(refusal.text, s.gate.analytes), false);</a:t>
-            </a:r>
-          </a:p>
-          <a:p>
-            <a:r>
-              <a:t>    }</a:t>
-            </a:r>
-          </a:p>
-          <a:p>
-            <a:r>
-              <a:t>  ```</a:t>
-            </a:r>
-          </a:p>
-          <a:p/>
-          <a:p>
-            <a:r>
-              <a:t>  In the prototype "tom" is the son (`lib/gate.mjs`: `{ id: "tom", name: "Tom", role: "son" }`). The test also covers the husband and the shared family thread, and checks that a direct question ("What were her liver results?") gets a refusal with no value in it. A second test, "no family message before disclosure, except escalation", asserts the escalation message to the family contains no analyte value.</a:t>
             </a:r>
           </a:p>
         </p:txBody>
@@ -8321,2103 +7876,6 @@
                 <a:latin typeface="Instrument Sans"/>
               </a:rPr>
               <a:t>All patient data synthetic · Fictional demo, not an official NHS product</a:t>
-            </a:r>
-          </a:p>
-        </p:txBody>
-      </p:sp>
-    </p:spTree>
-  </p:cSld>
-  <p:clrMapOvr>
-    <a:masterClrMapping/>
-  </p:clrMapOvr>
-</p:sld>
-</file>
-
-<file path=ppt/slides/slide6.xml><?xml version="1.0" encoding="utf-8"?>
-<p:sld xmlns:a="http://schemas.openxmlformats.org/drawingml/2006/main" xmlns:p="http://schemas.openxmlformats.org/presentationml/2006/main" xmlns:r="http://schemas.openxmlformats.org/officeDocument/2006/relationships">
-  <p:cSld>
-    <p:bg>
-      <p:bgPr>
-        <a:solidFill>
-          <a:srgbClr val="F2F4F1"/>
-        </a:solidFill>
-        <a:effectLst/>
-      </p:bgPr>
-    </p:bg>
-    <p:spTree>
-      <p:nvGrpSpPr>
-        <p:cNvPr id="1" name=""/>
-        <p:cNvGrpSpPr/>
-        <p:nvPr/>
-      </p:nvGrpSpPr>
-      <p:grpSpPr/>
-      <p:sp>
-        <p:nvSpPr>
-          <p:cNvPr id="2" name="TextBox 1"/>
-          <p:cNvSpPr txBox="1"/>
-          <p:nvPr/>
-        </p:nvSpPr>
-        <p:spPr>
-          <a:xfrm>
-            <a:off x="731520" y="411480"/>
-            <a:ext cx="10728655" cy="274320"/>
-          </a:xfrm>
-          <a:prstGeom prst="rect">
-            <a:avLst/>
-          </a:prstGeom>
-          <a:noFill/>
-        </p:spPr>
-        <p:txBody>
-          <a:bodyPr wrap="square" anchor="t" lIns="0" rIns="0" tIns="0" bIns="0">
-            <a:spAutoFit/>
-          </a:bodyPr>
-          <a:lstStyle/>
-          <a:p>
-            <a:pPr algn="l">
-              <a:lnSpc>
-                <a:spcPct val="115000"/>
-              </a:lnSpc>
-              <a:spcAft>
-                <a:spcPts val="0"/>
-              </a:spcAft>
-            </a:pPr>
-            <a:r>
-              <a:rPr sz="900" b="1">
-                <a:solidFill>
-                  <a:srgbClr val="5F6D66"/>
-                </a:solidFill>
-                <a:latin typeface="Instrument Sans"/>
-              </a:rPr>
-              <a:t>THE DEMO</a:t>
-            </a:r>
-          </a:p>
-        </p:txBody>
-      </p:sp>
-      <p:sp>
-        <p:nvSpPr>
-          <p:cNvPr id="3" name="TextBox 2"/>
-          <p:cNvSpPr txBox="1"/>
-          <p:nvPr/>
-        </p:nvSpPr>
-        <p:spPr>
-          <a:xfrm>
-            <a:off x="731520" y="868680"/>
-            <a:ext cx="9144000" cy="731520"/>
-          </a:xfrm>
-          <a:prstGeom prst="rect">
-            <a:avLst/>
-          </a:prstGeom>
-          <a:noFill/>
-        </p:spPr>
-        <p:txBody>
-          <a:bodyPr wrap="square" anchor="t" lIns="0" rIns="0" tIns="0" bIns="0">
-            <a:spAutoFit/>
-          </a:bodyPr>
-          <a:lstStyle/>
-          <a:p>
-            <a:pPr algn="l">
-              <a:lnSpc>
-                <a:spcPct val="115000"/>
-              </a:lnSpc>
-              <a:spcAft>
-                <a:spcPts val="0"/>
-              </a:spcAft>
-            </a:pPr>
-            <a:r>
-              <a:rPr sz="3600" b="1">
-                <a:solidFill>
-                  <a:srgbClr val="14261F"/>
-                </a:solidFill>
-                <a:latin typeface="Bricolage Grotesque"/>
-              </a:rPr>
-              <a:t>90 seconds, live against Anima.</a:t>
-            </a:r>
-          </a:p>
-        </p:txBody>
-      </p:sp>
-      <p:sp>
-        <p:nvSpPr>
-          <p:cNvPr id="4" name="Oval 3"/>
-          <p:cNvSpPr/>
-          <p:nvPr/>
-        </p:nvSpPr>
-        <p:spPr>
-          <a:xfrm>
-            <a:off x="731520" y="1965959"/>
-            <a:ext cx="128016" cy="128016"/>
-          </a:xfrm>
-          <a:prstGeom prst="ellipse">
-            <a:avLst/>
-          </a:prstGeom>
-          <a:solidFill>
-            <a:srgbClr val="2F6B4F"/>
-          </a:solidFill>
-          <a:ln>
-            <a:noFill/>
-          </a:ln>
-          <a:effectLst/>
-        </p:spPr>
-        <p:style>
-          <a:lnRef idx="1">
-            <a:schemeClr val="accent1"/>
-          </a:lnRef>
-          <a:fillRef idx="3">
-            <a:schemeClr val="accent1"/>
-          </a:fillRef>
-          <a:effectRef idx="2">
-            <a:schemeClr val="accent1"/>
-          </a:effectRef>
-          <a:fontRef idx="minor">
-            <a:schemeClr val="lt1"/>
-          </a:fontRef>
-        </p:style>
-        <p:txBody>
-          <a:bodyPr rtlCol="0" anchor="ctr"/>
-          <a:lstStyle/>
-          <a:p>
-            <a:pPr algn="ctr"/>
-          </a:p>
-        </p:txBody>
-      </p:sp>
-      <p:sp>
-        <p:nvSpPr>
-          <p:cNvPr id="5" name="TextBox 4"/>
-          <p:cNvSpPr txBox="1"/>
-          <p:nvPr/>
-        </p:nvSpPr>
-        <p:spPr>
-          <a:xfrm>
-            <a:off x="1097280" y="1874519"/>
-            <a:ext cx="9875520" cy="640080"/>
-          </a:xfrm>
-          <a:prstGeom prst="rect">
-            <a:avLst/>
-          </a:prstGeom>
-          <a:noFill/>
-        </p:spPr>
-        <p:txBody>
-          <a:bodyPr wrap="square" anchor="t" lIns="0" rIns="0" tIns="0" bIns="0">
-            <a:spAutoFit/>
-          </a:bodyPr>
-          <a:lstStyle/>
-          <a:p>
-            <a:pPr algn="l">
-              <a:lnSpc>
-                <a:spcPct val="125000"/>
-              </a:lnSpc>
-              <a:spcAft>
-                <a:spcPts val="0"/>
-              </a:spcAft>
-            </a:pPr>
-            <a:r>
-              <a:rPr sz="1450" b="1">
-                <a:solidFill>
-                  <a:srgbClr val="14261F"/>
-                </a:solidFill>
-                <a:latin typeface="Instrument Sans"/>
-              </a:rPr>
-              <a:t>Eleanor's body. </a:t>
-            </a:r>
-            <a:r>
-              <a:rPr sz="1450" b="0">
-                <a:solidFill>
-                  <a:srgbClr val="5F6D66"/>
-                </a:solidFill>
-                <a:latin typeface="Instrument Sans"/>
-              </a:rPr>
-              <a:t>Nine systems coloured from her live record in the Body tab, consent-gated per system; the Home boxes say what needs watching. Trend cards  </a:t>
-            </a:r>
-            <a:r>
-              <a:rPr sz="850" b="1">
-                <a:solidFill>
-                  <a:srgbClr val="1E4A36"/>
-                </a:solidFill>
-                <a:latin typeface="Instrument Sans"/>
-              </a:rPr>
-              <a:t>LIVE FROM THE PROTOTYPE</a:t>
-            </a:r>
-          </a:p>
-        </p:txBody>
-      </p:sp>
-      <p:sp>
-        <p:nvSpPr>
-          <p:cNvPr id="6" name="Oval 5"/>
-          <p:cNvSpPr/>
-          <p:nvPr/>
-        </p:nvSpPr>
-        <p:spPr>
-          <a:xfrm>
-            <a:off x="731520" y="2624327"/>
-            <a:ext cx="128016" cy="128016"/>
-          </a:xfrm>
-          <a:prstGeom prst="ellipse">
-            <a:avLst/>
-          </a:prstGeom>
-          <a:solidFill>
-            <a:srgbClr val="2F6B4F"/>
-          </a:solidFill>
-          <a:ln>
-            <a:noFill/>
-          </a:ln>
-          <a:effectLst/>
-        </p:spPr>
-        <p:style>
-          <a:lnRef idx="1">
-            <a:schemeClr val="accent1"/>
-          </a:lnRef>
-          <a:fillRef idx="3">
-            <a:schemeClr val="accent1"/>
-          </a:fillRef>
-          <a:effectRef idx="2">
-            <a:schemeClr val="accent1"/>
-          </a:effectRef>
-          <a:fontRef idx="minor">
-            <a:schemeClr val="lt1"/>
-          </a:fontRef>
-        </p:style>
-        <p:txBody>
-          <a:bodyPr rtlCol="0" anchor="ctr"/>
-          <a:lstStyle/>
-          <a:p>
-            <a:pPr algn="ctr"/>
-          </a:p>
-        </p:txBody>
-      </p:sp>
-      <p:sp>
-        <p:nvSpPr>
-          <p:cNvPr id="7" name="TextBox 6"/>
-          <p:cNvSpPr txBox="1"/>
-          <p:nvPr/>
-        </p:nvSpPr>
-        <p:spPr>
-          <a:xfrm>
-            <a:off x="1097280" y="2532887"/>
-            <a:ext cx="9875520" cy="640080"/>
-          </a:xfrm>
-          <a:prstGeom prst="rect">
-            <a:avLst/>
-          </a:prstGeom>
-          <a:noFill/>
-        </p:spPr>
-        <p:txBody>
-          <a:bodyPr wrap="square" anchor="t" lIns="0" rIns="0" tIns="0" bIns="0">
-            <a:spAutoFit/>
-          </a:bodyPr>
-          <a:lstStyle/>
-          <a:p>
-            <a:pPr algn="l">
-              <a:lnSpc>
-                <a:spcPct val="125000"/>
-              </a:lnSpc>
-              <a:spcAft>
-                <a:spcPts val="0"/>
-              </a:spcAft>
-            </a:pPr>
-            <a:r>
-              <a:rPr sz="1450" b="1">
-                <a:solidFill>
-                  <a:srgbClr val="14261F"/>
-                </a:solidFill>
-                <a:latin typeface="Instrument Sans"/>
-              </a:rPr>
-              <a:t>Order the LFT in Anima; advance the clock 121 minutes. </a:t>
-            </a:r>
-            <a:r>
-              <a:rPr sz="1450" b="0">
-                <a:solidFill>
-                  <a:srgbClr val="5F6D66"/>
-                </a:solidFill>
-                <a:latin typeface="Instrument Sans"/>
-              </a:rPr>
-              <a:t>The result lands as a real state change.</a:t>
-            </a:r>
-          </a:p>
-        </p:txBody>
-      </p:sp>
-      <p:sp>
-        <p:nvSpPr>
-          <p:cNvPr id="8" name="Oval 7"/>
-          <p:cNvSpPr/>
-          <p:nvPr/>
-        </p:nvSpPr>
-        <p:spPr>
-          <a:xfrm>
-            <a:off x="731520" y="3282695"/>
-            <a:ext cx="128016" cy="128016"/>
-          </a:xfrm>
-          <a:prstGeom prst="ellipse">
-            <a:avLst/>
-          </a:prstGeom>
-          <a:solidFill>
-            <a:srgbClr val="2F6B4F"/>
-          </a:solidFill>
-          <a:ln>
-            <a:noFill/>
-          </a:ln>
-          <a:effectLst/>
-        </p:spPr>
-        <p:style>
-          <a:lnRef idx="1">
-            <a:schemeClr val="accent1"/>
-          </a:lnRef>
-          <a:fillRef idx="3">
-            <a:schemeClr val="accent1"/>
-          </a:fillRef>
-          <a:effectRef idx="2">
-            <a:schemeClr val="accent1"/>
-          </a:effectRef>
-          <a:fontRef idx="minor">
-            <a:schemeClr val="lt1"/>
-          </a:fontRef>
-        </p:style>
-        <p:txBody>
-          <a:bodyPr rtlCol="0" anchor="ctr"/>
-          <a:lstStyle/>
-          <a:p>
-            <a:pPr algn="ctr"/>
-          </a:p>
-        </p:txBody>
-      </p:sp>
-      <p:sp>
-        <p:nvSpPr>
-          <p:cNvPr id="9" name="TextBox 8"/>
-          <p:cNvSpPr txBox="1"/>
-          <p:nvPr/>
-        </p:nvSpPr>
-        <p:spPr>
-          <a:xfrm>
-            <a:off x="1097280" y="3191255"/>
-            <a:ext cx="9875520" cy="640080"/>
-          </a:xfrm>
-          <a:prstGeom prst="rect">
-            <a:avLst/>
-          </a:prstGeom>
-          <a:noFill/>
-        </p:spPr>
-        <p:txBody>
-          <a:bodyPr wrap="square" anchor="t" lIns="0" rIns="0" tIns="0" bIns="0">
-            <a:spAutoFit/>
-          </a:bodyPr>
-          <a:lstStyle/>
-          <a:p>
-            <a:pPr algn="l">
-              <a:lnSpc>
-                <a:spcPct val="125000"/>
-              </a:lnSpc>
-              <a:spcAft>
-                <a:spcPts val="0"/>
-              </a:spcAft>
-            </a:pPr>
-            <a:r>
-              <a:rPr sz="1450" b="1">
-                <a:solidFill>
-                  <a:srgbClr val="14261F"/>
-                </a:solidFill>
-                <a:latin typeface="Instrument Sans"/>
-              </a:rPr>
-              <a:t>Held. </a:t>
-            </a:r>
-            <a:r>
-              <a:rPr sz="1450" b="0">
-                <a:solidFill>
-                  <a:srgbClr val="5F6D66"/>
-                </a:solidFill>
-                <a:latin typeface="Instrument Sans"/>
-              </a:rPr>
-              <a:t>Eleanor's phone: a result has arrived and the practice will talk her through it. Family sees nothing.</a:t>
-            </a:r>
-          </a:p>
-        </p:txBody>
-      </p:sp>
-      <p:sp>
-        <p:nvSpPr>
-          <p:cNvPr id="10" name="Oval 9"/>
-          <p:cNvSpPr/>
-          <p:nvPr/>
-        </p:nvSpPr>
-        <p:spPr>
-          <a:xfrm>
-            <a:off x="731520" y="3941063"/>
-            <a:ext cx="128016" cy="128016"/>
-          </a:xfrm>
-          <a:prstGeom prst="ellipse">
-            <a:avLst/>
-          </a:prstGeom>
-          <a:solidFill>
-            <a:srgbClr val="2F6B4F"/>
-          </a:solidFill>
-          <a:ln>
-            <a:noFill/>
-          </a:ln>
-          <a:effectLst/>
-        </p:spPr>
-        <p:style>
-          <a:lnRef idx="1">
-            <a:schemeClr val="accent1"/>
-          </a:lnRef>
-          <a:fillRef idx="3">
-            <a:schemeClr val="accent1"/>
-          </a:fillRef>
-          <a:effectRef idx="2">
-            <a:schemeClr val="accent1"/>
-          </a:effectRef>
-          <a:fontRef idx="minor">
-            <a:schemeClr val="lt1"/>
-          </a:fontRef>
-        </p:style>
-        <p:txBody>
-          <a:bodyPr rtlCol="0" anchor="ctr"/>
-          <a:lstStyle/>
-          <a:p>
-            <a:pPr algn="ctr"/>
-          </a:p>
-        </p:txBody>
-      </p:sp>
-      <p:sp>
-        <p:nvSpPr>
-          <p:cNvPr id="11" name="TextBox 10"/>
-          <p:cNvSpPr txBox="1"/>
-          <p:nvPr/>
-        </p:nvSpPr>
-        <p:spPr>
-          <a:xfrm>
-            <a:off x="1097280" y="3849623"/>
-            <a:ext cx="9875520" cy="640080"/>
-          </a:xfrm>
-          <a:prstGeom prst="rect">
-            <a:avLst/>
-          </a:prstGeom>
-          <a:noFill/>
-        </p:spPr>
-        <p:txBody>
-          <a:bodyPr wrap="square" anchor="t" lIns="0" rIns="0" tIns="0" bIns="0">
-            <a:spAutoFit/>
-          </a:bodyPr>
-          <a:lstStyle/>
-          <a:p>
-            <a:pPr algn="l">
-              <a:lnSpc>
-                <a:spcPct val="125000"/>
-              </a:lnSpc>
-              <a:spcAft>
-                <a:spcPts val="0"/>
-              </a:spcAft>
-            </a:pPr>
-            <a:r>
-              <a:rPr sz="1450" b="1">
-                <a:solidFill>
-                  <a:srgbClr val="14261F"/>
-                </a:solidFill>
-                <a:latin typeface="Instrument Sans"/>
-              </a:rPr>
-              <a:t>Her yes. </a:t>
-            </a:r>
-            <a:r>
-              <a:rPr sz="1450" b="0">
-                <a:solidFill>
-                  <a:srgbClr val="5F6D66"/>
-                </a:solidFill>
-                <a:latin typeface="Instrument Sans"/>
-              </a:rPr>
-              <a:t>Three versions go out: Grace numbers, Idris logistics, Thomas yes/no. A task appears in Anima's activity trail.</a:t>
-            </a:r>
-          </a:p>
-        </p:txBody>
-      </p:sp>
-      <p:sp>
-        <p:nvSpPr>
-          <p:cNvPr id="12" name="Oval 11"/>
-          <p:cNvSpPr/>
-          <p:nvPr/>
-        </p:nvSpPr>
-        <p:spPr>
-          <a:xfrm>
-            <a:off x="731520" y="4599431"/>
-            <a:ext cx="128016" cy="128016"/>
-          </a:xfrm>
-          <a:prstGeom prst="ellipse">
-            <a:avLst/>
-          </a:prstGeom>
-          <a:solidFill>
-            <a:srgbClr val="2F6B4F"/>
-          </a:solidFill>
-          <a:ln>
-            <a:noFill/>
-          </a:ln>
-          <a:effectLst/>
-        </p:spPr>
-        <p:style>
-          <a:lnRef idx="1">
-            <a:schemeClr val="accent1"/>
-          </a:lnRef>
-          <a:fillRef idx="3">
-            <a:schemeClr val="accent1"/>
-          </a:fillRef>
-          <a:effectRef idx="2">
-            <a:schemeClr val="accent1"/>
-          </a:effectRef>
-          <a:fontRef idx="minor">
-            <a:schemeClr val="lt1"/>
-          </a:fontRef>
-        </p:style>
-        <p:txBody>
-          <a:bodyPr rtlCol="0" anchor="ctr"/>
-          <a:lstStyle/>
-          <a:p>
-            <a:pPr algn="ctr"/>
-          </a:p>
-        </p:txBody>
-      </p:sp>
-      <p:sp>
-        <p:nvSpPr>
-          <p:cNvPr id="13" name="TextBox 12"/>
-          <p:cNvSpPr txBox="1"/>
-          <p:nvPr/>
-        </p:nvSpPr>
-        <p:spPr>
-          <a:xfrm>
-            <a:off x="1097280" y="4507991"/>
-            <a:ext cx="9875520" cy="640080"/>
-          </a:xfrm>
-          <a:prstGeom prst="rect">
-            <a:avLst/>
-          </a:prstGeom>
-          <a:noFill/>
-        </p:spPr>
-        <p:txBody>
-          <a:bodyPr wrap="square" anchor="t" lIns="0" rIns="0" tIns="0" bIns="0">
-            <a:spAutoFit/>
-          </a:bodyPr>
-          <a:lstStyle/>
-          <a:p>
-            <a:pPr algn="l">
-              <a:lnSpc>
-                <a:spcPct val="125000"/>
-              </a:lnSpc>
-              <a:spcAft>
-                <a:spcPts val="0"/>
-              </a:spcAft>
-            </a:pPr>
-            <a:r>
-              <a:rPr sz="1450" b="1">
-                <a:solidFill>
-                  <a:srgbClr val="14261F"/>
-                </a:solidFill>
-                <a:latin typeface="Instrument Sans"/>
-              </a:rPr>
-              <a:t>Grace asks about a result she cannot see. </a:t>
-            </a:r>
-            <a:r>
-              <a:rPr sz="1450" b="0">
-                <a:solidFill>
-                  <a:srgbClr val="6D2E5B"/>
-                </a:solidFill>
-                <a:latin typeface="JetBrains Mono"/>
-              </a:rPr>
-              <a:t>NOT_SHARED</a:t>
-            </a:r>
-            <a:r>
-              <a:rPr sz="1450" b="0">
-                <a:solidFill>
-                  <a:srgbClr val="5F6D66"/>
-                </a:solidFill>
-                <a:latin typeface="Instrument Sans"/>
-              </a:rPr>
-              <a:t>, no hint. She asks for access; Eleanor approves from a card; the GP consent view updates live.</a:t>
-            </a:r>
-          </a:p>
-        </p:txBody>
-      </p:sp>
-      <p:sp>
-        <p:nvSpPr>
-          <p:cNvPr id="14" name="Oval 13"/>
-          <p:cNvSpPr/>
-          <p:nvPr/>
-        </p:nvSpPr>
-        <p:spPr>
-          <a:xfrm>
-            <a:off x="731520" y="5257799"/>
-            <a:ext cx="128016" cy="128016"/>
-          </a:xfrm>
-          <a:prstGeom prst="ellipse">
-            <a:avLst/>
-          </a:prstGeom>
-          <a:solidFill>
-            <a:srgbClr val="2F6B4F"/>
-          </a:solidFill>
-          <a:ln>
-            <a:noFill/>
-          </a:ln>
-          <a:effectLst/>
-        </p:spPr>
-        <p:style>
-          <a:lnRef idx="1">
-            <a:schemeClr val="accent1"/>
-          </a:lnRef>
-          <a:fillRef idx="3">
-            <a:schemeClr val="accent1"/>
-          </a:fillRef>
-          <a:effectRef idx="2">
-            <a:schemeClr val="accent1"/>
-          </a:effectRef>
-          <a:fontRef idx="minor">
-            <a:schemeClr val="lt1"/>
-          </a:fontRef>
-        </p:style>
-        <p:txBody>
-          <a:bodyPr rtlCol="0" anchor="ctr"/>
-          <a:lstStyle/>
-          <a:p>
-            <a:pPr algn="ctr"/>
-          </a:p>
-        </p:txBody>
-      </p:sp>
-      <p:sp>
-        <p:nvSpPr>
-          <p:cNvPr id="15" name="TextBox 14"/>
-          <p:cNvSpPr txBox="1"/>
-          <p:nvPr/>
-        </p:nvSpPr>
-        <p:spPr>
-          <a:xfrm>
-            <a:off x="1097280" y="5166359"/>
-            <a:ext cx="9875520" cy="640080"/>
-          </a:xfrm>
-          <a:prstGeom prst="rect">
-            <a:avLst/>
-          </a:prstGeom>
-          <a:noFill/>
-        </p:spPr>
-        <p:txBody>
-          <a:bodyPr wrap="square" anchor="t" lIns="0" rIns="0" tIns="0" bIns="0">
-            <a:spAutoFit/>
-          </a:bodyPr>
-          <a:lstStyle/>
-          <a:p>
-            <a:pPr algn="l">
-              <a:lnSpc>
-                <a:spcPct val="125000"/>
-              </a:lnSpc>
-              <a:spcAft>
-                <a:spcPts val="0"/>
-              </a:spcAft>
-            </a:pPr>
-            <a:r>
-              <a:rPr sz="1450" b="1">
-                <a:solidFill>
-                  <a:srgbClr val="14261F"/>
-                </a:solidFill>
-                <a:latin typeface="Instrument Sans"/>
-              </a:rPr>
-              <a:t>The morning check </a:t>
-            </a:r>
-            <a:r>
-              <a:rPr sz="1450" b="0">
-                <a:solidFill>
-                  <a:srgbClr val="5F6D66"/>
-                </a:solidFill>
-                <a:latin typeface="Instrument Sans"/>
-              </a:rPr>
-              <a:t>reads the 08:30 appointment from the record and posts to the family group: who can give Eleanor a lift?</a:t>
-            </a:r>
-          </a:p>
-        </p:txBody>
-      </p:sp>
-      <p:sp>
-        <p:nvSpPr>
-          <p:cNvPr id="16" name="TextBox 15"/>
-          <p:cNvSpPr txBox="1"/>
-          <p:nvPr/>
-        </p:nvSpPr>
-        <p:spPr>
-          <a:xfrm>
-            <a:off x="731520" y="6309360"/>
-            <a:ext cx="7863840" cy="365760"/>
-          </a:xfrm>
-          <a:prstGeom prst="rect">
-            <a:avLst/>
-          </a:prstGeom>
-          <a:noFill/>
-        </p:spPr>
-        <p:txBody>
-          <a:bodyPr wrap="square" anchor="b" lIns="0" rIns="0" tIns="0" bIns="0">
-            <a:spAutoFit/>
-          </a:bodyPr>
-          <a:lstStyle/>
-          <a:p>
-            <a:pPr algn="l">
-              <a:lnSpc>
-                <a:spcPct val="115000"/>
-              </a:lnSpc>
-              <a:spcAft>
-                <a:spcPts val="0"/>
-              </a:spcAft>
-            </a:pPr>
-            <a:r>
-              <a:rPr sz="850" b="0">
-                <a:solidFill>
-                  <a:srgbClr val="5F6D66"/>
-                </a:solidFill>
-                <a:latin typeface="Instrument Sans"/>
-              </a:rPr>
-              <a:t>Visibly simulated: WhatsApp delivery, relative identity checks, the clinician's “discussed with patient” tap, the persona switcher. Consent writes go to the companion backend, not native FHIR Consent on the remote simulator.</a:t>
-            </a:r>
-          </a:p>
-        </p:txBody>
-      </p:sp>
-      <p:sp>
-        <p:nvSpPr>
-          <p:cNvPr id="17" name="TextBox 16"/>
-          <p:cNvSpPr txBox="1"/>
-          <p:nvPr/>
-        </p:nvSpPr>
-        <p:spPr>
-          <a:xfrm>
-            <a:off x="7345375" y="6309360"/>
-            <a:ext cx="4114800" cy="365760"/>
-          </a:xfrm>
-          <a:prstGeom prst="rect">
-            <a:avLst/>
-          </a:prstGeom>
-          <a:noFill/>
-        </p:spPr>
-        <p:txBody>
-          <a:bodyPr wrap="square" anchor="b" lIns="0" rIns="0" tIns="0" bIns="0">
-            <a:spAutoFit/>
-          </a:bodyPr>
-          <a:lstStyle/>
-          <a:p>
-            <a:pPr algn="r">
-              <a:lnSpc>
-                <a:spcPct val="115000"/>
-              </a:lnSpc>
-              <a:spcAft>
-                <a:spcPts val="0"/>
-              </a:spcAft>
-            </a:pPr>
-            <a:r>
-              <a:rPr sz="850" b="0">
-                <a:solidFill>
-                  <a:srgbClr val="5F6D66"/>
-                </a:solidFill>
-                <a:latin typeface="Instrument Sans"/>
-              </a:rPr>
-              <a:t>All patient data synthetic · Fictional demo, not an official NHS product</a:t>
-            </a:r>
-          </a:p>
-        </p:txBody>
-      </p:sp>
-    </p:spTree>
-  </p:cSld>
-  <p:clrMapOvr>
-    <a:masterClrMapping/>
-  </p:clrMapOvr>
-</p:sld>
-</file>
-
-<file path=ppt/slides/slide7.xml><?xml version="1.0" encoding="utf-8"?>
-<p:sld xmlns:a="http://schemas.openxmlformats.org/drawingml/2006/main" xmlns:p="http://schemas.openxmlformats.org/presentationml/2006/main" xmlns:r="http://schemas.openxmlformats.org/officeDocument/2006/relationships">
-  <p:cSld>
-    <p:bg>
-      <p:bgPr>
-        <a:solidFill>
-          <a:srgbClr val="F2F4F1"/>
-        </a:solidFill>
-        <a:effectLst/>
-      </p:bgPr>
-    </p:bg>
-    <p:spTree>
-      <p:nvGrpSpPr>
-        <p:cNvPr id="1" name=""/>
-        <p:cNvGrpSpPr/>
-        <p:nvPr/>
-      </p:nvGrpSpPr>
-      <p:grpSpPr/>
-      <p:sp>
-        <p:nvSpPr>
-          <p:cNvPr id="2" name="TextBox 1"/>
-          <p:cNvSpPr txBox="1"/>
-          <p:nvPr/>
-        </p:nvSpPr>
-        <p:spPr>
-          <a:xfrm>
-            <a:off x="731520" y="411480"/>
-            <a:ext cx="10728655" cy="274320"/>
-          </a:xfrm>
-          <a:prstGeom prst="rect">
-            <a:avLst/>
-          </a:prstGeom>
-          <a:noFill/>
-        </p:spPr>
-        <p:txBody>
-          <a:bodyPr wrap="square" anchor="t" lIns="0" rIns="0" tIns="0" bIns="0">
-            <a:spAutoFit/>
-          </a:bodyPr>
-          <a:lstStyle/>
-          <a:p>
-            <a:pPr algn="l">
-              <a:lnSpc>
-                <a:spcPct val="115000"/>
-              </a:lnSpc>
-              <a:spcAft>
-                <a:spcPts val="0"/>
-              </a:spcAft>
-            </a:pPr>
-            <a:r>
-              <a:rPr sz="900" b="1">
-                <a:solidFill>
-                  <a:srgbClr val="5F6D66"/>
-                </a:solidFill>
-                <a:latin typeface="Instrument Sans"/>
-              </a:rPr>
-              <a:t>10 YEAR HEALTH PLAN FIT</a:t>
-            </a:r>
-          </a:p>
-        </p:txBody>
-      </p:sp>
-      <p:sp>
-        <p:nvSpPr>
-          <p:cNvPr id="3" name="TextBox 2"/>
-          <p:cNvSpPr txBox="1"/>
-          <p:nvPr/>
-        </p:nvSpPr>
-        <p:spPr>
-          <a:xfrm>
-            <a:off x="731520" y="1188720"/>
-            <a:ext cx="10515600" cy="822960"/>
-          </a:xfrm>
-          <a:prstGeom prst="rect">
-            <a:avLst/>
-          </a:prstGeom>
-          <a:noFill/>
-        </p:spPr>
-        <p:txBody>
-          <a:bodyPr wrap="square" anchor="t" lIns="0" rIns="0" tIns="0" bIns="0">
-            <a:spAutoFit/>
-          </a:bodyPr>
-          <a:lstStyle/>
-          <a:p>
-            <a:pPr algn="l">
-              <a:lnSpc>
-                <a:spcPct val="115000"/>
-              </a:lnSpc>
-              <a:spcAft>
-                <a:spcPts val="0"/>
-              </a:spcAft>
-            </a:pPr>
-            <a:r>
-              <a:rPr sz="2400" b="1">
-                <a:solidFill>
-                  <a:srgbClr val="6D2E5B"/>
-                </a:solidFill>
-                <a:latin typeface="Bricolage Grotesque"/>
-              </a:rPr>
-              <a:t>“</a:t>
-            </a:r>
-            <a:r>
-              <a:rPr sz="2400" b="1">
-                <a:solidFill>
-                  <a:srgbClr val="14261F"/>
-                </a:solidFill>
-                <a:latin typeface="Bricolage Grotesque"/>
-              </a:rPr>
-              <a:t>There are 3 shifts, but only one core purpose: to put power in patients' hands.</a:t>
-            </a:r>
-            <a:r>
-              <a:rPr sz="2400" b="1">
-                <a:solidFill>
-                  <a:srgbClr val="6D2E5B"/>
-                </a:solidFill>
-                <a:latin typeface="Bricolage Grotesque"/>
-              </a:rPr>
-              <a:t>”</a:t>
-            </a:r>
-          </a:p>
-        </p:txBody>
-      </p:sp>
-      <p:sp>
-        <p:nvSpPr>
-          <p:cNvPr id="4" name="TextBox 3"/>
-          <p:cNvSpPr txBox="1"/>
-          <p:nvPr/>
-        </p:nvSpPr>
-        <p:spPr>
-          <a:xfrm>
-            <a:off x="731520" y="2057400"/>
-            <a:ext cx="10515600" cy="320040"/>
-          </a:xfrm>
-          <a:prstGeom prst="rect">
-            <a:avLst/>
-          </a:prstGeom>
-          <a:noFill/>
-        </p:spPr>
-        <p:txBody>
-          <a:bodyPr wrap="square" anchor="t" lIns="0" rIns="0" tIns="0" bIns="0">
-            <a:spAutoFit/>
-          </a:bodyPr>
-          <a:lstStyle/>
-          <a:p>
-            <a:pPr algn="l">
-              <a:lnSpc>
-                <a:spcPct val="115000"/>
-              </a:lnSpc>
-              <a:spcAft>
-                <a:spcPts val="0"/>
-              </a:spcAft>
-            </a:pPr>
-            <a:r>
-              <a:rPr sz="1050" b="0">
-                <a:solidFill>
-                  <a:srgbClr val="5F6D66"/>
-                </a:solidFill>
-                <a:latin typeface="Instrument Sans"/>
-              </a:rPr>
-              <a:t>Chapter 1, p22</a:t>
-            </a:r>
-          </a:p>
-        </p:txBody>
-      </p:sp>
-      <p:sp>
-        <p:nvSpPr>
-          <p:cNvPr id="5" name="TextBox 4"/>
-          <p:cNvSpPr txBox="1"/>
-          <p:nvPr/>
-        </p:nvSpPr>
-        <p:spPr>
-          <a:xfrm>
-            <a:off x="731520" y="2651760"/>
-            <a:ext cx="10515600" cy="822960"/>
-          </a:xfrm>
-          <a:prstGeom prst="rect">
-            <a:avLst/>
-          </a:prstGeom>
-          <a:noFill/>
-        </p:spPr>
-        <p:txBody>
-          <a:bodyPr wrap="square" anchor="t" lIns="0" rIns="0" tIns="0" bIns="0">
-            <a:spAutoFit/>
-          </a:bodyPr>
-          <a:lstStyle/>
-          <a:p>
-            <a:pPr algn="l">
-              <a:lnSpc>
-                <a:spcPct val="115000"/>
-              </a:lnSpc>
-              <a:spcAft>
-                <a:spcPts val="0"/>
-              </a:spcAft>
-            </a:pPr>
-            <a:r>
-              <a:rPr sz="2400" b="1">
-                <a:solidFill>
-                  <a:srgbClr val="6D2E5B"/>
-                </a:solidFill>
-                <a:latin typeface="Bricolage Grotesque"/>
-              </a:rPr>
-              <a:t>“</a:t>
-            </a:r>
-            <a:r>
-              <a:rPr sz="2400" b="1">
-                <a:solidFill>
-                  <a:srgbClr val="14261F"/>
-                </a:solidFill>
-                <a:latin typeface="Bricolage Grotesque"/>
-              </a:rPr>
-              <a:t>Patients will have control over whether this data is shared.</a:t>
-            </a:r>
-            <a:r>
-              <a:rPr sz="2400" b="1">
-                <a:solidFill>
-                  <a:srgbClr val="6D2E5B"/>
-                </a:solidFill>
-                <a:latin typeface="Bricolage Grotesque"/>
-              </a:rPr>
-              <a:t>”</a:t>
-            </a:r>
-          </a:p>
-        </p:txBody>
-      </p:sp>
-      <p:sp>
-        <p:nvSpPr>
-          <p:cNvPr id="6" name="TextBox 5"/>
-          <p:cNvSpPr txBox="1"/>
-          <p:nvPr/>
-        </p:nvSpPr>
-        <p:spPr>
-          <a:xfrm>
-            <a:off x="731520" y="3520440"/>
-            <a:ext cx="10515600" cy="320040"/>
-          </a:xfrm>
-          <a:prstGeom prst="rect">
-            <a:avLst/>
-          </a:prstGeom>
-          <a:noFill/>
-        </p:spPr>
-        <p:txBody>
-          <a:bodyPr wrap="square" anchor="t" lIns="0" rIns="0" tIns="0" bIns="0">
-            <a:spAutoFit/>
-          </a:bodyPr>
-          <a:lstStyle/>
-          <a:p>
-            <a:pPr algn="l">
-              <a:lnSpc>
-                <a:spcPct val="115000"/>
-              </a:lnSpc>
-              <a:spcAft>
-                <a:spcPts val="0"/>
-              </a:spcAft>
-            </a:pPr>
-            <a:r>
-              <a:rPr sz="1050" b="0">
-                <a:solidFill>
-                  <a:srgbClr val="5F6D66"/>
-                </a:solidFill>
-                <a:latin typeface="Instrument Sans"/>
-              </a:rPr>
-              <a:t>Chapter 3, My Health, pp50 to 51. And My Carer, p51: carers gain access to the App on their loved one's behalf.</a:t>
-            </a:r>
-          </a:p>
-        </p:txBody>
-      </p:sp>
-      <p:sp>
-        <p:nvSpPr>
-          <p:cNvPr id="7" name="TextBox 6"/>
-          <p:cNvSpPr txBox="1"/>
-          <p:nvPr/>
-        </p:nvSpPr>
-        <p:spPr>
-          <a:xfrm>
-            <a:off x="731520" y="4114800"/>
-            <a:ext cx="10515600" cy="822960"/>
-          </a:xfrm>
-          <a:prstGeom prst="rect">
-            <a:avLst/>
-          </a:prstGeom>
-          <a:noFill/>
-        </p:spPr>
-        <p:txBody>
-          <a:bodyPr wrap="square" anchor="t" lIns="0" rIns="0" tIns="0" bIns="0">
-            <a:spAutoFit/>
-          </a:bodyPr>
-          <a:lstStyle/>
-          <a:p>
-            <a:pPr algn="l">
-              <a:lnSpc>
-                <a:spcPct val="115000"/>
-              </a:lnSpc>
-              <a:spcAft>
-                <a:spcPts val="0"/>
-              </a:spcAft>
-            </a:pPr>
-            <a:r>
-              <a:rPr sz="2400" b="1">
-                <a:solidFill>
-                  <a:srgbClr val="6D2E5B"/>
-                </a:solidFill>
-                <a:latin typeface="Bricolage Grotesque"/>
-              </a:rPr>
-              <a:t>“</a:t>
-            </a:r>
-            <a:r>
-              <a:rPr sz="2400" b="1">
-                <a:solidFill>
-                  <a:srgbClr val="14261F"/>
-                </a:solidFill>
-                <a:latin typeface="Bricolage Grotesque"/>
-              </a:rPr>
-              <a:t>The most common reasons for complaints is poor communication.</a:t>
-            </a:r>
-            <a:r>
-              <a:rPr sz="2400" b="1">
-                <a:solidFill>
-                  <a:srgbClr val="6D2E5B"/>
-                </a:solidFill>
-                <a:latin typeface="Bricolage Grotesque"/>
-              </a:rPr>
-              <a:t>”</a:t>
-            </a:r>
-          </a:p>
-        </p:txBody>
-      </p:sp>
-      <p:sp>
-        <p:nvSpPr>
-          <p:cNvPr id="8" name="TextBox 7"/>
-          <p:cNvSpPr txBox="1"/>
-          <p:nvPr/>
-        </p:nvSpPr>
-        <p:spPr>
-          <a:xfrm>
-            <a:off x="731520" y="4983480"/>
-            <a:ext cx="10515600" cy="320040"/>
-          </a:xfrm>
-          <a:prstGeom prst="rect">
-            <a:avLst/>
-          </a:prstGeom>
-          <a:noFill/>
-        </p:spPr>
-        <p:txBody>
-          <a:bodyPr wrap="square" anchor="t" lIns="0" rIns="0" tIns="0" bIns="0">
-            <a:spAutoFit/>
-          </a:bodyPr>
-          <a:lstStyle/>
-          <a:p>
-            <a:pPr algn="l">
-              <a:lnSpc>
-                <a:spcPct val="115000"/>
-              </a:lnSpc>
-              <a:spcAft>
-                <a:spcPts val="0"/>
-              </a:spcAft>
-            </a:pPr>
-            <a:r>
-              <a:rPr sz="1050" b="0">
-                <a:solidFill>
-                  <a:srgbClr val="5F6D66"/>
-                </a:solidFill>
-                <a:latin typeface="Instrument Sans"/>
-              </a:rPr>
-              <a:t>Chapter 6, p89</a:t>
-            </a:r>
-          </a:p>
-        </p:txBody>
-      </p:sp>
-      <p:sp>
-        <p:nvSpPr>
-          <p:cNvPr id="9" name="TextBox 8"/>
-          <p:cNvSpPr txBox="1"/>
-          <p:nvPr/>
-        </p:nvSpPr>
-        <p:spPr>
-          <a:xfrm>
-            <a:off x="731520" y="5623560"/>
-            <a:ext cx="5486400" cy="365760"/>
-          </a:xfrm>
-          <a:prstGeom prst="rect">
-            <a:avLst/>
-          </a:prstGeom>
-          <a:noFill/>
-        </p:spPr>
-        <p:txBody>
-          <a:bodyPr wrap="square" anchor="t" lIns="0" rIns="0" tIns="0" bIns="0">
-            <a:spAutoFit/>
-          </a:bodyPr>
-          <a:lstStyle/>
-          <a:p>
-            <a:pPr algn="l">
-              <a:lnSpc>
-                <a:spcPct val="115000"/>
-              </a:lnSpc>
-              <a:spcAft>
-                <a:spcPts val="0"/>
-              </a:spcAft>
-            </a:pPr>
-            <a:r>
-              <a:rPr sz="1600" b="1">
-                <a:solidFill>
-                  <a:srgbClr val="6D2E5B"/>
-                </a:solidFill>
-                <a:latin typeface="Bricolage Grotesque"/>
-              </a:rPr>
-              <a:t>Chapters 2, 3 and 6.</a:t>
-            </a:r>
-          </a:p>
-        </p:txBody>
-      </p:sp>
-      <p:sp>
-        <p:nvSpPr>
-          <p:cNvPr id="10" name="TextBox 9"/>
-          <p:cNvSpPr txBox="1"/>
-          <p:nvPr/>
-        </p:nvSpPr>
-        <p:spPr>
-          <a:xfrm>
-            <a:off x="731520" y="6309360"/>
-            <a:ext cx="7863840" cy="365760"/>
-          </a:xfrm>
-          <a:prstGeom prst="rect">
-            <a:avLst/>
-          </a:prstGeom>
-          <a:noFill/>
-        </p:spPr>
-        <p:txBody>
-          <a:bodyPr wrap="square" anchor="b" lIns="0" rIns="0" tIns="0" bIns="0">
-            <a:spAutoFit/>
-          </a:bodyPr>
-          <a:lstStyle/>
-          <a:p>
-            <a:pPr algn="l">
-              <a:lnSpc>
-                <a:spcPct val="115000"/>
-              </a:lnSpc>
-              <a:spcAft>
-                <a:spcPts val="0"/>
-              </a:spcAft>
-            </a:pPr>
-            <a:r>
-              <a:rPr sz="850" b="0">
-                <a:solidFill>
-                  <a:srgbClr val="5F6D66"/>
-                </a:solidFill>
-                <a:latin typeface="Instrument Sans"/>
-              </a:rPr>
-              <a:t>Fit for the Future: the 10 Year Health Plan for England, July 2025.</a:t>
-            </a:r>
-          </a:p>
-        </p:txBody>
-      </p:sp>
-      <p:sp>
-        <p:nvSpPr>
-          <p:cNvPr id="11" name="TextBox 10"/>
-          <p:cNvSpPr txBox="1"/>
-          <p:nvPr/>
-        </p:nvSpPr>
-        <p:spPr>
-          <a:xfrm>
-            <a:off x="7345375" y="6309360"/>
-            <a:ext cx="4114800" cy="365760"/>
-          </a:xfrm>
-          <a:prstGeom prst="rect">
-            <a:avLst/>
-          </a:prstGeom>
-          <a:noFill/>
-        </p:spPr>
-        <p:txBody>
-          <a:bodyPr wrap="square" anchor="b" lIns="0" rIns="0" tIns="0" bIns="0">
-            <a:spAutoFit/>
-          </a:bodyPr>
-          <a:lstStyle/>
-          <a:p>
-            <a:pPr algn="r">
-              <a:lnSpc>
-                <a:spcPct val="115000"/>
-              </a:lnSpc>
-              <a:spcAft>
-                <a:spcPts val="0"/>
-              </a:spcAft>
-            </a:pPr>
-            <a:r>
-              <a:rPr sz="850" b="0">
-                <a:solidFill>
-                  <a:srgbClr val="5F6D66"/>
-                </a:solidFill>
-                <a:latin typeface="Instrument Sans"/>
-              </a:rPr>
-              <a:t>All patient data synthetic · Fictional demo, not an official NHS product</a:t>
-            </a:r>
-          </a:p>
-        </p:txBody>
-      </p:sp>
-    </p:spTree>
-  </p:cSld>
-  <p:clrMapOvr>
-    <a:masterClrMapping/>
-  </p:clrMapOvr>
-</p:sld>
-</file>
-
-<file path=ppt/slides/slide8.xml><?xml version="1.0" encoding="utf-8"?>
-<p:sld xmlns:a="http://schemas.openxmlformats.org/drawingml/2006/main" xmlns:p="http://schemas.openxmlformats.org/presentationml/2006/main" xmlns:r="http://schemas.openxmlformats.org/officeDocument/2006/relationships">
-  <p:cSld>
-    <p:bg>
-      <p:bgPr>
-        <a:solidFill>
-          <a:srgbClr val="F2F4F1"/>
-        </a:solidFill>
-        <a:effectLst/>
-      </p:bgPr>
-    </p:bg>
-    <p:spTree>
-      <p:nvGrpSpPr>
-        <p:cNvPr id="1" name=""/>
-        <p:cNvGrpSpPr/>
-        <p:nvPr/>
-      </p:nvGrpSpPr>
-      <p:grpSpPr/>
-      <p:sp>
-        <p:nvSpPr>
-          <p:cNvPr id="2" name="TextBox 1"/>
-          <p:cNvSpPr txBox="1"/>
-          <p:nvPr/>
-        </p:nvSpPr>
-        <p:spPr>
-          <a:xfrm>
-            <a:off x="731520" y="411480"/>
-            <a:ext cx="10728655" cy="274320"/>
-          </a:xfrm>
-          <a:prstGeom prst="rect">
-            <a:avLst/>
-          </a:prstGeom>
-          <a:noFill/>
-        </p:spPr>
-        <p:txBody>
-          <a:bodyPr wrap="square" anchor="t" lIns="0" rIns="0" tIns="0" bIns="0">
-            <a:spAutoFit/>
-          </a:bodyPr>
-          <a:lstStyle/>
-          <a:p>
-            <a:pPr algn="l">
-              <a:lnSpc>
-                <a:spcPct val="115000"/>
-              </a:lnSpc>
-              <a:spcAft>
-                <a:spcPts val="0"/>
-              </a:spcAft>
-            </a:pPr>
-            <a:r>
-              <a:rPr sz="900" b="1">
-                <a:solidFill>
-                  <a:srgbClr val="5F6D66"/>
-                </a:solidFill>
-                <a:latin typeface="Instrument Sans"/>
-              </a:rPr>
-              <a:t>CLOSE</a:t>
-            </a:r>
-          </a:p>
-        </p:txBody>
-      </p:sp>
-      <p:sp>
-        <p:nvSpPr>
-          <p:cNvPr id="3" name="TextBox 2"/>
-          <p:cNvSpPr txBox="1"/>
-          <p:nvPr/>
-        </p:nvSpPr>
-        <p:spPr>
-          <a:xfrm>
-            <a:off x="731520" y="731520"/>
-            <a:ext cx="10515600" cy="1645920"/>
-          </a:xfrm>
-          <a:prstGeom prst="rect">
-            <a:avLst/>
-          </a:prstGeom>
-          <a:noFill/>
-        </p:spPr>
-        <p:txBody>
-          <a:bodyPr wrap="square" anchor="t" lIns="0" rIns="0" tIns="0" bIns="0">
-            <a:spAutoFit/>
-          </a:bodyPr>
-          <a:lstStyle/>
-          <a:p>
-            <a:pPr algn="l">
-              <a:lnSpc>
-                <a:spcPct val="100000"/>
-              </a:lnSpc>
-              <a:spcAft>
-                <a:spcPts val="0"/>
-              </a:spcAft>
-            </a:pPr>
-            <a:r>
-              <a:rPr sz="4600" b="1">
-                <a:solidFill>
-                  <a:srgbClr val="14261F"/>
-                </a:solidFill>
-                <a:latin typeface="Bricolage Grotesque"/>
-              </a:rPr>
-              <a:t>No result ever sits uncommunicated.</a:t>
-            </a:r>
-          </a:p>
-        </p:txBody>
-      </p:sp>
-      <p:sp>
-        <p:nvSpPr>
-          <p:cNvPr id="4" name="TextBox 3"/>
-          <p:cNvSpPr txBox="1"/>
-          <p:nvPr/>
-        </p:nvSpPr>
-        <p:spPr>
-          <a:xfrm>
-            <a:off x="731520" y="2468880"/>
-            <a:ext cx="8686800" cy="731520"/>
-          </a:xfrm>
-          <a:prstGeom prst="rect">
-            <a:avLst/>
-          </a:prstGeom>
-          <a:noFill/>
-        </p:spPr>
-        <p:txBody>
-          <a:bodyPr wrap="square" anchor="t" lIns="0" rIns="0" tIns="0" bIns="0">
-            <a:spAutoFit/>
-          </a:bodyPr>
-          <a:lstStyle/>
-          <a:p>
-            <a:pPr algn="l">
-              <a:lnSpc>
-                <a:spcPct val="130000"/>
-              </a:lnSpc>
-              <a:spcAft>
-                <a:spcPts val="0"/>
-              </a:spcAft>
-            </a:pPr>
-            <a:r>
-              <a:rPr sz="1500" b="0">
-                <a:solidFill>
-                  <a:srgbClr val="5F6D66"/>
-                </a:solidFill>
-                <a:latin typeface="Instrument Sans"/>
-              </a:rPr>
-              <a:t>And when it is communicated, every trusted person gets the right version, in their words, under her control.</a:t>
-            </a:r>
-          </a:p>
-        </p:txBody>
-      </p:sp>
-      <p:sp>
-        <p:nvSpPr>
-          <p:cNvPr id="5" name="Rounded Rectangle 4"/>
-          <p:cNvSpPr/>
-          <p:nvPr/>
-        </p:nvSpPr>
-        <p:spPr>
-          <a:xfrm>
-            <a:off x="731520" y="3429000"/>
-            <a:ext cx="2510713" cy="1691640"/>
-          </a:xfrm>
-          <a:prstGeom prst="roundRect">
-            <a:avLst>
-              <a:gd name="adj" fmla="val 6000"/>
-            </a:avLst>
-          </a:prstGeom>
-          <a:solidFill>
-            <a:srgbClr val="FFFFFF"/>
-          </a:solidFill>
-          <a:ln w="9525">
-            <a:solidFill>
-              <a:srgbClr val="D8DED9"/>
-            </a:solidFill>
-          </a:ln>
-          <a:effectLst/>
-        </p:spPr>
-        <p:style>
-          <a:lnRef idx="1">
-            <a:schemeClr val="accent1"/>
-          </a:lnRef>
-          <a:fillRef idx="3">
-            <a:schemeClr val="accent1"/>
-          </a:fillRef>
-          <a:effectRef idx="2">
-            <a:schemeClr val="accent1"/>
-          </a:effectRef>
-          <a:fontRef idx="minor">
-            <a:schemeClr val="lt1"/>
-          </a:fontRef>
-        </p:style>
-        <p:txBody>
-          <a:bodyPr rtlCol="0" anchor="ctr"/>
-          <a:lstStyle/>
-          <a:p>
-            <a:pPr algn="ctr"/>
-          </a:p>
-        </p:txBody>
-      </p:sp>
-      <p:sp>
-        <p:nvSpPr>
-          <p:cNvPr id="6" name="TextBox 5"/>
-          <p:cNvSpPr txBox="1"/>
-          <p:nvPr/>
-        </p:nvSpPr>
-        <p:spPr>
-          <a:xfrm>
-            <a:off x="1005840" y="3657600"/>
-            <a:ext cx="1962073" cy="640080"/>
-          </a:xfrm>
-          <a:prstGeom prst="rect">
-            <a:avLst/>
-          </a:prstGeom>
-          <a:noFill/>
-        </p:spPr>
-        <p:txBody>
-          <a:bodyPr wrap="square" anchor="t" lIns="0" rIns="0" tIns="0" bIns="0">
-            <a:spAutoFit/>
-          </a:bodyPr>
-          <a:lstStyle/>
-          <a:p>
-            <a:pPr algn="l">
-              <a:lnSpc>
-                <a:spcPct val="115000"/>
-              </a:lnSpc>
-              <a:spcAft>
-                <a:spcPts val="0"/>
-              </a:spcAft>
-            </a:pPr>
-            <a:r>
-              <a:rPr sz="3400" b="1">
-                <a:solidFill>
-                  <a:srgbClr val="6D2E5B"/>
-                </a:solidFill>
-                <a:latin typeface="Bricolage Grotesque"/>
-              </a:rPr>
-              <a:t>3 × 6</a:t>
-            </a:r>
-          </a:p>
-        </p:txBody>
-      </p:sp>
-      <p:sp>
-        <p:nvSpPr>
-          <p:cNvPr id="7" name="TextBox 6"/>
-          <p:cNvSpPr txBox="1"/>
-          <p:nvPr/>
-        </p:nvSpPr>
-        <p:spPr>
-          <a:xfrm>
-            <a:off x="1005840" y="4297680"/>
-            <a:ext cx="1962073" cy="777240"/>
-          </a:xfrm>
-          <a:prstGeom prst="rect">
-            <a:avLst/>
-          </a:prstGeom>
-          <a:noFill/>
-        </p:spPr>
-        <p:txBody>
-          <a:bodyPr wrap="square" anchor="t" lIns="0" rIns="0" tIns="0" bIns="0">
-            <a:spAutoFit/>
-          </a:bodyPr>
-          <a:lstStyle/>
-          <a:p>
-            <a:pPr algn="l">
-              <a:lnSpc>
-                <a:spcPct val="125000"/>
-              </a:lnSpc>
-              <a:spcAft>
-                <a:spcPts val="0"/>
-              </a:spcAft>
-            </a:pPr>
-            <a:r>
-              <a:rPr sz="1100" b="0">
-                <a:solidFill>
-                  <a:srgbClr val="5F6D66"/>
-                </a:solidFill>
-                <a:latin typeface="Instrument Sans"/>
-              </a:rPr>
-              <a:t>sharing levels over six record categories, plus custom mixes</a:t>
-            </a:r>
-          </a:p>
-        </p:txBody>
-      </p:sp>
-      <p:sp>
-        <p:nvSpPr>
-          <p:cNvPr id="8" name="Rounded Rectangle 7"/>
-          <p:cNvSpPr/>
-          <p:nvPr/>
-        </p:nvSpPr>
-        <p:spPr>
-          <a:xfrm>
-            <a:off x="3470833" y="3429000"/>
-            <a:ext cx="2510713" cy="1691640"/>
-          </a:xfrm>
-          <a:prstGeom prst="roundRect">
-            <a:avLst>
-              <a:gd name="adj" fmla="val 6000"/>
-            </a:avLst>
-          </a:prstGeom>
-          <a:solidFill>
-            <a:srgbClr val="FFFFFF"/>
-          </a:solidFill>
-          <a:ln w="9525">
-            <a:solidFill>
-              <a:srgbClr val="D8DED9"/>
-            </a:solidFill>
-          </a:ln>
-          <a:effectLst/>
-        </p:spPr>
-        <p:style>
-          <a:lnRef idx="1">
-            <a:schemeClr val="accent1"/>
-          </a:lnRef>
-          <a:fillRef idx="3">
-            <a:schemeClr val="accent1"/>
-          </a:fillRef>
-          <a:effectRef idx="2">
-            <a:schemeClr val="accent1"/>
-          </a:effectRef>
-          <a:fontRef idx="minor">
-            <a:schemeClr val="lt1"/>
-          </a:fontRef>
-        </p:style>
-        <p:txBody>
-          <a:bodyPr rtlCol="0" anchor="ctr"/>
-          <a:lstStyle/>
-          <a:p>
-            <a:pPr algn="ctr"/>
-          </a:p>
-        </p:txBody>
-      </p:sp>
-      <p:sp>
-        <p:nvSpPr>
-          <p:cNvPr id="9" name="TextBox 8"/>
-          <p:cNvSpPr txBox="1"/>
-          <p:nvPr/>
-        </p:nvSpPr>
-        <p:spPr>
-          <a:xfrm>
-            <a:off x="3745153" y="3657600"/>
-            <a:ext cx="1962073" cy="640080"/>
-          </a:xfrm>
-          <a:prstGeom prst="rect">
-            <a:avLst/>
-          </a:prstGeom>
-          <a:noFill/>
-        </p:spPr>
-        <p:txBody>
-          <a:bodyPr wrap="square" anchor="t" lIns="0" rIns="0" tIns="0" bIns="0">
-            <a:spAutoFit/>
-          </a:bodyPr>
-          <a:lstStyle/>
-          <a:p>
-            <a:pPr algn="l">
-              <a:lnSpc>
-                <a:spcPct val="115000"/>
-              </a:lnSpc>
-              <a:spcAft>
-                <a:spcPts val="0"/>
-              </a:spcAft>
-            </a:pPr>
-            <a:r>
-              <a:rPr sz="3400" b="1">
-                <a:solidFill>
-                  <a:srgbClr val="6D2E5B"/>
-                </a:solidFill>
-                <a:latin typeface="Bricolage Grotesque"/>
-              </a:rPr>
-              <a:t>Every</a:t>
-            </a:r>
-          </a:p>
-        </p:txBody>
-      </p:sp>
-      <p:sp>
-        <p:nvSpPr>
-          <p:cNvPr id="10" name="TextBox 9"/>
-          <p:cNvSpPr txBox="1"/>
-          <p:nvPr/>
-        </p:nvSpPr>
-        <p:spPr>
-          <a:xfrm>
-            <a:off x="3745153" y="4297680"/>
-            <a:ext cx="1962073" cy="777240"/>
-          </a:xfrm>
-          <a:prstGeom prst="rect">
-            <a:avLst/>
-          </a:prstGeom>
-          <a:noFill/>
-        </p:spPr>
-        <p:txBody>
-          <a:bodyPr wrap="square" anchor="t" lIns="0" rIns="0" tIns="0" bIns="0">
-            <a:spAutoFit/>
-          </a:bodyPr>
-          <a:lstStyle/>
-          <a:p>
-            <a:pPr algn="l">
-              <a:lnSpc>
-                <a:spcPct val="125000"/>
-              </a:lnSpc>
-              <a:spcAft>
-                <a:spcPts val="0"/>
-              </a:spcAft>
-            </a:pPr>
-            <a:r>
-              <a:rPr sz="1100" b="0">
-                <a:solidFill>
-                  <a:srgbClr val="5F6D66"/>
-                </a:solidFill>
-                <a:latin typeface="Instrument Sans"/>
-              </a:rPr>
-              <a:t>agent tool call checks consent and is written to the audit rail</a:t>
-            </a:r>
-          </a:p>
-        </p:txBody>
-      </p:sp>
-      <p:sp>
-        <p:nvSpPr>
-          <p:cNvPr id="11" name="Rounded Rectangle 10"/>
-          <p:cNvSpPr/>
-          <p:nvPr/>
-        </p:nvSpPr>
-        <p:spPr>
-          <a:xfrm>
-            <a:off x="6210147" y="3429000"/>
-            <a:ext cx="2510713" cy="1691640"/>
-          </a:xfrm>
-          <a:prstGeom prst="roundRect">
-            <a:avLst>
-              <a:gd name="adj" fmla="val 6000"/>
-            </a:avLst>
-          </a:prstGeom>
-          <a:solidFill>
-            <a:srgbClr val="FFFFFF"/>
-          </a:solidFill>
-          <a:ln w="9525">
-            <a:solidFill>
-              <a:srgbClr val="D8DED9"/>
-            </a:solidFill>
-          </a:ln>
-          <a:effectLst/>
-        </p:spPr>
-        <p:style>
-          <a:lnRef idx="1">
-            <a:schemeClr val="accent1"/>
-          </a:lnRef>
-          <a:fillRef idx="3">
-            <a:schemeClr val="accent1"/>
-          </a:fillRef>
-          <a:effectRef idx="2">
-            <a:schemeClr val="accent1"/>
-          </a:effectRef>
-          <a:fontRef idx="minor">
-            <a:schemeClr val="lt1"/>
-          </a:fontRef>
-        </p:style>
-        <p:txBody>
-          <a:bodyPr rtlCol="0" anchor="ctr"/>
-          <a:lstStyle/>
-          <a:p>
-            <a:pPr algn="ctr"/>
-          </a:p>
-        </p:txBody>
-      </p:sp>
-      <p:sp>
-        <p:nvSpPr>
-          <p:cNvPr id="12" name="TextBox 11"/>
-          <p:cNvSpPr txBox="1"/>
-          <p:nvPr/>
-        </p:nvSpPr>
-        <p:spPr>
-          <a:xfrm>
-            <a:off x="6484467" y="3657600"/>
-            <a:ext cx="1962073" cy="640080"/>
-          </a:xfrm>
-          <a:prstGeom prst="rect">
-            <a:avLst/>
-          </a:prstGeom>
-          <a:noFill/>
-        </p:spPr>
-        <p:txBody>
-          <a:bodyPr wrap="square" anchor="t" lIns="0" rIns="0" tIns="0" bIns="0">
-            <a:spAutoFit/>
-          </a:bodyPr>
-          <a:lstStyle/>
-          <a:p>
-            <a:pPr algn="l">
-              <a:lnSpc>
-                <a:spcPct val="115000"/>
-              </a:lnSpc>
-              <a:spcAft>
-                <a:spcPts val="0"/>
-              </a:spcAft>
-            </a:pPr>
-            <a:r>
-              <a:rPr sz="3400" b="1">
-                <a:solidFill>
-                  <a:srgbClr val="C2572F"/>
-                </a:solidFill>
-                <a:latin typeface="Bricolage Grotesque"/>
-              </a:rPr>
-              <a:t>9</a:t>
-            </a:r>
-          </a:p>
-        </p:txBody>
-      </p:sp>
-      <p:sp>
-        <p:nvSpPr>
-          <p:cNvPr id="13" name="TextBox 12"/>
-          <p:cNvSpPr txBox="1"/>
-          <p:nvPr/>
-        </p:nvSpPr>
-        <p:spPr>
-          <a:xfrm>
-            <a:off x="6484467" y="4297680"/>
-            <a:ext cx="1962073" cy="777240"/>
-          </a:xfrm>
-          <a:prstGeom prst="rect">
-            <a:avLst/>
-          </a:prstGeom>
-          <a:noFill/>
-        </p:spPr>
-        <p:txBody>
-          <a:bodyPr wrap="square" anchor="t" lIns="0" rIns="0" tIns="0" bIns="0">
-            <a:spAutoFit/>
-          </a:bodyPr>
-          <a:lstStyle/>
-          <a:p>
-            <a:pPr algn="l">
-              <a:lnSpc>
-                <a:spcPct val="125000"/>
-              </a:lnSpc>
-              <a:spcAft>
-                <a:spcPts val="0"/>
-              </a:spcAft>
-            </a:pPr>
-            <a:r>
-              <a:rPr sz="1100" b="0">
-                <a:solidFill>
-                  <a:srgbClr val="5F6D66"/>
-                </a:solidFill>
-                <a:latin typeface="Instrument Sans"/>
-              </a:rPr>
-              <a:t>body systems coloured from the live record, consent-gated per system, on a licensed 3D figure</a:t>
-            </a:r>
-          </a:p>
-        </p:txBody>
-      </p:sp>
-      <p:sp>
-        <p:nvSpPr>
-          <p:cNvPr id="14" name="Rounded Rectangle 13"/>
-          <p:cNvSpPr/>
-          <p:nvPr/>
-        </p:nvSpPr>
-        <p:spPr>
-          <a:xfrm>
-            <a:off x="8949461" y="3429000"/>
-            <a:ext cx="2510713" cy="1691640"/>
-          </a:xfrm>
-          <a:prstGeom prst="roundRect">
-            <a:avLst>
-              <a:gd name="adj" fmla="val 6000"/>
-            </a:avLst>
-          </a:prstGeom>
-          <a:solidFill>
-            <a:srgbClr val="FFFFFF"/>
-          </a:solidFill>
-          <a:ln w="9525">
-            <a:solidFill>
-              <a:srgbClr val="D8DED9"/>
-            </a:solidFill>
-          </a:ln>
-          <a:effectLst/>
-        </p:spPr>
-        <p:style>
-          <a:lnRef idx="1">
-            <a:schemeClr val="accent1"/>
-          </a:lnRef>
-          <a:fillRef idx="3">
-            <a:schemeClr val="accent1"/>
-          </a:fillRef>
-          <a:effectRef idx="2">
-            <a:schemeClr val="accent1"/>
-          </a:effectRef>
-          <a:fontRef idx="minor">
-            <a:schemeClr val="lt1"/>
-          </a:fontRef>
-        </p:style>
-        <p:txBody>
-          <a:bodyPr rtlCol="0" anchor="ctr"/>
-          <a:lstStyle/>
-          <a:p>
-            <a:pPr algn="ctr"/>
-          </a:p>
-        </p:txBody>
-      </p:sp>
-      <p:sp>
-        <p:nvSpPr>
-          <p:cNvPr id="15" name="TextBox 14"/>
-          <p:cNvSpPr txBox="1"/>
-          <p:nvPr/>
-        </p:nvSpPr>
-        <p:spPr>
-          <a:xfrm>
-            <a:off x="9223781" y="3657600"/>
-            <a:ext cx="1962073" cy="640080"/>
-          </a:xfrm>
-          <a:prstGeom prst="rect">
-            <a:avLst/>
-          </a:prstGeom>
-          <a:noFill/>
-        </p:spPr>
-        <p:txBody>
-          <a:bodyPr wrap="square" anchor="t" lIns="0" rIns="0" tIns="0" bIns="0">
-            <a:spAutoFit/>
-          </a:bodyPr>
-          <a:lstStyle/>
-          <a:p>
-            <a:pPr algn="l">
-              <a:lnSpc>
-                <a:spcPct val="115000"/>
-              </a:lnSpc>
-              <a:spcAft>
-                <a:spcPts val="0"/>
-              </a:spcAft>
-            </a:pPr>
-            <a:r>
-              <a:rPr sz="3400" b="1">
-                <a:solidFill>
-                  <a:srgbClr val="6D2E5B"/>
-                </a:solidFill>
-                <a:latin typeface="Bricolage Grotesque"/>
-              </a:rPr>
-              <a:t>1</a:t>
-            </a:r>
-          </a:p>
-        </p:txBody>
-      </p:sp>
-      <p:sp>
-        <p:nvSpPr>
-          <p:cNvPr id="16" name="TextBox 15"/>
-          <p:cNvSpPr txBox="1"/>
-          <p:nvPr/>
-        </p:nvSpPr>
-        <p:spPr>
-          <a:xfrm>
-            <a:off x="9223781" y="4297680"/>
-            <a:ext cx="1962073" cy="777240"/>
-          </a:xfrm>
-          <a:prstGeom prst="rect">
-            <a:avLst/>
-          </a:prstGeom>
-          <a:noFill/>
-        </p:spPr>
-        <p:txBody>
-          <a:bodyPr wrap="square" anchor="t" lIns="0" rIns="0" tIns="0" bIns="0">
-            <a:spAutoFit/>
-          </a:bodyPr>
-          <a:lstStyle/>
-          <a:p>
-            <a:pPr algn="l">
-              <a:lnSpc>
-                <a:spcPct val="125000"/>
-              </a:lnSpc>
-              <a:spcAft>
-                <a:spcPts val="0"/>
-              </a:spcAft>
-            </a:pPr>
-            <a:r>
-              <a:rPr sz="1100" b="0">
-                <a:solidFill>
-                  <a:srgbClr val="5F6D66"/>
-                </a:solidFill>
-                <a:latin typeface="Instrument Sans"/>
-              </a:rPr>
-              <a:t>transaction mirrors each consent change to the GP view: observation plus audit</a:t>
-            </a:r>
-          </a:p>
-        </p:txBody>
-      </p:sp>
-      <p:sp>
-        <p:nvSpPr>
-          <p:cNvPr id="17" name="TextBox 16"/>
-          <p:cNvSpPr txBox="1"/>
-          <p:nvPr/>
-        </p:nvSpPr>
-        <p:spPr>
-          <a:xfrm>
-            <a:off x="731520" y="5349240"/>
-            <a:ext cx="10515600" cy="731520"/>
-          </a:xfrm>
-          <a:prstGeom prst="rect">
-            <a:avLst/>
-          </a:prstGeom>
-          <a:noFill/>
-        </p:spPr>
-        <p:txBody>
-          <a:bodyPr wrap="square" anchor="t" lIns="0" rIns="0" tIns="0" bIns="0">
-            <a:spAutoFit/>
-          </a:bodyPr>
-          <a:lstStyle/>
-          <a:p>
-            <a:pPr algn="l">
-              <a:lnSpc>
-                <a:spcPct val="130000"/>
-              </a:lnSpc>
-              <a:spcAft>
-                <a:spcPts val="0"/>
-              </a:spcAft>
-            </a:pPr>
-            <a:r>
-              <a:rPr sz="1300" b="1">
-                <a:solidFill>
-                  <a:srgbClr val="14261F"/>
-                </a:solidFill>
-                <a:latin typeface="Instrument Sans"/>
-              </a:rPr>
-              <a:t>Next: </a:t>
-            </a:r>
-            <a:r>
-              <a:rPr sz="1300" b="0">
-                <a:solidFill>
-                  <a:srgbClr val="5F6D66"/>
-                </a:solidFill>
-                <a:latin typeface="Instrument Sans"/>
-              </a:rPr>
-              <a:t>fold the disclosure gate, the escalation and the 30-day trend rules, prototyped today against the live Anima world, into the app's scheduled check. Pilot at one practice. Wire consent to NHS App proxy access.</a:t>
-            </a:r>
-          </a:p>
-        </p:txBody>
-      </p:sp>
-      <p:sp>
-        <p:nvSpPr>
-          <p:cNvPr id="18" name="TextBox 17"/>
-          <p:cNvSpPr txBox="1"/>
-          <p:nvPr/>
-        </p:nvSpPr>
-        <p:spPr>
-          <a:xfrm>
-            <a:off x="731520" y="6309360"/>
-            <a:ext cx="7863840" cy="365760"/>
-          </a:xfrm>
-          <a:prstGeom prst="rect">
-            <a:avLst/>
-          </a:prstGeom>
-          <a:noFill/>
-        </p:spPr>
-        <p:txBody>
-          <a:bodyPr wrap="square" anchor="b" lIns="0" rIns="0" tIns="0" bIns="0">
-            <a:spAutoFit/>
-          </a:bodyPr>
-          <a:lstStyle/>
-          <a:p>
-            <a:pPr algn="l">
-              <a:lnSpc>
-                <a:spcPct val="115000"/>
-              </a:lnSpc>
-              <a:spcAft>
-                <a:spcPts val="0"/>
-              </a:spcAft>
-            </a:pPr>
-            <a:r>
-              <a:rPr sz="850" b="0">
-                <a:solidFill>
-                  <a:srgbClr val="5F6D66"/>
-                </a:solidFill>
-                <a:latin typeface="Instrument Sans"/>
-              </a:rPr>
-              <a:t>All patient data synthetic. Fictional demo, not an official NHS product.</a:t>
-            </a:r>
-          </a:p>
-        </p:txBody>
-      </p:sp>
-      <p:sp>
-        <p:nvSpPr>
-          <p:cNvPr id="19" name="TextBox 18"/>
-          <p:cNvSpPr txBox="1"/>
-          <p:nvPr/>
-        </p:nvSpPr>
-        <p:spPr>
-          <a:xfrm>
-            <a:off x="7345375" y="6309360"/>
-            <a:ext cx="4114800" cy="365760"/>
-          </a:xfrm>
-          <a:prstGeom prst="rect">
-            <a:avLst/>
-          </a:prstGeom>
-          <a:noFill/>
-        </p:spPr>
-        <p:txBody>
-          <a:bodyPr wrap="square" anchor="b" lIns="0" rIns="0" tIns="0" bIns="0">
-            <a:spAutoFit/>
-          </a:bodyPr>
-          <a:lstStyle/>
-          <a:p>
-            <a:pPr algn="r">
-              <a:lnSpc>
-                <a:spcPct val="115000"/>
-              </a:lnSpc>
-              <a:spcAft>
-                <a:spcPts val="0"/>
-              </a:spcAft>
-            </a:pPr>
-            <a:r>
-              <a:rPr sz="850" b="0">
-                <a:solidFill>
-                  <a:srgbClr val="5F6D66"/>
-                </a:solidFill>
-                <a:latin typeface="Instrument Sans"/>
-              </a:rPr>
-              <a:t>CareCircle · Team 5</a:t>
             </a:r>
           </a:p>
         </p:txBody>

</xml_diff>